<commit_message>
Fix CI: attestation test portable across X.509 libraries; pin verified versions; deck link
CI (cryptography 50.0.1) refused to parse Google's sample attestation
certificates (non-DER signature-algorithm encoding) and the E15 module
crashed. The verifier already fails closed on such chains; the experiment
now records them as rejections, builds its forged-root case from a
synthetic certificate, and adds a replayed-nonce case (19/19).
Requirements pinned to the versions CI verified; cryptography held at
48.x. Logged as U26: a production verifier must parse genuine but
non-DER device certificates safely.

Deck: repository link on slides 3 and 6.

Co-Authored-By: Claude Opus 5.5 <noreply@anthropic.com>
</commit_message>
<xml_diff>
--- a/docs/deck/SIH26231_Idea_Submission.pptx
+++ b/docs/deck/SIH26231_Idea_Submission.pptx
@@ -261,7 +261,7 @@
             <a:fld id="{C4D5ADD5-2BBC-4A94-8F86-D9013941F742}" type="datetimeFigureOut">
               <a:rPr lang="en-US"/>
               <a:pPr/>
-              <a:t>9/29/2026</a:t>
+              <a:t>9/30/2026</a:t>
             </a:fld>
             <a:endParaRPr lang="en-US"/>
           </a:p>
@@ -1534,7 +1534,7 @@
           <a:p>
             <a:fld id="{E60792E3-D524-454C-8AFD-A91972900BCB}" type="datetime1">
               <a:rPr lang="en-US" smtClean="0"/>
-              <a:t>9/29/2026</a:t>
+              <a:t>9/30/2026</a:t>
             </a:fld>
             <a:endParaRPr lang="en-US"/>
           </a:p>
@@ -1716,7 +1716,7 @@
           <a:p>
             <a:fld id="{053C3A68-6922-42D3-8905-ECC2D82A3469}" type="datetime1">
               <a:rPr lang="en-US" smtClean="0"/>
-              <a:t>9/29/2026</a:t>
+              <a:t>9/30/2026</a:t>
             </a:fld>
             <a:endParaRPr lang="en-US"/>
           </a:p>
@@ -1908,7 +1908,7 @@
           <a:p>
             <a:fld id="{CB69E9F4-7604-4950-A8B2-8ACDEDB1506E}" type="datetime1">
               <a:rPr lang="en-US" smtClean="0"/>
-              <a:t>9/29/2026</a:t>
+              <a:t>9/30/2026</a:t>
             </a:fld>
             <a:endParaRPr lang="en-US"/>
           </a:p>
@@ -2090,7 +2090,7 @@
           <a:p>
             <a:fld id="{708B7524-32A2-4C20-A58C-BC3BAA1042FC}" type="datetime1">
               <a:rPr lang="en-US" smtClean="0"/>
-              <a:t>9/29/2026</a:t>
+              <a:t>9/30/2026</a:t>
             </a:fld>
             <a:endParaRPr lang="en-US"/>
           </a:p>
@@ -2349,7 +2349,7 @@
           <a:p>
             <a:fld id="{1E994447-D6B2-43BB-A877-57F1A267B999}" type="datetime1">
               <a:rPr lang="en-US" smtClean="0"/>
-              <a:t>9/29/2026</a:t>
+              <a:t>9/30/2026</a:t>
             </a:fld>
             <a:endParaRPr lang="en-US"/>
           </a:p>
@@ -2648,7 +2648,7 @@
           <a:p>
             <a:fld id="{68920E16-BD35-483C-AA6B-346FC7E46DEA}" type="datetime1">
               <a:rPr lang="en-US" smtClean="0"/>
-              <a:t>9/29/2026</a:t>
+              <a:t>9/30/2026</a:t>
             </a:fld>
             <a:endParaRPr lang="en-US"/>
           </a:p>
@@ -3081,7 +3081,7 @@
           <a:p>
             <a:fld id="{2FEAC6F8-5103-4FC0-A69E-5C6AE6469DA8}" type="datetime1">
               <a:rPr lang="en-US" smtClean="0"/>
-              <a:t>9/29/2026</a:t>
+              <a:t>9/30/2026</a:t>
             </a:fld>
             <a:endParaRPr lang="en-US"/>
           </a:p>
@@ -3212,7 +3212,7 @@
           <a:p>
             <a:fld id="{C60C6921-0627-4C8F-83D5-0CF936D2FFDD}" type="datetime1">
               <a:rPr lang="en-US" smtClean="0"/>
-              <a:t>9/29/2026</a:t>
+              <a:t>9/30/2026</a:t>
             </a:fld>
             <a:endParaRPr lang="en-US"/>
           </a:p>
@@ -3321,7 +3321,7 @@
           <a:p>
             <a:fld id="{2FF08AD7-8103-40F8-983C-E2BA6BB9CBE0}" type="datetime1">
               <a:rPr lang="en-US" smtClean="0"/>
-              <a:t>9/29/2026</a:t>
+              <a:t>9/30/2026</a:t>
             </a:fld>
             <a:endParaRPr lang="en-US"/>
           </a:p>
@@ -3610,7 +3610,7 @@
           <a:p>
             <a:fld id="{DF8C06B4-9380-4A4D-AF49-A3596E17DAF5}" type="datetime1">
               <a:rPr lang="en-US" smtClean="0"/>
-              <a:t>9/29/2026</a:t>
+              <a:t>9/30/2026</a:t>
             </a:fld>
             <a:endParaRPr lang="en-US"/>
           </a:p>
@@ -3879,7 +3879,7 @@
           <a:p>
             <a:fld id="{EF7FDEF1-C582-4E22-9E77-D68326471F28}" type="datetime1">
               <a:rPr lang="en-US" smtClean="0"/>
-              <a:t>9/29/2026</a:t>
+              <a:t>9/30/2026</a:t>
             </a:fld>
             <a:endParaRPr lang="en-US"/>
           </a:p>
@@ -4122,7 +4122,7 @@
           <a:p>
             <a:fld id="{780A9602-A9A9-453F-AEF1-37B5837E02CD}" type="datetime1">
               <a:rPr lang="en-US" smtClean="0"/>
-              <a:t>9/29/2026</a:t>
+              <a:t>9/30/2026</a:t>
             </a:fld>
             <a:endParaRPr lang="en-US"/>
           </a:p>
@@ -6164,7 +6164,7 @@
           <p:cNvPr id="2" name="TextBox 1">
             <a:extLst>
               <a:ext uri="{FF2B5EF4-FFF2-40B4-BE49-F238E27FC236}">
-                <a16:creationId xmlns:a16="http://schemas.microsoft.com/office/drawing/2014/main" id="{3DD9EF85-B998-9777-DB02-CF9B93E9974B}"/>
+                <a16:creationId xmlns:a16="http://schemas.microsoft.com/office/drawing/2014/main" id="{B4BA027E-0A92-0076-FD2B-C5E6877244FD}"/>
               </a:ext>
             </a:extLst>
           </p:cNvPr>
@@ -6218,7 +6218,7 @@
           <p:cNvPr id="3" name="Rectangle: Rounded Corners 2">
             <a:extLst>
               <a:ext uri="{FF2B5EF4-FFF2-40B4-BE49-F238E27FC236}">
-                <a16:creationId xmlns:a16="http://schemas.microsoft.com/office/drawing/2014/main" id="{A141FAD9-6BA0-F835-FACF-EEBD7B4946E4}"/>
+                <a16:creationId xmlns:a16="http://schemas.microsoft.com/office/drawing/2014/main" id="{96B2BC3E-3F7F-0EC4-AEBB-7284EB993945}"/>
               </a:ext>
             </a:extLst>
           </p:cNvPr>
@@ -6296,7 +6296,7 @@
           <p:cNvPr id="4" name="TextBox 3">
             <a:extLst>
               <a:ext uri="{FF2B5EF4-FFF2-40B4-BE49-F238E27FC236}">
-                <a16:creationId xmlns:a16="http://schemas.microsoft.com/office/drawing/2014/main" id="{FAE492B0-B9AD-05FE-FD68-E100FA679BE5}"/>
+                <a16:creationId xmlns:a16="http://schemas.microsoft.com/office/drawing/2014/main" id="{01BD609A-0D64-BBE1-E584-16CEC5D916B8}"/>
               </a:ext>
             </a:extLst>
           </p:cNvPr>
@@ -6344,7 +6344,7 @@
           <p:cNvPr id="5" name="TextBox 4">
             <a:extLst>
               <a:ext uri="{FF2B5EF4-FFF2-40B4-BE49-F238E27FC236}">
-                <a16:creationId xmlns:a16="http://schemas.microsoft.com/office/drawing/2014/main" id="{28A1D8C3-F631-3FBF-919A-716F325D8F93}"/>
+                <a16:creationId xmlns:a16="http://schemas.microsoft.com/office/drawing/2014/main" id="{4F1ED48E-0893-4EEB-EC87-5F0AE59A2B48}"/>
               </a:ext>
             </a:extLst>
           </p:cNvPr>
@@ -6511,7 +6511,7 @@
           <p:cNvPr id="8" name="TextBox 7">
             <a:extLst>
               <a:ext uri="{FF2B5EF4-FFF2-40B4-BE49-F238E27FC236}">
-                <a16:creationId xmlns:a16="http://schemas.microsoft.com/office/drawing/2014/main" id="{DE45DFDD-D4A5-EF9B-6697-6A4C4077AF48}"/>
+                <a16:creationId xmlns:a16="http://schemas.microsoft.com/office/drawing/2014/main" id="{200C9D84-6FF1-0111-88FB-F8DE23514122}"/>
               </a:ext>
             </a:extLst>
           </p:cNvPr>
@@ -6565,7 +6565,7 @@
           <p:cNvPr id="12" name="Oval 11">
             <a:extLst>
               <a:ext uri="{FF2B5EF4-FFF2-40B4-BE49-F238E27FC236}">
-                <a16:creationId xmlns:a16="http://schemas.microsoft.com/office/drawing/2014/main" id="{19587B8A-2B49-9861-97FD-47E1B2494E39}"/>
+                <a16:creationId xmlns:a16="http://schemas.microsoft.com/office/drawing/2014/main" id="{4781352A-6075-16CC-9D86-01D1780A2D56}"/>
               </a:ext>
             </a:extLst>
           </p:cNvPr>
@@ -6656,7 +6656,7 @@
           <p:cNvPr id="13" name="TextBox 12">
             <a:extLst>
               <a:ext uri="{FF2B5EF4-FFF2-40B4-BE49-F238E27FC236}">
-                <a16:creationId xmlns:a16="http://schemas.microsoft.com/office/drawing/2014/main" id="{A63B6228-60F1-E6CE-2B2A-CD1B5ACB8DB1}"/>
+                <a16:creationId xmlns:a16="http://schemas.microsoft.com/office/drawing/2014/main" id="{149D812E-F5F6-BCB5-0205-26613B08C61B}"/>
               </a:ext>
             </a:extLst>
           </p:cNvPr>
@@ -6729,7 +6729,7 @@
           <p:cNvPr id="14" name="Straight Connector 13">
             <a:extLst>
               <a:ext uri="{FF2B5EF4-FFF2-40B4-BE49-F238E27FC236}">
-                <a16:creationId xmlns:a16="http://schemas.microsoft.com/office/drawing/2014/main" id="{02CC8047-1E1E-C327-C878-769DAB1A7295}"/>
+                <a16:creationId xmlns:a16="http://schemas.microsoft.com/office/drawing/2014/main" id="{77ACE5DD-BB8E-354C-14E1-E00EE46B4797}"/>
               </a:ext>
             </a:extLst>
           </p:cNvPr>
@@ -6771,7 +6771,7 @@
           <p:cNvPr id="15" name="Oval 14">
             <a:extLst>
               <a:ext uri="{FF2B5EF4-FFF2-40B4-BE49-F238E27FC236}">
-                <a16:creationId xmlns:a16="http://schemas.microsoft.com/office/drawing/2014/main" id="{2C7434E4-543B-79D3-5DF3-6FCFAAD4844A}"/>
+                <a16:creationId xmlns:a16="http://schemas.microsoft.com/office/drawing/2014/main" id="{A8DA9A02-DD31-2D14-532F-FDEF30FF3CB9}"/>
               </a:ext>
             </a:extLst>
           </p:cNvPr>
@@ -6862,7 +6862,7 @@
           <p:cNvPr id="16" name="TextBox 15">
             <a:extLst>
               <a:ext uri="{FF2B5EF4-FFF2-40B4-BE49-F238E27FC236}">
-                <a16:creationId xmlns:a16="http://schemas.microsoft.com/office/drawing/2014/main" id="{EA7409F3-D732-4308-DBBE-A1EB15B9A44F}"/>
+                <a16:creationId xmlns:a16="http://schemas.microsoft.com/office/drawing/2014/main" id="{87175E1A-A3F2-D36A-3E04-7ECE9F3A5BB3}"/>
               </a:ext>
             </a:extLst>
           </p:cNvPr>
@@ -6935,7 +6935,7 @@
           <p:cNvPr id="17" name="Straight Connector 16">
             <a:extLst>
               <a:ext uri="{FF2B5EF4-FFF2-40B4-BE49-F238E27FC236}">
-                <a16:creationId xmlns:a16="http://schemas.microsoft.com/office/drawing/2014/main" id="{A0022243-DE6E-9812-66B3-7C56D48249FF}"/>
+                <a16:creationId xmlns:a16="http://schemas.microsoft.com/office/drawing/2014/main" id="{51D22222-1472-54B6-47A7-7BF1D8428B84}"/>
               </a:ext>
             </a:extLst>
           </p:cNvPr>
@@ -6977,7 +6977,7 @@
           <p:cNvPr id="18" name="Oval 17">
             <a:extLst>
               <a:ext uri="{FF2B5EF4-FFF2-40B4-BE49-F238E27FC236}">
-                <a16:creationId xmlns:a16="http://schemas.microsoft.com/office/drawing/2014/main" id="{DD207F1B-151C-E8FB-F8C7-66BA6756DB95}"/>
+                <a16:creationId xmlns:a16="http://schemas.microsoft.com/office/drawing/2014/main" id="{CF8BA2A3-6041-0926-165E-E006E9C13813}"/>
               </a:ext>
             </a:extLst>
           </p:cNvPr>
@@ -7068,7 +7068,7 @@
           <p:cNvPr id="19" name="TextBox 18">
             <a:extLst>
               <a:ext uri="{FF2B5EF4-FFF2-40B4-BE49-F238E27FC236}">
-                <a16:creationId xmlns:a16="http://schemas.microsoft.com/office/drawing/2014/main" id="{02723FBB-89C1-90C0-E976-30A08D940ABD}"/>
+                <a16:creationId xmlns:a16="http://schemas.microsoft.com/office/drawing/2014/main" id="{D99554F5-696A-327D-C8B2-32E23477BC94}"/>
               </a:ext>
             </a:extLst>
           </p:cNvPr>
@@ -7141,7 +7141,7 @@
           <p:cNvPr id="20" name="Straight Connector 19">
             <a:extLst>
               <a:ext uri="{FF2B5EF4-FFF2-40B4-BE49-F238E27FC236}">
-                <a16:creationId xmlns:a16="http://schemas.microsoft.com/office/drawing/2014/main" id="{0DC3CF53-24BE-DEBA-6337-EFECF8AD18CE}"/>
+                <a16:creationId xmlns:a16="http://schemas.microsoft.com/office/drawing/2014/main" id="{1A970276-C96B-1D28-9CB4-8ADD6B398342}"/>
               </a:ext>
             </a:extLst>
           </p:cNvPr>
@@ -7183,7 +7183,7 @@
           <p:cNvPr id="21" name="Oval 20">
             <a:extLst>
               <a:ext uri="{FF2B5EF4-FFF2-40B4-BE49-F238E27FC236}">
-                <a16:creationId xmlns:a16="http://schemas.microsoft.com/office/drawing/2014/main" id="{A3EBE2CD-011C-C09C-66CD-B0EF137E129C}"/>
+                <a16:creationId xmlns:a16="http://schemas.microsoft.com/office/drawing/2014/main" id="{6B597CE0-17FE-C771-957A-DBA3D1948E5C}"/>
               </a:ext>
             </a:extLst>
           </p:cNvPr>
@@ -7274,7 +7274,7 @@
           <p:cNvPr id="22" name="TextBox 21">
             <a:extLst>
               <a:ext uri="{FF2B5EF4-FFF2-40B4-BE49-F238E27FC236}">
-                <a16:creationId xmlns:a16="http://schemas.microsoft.com/office/drawing/2014/main" id="{E21BC79C-2584-AF18-E677-F53AB4B7C8EF}"/>
+                <a16:creationId xmlns:a16="http://schemas.microsoft.com/office/drawing/2014/main" id="{14360F33-DE26-CA73-2462-28E3961EE946}"/>
               </a:ext>
             </a:extLst>
           </p:cNvPr>
@@ -7347,7 +7347,7 @@
           <p:cNvPr id="23" name="Straight Connector 22">
             <a:extLst>
               <a:ext uri="{FF2B5EF4-FFF2-40B4-BE49-F238E27FC236}">
-                <a16:creationId xmlns:a16="http://schemas.microsoft.com/office/drawing/2014/main" id="{2A1E6FCD-0F3F-5B66-3A63-1D39E034A5C0}"/>
+                <a16:creationId xmlns:a16="http://schemas.microsoft.com/office/drawing/2014/main" id="{FFF0DAFB-B6A0-6839-7091-98BC165895C2}"/>
               </a:ext>
             </a:extLst>
           </p:cNvPr>
@@ -7389,7 +7389,7 @@
           <p:cNvPr id="24" name="Oval 23">
             <a:extLst>
               <a:ext uri="{FF2B5EF4-FFF2-40B4-BE49-F238E27FC236}">
-                <a16:creationId xmlns:a16="http://schemas.microsoft.com/office/drawing/2014/main" id="{33848648-82CB-5DC4-D4C1-0A8180C34F5A}"/>
+                <a16:creationId xmlns:a16="http://schemas.microsoft.com/office/drawing/2014/main" id="{30CD1916-F2F9-E994-B044-5AC541A09F0D}"/>
               </a:ext>
             </a:extLst>
           </p:cNvPr>
@@ -7480,7 +7480,7 @@
           <p:cNvPr id="25" name="TextBox 24">
             <a:extLst>
               <a:ext uri="{FF2B5EF4-FFF2-40B4-BE49-F238E27FC236}">
-                <a16:creationId xmlns:a16="http://schemas.microsoft.com/office/drawing/2014/main" id="{73B22157-EE2B-47F2-AD0A-15196FE08193}"/>
+                <a16:creationId xmlns:a16="http://schemas.microsoft.com/office/drawing/2014/main" id="{70956FCB-2301-A937-F88E-EAAF02A5EBF9}"/>
               </a:ext>
             </a:extLst>
           </p:cNvPr>
@@ -7553,7 +7553,7 @@
           <p:cNvPr id="26" name="Straight Connector 25">
             <a:extLst>
               <a:ext uri="{FF2B5EF4-FFF2-40B4-BE49-F238E27FC236}">
-                <a16:creationId xmlns:a16="http://schemas.microsoft.com/office/drawing/2014/main" id="{81425F1A-A66E-E89B-A432-8B79937019E6}"/>
+                <a16:creationId xmlns:a16="http://schemas.microsoft.com/office/drawing/2014/main" id="{A6CD65E7-12CB-F8F3-CA06-BC72ED9E1B64}"/>
               </a:ext>
             </a:extLst>
           </p:cNvPr>
@@ -7595,7 +7595,7 @@
           <p:cNvPr id="27" name="Oval 26">
             <a:extLst>
               <a:ext uri="{FF2B5EF4-FFF2-40B4-BE49-F238E27FC236}">
-                <a16:creationId xmlns:a16="http://schemas.microsoft.com/office/drawing/2014/main" id="{2396C38B-5E00-C83A-4E88-587D1DA40EC1}"/>
+                <a16:creationId xmlns:a16="http://schemas.microsoft.com/office/drawing/2014/main" id="{CC9936F5-D415-B2A1-A045-31E4C2BB6B7F}"/>
               </a:ext>
             </a:extLst>
           </p:cNvPr>
@@ -7686,7 +7686,7 @@
           <p:cNvPr id="28" name="TextBox 27">
             <a:extLst>
               <a:ext uri="{FF2B5EF4-FFF2-40B4-BE49-F238E27FC236}">
-                <a16:creationId xmlns:a16="http://schemas.microsoft.com/office/drawing/2014/main" id="{83FC8EC0-3849-2FC1-1FE6-5A1B8CB89356}"/>
+                <a16:creationId xmlns:a16="http://schemas.microsoft.com/office/drawing/2014/main" id="{FA639B10-08C8-0DDF-C357-E48E5A4DFD8D}"/>
               </a:ext>
             </a:extLst>
           </p:cNvPr>
@@ -7759,7 +7759,7 @@
           <p:cNvPr id="29" name="TextBox 28">
             <a:extLst>
               <a:ext uri="{FF2B5EF4-FFF2-40B4-BE49-F238E27FC236}">
-                <a16:creationId xmlns:a16="http://schemas.microsoft.com/office/drawing/2014/main" id="{64304FB9-3910-11AC-C305-3750B270B2C3}"/>
+                <a16:creationId xmlns:a16="http://schemas.microsoft.com/office/drawing/2014/main" id="{1226C746-2875-84BC-FABE-A53607CB101A}"/>
               </a:ext>
             </a:extLst>
           </p:cNvPr>
@@ -7807,7 +7807,7 @@
           <p:cNvPr id="30" name="Rectangle: Rounded Corners 29">
             <a:extLst>
               <a:ext uri="{FF2B5EF4-FFF2-40B4-BE49-F238E27FC236}">
-                <a16:creationId xmlns:a16="http://schemas.microsoft.com/office/drawing/2014/main" id="{ECAA1437-CE8A-ED94-2551-670CA31548C8}"/>
+                <a16:creationId xmlns:a16="http://schemas.microsoft.com/office/drawing/2014/main" id="{BA2E3774-0C85-D8D1-186E-C746C5C5BABB}"/>
               </a:ext>
             </a:extLst>
           </p:cNvPr>
@@ -7885,7 +7885,7 @@
           <p:cNvPr id="31" name="TextBox 30">
             <a:extLst>
               <a:ext uri="{FF2B5EF4-FFF2-40B4-BE49-F238E27FC236}">
-                <a16:creationId xmlns:a16="http://schemas.microsoft.com/office/drawing/2014/main" id="{984BC451-5A1F-8F07-1B19-DC6EAEB684F4}"/>
+                <a16:creationId xmlns:a16="http://schemas.microsoft.com/office/drawing/2014/main" id="{28EA960F-A7C7-7AFE-A451-3CAE5329B063}"/>
               </a:ext>
             </a:extLst>
           </p:cNvPr>
@@ -7958,7 +7958,7 @@
           <p:cNvPr id="32" name="Rectangle: Rounded Corners 31">
             <a:extLst>
               <a:ext uri="{FF2B5EF4-FFF2-40B4-BE49-F238E27FC236}">
-                <a16:creationId xmlns:a16="http://schemas.microsoft.com/office/drawing/2014/main" id="{3E89D731-E3FE-8DBB-3BA0-6A3226426CDC}"/>
+                <a16:creationId xmlns:a16="http://schemas.microsoft.com/office/drawing/2014/main" id="{BA4A8E8F-BBF7-32B3-2445-3F012732E8D9}"/>
               </a:ext>
             </a:extLst>
           </p:cNvPr>
@@ -8036,7 +8036,7 @@
           <p:cNvPr id="33" name="TextBox 32">
             <a:extLst>
               <a:ext uri="{FF2B5EF4-FFF2-40B4-BE49-F238E27FC236}">
-                <a16:creationId xmlns:a16="http://schemas.microsoft.com/office/drawing/2014/main" id="{4C0A8199-A69C-B07F-7466-48F83DE8BD55}"/>
+                <a16:creationId xmlns:a16="http://schemas.microsoft.com/office/drawing/2014/main" id="{B4BD9B6A-23A6-7AB7-5AC6-F940EBDAD3F3}"/>
               </a:ext>
             </a:extLst>
           </p:cNvPr>
@@ -8109,7 +8109,7 @@
           <p:cNvPr id="34" name="Rectangle: Rounded Corners 33">
             <a:extLst>
               <a:ext uri="{FF2B5EF4-FFF2-40B4-BE49-F238E27FC236}">
-                <a16:creationId xmlns:a16="http://schemas.microsoft.com/office/drawing/2014/main" id="{2DB32B6E-8E30-CF87-9DF3-65A49AE6F7A0}"/>
+                <a16:creationId xmlns:a16="http://schemas.microsoft.com/office/drawing/2014/main" id="{B54D1330-283F-3FD7-992A-4C429D9F6100}"/>
               </a:ext>
             </a:extLst>
           </p:cNvPr>
@@ -8202,7 +8202,7 @@
           <p:cNvPr id="35" name="Rectangle: Rounded Corners 34">
             <a:extLst>
               <a:ext uri="{FF2B5EF4-FFF2-40B4-BE49-F238E27FC236}">
-                <a16:creationId xmlns:a16="http://schemas.microsoft.com/office/drawing/2014/main" id="{0DFF8FFB-1974-3908-53AC-1C912AB1E25F}"/>
+                <a16:creationId xmlns:a16="http://schemas.microsoft.com/office/drawing/2014/main" id="{B8970BAF-5718-A286-E9CD-6E61CC3EE107}"/>
               </a:ext>
             </a:extLst>
           </p:cNvPr>
@@ -8280,7 +8280,7 @@
           <p:cNvPr id="36" name="TextBox 35">
             <a:extLst>
               <a:ext uri="{FF2B5EF4-FFF2-40B4-BE49-F238E27FC236}">
-                <a16:creationId xmlns:a16="http://schemas.microsoft.com/office/drawing/2014/main" id="{126677D6-1FE1-B9CA-2A82-2781C443498F}"/>
+                <a16:creationId xmlns:a16="http://schemas.microsoft.com/office/drawing/2014/main" id="{6E5BA662-34AB-A747-2036-9949F9648FB7}"/>
               </a:ext>
             </a:extLst>
           </p:cNvPr>
@@ -8353,7 +8353,7 @@
           <p:cNvPr id="37" name="Rectangle: Rounded Corners 36">
             <a:extLst>
               <a:ext uri="{FF2B5EF4-FFF2-40B4-BE49-F238E27FC236}">
-                <a16:creationId xmlns:a16="http://schemas.microsoft.com/office/drawing/2014/main" id="{01BBDC61-6855-2705-1D0C-261BAF1FED95}"/>
+                <a16:creationId xmlns:a16="http://schemas.microsoft.com/office/drawing/2014/main" id="{1E5E58A8-EC87-B41C-C885-7815E2C70C0A}"/>
               </a:ext>
             </a:extLst>
           </p:cNvPr>
@@ -8446,7 +8446,7 @@
           <p:cNvPr id="38" name="Rectangle: Rounded Corners 37">
             <a:extLst>
               <a:ext uri="{FF2B5EF4-FFF2-40B4-BE49-F238E27FC236}">
-                <a16:creationId xmlns:a16="http://schemas.microsoft.com/office/drawing/2014/main" id="{4A33B86A-9B88-FEE8-07FF-561422EA67EE}"/>
+                <a16:creationId xmlns:a16="http://schemas.microsoft.com/office/drawing/2014/main" id="{34B1515D-B6C6-25C1-9A8A-43C2C00F94C5}"/>
               </a:ext>
             </a:extLst>
           </p:cNvPr>
@@ -8524,7 +8524,7 @@
           <p:cNvPr id="39" name="TextBox 38">
             <a:extLst>
               <a:ext uri="{FF2B5EF4-FFF2-40B4-BE49-F238E27FC236}">
-                <a16:creationId xmlns:a16="http://schemas.microsoft.com/office/drawing/2014/main" id="{8E3004FB-1D2F-AA0C-9ED7-D7BCCFEEA045}"/>
+                <a16:creationId xmlns:a16="http://schemas.microsoft.com/office/drawing/2014/main" id="{465A7A3E-61C7-625C-61D7-8625A8A9E92A}"/>
               </a:ext>
             </a:extLst>
           </p:cNvPr>
@@ -8875,7 +8875,7 @@
           <p:cNvPr id="2" name="Rectangle: Rounded Corners 1">
             <a:extLst>
               <a:ext uri="{FF2B5EF4-FFF2-40B4-BE49-F238E27FC236}">
-                <a16:creationId xmlns:a16="http://schemas.microsoft.com/office/drawing/2014/main" id="{2848F0C4-C48B-6CEA-2EB7-58C33EBB7A8B}"/>
+                <a16:creationId xmlns:a16="http://schemas.microsoft.com/office/drawing/2014/main" id="{5F592037-561C-50D4-DBAC-6E22A2079E75}"/>
               </a:ext>
             </a:extLst>
           </p:cNvPr>
@@ -8943,7 +8943,7 @@
           <p:cNvPr id="3" name="TextBox 2">
             <a:extLst>
               <a:ext uri="{FF2B5EF4-FFF2-40B4-BE49-F238E27FC236}">
-                <a16:creationId xmlns:a16="http://schemas.microsoft.com/office/drawing/2014/main" id="{7B33B974-5F72-FEA1-FF72-D353E92D9CDC}"/>
+                <a16:creationId xmlns:a16="http://schemas.microsoft.com/office/drawing/2014/main" id="{0D464547-A096-075C-5F91-8C5E0FF36C5C}"/>
               </a:ext>
             </a:extLst>
           </p:cNvPr>
@@ -8991,7 +8991,7 @@
           <p:cNvPr id="4" name="Rectangle: Rounded Corners 3">
             <a:extLst>
               <a:ext uri="{FF2B5EF4-FFF2-40B4-BE49-F238E27FC236}">
-                <a16:creationId xmlns:a16="http://schemas.microsoft.com/office/drawing/2014/main" id="{FE308B5C-FE0D-C649-AF8F-6C4DC9013CEC}"/>
+                <a16:creationId xmlns:a16="http://schemas.microsoft.com/office/drawing/2014/main" id="{7E562693-7C5C-8A90-7104-836927749894}"/>
               </a:ext>
             </a:extLst>
           </p:cNvPr>
@@ -9059,7 +9059,7 @@
           <p:cNvPr id="5" name="TextBox 4">
             <a:extLst>
               <a:ext uri="{FF2B5EF4-FFF2-40B4-BE49-F238E27FC236}">
-                <a16:creationId xmlns:a16="http://schemas.microsoft.com/office/drawing/2014/main" id="{B79217ED-AB3B-091A-8FCD-587DD441ACE1}"/>
+                <a16:creationId xmlns:a16="http://schemas.microsoft.com/office/drawing/2014/main" id="{9AF5D716-F759-0C91-4F9D-CAFC3A74CF74}"/>
               </a:ext>
             </a:extLst>
           </p:cNvPr>
@@ -9132,7 +9132,7 @@
           <p:cNvPr id="8" name="Rectangle: Rounded Corners 7">
             <a:extLst>
               <a:ext uri="{FF2B5EF4-FFF2-40B4-BE49-F238E27FC236}">
-                <a16:creationId xmlns:a16="http://schemas.microsoft.com/office/drawing/2014/main" id="{F8C0FC88-647B-CDA2-4E4E-255EEAB4A335}"/>
+                <a16:creationId xmlns:a16="http://schemas.microsoft.com/office/drawing/2014/main" id="{35AD702D-32AF-A86C-D071-A6217376B72F}"/>
               </a:ext>
             </a:extLst>
           </p:cNvPr>
@@ -9200,7 +9200,7 @@
           <p:cNvPr id="9" name="TextBox 8">
             <a:extLst>
               <a:ext uri="{FF2B5EF4-FFF2-40B4-BE49-F238E27FC236}">
-                <a16:creationId xmlns:a16="http://schemas.microsoft.com/office/drawing/2014/main" id="{08105CBA-F5AE-BBAE-A51F-A741C99C2FB8}"/>
+                <a16:creationId xmlns:a16="http://schemas.microsoft.com/office/drawing/2014/main" id="{AD2D9560-7703-700E-04EF-F811B78B15B9}"/>
               </a:ext>
             </a:extLst>
           </p:cNvPr>
@@ -9273,7 +9273,7 @@
           <p:cNvPr id="13" name="Rectangle: Rounded Corners 12">
             <a:extLst>
               <a:ext uri="{FF2B5EF4-FFF2-40B4-BE49-F238E27FC236}">
-                <a16:creationId xmlns:a16="http://schemas.microsoft.com/office/drawing/2014/main" id="{A6536C9D-F6DB-707E-0AB7-84DA6C6CD4B2}"/>
+                <a16:creationId xmlns:a16="http://schemas.microsoft.com/office/drawing/2014/main" id="{4E7A88F4-18CF-94B5-8FA1-75CD557FFD23}"/>
               </a:ext>
             </a:extLst>
           </p:cNvPr>
@@ -9341,7 +9341,7 @@
           <p:cNvPr id="14" name="TextBox 13">
             <a:extLst>
               <a:ext uri="{FF2B5EF4-FFF2-40B4-BE49-F238E27FC236}">
-                <a16:creationId xmlns:a16="http://schemas.microsoft.com/office/drawing/2014/main" id="{E7087C5B-E987-AA05-DABC-CA1168AA4FAE}"/>
+                <a16:creationId xmlns:a16="http://schemas.microsoft.com/office/drawing/2014/main" id="{639E1C58-0E8B-B0AE-BE02-B0E2896D9680}"/>
               </a:ext>
             </a:extLst>
           </p:cNvPr>
@@ -9414,7 +9414,7 @@
           <p:cNvPr id="15" name="Rectangle: Rounded Corners 14">
             <a:extLst>
               <a:ext uri="{FF2B5EF4-FFF2-40B4-BE49-F238E27FC236}">
-                <a16:creationId xmlns:a16="http://schemas.microsoft.com/office/drawing/2014/main" id="{DDD720F8-93B1-DACD-4F97-DEF0556D376F}"/>
+                <a16:creationId xmlns:a16="http://schemas.microsoft.com/office/drawing/2014/main" id="{4E000A53-8926-F70B-B525-9A562F65A3B8}"/>
               </a:ext>
             </a:extLst>
           </p:cNvPr>
@@ -9482,7 +9482,7 @@
           <p:cNvPr id="16" name="TextBox 15">
             <a:extLst>
               <a:ext uri="{FF2B5EF4-FFF2-40B4-BE49-F238E27FC236}">
-                <a16:creationId xmlns:a16="http://schemas.microsoft.com/office/drawing/2014/main" id="{47C4AB56-10C3-019E-A197-0241E2EC73E3}"/>
+                <a16:creationId xmlns:a16="http://schemas.microsoft.com/office/drawing/2014/main" id="{E7136239-66D4-49CB-3F2E-9B4F44827749}"/>
               </a:ext>
             </a:extLst>
           </p:cNvPr>
@@ -9555,7 +9555,7 @@
           <p:cNvPr id="17" name="Rectangle: Rounded Corners 16">
             <a:extLst>
               <a:ext uri="{FF2B5EF4-FFF2-40B4-BE49-F238E27FC236}">
-                <a16:creationId xmlns:a16="http://schemas.microsoft.com/office/drawing/2014/main" id="{6AC359F3-3560-4EFC-89E4-46DB0154D7D1}"/>
+                <a16:creationId xmlns:a16="http://schemas.microsoft.com/office/drawing/2014/main" id="{A4BAB98C-72CC-AED6-5CA7-BAC2204440C0}"/>
               </a:ext>
             </a:extLst>
           </p:cNvPr>
@@ -9623,7 +9623,7 @@
           <p:cNvPr id="18" name="TextBox 17">
             <a:extLst>
               <a:ext uri="{FF2B5EF4-FFF2-40B4-BE49-F238E27FC236}">
-                <a16:creationId xmlns:a16="http://schemas.microsoft.com/office/drawing/2014/main" id="{1F2D62E0-089D-99D5-6890-A3A79E532A9F}"/>
+                <a16:creationId xmlns:a16="http://schemas.microsoft.com/office/drawing/2014/main" id="{1068B773-C61F-B6C1-92D5-FC380A8D1E98}"/>
               </a:ext>
             </a:extLst>
           </p:cNvPr>
@@ -9696,7 +9696,7 @@
           <p:cNvPr id="19" name="Rectangle: Rounded Corners 18">
             <a:extLst>
               <a:ext uri="{FF2B5EF4-FFF2-40B4-BE49-F238E27FC236}">
-                <a16:creationId xmlns:a16="http://schemas.microsoft.com/office/drawing/2014/main" id="{76D35F6B-285B-D682-F48B-8FAD64A7AD1F}"/>
+                <a16:creationId xmlns:a16="http://schemas.microsoft.com/office/drawing/2014/main" id="{D2FAA2D7-AFB3-8265-17FB-74EF5C1AF817}"/>
               </a:ext>
             </a:extLst>
           </p:cNvPr>
@@ -9764,7 +9764,7 @@
           <p:cNvPr id="20" name="TextBox 19">
             <a:extLst>
               <a:ext uri="{FF2B5EF4-FFF2-40B4-BE49-F238E27FC236}">
-                <a16:creationId xmlns:a16="http://schemas.microsoft.com/office/drawing/2014/main" id="{DC4A8E91-39C2-6BE3-96C2-DCADBBEACC37}"/>
+                <a16:creationId xmlns:a16="http://schemas.microsoft.com/office/drawing/2014/main" id="{026BD5EE-A56A-857B-D7AD-2340E0CB6F7F}"/>
               </a:ext>
             </a:extLst>
           </p:cNvPr>
@@ -9818,7 +9818,7 @@
           <p:cNvPr id="21" name="Rectangle: Rounded Corners 20">
             <a:extLst>
               <a:ext uri="{FF2B5EF4-FFF2-40B4-BE49-F238E27FC236}">
-                <a16:creationId xmlns:a16="http://schemas.microsoft.com/office/drawing/2014/main" id="{4869B19E-FD38-AA85-7204-5543347FB6C8}"/>
+                <a16:creationId xmlns:a16="http://schemas.microsoft.com/office/drawing/2014/main" id="{3D310CBD-0BF3-1FE4-5A3E-F3FBE6043D71}"/>
               </a:ext>
             </a:extLst>
           </p:cNvPr>
@@ -9886,7 +9886,7 @@
           <p:cNvPr id="22" name="TextBox 21">
             <a:extLst>
               <a:ext uri="{FF2B5EF4-FFF2-40B4-BE49-F238E27FC236}">
-                <a16:creationId xmlns:a16="http://schemas.microsoft.com/office/drawing/2014/main" id="{FFC14049-4AC6-7A00-9CDA-8AFA8DA8E83B}"/>
+                <a16:creationId xmlns:a16="http://schemas.microsoft.com/office/drawing/2014/main" id="{7588B814-0907-A324-16B7-F3F2E3057D76}"/>
               </a:ext>
             </a:extLst>
           </p:cNvPr>
@@ -9959,7 +9959,7 @@
           <p:cNvPr id="23" name="Rectangle: Rounded Corners 22">
             <a:extLst>
               <a:ext uri="{FF2B5EF4-FFF2-40B4-BE49-F238E27FC236}">
-                <a16:creationId xmlns:a16="http://schemas.microsoft.com/office/drawing/2014/main" id="{FA99C42A-CB90-B2FE-71CE-F305582ACDCD}"/>
+                <a16:creationId xmlns:a16="http://schemas.microsoft.com/office/drawing/2014/main" id="{23085109-7C26-E17F-43BC-F04DF3E47C51}"/>
               </a:ext>
             </a:extLst>
           </p:cNvPr>
@@ -10027,7 +10027,7 @@
           <p:cNvPr id="24" name="TextBox 23">
             <a:extLst>
               <a:ext uri="{FF2B5EF4-FFF2-40B4-BE49-F238E27FC236}">
-                <a16:creationId xmlns:a16="http://schemas.microsoft.com/office/drawing/2014/main" id="{2E20440D-D6D1-8F2B-1F27-FD3D2D898F08}"/>
+                <a16:creationId xmlns:a16="http://schemas.microsoft.com/office/drawing/2014/main" id="{B7A4099E-9CF7-0C54-6089-9AB62E435787}"/>
               </a:ext>
             </a:extLst>
           </p:cNvPr>
@@ -10100,7 +10100,7 @@
           <p:cNvPr id="25" name="Rectangle: Rounded Corners 24">
             <a:extLst>
               <a:ext uri="{FF2B5EF4-FFF2-40B4-BE49-F238E27FC236}">
-                <a16:creationId xmlns:a16="http://schemas.microsoft.com/office/drawing/2014/main" id="{99F7D462-0039-992D-12CB-715BAAB41164}"/>
+                <a16:creationId xmlns:a16="http://schemas.microsoft.com/office/drawing/2014/main" id="{16921AE2-2963-E545-35CA-85778A17D0C3}"/>
               </a:ext>
             </a:extLst>
           </p:cNvPr>
@@ -10168,7 +10168,7 @@
           <p:cNvPr id="26" name="TextBox 25">
             <a:extLst>
               <a:ext uri="{FF2B5EF4-FFF2-40B4-BE49-F238E27FC236}">
-                <a16:creationId xmlns:a16="http://schemas.microsoft.com/office/drawing/2014/main" id="{39670673-5132-DFB8-35D8-4C7798A266D4}"/>
+                <a16:creationId xmlns:a16="http://schemas.microsoft.com/office/drawing/2014/main" id="{01142FEF-0FAA-EA5A-CC27-28E7CF74E833}"/>
               </a:ext>
             </a:extLst>
           </p:cNvPr>
@@ -10241,7 +10241,7 @@
           <p:cNvPr id="27" name="Rectangle: Rounded Corners 26">
             <a:extLst>
               <a:ext uri="{FF2B5EF4-FFF2-40B4-BE49-F238E27FC236}">
-                <a16:creationId xmlns:a16="http://schemas.microsoft.com/office/drawing/2014/main" id="{B73D5151-CB7D-8CB5-3F53-3DFCFBD510C1}"/>
+                <a16:creationId xmlns:a16="http://schemas.microsoft.com/office/drawing/2014/main" id="{1ABB959A-1D61-F4CB-4F49-641B3D5A08A8}"/>
               </a:ext>
             </a:extLst>
           </p:cNvPr>
@@ -10309,7 +10309,7 @@
           <p:cNvPr id="28" name="TextBox 27">
             <a:extLst>
               <a:ext uri="{FF2B5EF4-FFF2-40B4-BE49-F238E27FC236}">
-                <a16:creationId xmlns:a16="http://schemas.microsoft.com/office/drawing/2014/main" id="{D9E0F224-33D8-CC6B-417A-51C2AAAA9046}"/>
+                <a16:creationId xmlns:a16="http://schemas.microsoft.com/office/drawing/2014/main" id="{A0A4FDCF-230B-6A8A-58D1-59F804A15C03}"/>
               </a:ext>
             </a:extLst>
           </p:cNvPr>
@@ -10382,7 +10382,7 @@
           <p:cNvPr id="29" name="Rectangle: Rounded Corners 28">
             <a:extLst>
               <a:ext uri="{FF2B5EF4-FFF2-40B4-BE49-F238E27FC236}">
-                <a16:creationId xmlns:a16="http://schemas.microsoft.com/office/drawing/2014/main" id="{94F0D864-D54E-E7EB-4684-616EF6874B23}"/>
+                <a16:creationId xmlns:a16="http://schemas.microsoft.com/office/drawing/2014/main" id="{A5959744-C9F3-EA72-ACE7-6E367F9AC061}"/>
               </a:ext>
             </a:extLst>
           </p:cNvPr>
@@ -10450,7 +10450,7 @@
           <p:cNvPr id="30" name="TextBox 29">
             <a:extLst>
               <a:ext uri="{FF2B5EF4-FFF2-40B4-BE49-F238E27FC236}">
-                <a16:creationId xmlns:a16="http://schemas.microsoft.com/office/drawing/2014/main" id="{F5F31445-4FA7-BE53-DF4B-F5EB795930A4}"/>
+                <a16:creationId xmlns:a16="http://schemas.microsoft.com/office/drawing/2014/main" id="{70A1DF49-9C25-2E1F-D0BC-2A442234F994}"/>
               </a:ext>
             </a:extLst>
           </p:cNvPr>
@@ -10523,7 +10523,7 @@
           <p:cNvPr id="31" name="Straight Connector 30">
             <a:extLst>
               <a:ext uri="{FF2B5EF4-FFF2-40B4-BE49-F238E27FC236}">
-                <a16:creationId xmlns:a16="http://schemas.microsoft.com/office/drawing/2014/main" id="{FBE2E673-3796-01C1-90B1-FFFF22C9A009}"/>
+                <a16:creationId xmlns:a16="http://schemas.microsoft.com/office/drawing/2014/main" id="{8D0B9B55-B8A1-1599-6B1E-0096C0B111B7}"/>
               </a:ext>
             </a:extLst>
           </p:cNvPr>
@@ -10565,7 +10565,7 @@
           <p:cNvPr id="32" name="TextBox 31">
             <a:extLst>
               <a:ext uri="{FF2B5EF4-FFF2-40B4-BE49-F238E27FC236}">
-                <a16:creationId xmlns:a16="http://schemas.microsoft.com/office/drawing/2014/main" id="{3625F59C-8DF2-49D3-9345-FDDAC9D18AA3}"/>
+                <a16:creationId xmlns:a16="http://schemas.microsoft.com/office/drawing/2014/main" id="{B0126A9A-68E2-3C64-E65B-75A64F8D328F}"/>
               </a:ext>
             </a:extLst>
           </p:cNvPr>
@@ -10613,7 +10613,7 @@
           <p:cNvPr id="33" name="Rectangle: Rounded Corners 32">
             <a:extLst>
               <a:ext uri="{FF2B5EF4-FFF2-40B4-BE49-F238E27FC236}">
-                <a16:creationId xmlns:a16="http://schemas.microsoft.com/office/drawing/2014/main" id="{99E1B24D-F4C4-65F7-C70F-0936A06ECC6D}"/>
+                <a16:creationId xmlns:a16="http://schemas.microsoft.com/office/drawing/2014/main" id="{E4612905-2351-367F-317B-CF4D0787509B}"/>
               </a:ext>
             </a:extLst>
           </p:cNvPr>
@@ -10681,7 +10681,7 @@
           <p:cNvPr id="34" name="TextBox 33">
             <a:extLst>
               <a:ext uri="{FF2B5EF4-FFF2-40B4-BE49-F238E27FC236}">
-                <a16:creationId xmlns:a16="http://schemas.microsoft.com/office/drawing/2014/main" id="{5EE7B65F-2E79-ACB9-B378-A884D55B5D57}"/>
+                <a16:creationId xmlns:a16="http://schemas.microsoft.com/office/drawing/2014/main" id="{E990752A-CDDD-B095-1079-975951C98E50}"/>
               </a:ext>
             </a:extLst>
           </p:cNvPr>
@@ -10744,7 +10744,7 @@
           <p:cNvPr id="35" name="Rectangle: Rounded Corners 34">
             <a:extLst>
               <a:ext uri="{FF2B5EF4-FFF2-40B4-BE49-F238E27FC236}">
-                <a16:creationId xmlns:a16="http://schemas.microsoft.com/office/drawing/2014/main" id="{6D1F36FB-33B6-9154-0E85-F8E557906840}"/>
+                <a16:creationId xmlns:a16="http://schemas.microsoft.com/office/drawing/2014/main" id="{E54DBB00-57FE-8B40-8685-FEDB7B373605}"/>
               </a:ext>
             </a:extLst>
           </p:cNvPr>
@@ -10837,7 +10837,7 @@
           <p:cNvPr id="36" name="TextBox 35">
             <a:extLst>
               <a:ext uri="{FF2B5EF4-FFF2-40B4-BE49-F238E27FC236}">
-                <a16:creationId xmlns:a16="http://schemas.microsoft.com/office/drawing/2014/main" id="{7BB96F44-6997-96E3-E48C-DFC54D35AD44}"/>
+                <a16:creationId xmlns:a16="http://schemas.microsoft.com/office/drawing/2014/main" id="{CAA09D46-A711-B9BD-0EDD-3EA1812FFDE4}"/>
               </a:ext>
             </a:extLst>
           </p:cNvPr>
@@ -10928,7 +10928,7 @@
           <p:cNvPr id="38" name="Picture 37">
             <a:extLst>
               <a:ext uri="{FF2B5EF4-FFF2-40B4-BE49-F238E27FC236}">
-                <a16:creationId xmlns:a16="http://schemas.microsoft.com/office/drawing/2014/main" id="{E6B1CB21-5A86-192F-8221-237BBFDA3059}"/>
+                <a16:creationId xmlns:a16="http://schemas.microsoft.com/office/drawing/2014/main" id="{BC511F99-B506-9042-F0D2-C0B698A5A7B3}"/>
               </a:ext>
             </a:extLst>
           </p:cNvPr>
@@ -10963,7 +10963,7 @@
           <p:cNvPr id="39" name="TextBox 38">
             <a:extLst>
               <a:ext uri="{FF2B5EF4-FFF2-40B4-BE49-F238E27FC236}">
-                <a16:creationId xmlns:a16="http://schemas.microsoft.com/office/drawing/2014/main" id="{07E2FA53-3F0B-106F-8EE8-0BEF8873547C}"/>
+                <a16:creationId xmlns:a16="http://schemas.microsoft.com/office/drawing/2014/main" id="{A8B55D54-E672-6B7F-3559-9F1ED41C7F0A}"/>
               </a:ext>
             </a:extLst>
           </p:cNvPr>
@@ -11017,7 +11017,7 @@
           <p:cNvPr id="40" name="TextBox 39">
             <a:extLst>
               <a:ext uri="{FF2B5EF4-FFF2-40B4-BE49-F238E27FC236}">
-                <a16:creationId xmlns:a16="http://schemas.microsoft.com/office/drawing/2014/main" id="{A50532A4-0B2A-0A17-5D00-B4D9628E501B}"/>
+                <a16:creationId xmlns:a16="http://schemas.microsoft.com/office/drawing/2014/main" id="{ECA1D5DC-D8D0-947F-E1E7-4BA1EE8634F0}"/>
               </a:ext>
             </a:extLst>
           </p:cNvPr>
@@ -11065,7 +11065,7 @@
           <p:cNvPr id="41" name="Rectangle: Rounded Corners 40">
             <a:extLst>
               <a:ext uri="{FF2B5EF4-FFF2-40B4-BE49-F238E27FC236}">
-                <a16:creationId xmlns:a16="http://schemas.microsoft.com/office/drawing/2014/main" id="{AE0DA124-BFF5-2AF2-083F-66805788DBBF}"/>
+                <a16:creationId xmlns:a16="http://schemas.microsoft.com/office/drawing/2014/main" id="{4C6C2C81-403B-40C4-E1D6-E34A011DD1C2}"/>
               </a:ext>
             </a:extLst>
           </p:cNvPr>
@@ -11158,7 +11158,7 @@
           <p:cNvPr id="42" name="TextBox 41">
             <a:extLst>
               <a:ext uri="{FF2B5EF4-FFF2-40B4-BE49-F238E27FC236}">
-                <a16:creationId xmlns:a16="http://schemas.microsoft.com/office/drawing/2014/main" id="{B6BEC77B-4FF7-7995-8BA3-87E7642CA39C}"/>
+                <a16:creationId xmlns:a16="http://schemas.microsoft.com/office/drawing/2014/main" id="{E33A0892-0AEA-2A43-C8F4-1AD557C47CF4}"/>
               </a:ext>
             </a:extLst>
           </p:cNvPr>
@@ -11196,7 +11196,7 @@
                 </a:solidFill>
                 <a:latin typeface="Arial" panose="020B0604020202020204" pitchFamily="34" charset="0"/>
               </a:rPr>
-              <a:t>Reference implementation: record core, verifier, colour engine, NDDK protocol, sync server, search</a:t>
+              <a:t>Reference implementation + one-command demo, 47 tests: github.com/Harshith029/fieldtest-recorder</a:t>
             </a:r>
             <a:endParaRPr lang="en-IN" sz="950">
               <a:solidFill>
@@ -11212,7 +11212,7 @@
           <p:cNvPr id="43" name="Rectangle: Rounded Corners 42">
             <a:extLst>
               <a:ext uri="{FF2B5EF4-FFF2-40B4-BE49-F238E27FC236}">
-                <a16:creationId xmlns:a16="http://schemas.microsoft.com/office/drawing/2014/main" id="{8925D016-8496-F5B2-9E9E-EB7AF702B570}"/>
+                <a16:creationId xmlns:a16="http://schemas.microsoft.com/office/drawing/2014/main" id="{52B3CC9D-B849-DC96-BD6A-A0A1BE903304}"/>
               </a:ext>
             </a:extLst>
           </p:cNvPr>
@@ -11305,7 +11305,7 @@
           <p:cNvPr id="44" name="TextBox 43">
             <a:extLst>
               <a:ext uri="{FF2B5EF4-FFF2-40B4-BE49-F238E27FC236}">
-                <a16:creationId xmlns:a16="http://schemas.microsoft.com/office/drawing/2014/main" id="{40F7EF53-D61D-2BEE-D563-A23AB558D9FB}"/>
+                <a16:creationId xmlns:a16="http://schemas.microsoft.com/office/drawing/2014/main" id="{1B3F819E-85A4-44A4-5C60-D9926E028C28}"/>
               </a:ext>
             </a:extLst>
           </p:cNvPr>
@@ -11359,7 +11359,7 @@
           <p:cNvPr id="45" name="Rectangle: Rounded Corners 44">
             <a:extLst>
               <a:ext uri="{FF2B5EF4-FFF2-40B4-BE49-F238E27FC236}">
-                <a16:creationId xmlns:a16="http://schemas.microsoft.com/office/drawing/2014/main" id="{CCCEC99D-3624-C2B8-3FC6-8CC559C0A4A1}"/>
+                <a16:creationId xmlns:a16="http://schemas.microsoft.com/office/drawing/2014/main" id="{77C8A9AF-0EF6-E71D-315B-ADF02B81F763}"/>
               </a:ext>
             </a:extLst>
           </p:cNvPr>
@@ -11452,7 +11452,7 @@
           <p:cNvPr id="46" name="TextBox 45">
             <a:extLst>
               <a:ext uri="{FF2B5EF4-FFF2-40B4-BE49-F238E27FC236}">
-                <a16:creationId xmlns:a16="http://schemas.microsoft.com/office/drawing/2014/main" id="{20087901-6D87-2953-91B8-838B135F21EA}"/>
+                <a16:creationId xmlns:a16="http://schemas.microsoft.com/office/drawing/2014/main" id="{71145CA6-0F7D-14D9-42E7-38668F84D8FF}"/>
               </a:ext>
             </a:extLst>
           </p:cNvPr>
@@ -11882,7 +11882,7 @@
           <p:cNvPr id="2" name="Rectangle: Rounded Corners 1">
             <a:extLst>
               <a:ext uri="{FF2B5EF4-FFF2-40B4-BE49-F238E27FC236}">
-                <a16:creationId xmlns:a16="http://schemas.microsoft.com/office/drawing/2014/main" id="{C2644B15-B59E-0F84-6A3E-CC885AC7C292}"/>
+                <a16:creationId xmlns:a16="http://schemas.microsoft.com/office/drawing/2014/main" id="{DC9513D2-F87F-4E79-453B-D3BA96302430}"/>
               </a:ext>
             </a:extLst>
           </p:cNvPr>
@@ -11960,7 +11960,7 @@
           <p:cNvPr id="3" name="TextBox 2">
             <a:extLst>
               <a:ext uri="{FF2B5EF4-FFF2-40B4-BE49-F238E27FC236}">
-                <a16:creationId xmlns:a16="http://schemas.microsoft.com/office/drawing/2014/main" id="{819E3181-9DA0-4506-1D35-378E6C89AC47}"/>
+                <a16:creationId xmlns:a16="http://schemas.microsoft.com/office/drawing/2014/main" id="{A3C7CFAF-7D9E-F6FD-E454-E44AB2CE14DB}"/>
               </a:ext>
             </a:extLst>
           </p:cNvPr>
@@ -12008,7 +12008,7 @@
           <p:cNvPr id="4" name="TextBox 3">
             <a:extLst>
               <a:ext uri="{FF2B5EF4-FFF2-40B4-BE49-F238E27FC236}">
-                <a16:creationId xmlns:a16="http://schemas.microsoft.com/office/drawing/2014/main" id="{F3CF8780-C0A1-7F3A-D4D7-2D1FBC97FD64}"/>
+                <a16:creationId xmlns:a16="http://schemas.microsoft.com/office/drawing/2014/main" id="{39C3DE08-440D-092E-1F9E-BB8F29FC62C6}"/>
               </a:ext>
             </a:extLst>
           </p:cNvPr>
@@ -12062,7 +12062,7 @@
           <p:cNvPr id="5" name="Rectangle: Rounded Corners 4">
             <a:extLst>
               <a:ext uri="{FF2B5EF4-FFF2-40B4-BE49-F238E27FC236}">
-                <a16:creationId xmlns:a16="http://schemas.microsoft.com/office/drawing/2014/main" id="{08027493-4DA1-FAF5-EA17-CE9CBEBE07DA}"/>
+                <a16:creationId xmlns:a16="http://schemas.microsoft.com/office/drawing/2014/main" id="{0532422C-9537-B3ED-5661-5FF50D0A3EA7}"/>
               </a:ext>
             </a:extLst>
           </p:cNvPr>
@@ -12155,7 +12155,7 @@
           <p:cNvPr id="8" name="Rectangle: Rounded Corners 7">
             <a:extLst>
               <a:ext uri="{FF2B5EF4-FFF2-40B4-BE49-F238E27FC236}">
-                <a16:creationId xmlns:a16="http://schemas.microsoft.com/office/drawing/2014/main" id="{25C1CEAE-9F49-24E0-C0E2-CF4E1435B0E5}"/>
+                <a16:creationId xmlns:a16="http://schemas.microsoft.com/office/drawing/2014/main" id="{AAB7A9D4-0E10-EFEF-5DCE-30B818525B76}"/>
               </a:ext>
             </a:extLst>
           </p:cNvPr>
@@ -12233,7 +12233,7 @@
           <p:cNvPr id="9" name="TextBox 8">
             <a:extLst>
               <a:ext uri="{FF2B5EF4-FFF2-40B4-BE49-F238E27FC236}">
-                <a16:creationId xmlns:a16="http://schemas.microsoft.com/office/drawing/2014/main" id="{10A3D510-343E-81D9-0861-023AAFF7B637}"/>
+                <a16:creationId xmlns:a16="http://schemas.microsoft.com/office/drawing/2014/main" id="{2941F4E2-3040-5241-D9B4-724ABA0EDAD2}"/>
               </a:ext>
             </a:extLst>
           </p:cNvPr>
@@ -12281,7 +12281,7 @@
           <p:cNvPr id="13" name="TextBox 12">
             <a:extLst>
               <a:ext uri="{FF2B5EF4-FFF2-40B4-BE49-F238E27FC236}">
-                <a16:creationId xmlns:a16="http://schemas.microsoft.com/office/drawing/2014/main" id="{FFAFB5B6-71B0-BED1-729F-750300F539AC}"/>
+                <a16:creationId xmlns:a16="http://schemas.microsoft.com/office/drawing/2014/main" id="{B899C054-E921-0738-B2E4-4B7139563381}"/>
               </a:ext>
             </a:extLst>
           </p:cNvPr>
@@ -12335,7 +12335,7 @@
           <p:cNvPr id="14" name="Rectangle: Rounded Corners 13">
             <a:extLst>
               <a:ext uri="{FF2B5EF4-FFF2-40B4-BE49-F238E27FC236}">
-                <a16:creationId xmlns:a16="http://schemas.microsoft.com/office/drawing/2014/main" id="{7776E337-92DD-0699-E18D-D9E95EE80C82}"/>
+                <a16:creationId xmlns:a16="http://schemas.microsoft.com/office/drawing/2014/main" id="{E74EAE8A-DD1F-CE10-B458-F36786DC83D4}"/>
               </a:ext>
             </a:extLst>
           </p:cNvPr>
@@ -12428,7 +12428,7 @@
           <p:cNvPr id="15" name="Rectangle: Rounded Corners 14">
             <a:extLst>
               <a:ext uri="{FF2B5EF4-FFF2-40B4-BE49-F238E27FC236}">
-                <a16:creationId xmlns:a16="http://schemas.microsoft.com/office/drawing/2014/main" id="{91B371D3-44C9-B8A5-5306-7D6935DDB856}"/>
+                <a16:creationId xmlns:a16="http://schemas.microsoft.com/office/drawing/2014/main" id="{B06BF98B-6CB5-270B-A28B-81E9CF1769AC}"/>
               </a:ext>
             </a:extLst>
           </p:cNvPr>
@@ -12506,7 +12506,7 @@
           <p:cNvPr id="16" name="TextBox 15">
             <a:extLst>
               <a:ext uri="{FF2B5EF4-FFF2-40B4-BE49-F238E27FC236}">
-                <a16:creationId xmlns:a16="http://schemas.microsoft.com/office/drawing/2014/main" id="{7E131001-DD7B-B5CB-F2EF-2A069CCBFE18}"/>
+                <a16:creationId xmlns:a16="http://schemas.microsoft.com/office/drawing/2014/main" id="{838C9BC6-9172-E98D-3141-0003DAF52C2E}"/>
               </a:ext>
             </a:extLst>
           </p:cNvPr>
@@ -12554,7 +12554,7 @@
           <p:cNvPr id="17" name="TextBox 16">
             <a:extLst>
               <a:ext uri="{FF2B5EF4-FFF2-40B4-BE49-F238E27FC236}">
-                <a16:creationId xmlns:a16="http://schemas.microsoft.com/office/drawing/2014/main" id="{3F05513A-3A09-8423-62EE-E378AABAF5D8}"/>
+                <a16:creationId xmlns:a16="http://schemas.microsoft.com/office/drawing/2014/main" id="{4F5D1CAB-2F9D-7763-2326-5F4C75085894}"/>
               </a:ext>
             </a:extLst>
           </p:cNvPr>
@@ -12608,7 +12608,7 @@
           <p:cNvPr id="18" name="Rectangle: Rounded Corners 17">
             <a:extLst>
               <a:ext uri="{FF2B5EF4-FFF2-40B4-BE49-F238E27FC236}">
-                <a16:creationId xmlns:a16="http://schemas.microsoft.com/office/drawing/2014/main" id="{DDB10EB8-0F8B-4F1D-31C7-1E3733935486}"/>
+                <a16:creationId xmlns:a16="http://schemas.microsoft.com/office/drawing/2014/main" id="{24E88AF3-ED19-23F5-3721-7D06D2D10CA1}"/>
               </a:ext>
             </a:extLst>
           </p:cNvPr>
@@ -12701,7 +12701,7 @@
           <p:cNvPr id="19" name="Rectangle: Rounded Corners 18">
             <a:extLst>
               <a:ext uri="{FF2B5EF4-FFF2-40B4-BE49-F238E27FC236}">
-                <a16:creationId xmlns:a16="http://schemas.microsoft.com/office/drawing/2014/main" id="{4A08FF76-1E09-DCB6-7BC5-20D39411A89E}"/>
+                <a16:creationId xmlns:a16="http://schemas.microsoft.com/office/drawing/2014/main" id="{66AFAF75-11B7-0768-623D-ACFCDE24FDB4}"/>
               </a:ext>
             </a:extLst>
           </p:cNvPr>
@@ -12779,7 +12779,7 @@
           <p:cNvPr id="20" name="TextBox 19">
             <a:extLst>
               <a:ext uri="{FF2B5EF4-FFF2-40B4-BE49-F238E27FC236}">
-                <a16:creationId xmlns:a16="http://schemas.microsoft.com/office/drawing/2014/main" id="{69485392-D423-D7C5-FCD4-C30BFB0F8E93}"/>
+                <a16:creationId xmlns:a16="http://schemas.microsoft.com/office/drawing/2014/main" id="{FE23A8A7-CCE0-0D53-1883-6CF239E91BBB}"/>
               </a:ext>
             </a:extLst>
           </p:cNvPr>
@@ -12827,7 +12827,7 @@
           <p:cNvPr id="21" name="TextBox 20">
             <a:extLst>
               <a:ext uri="{FF2B5EF4-FFF2-40B4-BE49-F238E27FC236}">
-                <a16:creationId xmlns:a16="http://schemas.microsoft.com/office/drawing/2014/main" id="{B558D3DE-9E95-3730-F7A3-63035D159789}"/>
+                <a16:creationId xmlns:a16="http://schemas.microsoft.com/office/drawing/2014/main" id="{189EA790-F8AA-4103-B891-A25F832D8E3C}"/>
               </a:ext>
             </a:extLst>
           </p:cNvPr>
@@ -12881,7 +12881,7 @@
           <p:cNvPr id="22" name="Rectangle: Rounded Corners 21">
             <a:extLst>
               <a:ext uri="{FF2B5EF4-FFF2-40B4-BE49-F238E27FC236}">
-                <a16:creationId xmlns:a16="http://schemas.microsoft.com/office/drawing/2014/main" id="{02B76BEE-D320-2AC8-A704-9117F78F51F5}"/>
+                <a16:creationId xmlns:a16="http://schemas.microsoft.com/office/drawing/2014/main" id="{9F5EA29A-8C0E-2485-188C-754D54C3DB07}"/>
               </a:ext>
             </a:extLst>
           </p:cNvPr>
@@ -12974,7 +12974,7 @@
           <p:cNvPr id="23" name="TextBox 22">
             <a:extLst>
               <a:ext uri="{FF2B5EF4-FFF2-40B4-BE49-F238E27FC236}">
-                <a16:creationId xmlns:a16="http://schemas.microsoft.com/office/drawing/2014/main" id="{F9F33B19-3FD9-9551-B02D-88F85942BB8B}"/>
+                <a16:creationId xmlns:a16="http://schemas.microsoft.com/office/drawing/2014/main" id="{0007E118-9EFA-C4C2-CBA7-066A137141CE}"/>
               </a:ext>
             </a:extLst>
           </p:cNvPr>
@@ -13028,7 +13028,7 @@
           <p:cNvPr id="24" name="Table 23">
             <a:extLst>
               <a:ext uri="{FF2B5EF4-FFF2-40B4-BE49-F238E27FC236}">
-                <a16:creationId xmlns:a16="http://schemas.microsoft.com/office/drawing/2014/main" id="{8CC4BA4E-F2C1-4D4D-D92F-58F289054A14}"/>
+                <a16:creationId xmlns:a16="http://schemas.microsoft.com/office/drawing/2014/main" id="{56399D97-A7FD-59A3-E44B-56E821AA52A0}"/>
               </a:ext>
             </a:extLst>
           </p:cNvPr>
@@ -13038,7 +13038,7 @@
           <p:nvPr>
             <p:extLst>
               <p:ext uri="{D42A27DB-BD31-4B8C-83A1-F6EECF244321}">
-                <p14:modId xmlns:p14="http://schemas.microsoft.com/office/powerpoint/2010/main" val="2340197700"/>
+                <p14:modId xmlns:p14="http://schemas.microsoft.com/office/powerpoint/2010/main" val="2249987201"/>
               </p:ext>
             </p:extLst>
           </p:nvPr>
@@ -13057,14 +13057,14 @@
                 <a:gridCol w="2540000">
                   <a:extLst>
                     <a:ext uri="{9D8B030D-6E8A-4147-A177-3AD203B41FA5}">
-                      <a16:colId xmlns:a16="http://schemas.microsoft.com/office/drawing/2014/main" val="1629399582"/>
+                      <a16:colId xmlns:a16="http://schemas.microsoft.com/office/drawing/2014/main" val="3749151646"/>
                     </a:ext>
                   </a:extLst>
                 </a:gridCol>
                 <a:gridCol w="5080000">
                   <a:extLst>
                     <a:ext uri="{9D8B030D-6E8A-4147-A177-3AD203B41FA5}">
-                      <a16:colId xmlns:a16="http://schemas.microsoft.com/office/drawing/2014/main" val="297146814"/>
+                      <a16:colId xmlns:a16="http://schemas.microsoft.com/office/drawing/2014/main" val="1568917766"/>
                     </a:ext>
                   </a:extLst>
                 </a:gridCol>
@@ -13142,7 +13142,7 @@
                 </a:tc>
                 <a:extLst>
                   <a:ext uri="{0D108BD9-81ED-4DB2-BD59-A6C34878D82A}">
-                    <a16:rowId xmlns:a16="http://schemas.microsoft.com/office/drawing/2014/main" val="2006421993"/>
+                    <a16:rowId xmlns:a16="http://schemas.microsoft.com/office/drawing/2014/main" val="1095139157"/>
                   </a:ext>
                 </a:extLst>
               </a:tr>
@@ -13231,7 +13231,7 @@
                 </a:tc>
                 <a:extLst>
                   <a:ext uri="{0D108BD9-81ED-4DB2-BD59-A6C34878D82A}">
-                    <a16:rowId xmlns:a16="http://schemas.microsoft.com/office/drawing/2014/main" val="739628789"/>
+                    <a16:rowId xmlns:a16="http://schemas.microsoft.com/office/drawing/2014/main" val="2535956663"/>
                   </a:ext>
                 </a:extLst>
               </a:tr>
@@ -13320,7 +13320,7 @@
                 </a:tc>
                 <a:extLst>
                   <a:ext uri="{0D108BD9-81ED-4DB2-BD59-A6C34878D82A}">
-                    <a16:rowId xmlns:a16="http://schemas.microsoft.com/office/drawing/2014/main" val="3851607958"/>
+                    <a16:rowId xmlns:a16="http://schemas.microsoft.com/office/drawing/2014/main" val="527615016"/>
                   </a:ext>
                 </a:extLst>
               </a:tr>
@@ -13403,7 +13403,7 @@
                 </a:tc>
                 <a:extLst>
                   <a:ext uri="{0D108BD9-81ED-4DB2-BD59-A6C34878D82A}">
-                    <a16:rowId xmlns:a16="http://schemas.microsoft.com/office/drawing/2014/main" val="4181671967"/>
+                    <a16:rowId xmlns:a16="http://schemas.microsoft.com/office/drawing/2014/main" val="1775379985"/>
                   </a:ext>
                 </a:extLst>
               </a:tr>
@@ -13492,7 +13492,7 @@
                 </a:tc>
                 <a:extLst>
                   <a:ext uri="{0D108BD9-81ED-4DB2-BD59-A6C34878D82A}">
-                    <a16:rowId xmlns:a16="http://schemas.microsoft.com/office/drawing/2014/main" val="1356606371"/>
+                    <a16:rowId xmlns:a16="http://schemas.microsoft.com/office/drawing/2014/main" val="672183112"/>
                   </a:ext>
                 </a:extLst>
               </a:tr>
@@ -13581,7 +13581,7 @@
                 </a:tc>
                 <a:extLst>
                   <a:ext uri="{0D108BD9-81ED-4DB2-BD59-A6C34878D82A}">
-                    <a16:rowId xmlns:a16="http://schemas.microsoft.com/office/drawing/2014/main" val="444907854"/>
+                    <a16:rowId xmlns:a16="http://schemas.microsoft.com/office/drawing/2014/main" val="2273122606"/>
                   </a:ext>
                 </a:extLst>
               </a:tr>
@@ -13594,7 +13594,7 @@
           <p:cNvPr id="25" name="Rectangle: Rounded Corners 24">
             <a:extLst>
               <a:ext uri="{FF2B5EF4-FFF2-40B4-BE49-F238E27FC236}">
-                <a16:creationId xmlns:a16="http://schemas.microsoft.com/office/drawing/2014/main" id="{3AC26958-DB05-43DC-FBA3-B242F87B56DA}"/>
+                <a16:creationId xmlns:a16="http://schemas.microsoft.com/office/drawing/2014/main" id="{452BC779-07F5-2312-9815-B66F28FE44C8}"/>
               </a:ext>
             </a:extLst>
           </p:cNvPr>
@@ -13672,7 +13672,7 @@
           <p:cNvPr id="26" name="TextBox 25">
             <a:extLst>
               <a:ext uri="{FF2B5EF4-FFF2-40B4-BE49-F238E27FC236}">
-                <a16:creationId xmlns:a16="http://schemas.microsoft.com/office/drawing/2014/main" id="{D1F30ECA-CD81-7010-2A83-D21C9525BBAD}"/>
+                <a16:creationId xmlns:a16="http://schemas.microsoft.com/office/drawing/2014/main" id="{D65220DD-0814-F6E3-0851-B33A1B89F67D}"/>
               </a:ext>
             </a:extLst>
           </p:cNvPr>
@@ -13720,7 +13720,7 @@
           <p:cNvPr id="27" name="TextBox 26">
             <a:extLst>
               <a:ext uri="{FF2B5EF4-FFF2-40B4-BE49-F238E27FC236}">
-                <a16:creationId xmlns:a16="http://schemas.microsoft.com/office/drawing/2014/main" id="{AD222290-27E0-313A-E9B4-EAAB59C1A808}"/>
+                <a16:creationId xmlns:a16="http://schemas.microsoft.com/office/drawing/2014/main" id="{AF4AA334-CD0A-A3FF-F6C5-6CD18C89F09A}"/>
               </a:ext>
             </a:extLst>
           </p:cNvPr>
@@ -14301,7 +14301,7 @@
           <p:cNvPr id="2" name="TextBox 1">
             <a:extLst>
               <a:ext uri="{FF2B5EF4-FFF2-40B4-BE49-F238E27FC236}">
-                <a16:creationId xmlns:a16="http://schemas.microsoft.com/office/drawing/2014/main" id="{56697C00-2074-A499-3D03-45D1E57E2C6B}"/>
+                <a16:creationId xmlns:a16="http://schemas.microsoft.com/office/drawing/2014/main" id="{8CC15AF6-07D9-8BF5-AF32-C1E05D39E25D}"/>
               </a:ext>
             </a:extLst>
           </p:cNvPr>
@@ -14349,7 +14349,7 @@
           <p:cNvPr id="3" name="Oval 2">
             <a:extLst>
               <a:ext uri="{FF2B5EF4-FFF2-40B4-BE49-F238E27FC236}">
-                <a16:creationId xmlns:a16="http://schemas.microsoft.com/office/drawing/2014/main" id="{5B5DB50A-072F-4404-0FD3-2D188F605096}"/>
+                <a16:creationId xmlns:a16="http://schemas.microsoft.com/office/drawing/2014/main" id="{F5E7CFCA-B723-B315-A198-169CC6B6CE31}"/>
               </a:ext>
             </a:extLst>
           </p:cNvPr>
@@ -14440,7 +14440,7 @@
           <p:cNvPr id="4" name="TextBox 3">
             <a:extLst>
               <a:ext uri="{FF2B5EF4-FFF2-40B4-BE49-F238E27FC236}">
-                <a16:creationId xmlns:a16="http://schemas.microsoft.com/office/drawing/2014/main" id="{D431704D-5775-2EF3-4865-15894D9F537B}"/>
+                <a16:creationId xmlns:a16="http://schemas.microsoft.com/office/drawing/2014/main" id="{F13868C2-F1DD-6DA5-C854-8A09D98F4B73}"/>
               </a:ext>
             </a:extLst>
           </p:cNvPr>
@@ -14513,7 +14513,7 @@
           <p:cNvPr id="5" name="Oval 4">
             <a:extLst>
               <a:ext uri="{FF2B5EF4-FFF2-40B4-BE49-F238E27FC236}">
-                <a16:creationId xmlns:a16="http://schemas.microsoft.com/office/drawing/2014/main" id="{053270EE-B343-60E9-5E4D-2B33A43A9B21}"/>
+                <a16:creationId xmlns:a16="http://schemas.microsoft.com/office/drawing/2014/main" id="{8002A58A-8F67-2C29-1885-027E823BD396}"/>
               </a:ext>
             </a:extLst>
           </p:cNvPr>
@@ -14604,7 +14604,7 @@
           <p:cNvPr id="8" name="TextBox 7">
             <a:extLst>
               <a:ext uri="{FF2B5EF4-FFF2-40B4-BE49-F238E27FC236}">
-                <a16:creationId xmlns:a16="http://schemas.microsoft.com/office/drawing/2014/main" id="{7416B4B2-CC0D-E3DF-526B-FB3946D472AC}"/>
+                <a16:creationId xmlns:a16="http://schemas.microsoft.com/office/drawing/2014/main" id="{3AC3740F-B513-F117-CE35-A87838A7A304}"/>
               </a:ext>
             </a:extLst>
           </p:cNvPr>
@@ -14677,7 +14677,7 @@
           <p:cNvPr id="9" name="Oval 8">
             <a:extLst>
               <a:ext uri="{FF2B5EF4-FFF2-40B4-BE49-F238E27FC236}">
-                <a16:creationId xmlns:a16="http://schemas.microsoft.com/office/drawing/2014/main" id="{992B9E7C-4780-5B50-1AEC-327188826061}"/>
+                <a16:creationId xmlns:a16="http://schemas.microsoft.com/office/drawing/2014/main" id="{892B478F-AC5D-811F-C374-97BFBAD2B270}"/>
               </a:ext>
             </a:extLst>
           </p:cNvPr>
@@ -14768,7 +14768,7 @@
           <p:cNvPr id="13" name="TextBox 12">
             <a:extLst>
               <a:ext uri="{FF2B5EF4-FFF2-40B4-BE49-F238E27FC236}">
-                <a16:creationId xmlns:a16="http://schemas.microsoft.com/office/drawing/2014/main" id="{F7895F4E-9AF9-FFDC-4207-094AA670B03E}"/>
+                <a16:creationId xmlns:a16="http://schemas.microsoft.com/office/drawing/2014/main" id="{91FD7D3A-C16B-EBBE-81EE-CDEE3333D60E}"/>
               </a:ext>
             </a:extLst>
           </p:cNvPr>
@@ -14841,7 +14841,7 @@
           <p:cNvPr id="14" name="Oval 13">
             <a:extLst>
               <a:ext uri="{FF2B5EF4-FFF2-40B4-BE49-F238E27FC236}">
-                <a16:creationId xmlns:a16="http://schemas.microsoft.com/office/drawing/2014/main" id="{A2684DE7-13B0-FAA9-3C18-452F79BD7A1A}"/>
+                <a16:creationId xmlns:a16="http://schemas.microsoft.com/office/drawing/2014/main" id="{1874BDB2-634D-44D5-E43D-1E50E9F95A55}"/>
               </a:ext>
             </a:extLst>
           </p:cNvPr>
@@ -14932,7 +14932,7 @@
           <p:cNvPr id="15" name="TextBox 14">
             <a:extLst>
               <a:ext uri="{FF2B5EF4-FFF2-40B4-BE49-F238E27FC236}">
-                <a16:creationId xmlns:a16="http://schemas.microsoft.com/office/drawing/2014/main" id="{9DEED57D-8145-9D96-D1C8-7ABA1B978EEB}"/>
+                <a16:creationId xmlns:a16="http://schemas.microsoft.com/office/drawing/2014/main" id="{F1E9EDEB-8CF3-18F5-DA3E-C604A8AACFEF}"/>
               </a:ext>
             </a:extLst>
           </p:cNvPr>
@@ -15005,7 +15005,7 @@
           <p:cNvPr id="16" name="TextBox 15">
             <a:extLst>
               <a:ext uri="{FF2B5EF4-FFF2-40B4-BE49-F238E27FC236}">
-                <a16:creationId xmlns:a16="http://schemas.microsoft.com/office/drawing/2014/main" id="{78DA707D-B223-F691-3B6A-18A4C59A0E25}"/>
+                <a16:creationId xmlns:a16="http://schemas.microsoft.com/office/drawing/2014/main" id="{5F9E63B6-774E-47D9-7343-F04DF9623F6B}"/>
               </a:ext>
             </a:extLst>
           </p:cNvPr>
@@ -15059,7 +15059,7 @@
           <p:cNvPr id="17" name="Table 16">
             <a:extLst>
               <a:ext uri="{FF2B5EF4-FFF2-40B4-BE49-F238E27FC236}">
-                <a16:creationId xmlns:a16="http://schemas.microsoft.com/office/drawing/2014/main" id="{11F073AC-9D1D-73E5-55B0-EA3AE3EF1EF8}"/>
+                <a16:creationId xmlns:a16="http://schemas.microsoft.com/office/drawing/2014/main" id="{4C23CD73-7C43-EDA3-0BFA-916434918C28}"/>
               </a:ext>
             </a:extLst>
           </p:cNvPr>
@@ -15069,7 +15069,7 @@
           <p:nvPr>
             <p:extLst>
               <p:ext uri="{D42A27DB-BD31-4B8C-83A1-F6EECF244321}">
-                <p14:modId xmlns:p14="http://schemas.microsoft.com/office/powerpoint/2010/main" val="1604192591"/>
+                <p14:modId xmlns:p14="http://schemas.microsoft.com/office/powerpoint/2010/main" val="3929097878"/>
               </p:ext>
             </p:extLst>
           </p:nvPr>
@@ -15088,14 +15088,14 @@
                 <a:gridCol w="2667000">
                   <a:extLst>
                     <a:ext uri="{9D8B030D-6E8A-4147-A177-3AD203B41FA5}">
-                      <a16:colId xmlns:a16="http://schemas.microsoft.com/office/drawing/2014/main" val="273352361"/>
+                      <a16:colId xmlns:a16="http://schemas.microsoft.com/office/drawing/2014/main" val="3881344347"/>
                     </a:ext>
                   </a:extLst>
                 </a:gridCol>
                 <a:gridCol w="3403600">
                   <a:extLst>
                     <a:ext uri="{9D8B030D-6E8A-4147-A177-3AD203B41FA5}">
-                      <a16:colId xmlns:a16="http://schemas.microsoft.com/office/drawing/2014/main" val="2747444429"/>
+                      <a16:colId xmlns:a16="http://schemas.microsoft.com/office/drawing/2014/main" val="490029604"/>
                     </a:ext>
                   </a:extLst>
                 </a:gridCol>
@@ -15173,7 +15173,7 @@
                 </a:tc>
                 <a:extLst>
                   <a:ext uri="{0D108BD9-81ED-4DB2-BD59-A6C34878D82A}">
-                    <a16:rowId xmlns:a16="http://schemas.microsoft.com/office/drawing/2014/main" val="1539213570"/>
+                    <a16:rowId xmlns:a16="http://schemas.microsoft.com/office/drawing/2014/main" val="2250091493"/>
                   </a:ext>
                 </a:extLst>
               </a:tr>
@@ -15256,7 +15256,7 @@
                 </a:tc>
                 <a:extLst>
                   <a:ext uri="{0D108BD9-81ED-4DB2-BD59-A6C34878D82A}">
-                    <a16:rowId xmlns:a16="http://schemas.microsoft.com/office/drawing/2014/main" val="2171240035"/>
+                    <a16:rowId xmlns:a16="http://schemas.microsoft.com/office/drawing/2014/main" val="3070574747"/>
                   </a:ext>
                 </a:extLst>
               </a:tr>
@@ -15345,7 +15345,7 @@
                 </a:tc>
                 <a:extLst>
                   <a:ext uri="{0D108BD9-81ED-4DB2-BD59-A6C34878D82A}">
-                    <a16:rowId xmlns:a16="http://schemas.microsoft.com/office/drawing/2014/main" val="1600220591"/>
+                    <a16:rowId xmlns:a16="http://schemas.microsoft.com/office/drawing/2014/main" val="565309203"/>
                   </a:ext>
                 </a:extLst>
               </a:tr>
@@ -15434,7 +15434,7 @@
                 </a:tc>
                 <a:extLst>
                   <a:ext uri="{0D108BD9-81ED-4DB2-BD59-A6C34878D82A}">
-                    <a16:rowId xmlns:a16="http://schemas.microsoft.com/office/drawing/2014/main" val="4206515632"/>
+                    <a16:rowId xmlns:a16="http://schemas.microsoft.com/office/drawing/2014/main" val="3110662868"/>
                   </a:ext>
                 </a:extLst>
               </a:tr>
@@ -15523,7 +15523,7 @@
                 </a:tc>
                 <a:extLst>
                   <a:ext uri="{0D108BD9-81ED-4DB2-BD59-A6C34878D82A}">
-                    <a16:rowId xmlns:a16="http://schemas.microsoft.com/office/drawing/2014/main" val="2765405855"/>
+                    <a16:rowId xmlns:a16="http://schemas.microsoft.com/office/drawing/2014/main" val="3559228761"/>
                   </a:ext>
                 </a:extLst>
               </a:tr>
@@ -15606,7 +15606,7 @@
                 </a:tc>
                 <a:extLst>
                   <a:ext uri="{0D108BD9-81ED-4DB2-BD59-A6C34878D82A}">
-                    <a16:rowId xmlns:a16="http://schemas.microsoft.com/office/drawing/2014/main" val="4207361975"/>
+                    <a16:rowId xmlns:a16="http://schemas.microsoft.com/office/drawing/2014/main" val="3418768884"/>
                   </a:ext>
                 </a:extLst>
               </a:tr>
@@ -15689,7 +15689,7 @@
                 </a:tc>
                 <a:extLst>
                   <a:ext uri="{0D108BD9-81ED-4DB2-BD59-A6C34878D82A}">
-                    <a16:rowId xmlns:a16="http://schemas.microsoft.com/office/drawing/2014/main" val="3510026117"/>
+                    <a16:rowId xmlns:a16="http://schemas.microsoft.com/office/drawing/2014/main" val="3085835276"/>
                   </a:ext>
                 </a:extLst>
               </a:tr>
@@ -15702,7 +15702,7 @@
           <p:cNvPr id="18" name="Rectangle: Rounded Corners 17">
             <a:extLst>
               <a:ext uri="{FF2B5EF4-FFF2-40B4-BE49-F238E27FC236}">
-                <a16:creationId xmlns:a16="http://schemas.microsoft.com/office/drawing/2014/main" id="{DB55F631-8A7B-02E8-63AB-E9BBA2D276C5}"/>
+                <a16:creationId xmlns:a16="http://schemas.microsoft.com/office/drawing/2014/main" id="{CF5F0632-439A-5E9B-FA19-AC44C6AC5E69}"/>
               </a:ext>
             </a:extLst>
           </p:cNvPr>
@@ -15770,7 +15770,7 @@
           <p:cNvPr id="19" name="TextBox 18">
             <a:extLst>
               <a:ext uri="{FF2B5EF4-FFF2-40B4-BE49-F238E27FC236}">
-                <a16:creationId xmlns:a16="http://schemas.microsoft.com/office/drawing/2014/main" id="{7658F77C-424F-6034-665E-31C7C3F290DF}"/>
+                <a16:creationId xmlns:a16="http://schemas.microsoft.com/office/drawing/2014/main" id="{E944A1DE-27B6-A03D-9599-6AB249361E12}"/>
               </a:ext>
             </a:extLst>
           </p:cNvPr>
@@ -15852,7 +15852,7 @@
           <p:cNvPr id="20" name="Rectangle: Rounded Corners 19">
             <a:extLst>
               <a:ext uri="{FF2B5EF4-FFF2-40B4-BE49-F238E27FC236}">
-                <a16:creationId xmlns:a16="http://schemas.microsoft.com/office/drawing/2014/main" id="{6FCFC66C-48FC-0294-9F42-969DB1C21EA2}"/>
+                <a16:creationId xmlns:a16="http://schemas.microsoft.com/office/drawing/2014/main" id="{9A3F9B0F-9B72-B3E5-C6B1-D708FAE93BE7}"/>
               </a:ext>
             </a:extLst>
           </p:cNvPr>
@@ -15930,7 +15930,7 @@
           <p:cNvPr id="21" name="TextBox 20">
             <a:extLst>
               <a:ext uri="{FF2B5EF4-FFF2-40B4-BE49-F238E27FC236}">
-                <a16:creationId xmlns:a16="http://schemas.microsoft.com/office/drawing/2014/main" id="{00EA4CCA-EE61-8383-DD2E-F2734708FE91}"/>
+                <a16:creationId xmlns:a16="http://schemas.microsoft.com/office/drawing/2014/main" id="{788375B1-595E-AE6B-89D1-4F7D02429F49}"/>
               </a:ext>
             </a:extLst>
           </p:cNvPr>
@@ -16003,7 +16003,7 @@
           <p:cNvPr id="22" name="TextBox 21">
             <a:extLst>
               <a:ext uri="{FF2B5EF4-FFF2-40B4-BE49-F238E27FC236}">
-                <a16:creationId xmlns:a16="http://schemas.microsoft.com/office/drawing/2014/main" id="{4E57DC3B-DB10-5B63-3F8C-F0B433721155}"/>
+                <a16:creationId xmlns:a16="http://schemas.microsoft.com/office/drawing/2014/main" id="{30D91862-3D4C-27A6-7E99-3704E8EDC40F}"/>
               </a:ext>
             </a:extLst>
           </p:cNvPr>
@@ -16076,7 +16076,7 @@
           <p:cNvPr id="23" name="TextBox 22">
             <a:extLst>
               <a:ext uri="{FF2B5EF4-FFF2-40B4-BE49-F238E27FC236}">
-                <a16:creationId xmlns:a16="http://schemas.microsoft.com/office/drawing/2014/main" id="{04511953-4DA9-92C9-1321-134E9DAA532F}"/>
+                <a16:creationId xmlns:a16="http://schemas.microsoft.com/office/drawing/2014/main" id="{4A0A5F1A-9452-1B9A-16A4-BAC6DE7CD3A3}"/>
               </a:ext>
             </a:extLst>
           </p:cNvPr>
@@ -16149,7 +16149,7 @@
           <p:cNvPr id="24" name="TextBox 23">
             <a:extLst>
               <a:ext uri="{FF2B5EF4-FFF2-40B4-BE49-F238E27FC236}">
-                <a16:creationId xmlns:a16="http://schemas.microsoft.com/office/drawing/2014/main" id="{D9ACB80D-0AF0-1CA5-ECD8-A14DE5A68083}"/>
+                <a16:creationId xmlns:a16="http://schemas.microsoft.com/office/drawing/2014/main" id="{4DEF190C-399D-9CF6-02BE-90CF61E21A17}"/>
               </a:ext>
             </a:extLst>
           </p:cNvPr>
@@ -16603,7 +16603,7 @@
           <p:cNvPr id="2" name="TextBox 1">
             <a:extLst>
               <a:ext uri="{FF2B5EF4-FFF2-40B4-BE49-F238E27FC236}">
-                <a16:creationId xmlns:a16="http://schemas.microsoft.com/office/drawing/2014/main" id="{6242B68F-2AA8-B452-0BD7-9F8A81BC520A}"/>
+                <a16:creationId xmlns:a16="http://schemas.microsoft.com/office/drawing/2014/main" id="{6CBE8889-6335-9319-EBC0-1C2D5A5F7FB2}"/>
               </a:ext>
             </a:extLst>
           </p:cNvPr>
@@ -16860,7 +16860,7 @@
           <p:cNvPr id="3" name="TextBox 2">
             <a:extLst>
               <a:ext uri="{FF2B5EF4-FFF2-40B4-BE49-F238E27FC236}">
-                <a16:creationId xmlns:a16="http://schemas.microsoft.com/office/drawing/2014/main" id="{2341B68E-8052-C016-9644-12B3AB5896EA}"/>
+                <a16:creationId xmlns:a16="http://schemas.microsoft.com/office/drawing/2014/main" id="{6193301D-411E-09C7-D10C-0E02267046A3}"/>
               </a:ext>
             </a:extLst>
           </p:cNvPr>
@@ -17111,7 +17111,7 @@
           <p:cNvPr id="4" name="Rectangle: Rounded Corners 3">
             <a:extLst>
               <a:ext uri="{FF2B5EF4-FFF2-40B4-BE49-F238E27FC236}">
-                <a16:creationId xmlns:a16="http://schemas.microsoft.com/office/drawing/2014/main" id="{9EFA8056-27CA-45B4-8121-C6A3F15D2EAC}"/>
+                <a16:creationId xmlns:a16="http://schemas.microsoft.com/office/drawing/2014/main" id="{613CACFE-B64F-1190-27F3-9C13595E4295}"/>
               </a:ext>
             </a:extLst>
           </p:cNvPr>
@@ -17189,7 +17189,7 @@
           <p:cNvPr id="5" name="TextBox 4">
             <a:extLst>
               <a:ext uri="{FF2B5EF4-FFF2-40B4-BE49-F238E27FC236}">
-                <a16:creationId xmlns:a16="http://schemas.microsoft.com/office/drawing/2014/main" id="{5B8E6FDE-D022-B214-BFD9-07518FA6C819}"/>
+                <a16:creationId xmlns:a16="http://schemas.microsoft.com/office/drawing/2014/main" id="{7A984EAA-1790-6756-CB97-48CECBCD900A}"/>
               </a:ext>
             </a:extLst>
           </p:cNvPr>
@@ -17221,17 +17221,27 @@
               </a:spcAft>
             </a:pPr>
             <a:r>
-              <a:rPr lang="en-US" sz="1200" b="1">
+              <a:rPr lang="en-IN" sz="1200" b="1">
                 <a:solidFill>
                   <a:srgbClr val="1F3864"/>
                 </a:solidFill>
                 <a:latin typeface="Arial" panose="020B0604020202020204" pitchFamily="34" charset="0"/>
               </a:rPr>
-              <a:t>OUR OWN RESEARCH (AVAILABLE ON REQUEST)</a:t>
+              <a:t>OUR CODE AND RESEARCH: </a:t>
+            </a:r>
+            <a:r>
+              <a:rPr lang="en-IN" sz="1200" b="1">
+                <a:solidFill>
+                  <a:srgbClr val="0070C0"/>
+                </a:solidFill>
+                <a:latin typeface="Arial" panose="020B0604020202020204" pitchFamily="34" charset="0"/>
+                <a:hlinkClick r:id="rId4"/>
+              </a:rPr>
+              <a:t>github.com/Harshith029/fieldtest-recorder</a:t>
             </a:r>
             <a:endParaRPr lang="en-IN" sz="1200" b="1">
               <a:solidFill>
-                <a:srgbClr val="1F3864"/>
+                <a:srgbClr val="0070C0"/>
               </a:solidFill>
               <a:latin typeface="Arial" panose="020B0604020202020204" pitchFamily="34" charset="0"/>
             </a:endParaRPr>
@@ -17243,7 +17253,7 @@
           <p:cNvPr id="8" name="TextBox 7">
             <a:extLst>
               <a:ext uri="{FF2B5EF4-FFF2-40B4-BE49-F238E27FC236}">
-                <a16:creationId xmlns:a16="http://schemas.microsoft.com/office/drawing/2014/main" id="{78C1DAB2-8BCF-133F-E43D-F79026542F98}"/>
+                <a16:creationId xmlns:a16="http://schemas.microsoft.com/office/drawing/2014/main" id="{51D415C7-2C4D-1A24-BD53-720C27DD21A5}"/>
               </a:ext>
             </a:extLst>
           </p:cNvPr>
@@ -17280,13 +17290,13 @@
               <a:buChar char="•"/>
             </a:pPr>
             <a:r>
-              <a:rPr lang="en-IN" sz="1050" b="1">
+              <a:rPr lang="en-US" sz="1050" b="1">
                 <a:solidFill>
                   <a:srgbClr val="262626"/>
                 </a:solidFill>
                 <a:latin typeface="Arial" panose="020B0604020202020204" pitchFamily="34" charset="0"/>
               </a:rPr>
-              <a:t>Executable reference implementation </a:t>
+              <a:t>Working reference implementation with a one-command demo and 47 automated tests: </a:t>
             </a:r>
             <a:r>
               <a:rPr lang="en-US" sz="1050">
@@ -17295,7 +17305,7 @@
                 </a:solidFill>
                 <a:latin typeface="Arial" panose="020B0604020202020204" pitchFamily="34" charset="0"/>
               </a:rPr>
-              <a:t>of the record format, verifier, colour engine, NCB kit protocol, searchable log and sync server; the Android app must match its outputs byte for byte.</a:t>
+              <a:t>record format and offline verifier, colour engine, NCB kit protocol, searchable log, sync server. The Android app must match its outputs byte for byte.</a:t>
             </a:r>
           </a:p>
           <a:p>

</xml_diff>

<commit_message>
Submission triage: align deck, README and architecture page with what is built
- Deck: phone app, hardware keys, DSC, memo/Form-1/s.63, tube reading,
  liveness and night mode now say designed/planned; 11.7% -> 0% labelled
  simulated; limitations stated on slides 4 and 6. Layout re-checked.
- README: reference prototype framing; test keys; 89% figure removed
  (it was a consistency check on the chart's own colours); demo marked
  best case; limitations expanded with the audit findings.
- Problem register: audit findings U27-U34.
- Architecture page: marked as target design with the list of
  statements that are not built.

Co-Authored-By: Claude Opus 5.5 <noreply@anthropic.com>
</commit_message>
<xml_diff>
--- a/docs/deck/SIH26231_Idea_Submission.pptx
+++ b/docs/deck/SIH26231_Idea_Submission.pptx
@@ -6164,7 +6164,7 @@
           <p:cNvPr id="2" name="TextBox 1">
             <a:extLst>
               <a:ext uri="{FF2B5EF4-FFF2-40B4-BE49-F238E27FC236}">
-                <a16:creationId xmlns:a16="http://schemas.microsoft.com/office/drawing/2014/main" id="{B4BA027E-0A92-0076-FD2B-C5E6877244FD}"/>
+                <a16:creationId xmlns:a16="http://schemas.microsoft.com/office/drawing/2014/main" id="{FE044FD0-FA46-432C-162C-3FCCA8D59328}"/>
               </a:ext>
             </a:extLst>
           </p:cNvPr>
@@ -6218,7 +6218,7 @@
           <p:cNvPr id="3" name="Rectangle: Rounded Corners 2">
             <a:extLst>
               <a:ext uri="{FF2B5EF4-FFF2-40B4-BE49-F238E27FC236}">
-                <a16:creationId xmlns:a16="http://schemas.microsoft.com/office/drawing/2014/main" id="{96B2BC3E-3F7F-0EC4-AEBB-7284EB993945}"/>
+                <a16:creationId xmlns:a16="http://schemas.microsoft.com/office/drawing/2014/main" id="{1672E95A-E4AC-695C-6DF6-F25881421B83}"/>
               </a:ext>
             </a:extLst>
           </p:cNvPr>
@@ -6296,7 +6296,7 @@
           <p:cNvPr id="4" name="TextBox 3">
             <a:extLst>
               <a:ext uri="{FF2B5EF4-FFF2-40B4-BE49-F238E27FC236}">
-                <a16:creationId xmlns:a16="http://schemas.microsoft.com/office/drawing/2014/main" id="{01BD609A-0D64-BBE1-E584-16CEC5D916B8}"/>
+                <a16:creationId xmlns:a16="http://schemas.microsoft.com/office/drawing/2014/main" id="{1E7ACDC5-4A6D-AE3C-45CA-AB8F196BB399}"/>
               </a:ext>
             </a:extLst>
           </p:cNvPr>
@@ -6344,7 +6344,7 @@
           <p:cNvPr id="5" name="TextBox 4">
             <a:extLst>
               <a:ext uri="{FF2B5EF4-FFF2-40B4-BE49-F238E27FC236}">
-                <a16:creationId xmlns:a16="http://schemas.microsoft.com/office/drawing/2014/main" id="{4F1ED48E-0893-4EEB-EC87-5F0AE59A2B48}"/>
+                <a16:creationId xmlns:a16="http://schemas.microsoft.com/office/drawing/2014/main" id="{E438140E-45C3-FF30-B31F-40B0A3EB116A}"/>
               </a:ext>
             </a:extLst>
           </p:cNvPr>
@@ -6495,7 +6495,7 @@
                 </a:solidFill>
                 <a:latin typeface="Arial" panose="020B0604020202020204" pitchFamily="34" charset="0"/>
               </a:rPr>
-              <a:t>disputed seizures, bail on procedure, and no data on how often field tests are wrong.</a:t>
+              <a:t>disputed seizures, bail on procedure, and field results that cannot later be checked against the lab report.</a:t>
             </a:r>
             <a:endParaRPr lang="en-IN" sz="1100">
               <a:solidFill>
@@ -6511,7 +6511,7 @@
           <p:cNvPr id="8" name="TextBox 7">
             <a:extLst>
               <a:ext uri="{FF2B5EF4-FFF2-40B4-BE49-F238E27FC236}">
-                <a16:creationId xmlns:a16="http://schemas.microsoft.com/office/drawing/2014/main" id="{200C9D84-6FF1-0111-88FB-F8DE23514122}"/>
+                <a16:creationId xmlns:a16="http://schemas.microsoft.com/office/drawing/2014/main" id="{452C689E-6299-C00E-F769-921AD259F881}"/>
               </a:ext>
             </a:extLst>
           </p:cNvPr>
@@ -6549,7 +6549,7 @@
                 </a:solidFill>
                 <a:latin typeface="Arial" panose="020B0604020202020204" pitchFamily="34" charset="0"/>
               </a:rPr>
-              <a:t>HOW IT WORKS (OFFLINE, ON THE OFFICER'S PHONE)</a:t>
+              <a:t>HOW IT WILL WORK (PHONE, OFFLINE)</a:t>
             </a:r>
             <a:endParaRPr lang="en-IN" sz="1200" b="1">
               <a:solidFill>
@@ -6565,7 +6565,7 @@
           <p:cNvPr id="12" name="Oval 11">
             <a:extLst>
               <a:ext uri="{FF2B5EF4-FFF2-40B4-BE49-F238E27FC236}">
-                <a16:creationId xmlns:a16="http://schemas.microsoft.com/office/drawing/2014/main" id="{4781352A-6075-16CC-9D86-01D1780A2D56}"/>
+                <a16:creationId xmlns:a16="http://schemas.microsoft.com/office/drawing/2014/main" id="{E09070AB-D431-55F7-7B46-7529CF5C8D7F}"/>
               </a:ext>
             </a:extLst>
           </p:cNvPr>
@@ -6656,7 +6656,7 @@
           <p:cNvPr id="13" name="TextBox 12">
             <a:extLst>
               <a:ext uri="{FF2B5EF4-FFF2-40B4-BE49-F238E27FC236}">
-                <a16:creationId xmlns:a16="http://schemas.microsoft.com/office/drawing/2014/main" id="{149D812E-F5F6-BCB5-0205-26613B08C61B}"/>
+                <a16:creationId xmlns:a16="http://schemas.microsoft.com/office/drawing/2014/main" id="{94BC351E-79D6-5C34-83E0-92C3218259E9}"/>
               </a:ext>
             </a:extLst>
           </p:cNvPr>
@@ -6713,7 +6713,7 @@
                 </a:solidFill>
                 <a:latin typeface="Arial" panose="020B0604020202020204" pitchFamily="34" charset="0"/>
               </a:rPr>
-              <a:t>NCB kit Tests A–E in the printed flow-chart order: drops, wait time, which layer to read</a:t>
+              <a:t>NCB kit Tests A–E in the order of the kit's printed flow charts, with the drops and steps printed for each test</a:t>
             </a:r>
             <a:endParaRPr lang="en-IN" sz="1000">
               <a:solidFill>
@@ -6729,7 +6729,7 @@
           <p:cNvPr id="14" name="Straight Connector 13">
             <a:extLst>
               <a:ext uri="{FF2B5EF4-FFF2-40B4-BE49-F238E27FC236}">
-                <a16:creationId xmlns:a16="http://schemas.microsoft.com/office/drawing/2014/main" id="{77ACE5DD-BB8E-354C-14E1-E00EE46B4797}"/>
+                <a16:creationId xmlns:a16="http://schemas.microsoft.com/office/drawing/2014/main" id="{1AE54921-EA15-08C6-4C7E-CBAE391A83B6}"/>
               </a:ext>
             </a:extLst>
           </p:cNvPr>
@@ -6771,7 +6771,7 @@
           <p:cNvPr id="15" name="Oval 14">
             <a:extLst>
               <a:ext uri="{FF2B5EF4-FFF2-40B4-BE49-F238E27FC236}">
-                <a16:creationId xmlns:a16="http://schemas.microsoft.com/office/drawing/2014/main" id="{A8DA9A02-DD31-2D14-532F-FDEF30FF3CB9}"/>
+                <a16:creationId xmlns:a16="http://schemas.microsoft.com/office/drawing/2014/main" id="{A94CB840-5C63-5A28-8DEF-94ED67634CBA}"/>
               </a:ext>
             </a:extLst>
           </p:cNvPr>
@@ -6862,7 +6862,7 @@
           <p:cNvPr id="16" name="TextBox 15">
             <a:extLst>
               <a:ext uri="{FF2B5EF4-FFF2-40B4-BE49-F238E27FC236}">
-                <a16:creationId xmlns:a16="http://schemas.microsoft.com/office/drawing/2014/main" id="{87175E1A-A3F2-D36A-3E04-7ECE9F3A5BB3}"/>
+                <a16:creationId xmlns:a16="http://schemas.microsoft.com/office/drawing/2014/main" id="{4E451FB5-98B2-6C00-D03E-0A4316E70226}"/>
               </a:ext>
             </a:extLst>
           </p:cNvPr>
@@ -6919,7 +6919,7 @@
                 </a:solidFill>
                 <a:latin typeface="Arial" panose="020B0604020202020204" pitchFamily="34" charset="0"/>
               </a:rPr>
-              <a:t>Photo of the reaction on a reference colour card, next to a reagent-only blank well</a:t>
+              <a:t>Photo of the reaction on a reference colour card beside a reagent-only blank well (spot-plate tests first; tube holder for Tests B and E next)</a:t>
             </a:r>
             <a:endParaRPr lang="en-IN" sz="1000">
               <a:solidFill>
@@ -6935,7 +6935,7 @@
           <p:cNvPr id="17" name="Straight Connector 16">
             <a:extLst>
               <a:ext uri="{FF2B5EF4-FFF2-40B4-BE49-F238E27FC236}">
-                <a16:creationId xmlns:a16="http://schemas.microsoft.com/office/drawing/2014/main" id="{51D22222-1472-54B6-47A7-7BF1D8428B84}"/>
+                <a16:creationId xmlns:a16="http://schemas.microsoft.com/office/drawing/2014/main" id="{EB2EF547-82F1-1CAD-C8B1-519632C1F9CF}"/>
               </a:ext>
             </a:extLst>
           </p:cNvPr>
@@ -6977,7 +6977,7 @@
           <p:cNvPr id="18" name="Oval 17">
             <a:extLst>
               <a:ext uri="{FF2B5EF4-FFF2-40B4-BE49-F238E27FC236}">
-                <a16:creationId xmlns:a16="http://schemas.microsoft.com/office/drawing/2014/main" id="{CF8BA2A3-6041-0926-165E-E006E9C13813}"/>
+                <a16:creationId xmlns:a16="http://schemas.microsoft.com/office/drawing/2014/main" id="{6D9D6D64-CECD-6042-E955-C3C9631573C5}"/>
               </a:ext>
             </a:extLst>
           </p:cNvPr>
@@ -7068,7 +7068,7 @@
           <p:cNvPr id="19" name="TextBox 18">
             <a:extLst>
               <a:ext uri="{FF2B5EF4-FFF2-40B4-BE49-F238E27FC236}">
-                <a16:creationId xmlns:a16="http://schemas.microsoft.com/office/drawing/2014/main" id="{D99554F5-696A-327D-C8B2-32E23477BC94}"/>
+                <a16:creationId xmlns:a16="http://schemas.microsoft.com/office/drawing/2014/main" id="{ABC0860E-32F7-DB3C-0124-4DE719582F16}"/>
               </a:ext>
             </a:extLst>
           </p:cNvPr>
@@ -7125,7 +7125,7 @@
                 </a:solidFill>
                 <a:latin typeface="Arial" panose="020B0604020202020204" pitchFamily="34" charset="0"/>
               </a:rPr>
-              <a:t>Colour bands from the kit's own ranges: positive / no colour change / inconclusive + every drug it fits</a:t>
+              <a:t>Colour bands from the kit's printed ranges: positive / no colour change / inconclusive, plus every drug on the kit chart that the colour fits</a:t>
             </a:r>
             <a:endParaRPr lang="en-IN" sz="1000">
               <a:solidFill>
@@ -7141,7 +7141,7 @@
           <p:cNvPr id="20" name="Straight Connector 19">
             <a:extLst>
               <a:ext uri="{FF2B5EF4-FFF2-40B4-BE49-F238E27FC236}">
-                <a16:creationId xmlns:a16="http://schemas.microsoft.com/office/drawing/2014/main" id="{1A970276-C96B-1D28-9CB4-8ADD6B398342}"/>
+                <a16:creationId xmlns:a16="http://schemas.microsoft.com/office/drawing/2014/main" id="{E36D8320-A5AF-18C0-5C3F-0F9400A67867}"/>
               </a:ext>
             </a:extLst>
           </p:cNvPr>
@@ -7183,7 +7183,7 @@
           <p:cNvPr id="21" name="Oval 20">
             <a:extLst>
               <a:ext uri="{FF2B5EF4-FFF2-40B4-BE49-F238E27FC236}">
-                <a16:creationId xmlns:a16="http://schemas.microsoft.com/office/drawing/2014/main" id="{6B597CE0-17FE-C771-957A-DBA3D1948E5C}"/>
+                <a16:creationId xmlns:a16="http://schemas.microsoft.com/office/drawing/2014/main" id="{A852D340-0729-5E32-03C4-705BA811F69D}"/>
               </a:ext>
             </a:extLst>
           </p:cNvPr>
@@ -7274,7 +7274,7 @@
           <p:cNvPr id="22" name="TextBox 21">
             <a:extLst>
               <a:ext uri="{FF2B5EF4-FFF2-40B4-BE49-F238E27FC236}">
-                <a16:creationId xmlns:a16="http://schemas.microsoft.com/office/drawing/2014/main" id="{14360F33-DE26-CA73-2462-28E3961EE946}"/>
+                <a16:creationId xmlns:a16="http://schemas.microsoft.com/office/drawing/2014/main" id="{E3B91B92-8D11-D643-D9A9-DB79A642713C}"/>
               </a:ext>
             </a:extLst>
           </p:cNvPr>
@@ -7331,7 +7331,7 @@
                 </a:solidFill>
                 <a:latin typeface="Arial" panose="020B0604020202020204" pitchFamily="34" charset="0"/>
               </a:rPr>
-              <a:t>Time, GPS, officer and image hash, signed in phone hardware and hash-chained</a:t>
+              <a:t>Time, GPS, officer and image hash in every record, signed and hash-chained (designed for the phone's secure hardware key)</a:t>
             </a:r>
             <a:endParaRPr lang="en-IN" sz="1000">
               <a:solidFill>
@@ -7347,7 +7347,7 @@
           <p:cNvPr id="23" name="Straight Connector 22">
             <a:extLst>
               <a:ext uri="{FF2B5EF4-FFF2-40B4-BE49-F238E27FC236}">
-                <a16:creationId xmlns:a16="http://schemas.microsoft.com/office/drawing/2014/main" id="{FFF0DAFB-B6A0-6839-7091-98BC165895C2}"/>
+                <a16:creationId xmlns:a16="http://schemas.microsoft.com/office/drawing/2014/main" id="{147A5969-6C46-3E92-A8CC-3720BD256BCC}"/>
               </a:ext>
             </a:extLst>
           </p:cNvPr>
@@ -7389,7 +7389,7 @@
           <p:cNvPr id="24" name="Oval 23">
             <a:extLst>
               <a:ext uri="{FF2B5EF4-FFF2-40B4-BE49-F238E27FC236}">
-                <a16:creationId xmlns:a16="http://schemas.microsoft.com/office/drawing/2014/main" id="{30CD1916-F2F9-E994-B044-5AC541A09F0D}"/>
+                <a16:creationId xmlns:a16="http://schemas.microsoft.com/office/drawing/2014/main" id="{2D6A4795-DA47-712D-321B-46402171016B}"/>
               </a:ext>
             </a:extLst>
           </p:cNvPr>
@@ -7480,7 +7480,7 @@
           <p:cNvPr id="25" name="TextBox 24">
             <a:extLst>
               <a:ext uri="{FF2B5EF4-FFF2-40B4-BE49-F238E27FC236}">
-                <a16:creationId xmlns:a16="http://schemas.microsoft.com/office/drawing/2014/main" id="{70956FCB-2301-A937-F88E-EAAF02A5EBF9}"/>
+                <a16:creationId xmlns:a16="http://schemas.microsoft.com/office/drawing/2014/main" id="{EA3FD9F7-D42C-604D-0D08-AA4C55570F17}"/>
               </a:ext>
             </a:extLst>
           </p:cNvPr>
@@ -7553,7 +7553,7 @@
           <p:cNvPr id="26" name="Straight Connector 25">
             <a:extLst>
               <a:ext uri="{FF2B5EF4-FFF2-40B4-BE49-F238E27FC236}">
-                <a16:creationId xmlns:a16="http://schemas.microsoft.com/office/drawing/2014/main" id="{A6CD65E7-12CB-F8F3-CA06-BC72ED9E1B64}"/>
+                <a16:creationId xmlns:a16="http://schemas.microsoft.com/office/drawing/2014/main" id="{186B997A-9EEF-C8EE-D098-7FAD77F7C539}"/>
               </a:ext>
             </a:extLst>
           </p:cNvPr>
@@ -7595,7 +7595,7 @@
           <p:cNvPr id="27" name="Oval 26">
             <a:extLst>
               <a:ext uri="{FF2B5EF4-FFF2-40B4-BE49-F238E27FC236}">
-                <a16:creationId xmlns:a16="http://schemas.microsoft.com/office/drawing/2014/main" id="{CC9936F5-D415-B2A1-A045-31E4C2BB6B7F}"/>
+                <a16:creationId xmlns:a16="http://schemas.microsoft.com/office/drawing/2014/main" id="{B54627DA-041B-E886-F189-7AE16B4BC877}"/>
               </a:ext>
             </a:extLst>
           </p:cNvPr>
@@ -7686,7 +7686,7 @@
           <p:cNvPr id="28" name="TextBox 27">
             <a:extLst>
               <a:ext uri="{FF2B5EF4-FFF2-40B4-BE49-F238E27FC236}">
-                <a16:creationId xmlns:a16="http://schemas.microsoft.com/office/drawing/2014/main" id="{FA639B10-08C8-0DDF-C357-E48E5A4DFD8D}"/>
+                <a16:creationId xmlns:a16="http://schemas.microsoft.com/office/drawing/2014/main" id="{F809868C-2DA6-5BB0-07DE-EF86B5F18572}"/>
               </a:ext>
             </a:extLst>
           </p:cNvPr>
@@ -7724,7 +7724,7 @@
                 </a:solidFill>
                 <a:latin typeface="Arial" panose="020B0604020202020204" pitchFamily="34" charset="0"/>
               </a:rPr>
-              <a:t>Report</a:t>
+              <a:t>Verify</a:t>
             </a:r>
           </a:p>
           <a:p>
@@ -7743,7 +7743,7 @@
                 </a:solidFill>
                 <a:latin typeface="Arial" panose="020B0604020202020204" pitchFamily="34" charset="0"/>
               </a:rPr>
-              <a:t>Field Test Memo, Form-1 item 5, BSA s.63 data; anyone can verify offline</a:t>
+              <a:t>Anyone can check the records offline with our verifier. Planned: Field Test Memo, Form-1 item 5 text, BSA s.63 data</a:t>
             </a:r>
             <a:endParaRPr lang="en-IN" sz="1000">
               <a:solidFill>
@@ -7759,7 +7759,7 @@
           <p:cNvPr id="29" name="TextBox 28">
             <a:extLst>
               <a:ext uri="{FF2B5EF4-FFF2-40B4-BE49-F238E27FC236}">
-                <a16:creationId xmlns:a16="http://schemas.microsoft.com/office/drawing/2014/main" id="{1226C746-2875-84BC-FABE-A53607CB101A}"/>
+                <a16:creationId xmlns:a16="http://schemas.microsoft.com/office/drawing/2014/main" id="{E3DF5404-412B-BBE8-B8E5-5254D7BF0183}"/>
               </a:ext>
             </a:extLst>
           </p:cNvPr>
@@ -7807,7 +7807,7 @@
           <p:cNvPr id="30" name="Rectangle: Rounded Corners 29">
             <a:extLst>
               <a:ext uri="{FF2B5EF4-FFF2-40B4-BE49-F238E27FC236}">
-                <a16:creationId xmlns:a16="http://schemas.microsoft.com/office/drawing/2014/main" id="{BA2E3774-0C85-D8D1-186E-C746C5C5BABB}"/>
+                <a16:creationId xmlns:a16="http://schemas.microsoft.com/office/drawing/2014/main" id="{A4FD0406-634D-57A0-3377-FEE09EBB21BF}"/>
               </a:ext>
             </a:extLst>
           </p:cNvPr>
@@ -7885,7 +7885,7 @@
           <p:cNvPr id="31" name="TextBox 30">
             <a:extLst>
               <a:ext uri="{FF2B5EF4-FFF2-40B4-BE49-F238E27FC236}">
-                <a16:creationId xmlns:a16="http://schemas.microsoft.com/office/drawing/2014/main" id="{28EA960F-A7C7-7AFE-A451-3CAE5329B063}"/>
+                <a16:creationId xmlns:a16="http://schemas.microsoft.com/office/drawing/2014/main" id="{C10E6FD6-4FD4-3F05-ED36-BC4DD14A0C73}"/>
               </a:ext>
             </a:extLst>
           </p:cNvPr>
@@ -7958,7 +7958,7 @@
           <p:cNvPr id="32" name="Rectangle: Rounded Corners 31">
             <a:extLst>
               <a:ext uri="{FF2B5EF4-FFF2-40B4-BE49-F238E27FC236}">
-                <a16:creationId xmlns:a16="http://schemas.microsoft.com/office/drawing/2014/main" id="{BA4A8E8F-BBF7-32B3-2445-3F012732E8D9}"/>
+                <a16:creationId xmlns:a16="http://schemas.microsoft.com/office/drawing/2014/main" id="{C0BB615B-15DE-C8B5-AE25-4D5CBA4A5C81}"/>
               </a:ext>
             </a:extLst>
           </p:cNvPr>
@@ -8036,7 +8036,7 @@
           <p:cNvPr id="33" name="TextBox 32">
             <a:extLst>
               <a:ext uri="{FF2B5EF4-FFF2-40B4-BE49-F238E27FC236}">
-                <a16:creationId xmlns:a16="http://schemas.microsoft.com/office/drawing/2014/main" id="{B4BD9B6A-23A6-7AB7-5AC6-F940EBDAD3F3}"/>
+                <a16:creationId xmlns:a16="http://schemas.microsoft.com/office/drawing/2014/main" id="{C63E56DC-E9F5-40BA-D9B9-2A36A4EE2AE3}"/>
               </a:ext>
             </a:extLst>
           </p:cNvPr>
@@ -8074,7 +8074,7 @@
                 </a:solidFill>
                 <a:latin typeface="Arial" panose="020B0604020202020204" pitchFamily="34" charset="0"/>
               </a:rPr>
-              <a:t>Holds up when the sample amount varies</a:t>
+              <a:t>Designed for varying sample amounts</a:t>
             </a:r>
           </a:p>
           <a:p>
@@ -8093,7 +8093,7 @@
                 </a:solidFill>
                 <a:latin typeface="Arial" panose="020B0604020202020204" pitchFamily="34" charset="0"/>
               </a:rPr>
-              <a:t>Bands + blank well: 0% false positives where single-point colour matching gave up to 11.7%.</a:t>
+              <a:t>In simulation, colour bands + a blank well gave 0% false positives where our first single-point rule gave up to 11.7%. Real reactions: next.</a:t>
             </a:r>
             <a:endParaRPr lang="en-IN" sz="1050">
               <a:solidFill>
@@ -8109,7 +8109,7 @@
           <p:cNvPr id="34" name="Rectangle: Rounded Corners 33">
             <a:extLst>
               <a:ext uri="{FF2B5EF4-FFF2-40B4-BE49-F238E27FC236}">
-                <a16:creationId xmlns:a16="http://schemas.microsoft.com/office/drawing/2014/main" id="{B54D1330-283F-3FD7-992A-4C429D9F6100}"/>
+                <a16:creationId xmlns:a16="http://schemas.microsoft.com/office/drawing/2014/main" id="{3DE94B2F-79C5-D1F0-804C-900FF1455697}"/>
               </a:ext>
             </a:extLst>
           </p:cNvPr>
@@ -8202,7 +8202,7 @@
           <p:cNvPr id="35" name="Rectangle: Rounded Corners 34">
             <a:extLst>
               <a:ext uri="{FF2B5EF4-FFF2-40B4-BE49-F238E27FC236}">
-                <a16:creationId xmlns:a16="http://schemas.microsoft.com/office/drawing/2014/main" id="{B8970BAF-5718-A286-E9CD-6E61CC3EE107}"/>
+                <a16:creationId xmlns:a16="http://schemas.microsoft.com/office/drawing/2014/main" id="{739D9F83-3202-1E1C-49C3-B7D38D9180FD}"/>
               </a:ext>
             </a:extLst>
           </p:cNvPr>
@@ -8280,7 +8280,7 @@
           <p:cNvPr id="36" name="TextBox 35">
             <a:extLst>
               <a:ext uri="{FF2B5EF4-FFF2-40B4-BE49-F238E27FC236}">
-                <a16:creationId xmlns:a16="http://schemas.microsoft.com/office/drawing/2014/main" id="{6E5BA662-34AB-A747-2036-9949F9648FB7}"/>
+                <a16:creationId xmlns:a16="http://schemas.microsoft.com/office/drawing/2014/main" id="{652E624F-05F4-2D6F-F909-982235EB8A58}"/>
               </a:ext>
             </a:extLst>
           </p:cNvPr>
@@ -8337,7 +8337,7 @@
                 </a:solidFill>
                 <a:latin typeface="Arial" panose="020B0604020202020204" pitchFamily="34" charset="0"/>
               </a:rPr>
-              <a:t>Deleted or re-run tests are caught; not even our server admin can forge a record.</a:t>
+              <a:t>Once the panchnama code is written, deleted or re-run tests are caught, and a server admin cannot forge a record (prototype, test keys).</a:t>
             </a:r>
             <a:endParaRPr lang="en-IN" sz="1050">
               <a:solidFill>
@@ -8353,7 +8353,7 @@
           <p:cNvPr id="37" name="Rectangle: Rounded Corners 36">
             <a:extLst>
               <a:ext uri="{FF2B5EF4-FFF2-40B4-BE49-F238E27FC236}">
-                <a16:creationId xmlns:a16="http://schemas.microsoft.com/office/drawing/2014/main" id="{1E5E58A8-EC87-B41C-C885-7815E2C70C0A}"/>
+                <a16:creationId xmlns:a16="http://schemas.microsoft.com/office/drawing/2014/main" id="{AA9B9E2A-8294-99EA-C0A3-5F31251FCEDA}"/>
               </a:ext>
             </a:extLst>
           </p:cNvPr>
@@ -8446,7 +8446,7 @@
           <p:cNvPr id="38" name="Rectangle: Rounded Corners 37">
             <a:extLst>
               <a:ext uri="{FF2B5EF4-FFF2-40B4-BE49-F238E27FC236}">
-                <a16:creationId xmlns:a16="http://schemas.microsoft.com/office/drawing/2014/main" id="{34B1515D-B6C6-25C1-9A8A-43C2C00F94C5}"/>
+                <a16:creationId xmlns:a16="http://schemas.microsoft.com/office/drawing/2014/main" id="{5C3E4662-9D8A-BC75-8C6A-AFF711F6C9A2}"/>
               </a:ext>
             </a:extLst>
           </p:cNvPr>
@@ -8524,7 +8524,7 @@
           <p:cNvPr id="39" name="TextBox 38">
             <a:extLst>
               <a:ext uri="{FF2B5EF4-FFF2-40B4-BE49-F238E27FC236}">
-                <a16:creationId xmlns:a16="http://schemas.microsoft.com/office/drawing/2014/main" id="{465A7A3E-61C7-625C-61D7-8625A8A9E92A}"/>
+                <a16:creationId xmlns:a16="http://schemas.microsoft.com/office/drawing/2014/main" id="{3B3AFCB0-211A-8057-A193-5B7396CA4C79}"/>
               </a:ext>
             </a:extLst>
           </p:cNvPr>
@@ -8581,7 +8581,7 @@
                 </a:solidFill>
                 <a:latin typeface="Arial" panose="020B0604020202020204" pitchFamily="34" charset="0"/>
               </a:rPr>
-              <a:t>Existing NCB kit + officer's phone + a printed card. Works offline; embeds in e-Sakshya as an SDK.</a:t>
+              <a:t>Existing NCB kit + officer's phone + a printed card. Designed to work offline and to be embeddable in apps such as e-Sakshya.</a:t>
             </a:r>
             <a:endParaRPr lang="en-IN" sz="1050">
               <a:solidFill>
@@ -8875,7 +8875,7 @@
           <p:cNvPr id="2" name="Rectangle: Rounded Corners 1">
             <a:extLst>
               <a:ext uri="{FF2B5EF4-FFF2-40B4-BE49-F238E27FC236}">
-                <a16:creationId xmlns:a16="http://schemas.microsoft.com/office/drawing/2014/main" id="{5F592037-561C-50D4-DBAC-6E22A2079E75}"/>
+                <a16:creationId xmlns:a16="http://schemas.microsoft.com/office/drawing/2014/main" id="{15B638E4-EF20-8DCF-7750-CFD316C50DE2}"/>
               </a:ext>
             </a:extLst>
           </p:cNvPr>
@@ -8943,7 +8943,7 @@
           <p:cNvPr id="3" name="TextBox 2">
             <a:extLst>
               <a:ext uri="{FF2B5EF4-FFF2-40B4-BE49-F238E27FC236}">
-                <a16:creationId xmlns:a16="http://schemas.microsoft.com/office/drawing/2014/main" id="{0D464547-A096-075C-5F91-8C5E0FF36C5C}"/>
+                <a16:creationId xmlns:a16="http://schemas.microsoft.com/office/drawing/2014/main" id="{AAD8AE4A-4E2E-CDD7-D7C9-FA8E8F3345D0}"/>
               </a:ext>
             </a:extLst>
           </p:cNvPr>
@@ -8975,14 +8975,20 @@
               </a:spcAft>
             </a:pPr>
             <a:r>
-              <a:rPr lang="en-IN" sz="1100" b="1">
+              <a:rPr lang="en-US" sz="1100" b="1">
                 <a:solidFill>
                   <a:srgbClr val="1F3864"/>
                 </a:solidFill>
                 <a:latin typeface="Arial" panose="020B0604020202020204" pitchFamily="34" charset="0"/>
               </a:rPr>
-              <a:t>OFFICER'S PHONE (offline SDK)</a:t>
-            </a:r>
+              <a:t>OFFICER'S PHONE APP (design, offline)</a:t>
+            </a:r>
+            <a:endParaRPr lang="en-IN" sz="1100" b="1">
+              <a:solidFill>
+                <a:srgbClr val="1F3864"/>
+              </a:solidFill>
+              <a:latin typeface="Arial" panose="020B0604020202020204" pitchFamily="34" charset="0"/>
+            </a:endParaRPr>
           </a:p>
         </p:txBody>
       </p:sp>
@@ -8991,7 +8997,7 @@
           <p:cNvPr id="4" name="Rectangle: Rounded Corners 3">
             <a:extLst>
               <a:ext uri="{FF2B5EF4-FFF2-40B4-BE49-F238E27FC236}">
-                <a16:creationId xmlns:a16="http://schemas.microsoft.com/office/drawing/2014/main" id="{7E562693-7C5C-8A90-7104-836927749894}"/>
+                <a16:creationId xmlns:a16="http://schemas.microsoft.com/office/drawing/2014/main" id="{54D2C7E0-6C68-32FB-C327-483952118603}"/>
               </a:ext>
             </a:extLst>
           </p:cNvPr>
@@ -9059,7 +9065,7 @@
           <p:cNvPr id="5" name="TextBox 4">
             <a:extLst>
               <a:ext uri="{FF2B5EF4-FFF2-40B4-BE49-F238E27FC236}">
-                <a16:creationId xmlns:a16="http://schemas.microsoft.com/office/drawing/2014/main" id="{9AF5D716-F759-0C91-4F9D-CAFC3A74CF74}"/>
+                <a16:creationId xmlns:a16="http://schemas.microsoft.com/office/drawing/2014/main" id="{F5259DDC-3463-8470-FDCD-CC7725955F7F}"/>
               </a:ext>
             </a:extLst>
           </p:cNvPr>
@@ -9116,7 +9122,7 @@
                 </a:solidFill>
                 <a:latin typeface="Arial" panose="020B0604020202020204" pitchFamily="34" charset="0"/>
               </a:rPr>
-              <a:t>signed: steps, drops, read times, flow charts</a:t>
+              <a:t>signed file: steps, drops, flow charts (in prototype)</a:t>
             </a:r>
             <a:endParaRPr lang="en-IN" sz="900">
               <a:solidFill>
@@ -9132,7 +9138,7 @@
           <p:cNvPr id="8" name="Rectangle: Rounded Corners 7">
             <a:extLst>
               <a:ext uri="{FF2B5EF4-FFF2-40B4-BE49-F238E27FC236}">
-                <a16:creationId xmlns:a16="http://schemas.microsoft.com/office/drawing/2014/main" id="{35AD702D-32AF-A86C-D071-A6217376B72F}"/>
+                <a16:creationId xmlns:a16="http://schemas.microsoft.com/office/drawing/2014/main" id="{D926C7F6-C976-A2A6-1358-0E0EFAAFD492}"/>
               </a:ext>
             </a:extLst>
           </p:cNvPr>
@@ -9200,7 +9206,7 @@
           <p:cNvPr id="9" name="TextBox 8">
             <a:extLst>
               <a:ext uri="{FF2B5EF4-FFF2-40B4-BE49-F238E27FC236}">
-                <a16:creationId xmlns:a16="http://schemas.microsoft.com/office/drawing/2014/main" id="{AD2D9560-7703-700E-04EF-F811B78B15B9}"/>
+                <a16:creationId xmlns:a16="http://schemas.microsoft.com/office/drawing/2014/main" id="{FECC60BE-CA88-3ED5-79F9-9C4634092E8C}"/>
               </a:ext>
             </a:extLst>
           </p:cNvPr>
@@ -9257,7 +9263,7 @@
                 </a:solidFill>
                 <a:latin typeface="Arial" panose="020B0604020202020204" pitchFamily="34" charset="0"/>
               </a:rPr>
-              <a:t>CameraX / Camera2 RAW, card located by ArUco markers</a:t>
+              <a:t>CameraX / Camera2 RAW; card found by ArUco markers</a:t>
             </a:r>
             <a:endParaRPr lang="en-IN" sz="900">
               <a:solidFill>
@@ -9273,7 +9279,7 @@
           <p:cNvPr id="13" name="Rectangle: Rounded Corners 12">
             <a:extLst>
               <a:ext uri="{FF2B5EF4-FFF2-40B4-BE49-F238E27FC236}">
-                <a16:creationId xmlns:a16="http://schemas.microsoft.com/office/drawing/2014/main" id="{4E7A88F4-18CF-94B5-8FA1-75CD557FFD23}"/>
+                <a16:creationId xmlns:a16="http://schemas.microsoft.com/office/drawing/2014/main" id="{CA60964A-5DDA-83B4-1A88-C59E322B4EEE}"/>
               </a:ext>
             </a:extLst>
           </p:cNvPr>
@@ -9341,7 +9347,7 @@
           <p:cNvPr id="14" name="TextBox 13">
             <a:extLst>
               <a:ext uri="{FF2B5EF4-FFF2-40B4-BE49-F238E27FC236}">
-                <a16:creationId xmlns:a16="http://schemas.microsoft.com/office/drawing/2014/main" id="{639E1C58-0E8B-B0AE-BE02-B0E2896D9680}"/>
+                <a16:creationId xmlns:a16="http://schemas.microsoft.com/office/drawing/2014/main" id="{DD6F0DF0-3DF7-70C3-CBD3-1DC6781100B4}"/>
               </a:ext>
             </a:extLst>
           </p:cNvPr>
@@ -9398,7 +9404,7 @@
                 </a:solidFill>
                 <a:latin typeface="Arial" panose="020B0604020202020204" pitchFamily="34" charset="0"/>
               </a:rPr>
-              <a:t>card correction, blank well, CIELAB colour bands</a:t>
+              <a:t>card correction, blank well, colour bands (in prototype)</a:t>
             </a:r>
             <a:endParaRPr lang="en-IN" sz="900">
               <a:solidFill>
@@ -9414,7 +9420,7 @@
           <p:cNvPr id="15" name="Rectangle: Rounded Corners 14">
             <a:extLst>
               <a:ext uri="{FF2B5EF4-FFF2-40B4-BE49-F238E27FC236}">
-                <a16:creationId xmlns:a16="http://schemas.microsoft.com/office/drawing/2014/main" id="{4E000A53-8926-F70B-B525-9A562F65A3B8}"/>
+                <a16:creationId xmlns:a16="http://schemas.microsoft.com/office/drawing/2014/main" id="{D4A3D926-171C-CF5E-86C4-E394CEE18E63}"/>
               </a:ext>
             </a:extLst>
           </p:cNvPr>
@@ -9482,7 +9488,7 @@
           <p:cNvPr id="16" name="TextBox 15">
             <a:extLst>
               <a:ext uri="{FF2B5EF4-FFF2-40B4-BE49-F238E27FC236}">
-                <a16:creationId xmlns:a16="http://schemas.microsoft.com/office/drawing/2014/main" id="{E7136239-66D4-49CB-3F2E-9B4F44827749}"/>
+                <a16:creationId xmlns:a16="http://schemas.microsoft.com/office/drawing/2014/main" id="{C70A0CE5-97AF-A482-CE44-088D0E6F2FA1}"/>
               </a:ext>
             </a:extLst>
           </p:cNvPr>
@@ -9539,7 +9545,7 @@
                 </a:solidFill>
                 <a:latin typeface="Arial" panose="020B0604020202020204" pitchFamily="34" charset="0"/>
               </a:rPr>
-              <a:t>ECDSA P-256 in StrongBox/TEE, SHA-256 chain</a:t>
+              <a:t>ECDSA P-256 + SHA-256 chain; key in StrongBox/TEE</a:t>
             </a:r>
             <a:endParaRPr lang="en-IN" sz="900">
               <a:solidFill>
@@ -9555,7 +9561,7 @@
           <p:cNvPr id="17" name="Rectangle: Rounded Corners 16">
             <a:extLst>
               <a:ext uri="{FF2B5EF4-FFF2-40B4-BE49-F238E27FC236}">
-                <a16:creationId xmlns:a16="http://schemas.microsoft.com/office/drawing/2014/main" id="{A4BAB98C-72CC-AED6-5CA7-BAC2204440C0}"/>
+                <a16:creationId xmlns:a16="http://schemas.microsoft.com/office/drawing/2014/main" id="{27AD4CD6-D018-F67E-4C1C-050E5E57B83E}"/>
               </a:ext>
             </a:extLst>
           </p:cNvPr>
@@ -9623,7 +9629,7 @@
           <p:cNvPr id="18" name="TextBox 17">
             <a:extLst>
               <a:ext uri="{FF2B5EF4-FFF2-40B4-BE49-F238E27FC236}">
-                <a16:creationId xmlns:a16="http://schemas.microsoft.com/office/drawing/2014/main" id="{1068B773-C61F-B6C1-92D5-FC380A8D1E98}"/>
+                <a16:creationId xmlns:a16="http://schemas.microsoft.com/office/drawing/2014/main" id="{6AD1BE6E-588D-7390-BD5A-6C49C0D51106}"/>
               </a:ext>
             </a:extLst>
           </p:cNvPr>
@@ -9680,7 +9686,7 @@
                 </a:solidFill>
                 <a:latin typeface="Arial" panose="020B0604020202020204" pitchFamily="34" charset="0"/>
               </a:rPr>
-              <a:t>searchable log, Field Test Memo, Form-1 item 5</a:t>
+              <a:t>searchable log (in prototype); memo, Form-1 (planned)</a:t>
             </a:r>
             <a:endParaRPr lang="en-IN" sz="900">
               <a:solidFill>
@@ -9696,7 +9702,7 @@
           <p:cNvPr id="19" name="Rectangle: Rounded Corners 18">
             <a:extLst>
               <a:ext uri="{FF2B5EF4-FFF2-40B4-BE49-F238E27FC236}">
-                <a16:creationId xmlns:a16="http://schemas.microsoft.com/office/drawing/2014/main" id="{D2FAA2D7-AFB3-8265-17FB-74EF5C1AF817}"/>
+                <a16:creationId xmlns:a16="http://schemas.microsoft.com/office/drawing/2014/main" id="{771F4C02-830A-A890-F73D-676804AA3727}"/>
               </a:ext>
             </a:extLst>
           </p:cNvPr>
@@ -9764,7 +9770,7 @@
           <p:cNvPr id="20" name="TextBox 19">
             <a:extLst>
               <a:ext uri="{FF2B5EF4-FFF2-40B4-BE49-F238E27FC236}">
-                <a16:creationId xmlns:a16="http://schemas.microsoft.com/office/drawing/2014/main" id="{026BD5EE-A56A-857B-D7AD-2340E0CB6F7F}"/>
+                <a16:creationId xmlns:a16="http://schemas.microsoft.com/office/drawing/2014/main" id="{FF3BE55F-7070-F178-3FD6-B7C6AAD634C5}"/>
               </a:ext>
             </a:extLst>
           </p:cNvPr>
@@ -9802,7 +9808,7 @@
                 </a:solidFill>
                 <a:latin typeface="Arial" panose="020B0604020202020204" pitchFamily="34" charset="0"/>
               </a:rPr>
-              <a:t>THIN SERVER: NIC / MeitY cloud</a:t>
+              <a:t>THIN SERVER (design): NIC / MeitY cloud</a:t>
             </a:r>
             <a:endParaRPr lang="en-IN" sz="1100" b="1">
               <a:solidFill>
@@ -9818,7 +9824,7 @@
           <p:cNvPr id="21" name="Rectangle: Rounded Corners 20">
             <a:extLst>
               <a:ext uri="{FF2B5EF4-FFF2-40B4-BE49-F238E27FC236}">
-                <a16:creationId xmlns:a16="http://schemas.microsoft.com/office/drawing/2014/main" id="{3D310CBD-0BF3-1FE4-5A3E-F3FBE6043D71}"/>
+                <a16:creationId xmlns:a16="http://schemas.microsoft.com/office/drawing/2014/main" id="{58CC4016-62DC-7E97-4670-DF326A8FAD63}"/>
               </a:ext>
             </a:extLst>
           </p:cNvPr>
@@ -9886,7 +9892,7 @@
           <p:cNvPr id="22" name="TextBox 21">
             <a:extLst>
               <a:ext uri="{FF2B5EF4-FFF2-40B4-BE49-F238E27FC236}">
-                <a16:creationId xmlns:a16="http://schemas.microsoft.com/office/drawing/2014/main" id="{7588B814-0907-A324-16B7-F3F2E3057D76}"/>
+                <a16:creationId xmlns:a16="http://schemas.microsoft.com/office/drawing/2014/main" id="{D8C1087B-1066-DEB3-9CB3-FEC116B5EE85}"/>
               </a:ext>
             </a:extLst>
           </p:cNvPr>
@@ -9937,20 +9943,14 @@
               </a:spcAft>
             </a:pPr>
             <a:r>
-              <a:rPr lang="en-US" sz="900">
+              <a:rPr lang="en-IN" sz="900">
                 <a:solidFill>
                   <a:srgbClr val="595959"/>
                 </a:solidFill>
                 <a:latin typeface="Arial" panose="020B0604020202020204" pitchFamily="34" charset="0"/>
               </a:rPr>
-              <a:t>Android key attestation + supervisor's DSC</a:t>
-            </a:r>
-            <a:endParaRPr lang="en-IN" sz="900">
-              <a:solidFill>
-                <a:srgbClr val="595959"/>
-              </a:solidFill>
-              <a:latin typeface="Arial" panose="020B0604020202020204" pitchFamily="34" charset="0"/>
-            </a:endParaRPr>
+              <a:t>attestation + supervisor DSC (checker prototyped)</a:t>
+            </a:r>
           </a:p>
         </p:txBody>
       </p:sp>
@@ -9959,7 +9959,7 @@
           <p:cNvPr id="23" name="Rectangle: Rounded Corners 22">
             <a:extLst>
               <a:ext uri="{FF2B5EF4-FFF2-40B4-BE49-F238E27FC236}">
-                <a16:creationId xmlns:a16="http://schemas.microsoft.com/office/drawing/2014/main" id="{23085109-7C26-E17F-43BC-F04DF3E47C51}"/>
+                <a16:creationId xmlns:a16="http://schemas.microsoft.com/office/drawing/2014/main" id="{5F167E2A-91D5-3ADE-C522-C51503150593}"/>
               </a:ext>
             </a:extLst>
           </p:cNvPr>
@@ -10027,7 +10027,7 @@
           <p:cNvPr id="24" name="TextBox 23">
             <a:extLst>
               <a:ext uri="{FF2B5EF4-FFF2-40B4-BE49-F238E27FC236}">
-                <a16:creationId xmlns:a16="http://schemas.microsoft.com/office/drawing/2014/main" id="{B7A4099E-9CF7-0C54-6089-9AB62E435787}"/>
+                <a16:creationId xmlns:a16="http://schemas.microsoft.com/office/drawing/2014/main" id="{BFE15F68-F172-D146-E642-5A3F3B046B1B}"/>
               </a:ext>
             </a:extLst>
           </p:cNvPr>
@@ -10084,7 +10084,7 @@
                 </a:solidFill>
                 <a:latin typeface="Arial" panose="020B0604020202020204" pitchFamily="34" charset="0"/>
               </a:rPr>
-              <a:t>idempotent, fork/replay checks, signed receipts</a:t>
+              <a:t>idempotent, fork/replay checks (protocol prototyped)</a:t>
             </a:r>
             <a:endParaRPr lang="en-IN" sz="900">
               <a:solidFill>
@@ -10100,7 +10100,7 @@
           <p:cNvPr id="25" name="Rectangle: Rounded Corners 24">
             <a:extLst>
               <a:ext uri="{FF2B5EF4-FFF2-40B4-BE49-F238E27FC236}">
-                <a16:creationId xmlns:a16="http://schemas.microsoft.com/office/drawing/2014/main" id="{16921AE2-2963-E545-35CA-85778A17D0C3}"/>
+                <a16:creationId xmlns:a16="http://schemas.microsoft.com/office/drawing/2014/main" id="{72CAFFFB-96B8-E1DF-B482-959178DF3958}"/>
               </a:ext>
             </a:extLst>
           </p:cNvPr>
@@ -10168,7 +10168,7 @@
           <p:cNvPr id="26" name="TextBox 25">
             <a:extLst>
               <a:ext uri="{FF2B5EF4-FFF2-40B4-BE49-F238E27FC236}">
-                <a16:creationId xmlns:a16="http://schemas.microsoft.com/office/drawing/2014/main" id="{01142FEF-0FAA-EA5A-CC27-28E7CF74E833}"/>
+                <a16:creationId xmlns:a16="http://schemas.microsoft.com/office/drawing/2014/main" id="{99E8AF96-6220-BF34-9CEF-A951F8C1884A}"/>
               </a:ext>
             </a:extLst>
           </p:cNvPr>
@@ -10225,7 +10225,7 @@
                 </a:solidFill>
                 <a:latin typeface="Arial" panose="020B0604020202020204" pitchFamily="34" charset="0"/>
               </a:rPr>
-              <a:t>PostgreSQL + S3 write-once, durable checkpoints</a:t>
+              <a:t>PostgreSQL + S3 write-once (prototype: SQLite)</a:t>
             </a:r>
             <a:endParaRPr lang="en-IN" sz="900">
               <a:solidFill>
@@ -10241,7 +10241,7 @@
           <p:cNvPr id="27" name="Rectangle: Rounded Corners 26">
             <a:extLst>
               <a:ext uri="{FF2B5EF4-FFF2-40B4-BE49-F238E27FC236}">
-                <a16:creationId xmlns:a16="http://schemas.microsoft.com/office/drawing/2014/main" id="{1ABB959A-1D61-F4CB-4F49-641B3D5A08A8}"/>
+                <a16:creationId xmlns:a16="http://schemas.microsoft.com/office/drawing/2014/main" id="{C9C9FBBE-E397-2EA7-78BE-D9D5DF9BEAF5}"/>
               </a:ext>
             </a:extLst>
           </p:cNvPr>
@@ -10309,7 +10309,7 @@
           <p:cNvPr id="28" name="TextBox 27">
             <a:extLst>
               <a:ext uri="{FF2B5EF4-FFF2-40B4-BE49-F238E27FC236}">
-                <a16:creationId xmlns:a16="http://schemas.microsoft.com/office/drawing/2014/main" id="{A0A4FDCF-230B-6A8A-58D1-59F804A15C03}"/>
+                <a16:creationId xmlns:a16="http://schemas.microsoft.com/office/drawing/2014/main" id="{39B4DE85-3857-DD6E-B3A0-49CAF5DB2B92}"/>
               </a:ext>
             </a:extLst>
           </p:cNvPr>
@@ -10366,7 +10366,7 @@
                 </a:solidFill>
                 <a:latin typeface="Arial" panose="020B0604020202020204" pitchFamily="34" charset="0"/>
               </a:rPr>
-              <a:t>case search; Rule 14 lab result vs field result</a:t>
+              <a:t>case search (prototyped); lab-result link (planned)</a:t>
             </a:r>
             <a:endParaRPr lang="en-IN" sz="900">
               <a:solidFill>
@@ -10382,7 +10382,7 @@
           <p:cNvPr id="29" name="Rectangle: Rounded Corners 28">
             <a:extLst>
               <a:ext uri="{FF2B5EF4-FFF2-40B4-BE49-F238E27FC236}">
-                <a16:creationId xmlns:a16="http://schemas.microsoft.com/office/drawing/2014/main" id="{A5959744-C9F3-EA72-ACE7-6E367F9AC061}"/>
+                <a16:creationId xmlns:a16="http://schemas.microsoft.com/office/drawing/2014/main" id="{1673DED0-48EC-7CA2-0802-9150FC7F9189}"/>
               </a:ext>
             </a:extLst>
           </p:cNvPr>
@@ -10450,7 +10450,7 @@
           <p:cNvPr id="30" name="TextBox 29">
             <a:extLst>
               <a:ext uri="{FF2B5EF4-FFF2-40B4-BE49-F238E27FC236}">
-                <a16:creationId xmlns:a16="http://schemas.microsoft.com/office/drawing/2014/main" id="{70A1DF49-9C25-2E1F-D0BC-2A442234F994}"/>
+                <a16:creationId xmlns:a16="http://schemas.microsoft.com/office/drawing/2014/main" id="{E31F4C1F-3574-2948-386E-4430247EBA65}"/>
               </a:ext>
             </a:extLst>
           </p:cNvPr>
@@ -10523,7 +10523,7 @@
           <p:cNvPr id="31" name="Straight Connector 30">
             <a:extLst>
               <a:ext uri="{FF2B5EF4-FFF2-40B4-BE49-F238E27FC236}">
-                <a16:creationId xmlns:a16="http://schemas.microsoft.com/office/drawing/2014/main" id="{8D0B9B55-B8A1-1599-6B1E-0096C0B111B7}"/>
+                <a16:creationId xmlns:a16="http://schemas.microsoft.com/office/drawing/2014/main" id="{93A5BBFE-732D-C1B5-C779-7EF3D575F368}"/>
               </a:ext>
             </a:extLst>
           </p:cNvPr>
@@ -10565,7 +10565,7 @@
           <p:cNvPr id="32" name="TextBox 31">
             <a:extLst>
               <a:ext uri="{FF2B5EF4-FFF2-40B4-BE49-F238E27FC236}">
-                <a16:creationId xmlns:a16="http://schemas.microsoft.com/office/drawing/2014/main" id="{B0126A9A-68E2-3C64-E65B-75A64F8D328F}"/>
+                <a16:creationId xmlns:a16="http://schemas.microsoft.com/office/drawing/2014/main" id="{98276F54-65D9-DF0B-6A81-9CF018D4728F}"/>
               </a:ext>
             </a:extLst>
           </p:cNvPr>
@@ -10613,7 +10613,7 @@
           <p:cNvPr id="33" name="Rectangle: Rounded Corners 32">
             <a:extLst>
               <a:ext uri="{FF2B5EF4-FFF2-40B4-BE49-F238E27FC236}">
-                <a16:creationId xmlns:a16="http://schemas.microsoft.com/office/drawing/2014/main" id="{E4612905-2351-367F-317B-CF4D0787509B}"/>
+                <a16:creationId xmlns:a16="http://schemas.microsoft.com/office/drawing/2014/main" id="{826CA5A5-2CAE-81C3-0093-36573AC1D2E6}"/>
               </a:ext>
             </a:extLst>
           </p:cNvPr>
@@ -10681,7 +10681,7 @@
           <p:cNvPr id="34" name="TextBox 33">
             <a:extLst>
               <a:ext uri="{FF2B5EF4-FFF2-40B4-BE49-F238E27FC236}">
-                <a16:creationId xmlns:a16="http://schemas.microsoft.com/office/drawing/2014/main" id="{E990752A-CDDD-B095-1079-975951C98E50}"/>
+                <a16:creationId xmlns:a16="http://schemas.microsoft.com/office/drawing/2014/main" id="{A3B6811D-3F72-33C0-CDE3-A0044373C25E}"/>
               </a:ext>
             </a:extLst>
           </p:cNvPr>
@@ -10728,7 +10728,7 @@
                 </a:solidFill>
                 <a:latin typeface="Arial" panose="020B0604020202020204" pitchFamily="34" charset="0"/>
               </a:rPr>
-              <a:t>NCB signs the supervisor list; a supervisor's DSC binds officer + phone + key; the phone signs and chains every test; the chain heads of every phone go into the witness-signed panchnama. An offline verifier (same record core) checks it all in court.</a:t>
+              <a:t>NCB signs the supervisor list; a supervisor's key (a Class 3 DSC in production) binds officer + phone + key; the phone signs and chains every test; every phone's chain head goes into the witness-signed panchnama. Our offline verifier checks all of it (prototype uses test keys).</a:t>
             </a:r>
             <a:endParaRPr lang="en-IN" sz="950">
               <a:solidFill>
@@ -10744,7 +10744,7 @@
           <p:cNvPr id="35" name="Rectangle: Rounded Corners 34">
             <a:extLst>
               <a:ext uri="{FF2B5EF4-FFF2-40B4-BE49-F238E27FC236}">
-                <a16:creationId xmlns:a16="http://schemas.microsoft.com/office/drawing/2014/main" id="{E54DBB00-57FE-8B40-8685-FEDB7B373605}"/>
+                <a16:creationId xmlns:a16="http://schemas.microsoft.com/office/drawing/2014/main" id="{E056D584-5AE0-39D6-4F6E-5E29876223DB}"/>
               </a:ext>
             </a:extLst>
           </p:cNvPr>
@@ -10837,7 +10837,7 @@
           <p:cNvPr id="36" name="TextBox 35">
             <a:extLst>
               <a:ext uri="{FF2B5EF4-FFF2-40B4-BE49-F238E27FC236}">
-                <a16:creationId xmlns:a16="http://schemas.microsoft.com/office/drawing/2014/main" id="{CAA09D46-A711-B9BD-0EDD-3EA1812FFDE4}"/>
+                <a16:creationId xmlns:a16="http://schemas.microsoft.com/office/drawing/2014/main" id="{32A94A97-8A1B-8B7F-9FED-0A09E850C8DC}"/>
               </a:ext>
             </a:extLst>
           </p:cNvPr>
@@ -10875,7 +10875,7 @@
                 </a:solidFill>
                 <a:latin typeface="Arial" panose="020B0604020202020204" pitchFamily="34" charset="0"/>
               </a:rPr>
-              <a:t>Stack: </a:t>
+              <a:t>Planned stack: </a:t>
             </a:r>
             <a:r>
               <a:rPr lang="en-IN" sz="950">
@@ -10884,7 +10884,7 @@
                 </a:solidFill>
                 <a:latin typeface="Arial" panose="020B0604020202020204" pitchFamily="34" charset="0"/>
               </a:rPr>
-              <a:t>Kotlin · CameraX/Camera2 · OpenCV · Android Keystore + key attestation · SQLCipher · RFC 8785 JSON · ECDSA P-256 · Spring Boot · PostgreSQL · S3 object lock · Parichay / Class 3 DSC</a:t>
+              <a:t>Kotlin · CameraX/Camera2 · OpenCV · Android Keystore + attestation · SQLCipher · RFC 8785 JSON · ECDSA P-256 · Spring Boot · PostgreSQL · S3. Prototype today: Python, OpenCV, SQLite.</a:t>
             </a:r>
           </a:p>
           <a:p>
@@ -10928,7 +10928,7 @@
           <p:cNvPr id="38" name="Picture 37">
             <a:extLst>
               <a:ext uri="{FF2B5EF4-FFF2-40B4-BE49-F238E27FC236}">
-                <a16:creationId xmlns:a16="http://schemas.microsoft.com/office/drawing/2014/main" id="{BC511F99-B506-9042-F0D2-C0B698A5A7B3}"/>
+                <a16:creationId xmlns:a16="http://schemas.microsoft.com/office/drawing/2014/main" id="{5A262DAA-8197-2D6A-5E1D-FEB0F915F1CA}"/>
               </a:ext>
             </a:extLst>
           </p:cNvPr>
@@ -10963,7 +10963,7 @@
           <p:cNvPr id="39" name="TextBox 38">
             <a:extLst>
               <a:ext uri="{FF2B5EF4-FFF2-40B4-BE49-F238E27FC236}">
-                <a16:creationId xmlns:a16="http://schemas.microsoft.com/office/drawing/2014/main" id="{A8B55D54-E672-6B7F-3559-9F1ED41C7F0A}"/>
+                <a16:creationId xmlns:a16="http://schemas.microsoft.com/office/drawing/2014/main" id="{80938612-B6CA-E3A9-4275-DA4FFB839E9A}"/>
               </a:ext>
             </a:extLst>
           </p:cNvPr>
@@ -11001,7 +11001,7 @@
                 </a:solidFill>
                 <a:latin typeface="Arial" panose="020B0604020202020204" pitchFamily="34" charset="0"/>
               </a:rPr>
-              <a:t>Reference card v2 (printable, 150 x 105 mm): 24 colour patches, 4 markers, SAMPLE and BLANK zones. The engine finds it in the print file.</a:t>
+              <a:t>Reference card v2 (printable, 150 x 105 mm). Tested on the print file; photos of real prints on real phones come next.</a:t>
             </a:r>
             <a:endParaRPr lang="en-IN" sz="850" i="1">
               <a:solidFill>
@@ -11017,7 +11017,7 @@
           <p:cNvPr id="40" name="TextBox 39">
             <a:extLst>
               <a:ext uri="{FF2B5EF4-FFF2-40B4-BE49-F238E27FC236}">
-                <a16:creationId xmlns:a16="http://schemas.microsoft.com/office/drawing/2014/main" id="{ECA1D5DC-D8D0-947F-E1E7-4BA1EE8634F0}"/>
+                <a16:creationId xmlns:a16="http://schemas.microsoft.com/office/drawing/2014/main" id="{CBF2A993-4AC0-E1C5-D9FD-427CFBA879D5}"/>
               </a:ext>
             </a:extLst>
           </p:cNvPr>
@@ -11065,7 +11065,7 @@
           <p:cNvPr id="41" name="Rectangle: Rounded Corners 40">
             <a:extLst>
               <a:ext uri="{FF2B5EF4-FFF2-40B4-BE49-F238E27FC236}">
-                <a16:creationId xmlns:a16="http://schemas.microsoft.com/office/drawing/2014/main" id="{4C6C2C81-403B-40C4-E1D6-E34A011DD1C2}"/>
+                <a16:creationId xmlns:a16="http://schemas.microsoft.com/office/drawing/2014/main" id="{6F9C6B30-4397-C5FF-1E4C-AEB1D52098B6}"/>
               </a:ext>
             </a:extLst>
           </p:cNvPr>
@@ -11158,7 +11158,7 @@
           <p:cNvPr id="42" name="TextBox 41">
             <a:extLst>
               <a:ext uri="{FF2B5EF4-FFF2-40B4-BE49-F238E27FC236}">
-                <a16:creationId xmlns:a16="http://schemas.microsoft.com/office/drawing/2014/main" id="{E33A0892-0AEA-2A43-C8F4-1AD557C47CF4}"/>
+                <a16:creationId xmlns:a16="http://schemas.microsoft.com/office/drawing/2014/main" id="{6FCFDF3A-76D5-A8B1-1E17-357270FA9513}"/>
               </a:ext>
             </a:extLst>
           </p:cNvPr>
@@ -11196,7 +11196,7 @@
                 </a:solidFill>
                 <a:latin typeface="Arial" panose="020B0604020202020204" pitchFamily="34" charset="0"/>
               </a:rPr>
-              <a:t>Reference implementation + one-command demo, 47 tests: github.com/Harshith029/fieldtest-recorder</a:t>
+              <a:t>Python reference prototype + one-command demo, 47 tests: github.com/Harshith029/fieldtest-recorder</a:t>
             </a:r>
             <a:endParaRPr lang="en-IN" sz="950">
               <a:solidFill>
@@ -11212,7 +11212,7 @@
           <p:cNvPr id="43" name="Rectangle: Rounded Corners 42">
             <a:extLst>
               <a:ext uri="{FF2B5EF4-FFF2-40B4-BE49-F238E27FC236}">
-                <a16:creationId xmlns:a16="http://schemas.microsoft.com/office/drawing/2014/main" id="{52B3CC9D-B849-DC96-BD6A-A0A1BE903304}"/>
+                <a16:creationId xmlns:a16="http://schemas.microsoft.com/office/drawing/2014/main" id="{564E24C1-3FD9-A9BA-F895-64F9EBDE80C6}"/>
               </a:ext>
             </a:extLst>
           </p:cNvPr>
@@ -11305,7 +11305,7 @@
           <p:cNvPr id="44" name="TextBox 43">
             <a:extLst>
               <a:ext uri="{FF2B5EF4-FFF2-40B4-BE49-F238E27FC236}">
-                <a16:creationId xmlns:a16="http://schemas.microsoft.com/office/drawing/2014/main" id="{1B3F819E-85A4-44A4-5C60-D9926E028C28}"/>
+                <a16:creationId xmlns:a16="http://schemas.microsoft.com/office/drawing/2014/main" id="{089A12C7-7EDD-2D29-94C5-AA7C0A10C19E}"/>
               </a:ext>
             </a:extLst>
           </p:cNvPr>
@@ -11343,7 +11343,7 @@
                 </a:solidFill>
                 <a:latin typeface="Arial" panose="020B0604020202020204" pitchFamily="34" charset="0"/>
               </a:rPr>
-              <a:t>17 experiments with 95% intervals (colour, liveness, night light, amount)</a:t>
+              <a:t>Colour, liveness, night-light and amount experiments on simulated photos</a:t>
             </a:r>
             <a:endParaRPr lang="en-IN" sz="950">
               <a:solidFill>
@@ -11359,7 +11359,7 @@
           <p:cNvPr id="45" name="Rectangle: Rounded Corners 44">
             <a:extLst>
               <a:ext uri="{FF2B5EF4-FFF2-40B4-BE49-F238E27FC236}">
-                <a16:creationId xmlns:a16="http://schemas.microsoft.com/office/drawing/2014/main" id="{77C8A9AF-0EF6-E71D-315B-ADF02B81F763}"/>
+                <a16:creationId xmlns:a16="http://schemas.microsoft.com/office/drawing/2014/main" id="{676D007D-C0C5-9668-E766-1624C3BC4909}"/>
               </a:ext>
             </a:extLst>
           </p:cNvPr>
@@ -11452,7 +11452,7 @@
           <p:cNvPr id="46" name="TextBox 45">
             <a:extLst>
               <a:ext uri="{FF2B5EF4-FFF2-40B4-BE49-F238E27FC236}">
-                <a16:creationId xmlns:a16="http://schemas.microsoft.com/office/drawing/2014/main" id="{71145CA6-0F7D-14D9-42E7-38668F84D8FF}"/>
+                <a16:creationId xmlns:a16="http://schemas.microsoft.com/office/drawing/2014/main" id="{62105F91-AAB1-35F2-740A-14A25972F8BE}"/>
               </a:ext>
             </a:extLst>
           </p:cNvPr>
@@ -11490,7 +11490,7 @@
                 </a:solidFill>
                 <a:latin typeface="Arial" panose="020B0604020202020204" pitchFamily="34" charset="0"/>
               </a:rPr>
-              <a:t>Android app (Kotlin) on the same test vectors</a:t>
+              <a:t>Android app; real-phone and real-reaction validation</a:t>
             </a:r>
             <a:endParaRPr lang="en-IN" sz="950">
               <a:solidFill>
@@ -11882,7 +11882,7 @@
           <p:cNvPr id="2" name="Rectangle: Rounded Corners 1">
             <a:extLst>
               <a:ext uri="{FF2B5EF4-FFF2-40B4-BE49-F238E27FC236}">
-                <a16:creationId xmlns:a16="http://schemas.microsoft.com/office/drawing/2014/main" id="{DC9513D2-F87F-4E79-453B-D3BA96302430}"/>
+                <a16:creationId xmlns:a16="http://schemas.microsoft.com/office/drawing/2014/main" id="{D5F84EA6-4107-E65B-1949-DE5857E81A7D}"/>
               </a:ext>
             </a:extLst>
           </p:cNvPr>
@@ -11960,7 +11960,7 @@
           <p:cNvPr id="3" name="TextBox 2">
             <a:extLst>
               <a:ext uri="{FF2B5EF4-FFF2-40B4-BE49-F238E27FC236}">
-                <a16:creationId xmlns:a16="http://schemas.microsoft.com/office/drawing/2014/main" id="{A3C7CFAF-7D9E-F6FD-E454-E44AB2CE14DB}"/>
+                <a16:creationId xmlns:a16="http://schemas.microsoft.com/office/drawing/2014/main" id="{6AE8ADCA-1190-98F3-AE4E-E97DF899B3FC}"/>
               </a:ext>
             </a:extLst>
           </p:cNvPr>
@@ -12008,7 +12008,7 @@
           <p:cNvPr id="4" name="TextBox 3">
             <a:extLst>
               <a:ext uri="{FF2B5EF4-FFF2-40B4-BE49-F238E27FC236}">
-                <a16:creationId xmlns:a16="http://schemas.microsoft.com/office/drawing/2014/main" id="{39C3DE08-440D-092E-1F9E-BB8F29FC62C6}"/>
+                <a16:creationId xmlns:a16="http://schemas.microsoft.com/office/drawing/2014/main" id="{7BEF55FB-3F12-32D6-E38A-63543516A5AB}"/>
               </a:ext>
             </a:extLst>
           </p:cNvPr>
@@ -12046,7 +12046,7 @@
                 </a:solidFill>
                 <a:latin typeface="Arial" panose="020B0604020202020204" pitchFamily="34" charset="0"/>
               </a:rPr>
-              <a:t>tampering attacks caught, incl. insider-admin forgery and deleted records</a:t>
+              <a:t>of our tampering attacks caught by the verifier, incl. insider-admin forgery and deleted records</a:t>
             </a:r>
             <a:endParaRPr lang="en-IN" sz="950">
               <a:solidFill>
@@ -12062,7 +12062,7 @@
           <p:cNvPr id="5" name="Rectangle: Rounded Corners 4">
             <a:extLst>
               <a:ext uri="{FF2B5EF4-FFF2-40B4-BE49-F238E27FC236}">
-                <a16:creationId xmlns:a16="http://schemas.microsoft.com/office/drawing/2014/main" id="{0532422C-9537-B3ED-5661-5FF50D0A3EA7}"/>
+                <a16:creationId xmlns:a16="http://schemas.microsoft.com/office/drawing/2014/main" id="{F95F90B6-02FD-5700-F12C-9A6B29740D1C}"/>
               </a:ext>
             </a:extLst>
           </p:cNvPr>
@@ -12155,7 +12155,7 @@
           <p:cNvPr id="8" name="Rectangle: Rounded Corners 7">
             <a:extLst>
               <a:ext uri="{FF2B5EF4-FFF2-40B4-BE49-F238E27FC236}">
-                <a16:creationId xmlns:a16="http://schemas.microsoft.com/office/drawing/2014/main" id="{AAB7A9D4-0E10-EFEF-5DCE-30B818525B76}"/>
+                <a16:creationId xmlns:a16="http://schemas.microsoft.com/office/drawing/2014/main" id="{527CEB56-447E-F0A4-ED41-7670D8648CC4}"/>
               </a:ext>
             </a:extLst>
           </p:cNvPr>
@@ -12233,7 +12233,7 @@
           <p:cNvPr id="9" name="TextBox 8">
             <a:extLst>
               <a:ext uri="{FF2B5EF4-FFF2-40B4-BE49-F238E27FC236}">
-                <a16:creationId xmlns:a16="http://schemas.microsoft.com/office/drawing/2014/main" id="{2941F4E2-3040-5241-D9B4-724ABA0EDAD2}"/>
+                <a16:creationId xmlns:a16="http://schemas.microsoft.com/office/drawing/2014/main" id="{43FDD666-7551-1921-4F6C-0A48F044C193}"/>
               </a:ext>
             </a:extLst>
           </p:cNvPr>
@@ -12281,7 +12281,7 @@
           <p:cNvPr id="13" name="TextBox 12">
             <a:extLst>
               <a:ext uri="{FF2B5EF4-FFF2-40B4-BE49-F238E27FC236}">
-                <a16:creationId xmlns:a16="http://schemas.microsoft.com/office/drawing/2014/main" id="{B899C054-E921-0738-B2E4-4B7139563381}"/>
+                <a16:creationId xmlns:a16="http://schemas.microsoft.com/office/drawing/2014/main" id="{1D03BAB0-B7DC-EB30-2E16-8AA273136322}"/>
               </a:ext>
             </a:extLst>
           </p:cNvPr>
@@ -12319,7 +12319,7 @@
                 </a:solidFill>
                 <a:latin typeface="Arial" panose="020B0604020202020204" pitchFamily="34" charset="0"/>
               </a:rPr>
-              <a:t>sync and failure scenarios handled, incl. restore from an old backup</a:t>
+              <a:t>sync and failure scenarios handled by the reference sync protocol, incl. an old-backup restore</a:t>
             </a:r>
             <a:endParaRPr lang="en-IN" sz="950">
               <a:solidFill>
@@ -12335,7 +12335,7 @@
           <p:cNvPr id="14" name="Rectangle: Rounded Corners 13">
             <a:extLst>
               <a:ext uri="{FF2B5EF4-FFF2-40B4-BE49-F238E27FC236}">
-                <a16:creationId xmlns:a16="http://schemas.microsoft.com/office/drawing/2014/main" id="{E74EAE8A-DD1F-CE10-B458-F36786DC83D4}"/>
+                <a16:creationId xmlns:a16="http://schemas.microsoft.com/office/drawing/2014/main" id="{B8907FD4-5245-C9D2-3EB6-204F2FFFD921}"/>
               </a:ext>
             </a:extLst>
           </p:cNvPr>
@@ -12428,7 +12428,7 @@
           <p:cNvPr id="15" name="Rectangle: Rounded Corners 14">
             <a:extLst>
               <a:ext uri="{FF2B5EF4-FFF2-40B4-BE49-F238E27FC236}">
-                <a16:creationId xmlns:a16="http://schemas.microsoft.com/office/drawing/2014/main" id="{B06BF98B-6CB5-270B-A28B-81E9CF1769AC}"/>
+                <a16:creationId xmlns:a16="http://schemas.microsoft.com/office/drawing/2014/main" id="{A5C6A85D-B99A-FE35-4DD2-F4834E72A37B}"/>
               </a:ext>
             </a:extLst>
           </p:cNvPr>
@@ -12506,7 +12506,7 @@
           <p:cNvPr id="16" name="TextBox 15">
             <a:extLst>
               <a:ext uri="{FF2B5EF4-FFF2-40B4-BE49-F238E27FC236}">
-                <a16:creationId xmlns:a16="http://schemas.microsoft.com/office/drawing/2014/main" id="{838C9BC6-9172-E98D-3141-0003DAF52C2E}"/>
+                <a16:creationId xmlns:a16="http://schemas.microsoft.com/office/drawing/2014/main" id="{A10755C2-8CFC-4450-009E-DC2AA037F7EC}"/>
               </a:ext>
             </a:extLst>
           </p:cNvPr>
@@ -12554,7 +12554,7 @@
           <p:cNvPr id="17" name="TextBox 16">
             <a:extLst>
               <a:ext uri="{FF2B5EF4-FFF2-40B4-BE49-F238E27FC236}">
-                <a16:creationId xmlns:a16="http://schemas.microsoft.com/office/drawing/2014/main" id="{4F5D1CAB-2F9D-7763-2326-5F4C75085894}"/>
+                <a16:creationId xmlns:a16="http://schemas.microsoft.com/office/drawing/2014/main" id="{B1CD674F-A7A6-DFAF-A554-D2BC3EB11624}"/>
               </a:ext>
             </a:extLst>
           </p:cNvPr>
@@ -12592,7 +12592,7 @@
                 </a:solidFill>
                 <a:latin typeface="Arial" panose="020B0604020202020204" pitchFamily="34" charset="0"/>
               </a:rPr>
-              <a:t>false positives when the sample amount varies (single-point rule vs colour bands)</a:t>
+              <a:t>false positives as sample amount varies: our first single-point rule vs colour bands (published US colours)</a:t>
             </a:r>
             <a:endParaRPr lang="en-IN" sz="950">
               <a:solidFill>
@@ -12608,7 +12608,7 @@
           <p:cNvPr id="18" name="Rectangle: Rounded Corners 17">
             <a:extLst>
               <a:ext uri="{FF2B5EF4-FFF2-40B4-BE49-F238E27FC236}">
-                <a16:creationId xmlns:a16="http://schemas.microsoft.com/office/drawing/2014/main" id="{24E88AF3-ED19-23F5-3721-7D06D2D10CA1}"/>
+                <a16:creationId xmlns:a16="http://schemas.microsoft.com/office/drawing/2014/main" id="{E3DCFEBC-D3A1-964E-FFA2-7190E5CC70B5}"/>
               </a:ext>
             </a:extLst>
           </p:cNvPr>
@@ -12701,7 +12701,7 @@
           <p:cNvPr id="19" name="Rectangle: Rounded Corners 18">
             <a:extLst>
               <a:ext uri="{FF2B5EF4-FFF2-40B4-BE49-F238E27FC236}">
-                <a16:creationId xmlns:a16="http://schemas.microsoft.com/office/drawing/2014/main" id="{66AFAF75-11B7-0768-623D-ACFCDE24FDB4}"/>
+                <a16:creationId xmlns:a16="http://schemas.microsoft.com/office/drawing/2014/main" id="{7A63642E-6566-6894-BC29-8A54FAB2A201}"/>
               </a:ext>
             </a:extLst>
           </p:cNvPr>
@@ -12779,7 +12779,7 @@
           <p:cNvPr id="20" name="TextBox 19">
             <a:extLst>
               <a:ext uri="{FF2B5EF4-FFF2-40B4-BE49-F238E27FC236}">
-                <a16:creationId xmlns:a16="http://schemas.microsoft.com/office/drawing/2014/main" id="{FE23A8A7-CCE0-0D53-1883-6CF239E91BBB}"/>
+                <a16:creationId xmlns:a16="http://schemas.microsoft.com/office/drawing/2014/main" id="{F92B7F10-4E08-ABAA-719E-3619856B622D}"/>
               </a:ext>
             </a:extLst>
           </p:cNvPr>
@@ -12817,7 +12817,7 @@
                 </a:solidFill>
                 <a:latin typeface="Arial" panose="020B0604020202020204" pitchFamily="34" charset="0"/>
               </a:rPr>
-              <a:t>89%</a:t>
+              <a:t>≤ 1%</a:t>
             </a:r>
           </a:p>
         </p:txBody>
@@ -12827,7 +12827,7 @@
           <p:cNvPr id="21" name="TextBox 20">
             <a:extLst>
               <a:ext uri="{FF2B5EF4-FFF2-40B4-BE49-F238E27FC236}">
-                <a16:creationId xmlns:a16="http://schemas.microsoft.com/office/drawing/2014/main" id="{189EA790-F8AA-4103-B891-A25F832D8E3C}"/>
+                <a16:creationId xmlns:a16="http://schemas.microsoft.com/office/drawing/2014/main" id="{90ABAC3D-7A78-8228-B9C7-BF5ACE45A12B}"/>
               </a:ext>
             </a:extLst>
           </p:cNvPr>
@@ -12865,7 +12865,7 @@
                 </a:solidFill>
                 <a:latin typeface="Arial" panose="020B0604020202020204" pitchFamily="34" charset="0"/>
               </a:rPr>
-              <a:t>NCB-kit chart outcomes read correctly, 1.7% wrong, rest inconclusive</a:t>
+              <a:t>false-positive target for real-kit validation: 1,296 captures, 3 sample amounts, 95% confidence</a:t>
             </a:r>
             <a:endParaRPr lang="en-IN" sz="950">
               <a:solidFill>
@@ -12881,7 +12881,7 @@
           <p:cNvPr id="22" name="Rectangle: Rounded Corners 21">
             <a:extLst>
               <a:ext uri="{FF2B5EF4-FFF2-40B4-BE49-F238E27FC236}">
-                <a16:creationId xmlns:a16="http://schemas.microsoft.com/office/drawing/2014/main" id="{9F5EA29A-8C0E-2485-188C-754D54C3DB07}"/>
+                <a16:creationId xmlns:a16="http://schemas.microsoft.com/office/drawing/2014/main" id="{78ECCE67-FC73-0618-DCC8-B838C6C83FAF}"/>
               </a:ext>
             </a:extLst>
           </p:cNvPr>
@@ -12890,8 +12890,8 @@
         </p:nvSpPr>
         <p:spPr>
           <a:xfrm>
-            <a:off x="11099800" y="1295400"/>
-            <a:ext cx="609600" cy="139700"/>
+            <a:off x="11353800" y="1295400"/>
+            <a:ext cx="355600" cy="139700"/>
           </a:xfrm>
           <a:prstGeom prst="roundRect">
             <a:avLst>
@@ -12899,7 +12899,7 @@
             </a:avLst>
           </a:prstGeom>
           <a:solidFill>
-            <a:srgbClr val="C55A11"/>
+            <a:srgbClr val="7F7F7F"/>
           </a:solidFill>
           <a:ln w="9525" cap="flat" cmpd="sng" algn="ctr">
             <a:noFill/>
@@ -12964,7 +12964,7 @@
                 </a:solidFill>
                 <a:latin typeface="Arial" panose="020B0604020202020204" pitchFamily="34" charset="0"/>
               </a:rPr>
-              <a:t>SIMULATED</a:t>
+              <a:t>NEXT</a:t>
             </a:r>
           </a:p>
         </p:txBody>
@@ -12974,7 +12974,7 @@
           <p:cNvPr id="23" name="TextBox 22">
             <a:extLst>
               <a:ext uri="{FF2B5EF4-FFF2-40B4-BE49-F238E27FC236}">
-                <a16:creationId xmlns:a16="http://schemas.microsoft.com/office/drawing/2014/main" id="{0007E118-9EFA-C4C2-CBA7-066A137141CE}"/>
+                <a16:creationId xmlns:a16="http://schemas.microsoft.com/office/drawing/2014/main" id="{E8A40919-FC8E-5CE4-2675-FFC8BE1CAA47}"/>
               </a:ext>
             </a:extLst>
           </p:cNvPr>
@@ -13028,7 +13028,7 @@
           <p:cNvPr id="24" name="Table 23">
             <a:extLst>
               <a:ext uri="{FF2B5EF4-FFF2-40B4-BE49-F238E27FC236}">
-                <a16:creationId xmlns:a16="http://schemas.microsoft.com/office/drawing/2014/main" id="{56399D97-A7FD-59A3-E44B-56E821AA52A0}"/>
+                <a16:creationId xmlns:a16="http://schemas.microsoft.com/office/drawing/2014/main" id="{014C0EE7-B1FA-30BF-ED7F-D6B5F0AB9875}"/>
               </a:ext>
             </a:extLst>
           </p:cNvPr>
@@ -13038,7 +13038,7 @@
           <p:nvPr>
             <p:extLst>
               <p:ext uri="{D42A27DB-BD31-4B8C-83A1-F6EECF244321}">
-                <p14:modId xmlns:p14="http://schemas.microsoft.com/office/powerpoint/2010/main" val="2249987201"/>
+                <p14:modId xmlns:p14="http://schemas.microsoft.com/office/powerpoint/2010/main" val="1759664214"/>
               </p:ext>
             </p:extLst>
           </p:nvPr>
@@ -13057,14 +13057,14 @@
                 <a:gridCol w="2540000">
                   <a:extLst>
                     <a:ext uri="{9D8B030D-6E8A-4147-A177-3AD203B41FA5}">
-                      <a16:colId xmlns:a16="http://schemas.microsoft.com/office/drawing/2014/main" val="3749151646"/>
+                      <a16:colId xmlns:a16="http://schemas.microsoft.com/office/drawing/2014/main" val="1824592745"/>
                     </a:ext>
                   </a:extLst>
                 </a:gridCol>
                 <a:gridCol w="5080000">
                   <a:extLst>
                     <a:ext uri="{9D8B030D-6E8A-4147-A177-3AD203B41FA5}">
-                      <a16:colId xmlns:a16="http://schemas.microsoft.com/office/drawing/2014/main" val="1568917766"/>
+                      <a16:colId xmlns:a16="http://schemas.microsoft.com/office/drawing/2014/main" val="1184983447"/>
                     </a:ext>
                   </a:extLst>
                 </a:gridCol>
@@ -13142,7 +13142,7 @@
                 </a:tc>
                 <a:extLst>
                   <a:ext uri="{0D108BD9-81ED-4DB2-BD59-A6C34878D82A}">
-                    <a16:rowId xmlns:a16="http://schemas.microsoft.com/office/drawing/2014/main" val="1095139157"/>
+                    <a16:rowId xmlns:a16="http://schemas.microsoft.com/office/drawing/2014/main" val="1080336754"/>
                   </a:ext>
                 </a:extLst>
               </a:tr>
@@ -13231,7 +13231,7 @@
                 </a:tc>
                 <a:extLst>
                   <a:ext uri="{0D108BD9-81ED-4DB2-BD59-A6C34878D82A}">
-                    <a16:rowId xmlns:a16="http://schemas.microsoft.com/office/drawing/2014/main" val="2535956663"/>
+                    <a16:rowId xmlns:a16="http://schemas.microsoft.com/office/drawing/2014/main" val="3539975629"/>
                   </a:ext>
                 </a:extLst>
               </a:tr>
@@ -13302,7 +13302,7 @@
                           </a:solidFill>
                           <a:latin typeface="Arial" panose="020B0604020202020204" pitchFamily="34" charset="0"/>
                         </a:rPr>
-                        <a:t>Reference card + RAW capture; bad-light gate; flash/no-flash night mode; say "inconclusive" rather than guess</a:t>
+                        <a:t>Reference card + RAW capture and a bad-light gate (prototype); say "inconclusive" rather than guess; flash/no-flash night mode (simulated, not yet integrated)</a:t>
                       </a:r>
                       <a:endParaRPr lang="en-IN" sz="1000" b="0" i="0">
                         <a:solidFill>
@@ -13320,7 +13320,7 @@
                 </a:tc>
                 <a:extLst>
                   <a:ext uri="{0D108BD9-81ED-4DB2-BD59-A6C34878D82A}">
-                    <a16:rowId xmlns:a16="http://schemas.microsoft.com/office/drawing/2014/main" val="527615016"/>
+                    <a16:rowId xmlns:a16="http://schemas.microsoft.com/office/drawing/2014/main" val="1392500454"/>
                   </a:ext>
                 </a:extLst>
               </a:tr>
@@ -13385,7 +13385,7 @@
                           </a:solidFill>
                           <a:latin typeface="Arial" panose="020B0604020202020204" pitchFamily="34" charset="0"/>
                         </a:rPr>
-                        <a:t>Capture starts before the reagent drop; liveness check; package label in frame; link to the s.105 video</a:t>
+                        <a:t>Planned: capture from before the reagent drop, liveness check (simulated so far), package label in frame, link to the s.105 video</a:t>
                       </a:r>
                       <a:endParaRPr lang="en-IN" sz="1000" b="0" i="0">
                         <a:solidFill>
@@ -13403,7 +13403,7 @@
                 </a:tc>
                 <a:extLst>
                   <a:ext uri="{0D108BD9-81ED-4DB2-BD59-A6C34878D82A}">
-                    <a16:rowId xmlns:a16="http://schemas.microsoft.com/office/drawing/2014/main" val="1775379985"/>
+                    <a16:rowId xmlns:a16="http://schemas.microsoft.com/office/drawing/2014/main" val="1801386879"/>
                   </a:ext>
                 </a:extLst>
               </a:tr>
@@ -13468,20 +13468,14 @@
                         <a:buNone/>
                       </a:pPr>
                       <a:r>
-                        <a:rPr lang="en-US" sz="1000" b="0" i="0">
+                        <a:rPr lang="en-IN" sz="1000" b="0" i="0">
                           <a:solidFill>
                             <a:srgbClr val="262626"/>
                           </a:solidFill>
                           <a:latin typeface="Arial" panose="020B0604020202020204" pitchFamily="34" charset="0"/>
                         </a:rPr>
-                        <a:t>Hardware keys + attestation; supervisor-signed binding; panchnama anchor; server never trusted</a:t>
+                        <a:t>Supervisor-signed binding, panchnama anchor, untrusted server (prototype); hardware keys + attestation (designed; checker prototyped)</a:t>
                       </a:r>
-                      <a:endParaRPr lang="en-IN" sz="1000" b="0" i="0">
-                        <a:solidFill>
-                          <a:srgbClr val="262626"/>
-                        </a:solidFill>
-                        <a:latin typeface="Arial" panose="020B0604020202020204" pitchFamily="34" charset="0"/>
-                      </a:endParaRPr>
                     </a:p>
                   </a:txBody>
                   <a:tcPr marL="76200" marR="76200" marT="76200" marB="76200">
@@ -13492,7 +13486,7 @@
                 </a:tc>
                 <a:extLst>
                   <a:ext uri="{0D108BD9-81ED-4DB2-BD59-A6C34878D82A}">
-                    <a16:rowId xmlns:a16="http://schemas.microsoft.com/office/drawing/2014/main" val="672183112"/>
+                    <a16:rowId xmlns:a16="http://schemas.microsoft.com/office/drawing/2014/main" val="1067411535"/>
                   </a:ext>
                 </a:extLst>
               </a:tr>
@@ -13563,7 +13557,7 @@
                           </a:solidFill>
                           <a:latin typeface="Arial" panose="020B0604020202020204" pitchFamily="34" charset="0"/>
                         </a:rPr>
-                        <a:t>File exports first; the engine ships as an SDK e-Sakshya can embed</a:t>
+                        <a:t>File exports first; the engine is designed as an SDK that e-Sakshya could embed</a:t>
                       </a:r>
                       <a:endParaRPr lang="en-IN" sz="1000" b="0" i="0">
                         <a:solidFill>
@@ -13581,7 +13575,7 @@
                 </a:tc>
                 <a:extLst>
                   <a:ext uri="{0D108BD9-81ED-4DB2-BD59-A6C34878D82A}">
-                    <a16:rowId xmlns:a16="http://schemas.microsoft.com/office/drawing/2014/main" val="2273122606"/>
+                    <a16:rowId xmlns:a16="http://schemas.microsoft.com/office/drawing/2014/main" val="3355753108"/>
                   </a:ext>
                 </a:extLst>
               </a:tr>
@@ -13594,7 +13588,7 @@
           <p:cNvPr id="25" name="Rectangle: Rounded Corners 24">
             <a:extLst>
               <a:ext uri="{FF2B5EF4-FFF2-40B4-BE49-F238E27FC236}">
-                <a16:creationId xmlns:a16="http://schemas.microsoft.com/office/drawing/2014/main" id="{452BC779-07F5-2312-9815-B66F28FE44C8}"/>
+                <a16:creationId xmlns:a16="http://schemas.microsoft.com/office/drawing/2014/main" id="{D5E829A5-10A4-87FE-FF31-66B1FAE7CC83}"/>
               </a:ext>
             </a:extLst>
           </p:cNvPr>
@@ -13672,7 +13666,7 @@
           <p:cNvPr id="26" name="TextBox 25">
             <a:extLst>
               <a:ext uri="{FF2B5EF4-FFF2-40B4-BE49-F238E27FC236}">
-                <a16:creationId xmlns:a16="http://schemas.microsoft.com/office/drawing/2014/main" id="{D65220DD-0814-F6E3-0851-B33A1B89F67D}"/>
+                <a16:creationId xmlns:a16="http://schemas.microsoft.com/office/drawing/2014/main" id="{F7D5B817-9A91-94EB-CC53-F989B06496E1}"/>
               </a:ext>
             </a:extLst>
           </p:cNvPr>
@@ -13720,7 +13714,7 @@
           <p:cNvPr id="27" name="TextBox 26">
             <a:extLst>
               <a:ext uri="{FF2B5EF4-FFF2-40B4-BE49-F238E27FC236}">
-                <a16:creationId xmlns:a16="http://schemas.microsoft.com/office/drawing/2014/main" id="{AF4AA334-CD0A-A3FF-F6C5-6CD18C89F09A}"/>
+                <a16:creationId xmlns:a16="http://schemas.microsoft.com/office/drawing/2014/main" id="{E135EF74-4CC0-7BBF-0614-94984987144B}"/>
               </a:ext>
             </a:extLst>
           </p:cNvPr>
@@ -13772,7 +13766,7 @@
                 </a:solidFill>
                 <a:latin typeface="Arial" panose="020B0604020202020204" pitchFamily="34" charset="0"/>
               </a:rPr>
-              <a:t>NCB already supplies the kit free; the only addition is a printed colour card per kit.</a:t>
+              <a:t>NCB already supplies the kit free; the additions are a printed colour card per kit and a few reagent drops for the blank well.</a:t>
             </a:r>
           </a:p>
           <a:p>
@@ -13796,7 +13790,7 @@
                 </a:solidFill>
                 <a:latin typeface="Arial" panose="020B0604020202020204" pitchFamily="34" charset="0"/>
               </a:rPr>
-              <a:t>Small infrastructure: </a:t>
+              <a:t>Small infrastructure (estimate): </a:t>
             </a:r>
             <a:r>
               <a:rPr lang="en-US" sz="1050">
@@ -13829,7 +13823,7 @@
                 </a:solidFill>
                 <a:latin typeface="Arial" panose="020B0604020202020204" pitchFamily="34" charset="0"/>
               </a:rPr>
-              <a:t>Government-owned: </a:t>
+              <a:t>Government-owned by design: </a:t>
             </a:r>
             <a:r>
               <a:rPr lang="en-US" sz="1050">
@@ -13838,7 +13832,7 @@
                 </a:solidFill>
                 <a:latin typeface="Arial" panose="020B0604020202020204" pitchFamily="34" charset="0"/>
               </a:rPr>
-              <a:t>NCB holds the signing keys, the colour standard and the code; open formats, no licences.</a:t>
+              <a:t>NCB would hold the signing keys, the colour standard and the code; open formats, no licences.</a:t>
             </a:r>
           </a:p>
           <a:p>
@@ -13904,7 +13898,7 @@
                 </a:solidFill>
                 <a:latin typeface="Arial" panose="020B0604020202020204" pitchFamily="34" charset="0"/>
               </a:rPr>
-              <a:t>every number here is labelled proven in code or simulated. Real-phone and real-kit numbers come next.</a:t>
+              <a:t>every number is labelled proven in code, simulated or next. No real phone photo or real reaction has been tested yet; that is the next stage.</a:t>
             </a:r>
             <a:endParaRPr lang="en-IN" sz="1050">
               <a:solidFill>
@@ -14301,7 +14295,7 @@
           <p:cNvPr id="2" name="TextBox 1">
             <a:extLst>
               <a:ext uri="{FF2B5EF4-FFF2-40B4-BE49-F238E27FC236}">
-                <a16:creationId xmlns:a16="http://schemas.microsoft.com/office/drawing/2014/main" id="{8CC15AF6-07D9-8BF5-AF32-C1E05D39E25D}"/>
+                <a16:creationId xmlns:a16="http://schemas.microsoft.com/office/drawing/2014/main" id="{A77B364C-E3B5-28A9-A618-1E2C8CFB44AA}"/>
               </a:ext>
             </a:extLst>
           </p:cNvPr>
@@ -14349,7 +14343,7 @@
           <p:cNvPr id="3" name="Oval 2">
             <a:extLst>
               <a:ext uri="{FF2B5EF4-FFF2-40B4-BE49-F238E27FC236}">
-                <a16:creationId xmlns:a16="http://schemas.microsoft.com/office/drawing/2014/main" id="{F5E7CFCA-B723-B315-A198-169CC6B6CE31}"/>
+                <a16:creationId xmlns:a16="http://schemas.microsoft.com/office/drawing/2014/main" id="{68694D9D-B1D9-4C2A-60CA-1858DEA03608}"/>
               </a:ext>
             </a:extLst>
           </p:cNvPr>
@@ -14440,7 +14434,7 @@
           <p:cNvPr id="4" name="TextBox 3">
             <a:extLst>
               <a:ext uri="{FF2B5EF4-FFF2-40B4-BE49-F238E27FC236}">
-                <a16:creationId xmlns:a16="http://schemas.microsoft.com/office/drawing/2014/main" id="{F13868C2-F1DD-6DA5-C854-8A09D98F4B73}"/>
+                <a16:creationId xmlns:a16="http://schemas.microsoft.com/office/drawing/2014/main" id="{DD63E0B7-DB40-6C9E-1BD2-A2C0E1C0D857}"/>
               </a:ext>
             </a:extLst>
           </p:cNvPr>
@@ -14497,7 +14491,7 @@
                 </a:solidFill>
                 <a:latin typeface="Arial" panose="020B0604020202020204" pitchFamily="34" charset="0"/>
               </a:rPr>
-              <a:t>A guided test, a Field Test Memo and Form-1 item 5 filled in, and a record that shows good-faith action.</a:t>
+              <a:t>A guided test and a signed record that shows good-faith action; planned: Field Test Memo and Form-1 item 5 filled in.</a:t>
             </a:r>
             <a:endParaRPr lang="en-IN" sz="950">
               <a:solidFill>
@@ -14513,7 +14507,7 @@
           <p:cNvPr id="5" name="Oval 4">
             <a:extLst>
               <a:ext uri="{FF2B5EF4-FFF2-40B4-BE49-F238E27FC236}">
-                <a16:creationId xmlns:a16="http://schemas.microsoft.com/office/drawing/2014/main" id="{8002A58A-8F67-2C29-1885-027E823BD396}"/>
+                <a16:creationId xmlns:a16="http://schemas.microsoft.com/office/drawing/2014/main" id="{FF85240F-C27A-B169-6AD1-CBA0F36562D6}"/>
               </a:ext>
             </a:extLst>
           </p:cNvPr>
@@ -14604,7 +14598,7 @@
           <p:cNvPr id="8" name="TextBox 7">
             <a:extLst>
               <a:ext uri="{FF2B5EF4-FFF2-40B4-BE49-F238E27FC236}">
-                <a16:creationId xmlns:a16="http://schemas.microsoft.com/office/drawing/2014/main" id="{3AC3740F-B513-F117-CE35-A87838A7A304}"/>
+                <a16:creationId xmlns:a16="http://schemas.microsoft.com/office/drawing/2014/main" id="{09818008-E663-7234-4109-FD7CF4B511E4}"/>
               </a:ext>
             </a:extLst>
           </p:cNvPr>
@@ -14661,7 +14655,7 @@
                 </a:solidFill>
                 <a:latin typeface="Arial" panose="020B0604020202020204" pitchFamily="34" charset="0"/>
               </a:rPr>
-              <a:t>Checkable evidence for remand and bail; a Rule 10(2) grouping check before sampling; the lab result linked back.</a:t>
+              <a:t>Checkable records for remand and bail; planned: a Rule 10(2) grouping check and the lab result linked back.</a:t>
             </a:r>
             <a:endParaRPr lang="en-IN" sz="950">
               <a:solidFill>
@@ -14677,7 +14671,7 @@
           <p:cNvPr id="9" name="Oval 8">
             <a:extLst>
               <a:ext uri="{FF2B5EF4-FFF2-40B4-BE49-F238E27FC236}">
-                <a16:creationId xmlns:a16="http://schemas.microsoft.com/office/drawing/2014/main" id="{892B478F-AC5D-811F-C374-97BFBAD2B270}"/>
+                <a16:creationId xmlns:a16="http://schemas.microsoft.com/office/drawing/2014/main" id="{173F6C4D-8E45-F635-2031-41D4D2CE371F}"/>
               </a:ext>
             </a:extLst>
           </p:cNvPr>
@@ -14768,7 +14762,7 @@
           <p:cNvPr id="13" name="TextBox 12">
             <a:extLst>
               <a:ext uri="{FF2B5EF4-FFF2-40B4-BE49-F238E27FC236}">
-                <a16:creationId xmlns:a16="http://schemas.microsoft.com/office/drawing/2014/main" id="{91FD7D3A-C16B-EBBE-81EE-CDEE3333D60E}"/>
+                <a16:creationId xmlns:a16="http://schemas.microsoft.com/office/drawing/2014/main" id="{AB133137-87A7-EE21-869C-1AC8EA577539}"/>
               </a:ext>
             </a:extLst>
           </p:cNvPr>
@@ -14841,7 +14835,7 @@
           <p:cNvPr id="14" name="Oval 13">
             <a:extLst>
               <a:ext uri="{FF2B5EF4-FFF2-40B4-BE49-F238E27FC236}">
-                <a16:creationId xmlns:a16="http://schemas.microsoft.com/office/drawing/2014/main" id="{1874BDB2-634D-44D5-E43D-1E50E9F95A55}"/>
+                <a16:creationId xmlns:a16="http://schemas.microsoft.com/office/drawing/2014/main" id="{C9E78B27-2974-4966-F725-F64C88497155}"/>
               </a:ext>
             </a:extLst>
           </p:cNvPr>
@@ -14932,7 +14926,7 @@
           <p:cNvPr id="15" name="TextBox 14">
             <a:extLst>
               <a:ext uri="{FF2B5EF4-FFF2-40B4-BE49-F238E27FC236}">
-                <a16:creationId xmlns:a16="http://schemas.microsoft.com/office/drawing/2014/main" id="{F1E9EDEB-8CF3-18F5-DA3E-C604A8AACFEF}"/>
+                <a16:creationId xmlns:a16="http://schemas.microsoft.com/office/drawing/2014/main" id="{6064F864-3C3A-1090-A05B-661E4460EA2D}"/>
               </a:ext>
             </a:extLst>
           </p:cNvPr>
@@ -14989,7 +14983,7 @@
                 </a:solidFill>
                 <a:latin typeface="Arial" panose="020B0604020202020204" pitchFamily="34" charset="0"/>
               </a:rPr>
-              <a:t>India's first field-vs-lab accuracy data, per kit batch and per test.</a:t>
+              <a:t>Planned: field-vs-lab accuracy per kit batch and per test, from lab reports the IO already receives.</a:t>
             </a:r>
             <a:endParaRPr lang="en-IN" sz="950">
               <a:solidFill>
@@ -15005,7 +14999,7 @@
           <p:cNvPr id="16" name="TextBox 15">
             <a:extLst>
               <a:ext uri="{FF2B5EF4-FFF2-40B4-BE49-F238E27FC236}">
-                <a16:creationId xmlns:a16="http://schemas.microsoft.com/office/drawing/2014/main" id="{5F9E63B6-774E-47D9-7343-F04DF9623F6B}"/>
+                <a16:creationId xmlns:a16="http://schemas.microsoft.com/office/drawing/2014/main" id="{D922D117-773F-F11D-ABDB-67A1FCF25C76}"/>
               </a:ext>
             </a:extLst>
           </p:cNvPr>
@@ -15059,7 +15053,7 @@
           <p:cNvPr id="17" name="Table 16">
             <a:extLst>
               <a:ext uri="{FF2B5EF4-FFF2-40B4-BE49-F238E27FC236}">
-                <a16:creationId xmlns:a16="http://schemas.microsoft.com/office/drawing/2014/main" id="{4C23CD73-7C43-EDA3-0BFA-916434918C28}"/>
+                <a16:creationId xmlns:a16="http://schemas.microsoft.com/office/drawing/2014/main" id="{E95ED0DF-34FF-51FD-4069-34FEA5D22C68}"/>
               </a:ext>
             </a:extLst>
           </p:cNvPr>
@@ -15069,7 +15063,7 @@
           <p:nvPr>
             <p:extLst>
               <p:ext uri="{D42A27DB-BD31-4B8C-83A1-F6EECF244321}">
-                <p14:modId xmlns:p14="http://schemas.microsoft.com/office/powerpoint/2010/main" val="3929097878"/>
+                <p14:modId xmlns:p14="http://schemas.microsoft.com/office/powerpoint/2010/main" val="776735074"/>
               </p:ext>
             </p:extLst>
           </p:nvPr>
@@ -15088,14 +15082,14 @@
                 <a:gridCol w="2667000">
                   <a:extLst>
                     <a:ext uri="{9D8B030D-6E8A-4147-A177-3AD203B41FA5}">
-                      <a16:colId xmlns:a16="http://schemas.microsoft.com/office/drawing/2014/main" val="3881344347"/>
+                      <a16:colId xmlns:a16="http://schemas.microsoft.com/office/drawing/2014/main" val="3567713640"/>
                     </a:ext>
                   </a:extLst>
                 </a:gridCol>
                 <a:gridCol w="3403600">
                   <a:extLst>
                     <a:ext uri="{9D8B030D-6E8A-4147-A177-3AD203B41FA5}">
-                      <a16:colId xmlns:a16="http://schemas.microsoft.com/office/drawing/2014/main" val="490029604"/>
+                      <a16:colId xmlns:a16="http://schemas.microsoft.com/office/drawing/2014/main" val="3832311499"/>
                     </a:ext>
                   </a:extLst>
                 </a:gridCol>
@@ -15173,7 +15167,7 @@
                 </a:tc>
                 <a:extLst>
                   <a:ext uri="{0D108BD9-81ED-4DB2-BD59-A6C34878D82A}">
-                    <a16:rowId xmlns:a16="http://schemas.microsoft.com/office/drawing/2014/main" val="2250091493"/>
+                    <a16:rowId xmlns:a16="http://schemas.microsoft.com/office/drawing/2014/main" val="3846193769"/>
                   </a:ext>
                 </a:extLst>
               </a:tr>
@@ -15256,7 +15250,7 @@
                 </a:tc>
                 <a:extLst>
                   <a:ext uri="{0D108BD9-81ED-4DB2-BD59-A6C34878D82A}">
-                    <a16:rowId xmlns:a16="http://schemas.microsoft.com/office/drawing/2014/main" val="3070574747"/>
+                    <a16:rowId xmlns:a16="http://schemas.microsoft.com/office/drawing/2014/main" val="3830704223"/>
                   </a:ext>
                 </a:extLst>
               </a:tr>
@@ -15327,7 +15321,7 @@
                           </a:solidFill>
                           <a:latin typeface="Arial" panose="020B0604020202020204" pitchFamily="34" charset="0"/>
                         </a:rPr>
-                        <a:t>Photo + reading + every drug the colour is consistent with</a:t>
+                        <a:t>Photo + reading + every drug on the kit chart the colour fits</a:t>
                       </a:r>
                       <a:endParaRPr lang="en-IN" sz="950" b="1" i="0">
                         <a:solidFill>
@@ -15345,7 +15339,7 @@
                 </a:tc>
                 <a:extLst>
                   <a:ext uri="{0D108BD9-81ED-4DB2-BD59-A6C34878D82A}">
-                    <a16:rowId xmlns:a16="http://schemas.microsoft.com/office/drawing/2014/main" val="565309203"/>
+                    <a16:rowId xmlns:a16="http://schemas.microsoft.com/office/drawing/2014/main" val="1227537220"/>
                   </a:ext>
                 </a:extLst>
               </a:tr>
@@ -15434,7 +15428,7 @@
                 </a:tc>
                 <a:extLst>
                   <a:ext uri="{0D108BD9-81ED-4DB2-BD59-A6C34878D82A}">
-                    <a16:rowId xmlns:a16="http://schemas.microsoft.com/office/drawing/2014/main" val="3110662868"/>
+                    <a16:rowId xmlns:a16="http://schemas.microsoft.com/office/drawing/2014/main" val="1571225013"/>
                   </a:ext>
                 </a:extLst>
               </a:tr>
@@ -15523,7 +15517,7 @@
                 </a:tc>
                 <a:extLst>
                   <a:ext uri="{0D108BD9-81ED-4DB2-BD59-A6C34878D82A}">
-                    <a16:rowId xmlns:a16="http://schemas.microsoft.com/office/drawing/2014/main" val="3559228761"/>
+                    <a16:rowId xmlns:a16="http://schemas.microsoft.com/office/drawing/2014/main" val="351212170"/>
                   </a:ext>
                 </a:extLst>
               </a:tr>
@@ -15606,7 +15600,7 @@
                 </a:tc>
                 <a:extLst>
                   <a:ext uri="{0D108BD9-81ED-4DB2-BD59-A6C34878D82A}">
-                    <a16:rowId xmlns:a16="http://schemas.microsoft.com/office/drawing/2014/main" val="3418768884"/>
+                    <a16:rowId xmlns:a16="http://schemas.microsoft.com/office/drawing/2014/main" val="306858296"/>
                   </a:ext>
                 </a:extLst>
               </a:tr>
@@ -15671,7 +15665,7 @@
                           </a:solidFill>
                           <a:latin typeface="Arial" panose="020B0604020202020204" pitchFamily="34" charset="0"/>
                         </a:rPr>
-                        <a:t>Field result vs lab result, per kit batch</a:t>
+                        <a:t>Field result vs lab result, per kit batch (planned)</a:t>
                       </a:r>
                       <a:endParaRPr lang="en-IN" sz="950" b="1" i="0">
                         <a:solidFill>
@@ -15689,7 +15683,7 @@
                 </a:tc>
                 <a:extLst>
                   <a:ext uri="{0D108BD9-81ED-4DB2-BD59-A6C34878D82A}">
-                    <a16:rowId xmlns:a16="http://schemas.microsoft.com/office/drawing/2014/main" val="3085835276"/>
+                    <a16:rowId xmlns:a16="http://schemas.microsoft.com/office/drawing/2014/main" val="827024154"/>
                   </a:ext>
                 </a:extLst>
               </a:tr>
@@ -15702,7 +15696,7 @@
           <p:cNvPr id="18" name="Rectangle: Rounded Corners 17">
             <a:extLst>
               <a:ext uri="{FF2B5EF4-FFF2-40B4-BE49-F238E27FC236}">
-                <a16:creationId xmlns:a16="http://schemas.microsoft.com/office/drawing/2014/main" id="{CF5F0632-439A-5E9B-FA19-AC44C6AC5E69}"/>
+                <a16:creationId xmlns:a16="http://schemas.microsoft.com/office/drawing/2014/main" id="{36DF5E2A-5703-F00E-E703-D565BD9E135C}"/>
               </a:ext>
             </a:extLst>
           </p:cNvPr>
@@ -15770,7 +15764,7 @@
           <p:cNvPr id="19" name="TextBox 18">
             <a:extLst>
               <a:ext uri="{FF2B5EF4-FFF2-40B4-BE49-F238E27FC236}">
-                <a16:creationId xmlns:a16="http://schemas.microsoft.com/office/drawing/2014/main" id="{E944A1DE-27B6-A03D-9599-6AB249361E12}"/>
+                <a16:creationId xmlns:a16="http://schemas.microsoft.com/office/drawing/2014/main" id="{75C366C6-9F4F-F03B-42B0-7A97F17FB5E2}"/>
               </a:ext>
             </a:extLst>
           </p:cNvPr>
@@ -15836,7 +15830,7 @@
                 </a:solidFill>
                 <a:latin typeface="Arial" panose="020B0604020202020204" pitchFamily="34" charset="0"/>
               </a:rPr>
-              <a:t>police alleged commercial-quantity MDMA; the lab found methamphetamine in intermediate quantity (MDMA 0.5 g / 10 g vs methamphetamine 2 g / 50 g). Our record states only what the kit's colour supports, lists every drug that colour fits, and warns when they fall under different NDPS thresholds.</a:t>
+              <a:t>police alleged commercial-quantity MDMA; the lab found methamphetamine in intermediate quantity (MDMA 0.5 g / 10 g vs methamphetamine 2 g / 50 g). Our record states only what the kit's colour supports, lists every drug on the kit chart that the colour fits, and warns when they fall under different NDPS thresholds.</a:t>
             </a:r>
             <a:endParaRPr lang="en-IN" sz="950">
               <a:solidFill>
@@ -15852,7 +15846,7 @@
           <p:cNvPr id="20" name="Rectangle: Rounded Corners 19">
             <a:extLst>
               <a:ext uri="{FF2B5EF4-FFF2-40B4-BE49-F238E27FC236}">
-                <a16:creationId xmlns:a16="http://schemas.microsoft.com/office/drawing/2014/main" id="{9A3F9B0F-9B72-B3E5-C6B1-D708FAE93BE7}"/>
+                <a16:creationId xmlns:a16="http://schemas.microsoft.com/office/drawing/2014/main" id="{3EE04EBD-27C3-EF5F-9A29-BB02E545341C}"/>
               </a:ext>
             </a:extLst>
           </p:cNvPr>
@@ -15930,7 +15924,7 @@
           <p:cNvPr id="21" name="TextBox 20">
             <a:extLst>
               <a:ext uri="{FF2B5EF4-FFF2-40B4-BE49-F238E27FC236}">
-                <a16:creationId xmlns:a16="http://schemas.microsoft.com/office/drawing/2014/main" id="{788375B1-595E-AE6B-89D1-4F7D02429F49}"/>
+                <a16:creationId xmlns:a16="http://schemas.microsoft.com/office/drawing/2014/main" id="{311AEEE5-1263-CD90-CA28-3A1384860DA8}"/>
               </a:ext>
             </a:extLst>
           </p:cNvPr>
@@ -16003,7 +15997,7 @@
           <p:cNvPr id="22" name="TextBox 21">
             <a:extLst>
               <a:ext uri="{FF2B5EF4-FFF2-40B4-BE49-F238E27FC236}">
-                <a16:creationId xmlns:a16="http://schemas.microsoft.com/office/drawing/2014/main" id="{30D91862-3D4C-27A6-7E99-3704E8EDC40F}"/>
+                <a16:creationId xmlns:a16="http://schemas.microsoft.com/office/drawing/2014/main" id="{0EF0900E-FB18-D158-F5D4-8BD351C1D185}"/>
               </a:ext>
             </a:extLst>
           </p:cNvPr>
@@ -16076,7 +16070,7 @@
           <p:cNvPr id="23" name="TextBox 22">
             <a:extLst>
               <a:ext uri="{FF2B5EF4-FFF2-40B4-BE49-F238E27FC236}">
-                <a16:creationId xmlns:a16="http://schemas.microsoft.com/office/drawing/2014/main" id="{4A0A5F1A-9452-1B9A-16A4-BAC6DE7CD3A3}"/>
+                <a16:creationId xmlns:a16="http://schemas.microsoft.com/office/drawing/2014/main" id="{929C54EA-296F-C8B6-FAD7-EFB56F33B9DC}"/>
               </a:ext>
             </a:extLst>
           </p:cNvPr>
@@ -16133,7 +16127,7 @@
                 </a:solidFill>
                 <a:latin typeface="Arial" panose="020B0604020202020204" pitchFamily="34" charset="0"/>
               </a:rPr>
-              <a:t>Paperless records; no extra consumables beyond one printed card per kit.</a:t>
+              <a:t>Paperless records; the only extra consumables are a printed card per kit and blank-well reagent drops.</a:t>
             </a:r>
             <a:endParaRPr lang="en-IN" sz="1050">
               <a:solidFill>
@@ -16149,7 +16143,7 @@
           <p:cNvPr id="24" name="TextBox 23">
             <a:extLst>
               <a:ext uri="{FF2B5EF4-FFF2-40B4-BE49-F238E27FC236}">
-                <a16:creationId xmlns:a16="http://schemas.microsoft.com/office/drawing/2014/main" id="{4DEF190C-399D-9CF6-02BE-90CF61E21A17}"/>
+                <a16:creationId xmlns:a16="http://schemas.microsoft.com/office/drawing/2014/main" id="{AD363C72-2EEB-A0D9-DFFF-900630CCD2D7}"/>
               </a:ext>
             </a:extLst>
           </p:cNvPr>
@@ -16206,7 +16200,7 @@
                 </a:solidFill>
                 <a:latin typeface="Arial" panose="020B0604020202020204" pitchFamily="34" charset="0"/>
               </a:rPr>
-              <a:t>1,15,236 NDPS cases in 2022 (MHA); every package in every case gets a field test.</a:t>
+              <a:t>1,15,236 NDPS cases in 2022 (MHA); each seized package can get a recorded field test.</a:t>
             </a:r>
             <a:endParaRPr lang="en-IN" sz="1050">
               <a:solidFill>
@@ -16603,7 +16597,7 @@
           <p:cNvPr id="2" name="TextBox 1">
             <a:extLst>
               <a:ext uri="{FF2B5EF4-FFF2-40B4-BE49-F238E27FC236}">
-                <a16:creationId xmlns:a16="http://schemas.microsoft.com/office/drawing/2014/main" id="{6CBE8889-6335-9319-EBC0-1C2D5A5F7FB2}"/>
+                <a16:creationId xmlns:a16="http://schemas.microsoft.com/office/drawing/2014/main" id="{0E449284-7CCE-CB43-1F3C-078CC196CC63}"/>
               </a:ext>
             </a:extLst>
           </p:cNvPr>
@@ -16860,7 +16854,7 @@
           <p:cNvPr id="3" name="TextBox 2">
             <a:extLst>
               <a:ext uri="{FF2B5EF4-FFF2-40B4-BE49-F238E27FC236}">
-                <a16:creationId xmlns:a16="http://schemas.microsoft.com/office/drawing/2014/main" id="{6193301D-411E-09C7-D10C-0E02267046A3}"/>
+                <a16:creationId xmlns:a16="http://schemas.microsoft.com/office/drawing/2014/main" id="{F6BD9AB7-E5A8-D409-C502-77CBDE873D80}"/>
               </a:ext>
             </a:extLst>
           </p:cNvPr>
@@ -17111,7 +17105,7 @@
           <p:cNvPr id="4" name="Rectangle: Rounded Corners 3">
             <a:extLst>
               <a:ext uri="{FF2B5EF4-FFF2-40B4-BE49-F238E27FC236}">
-                <a16:creationId xmlns:a16="http://schemas.microsoft.com/office/drawing/2014/main" id="{613CACFE-B64F-1190-27F3-9C13595E4295}"/>
+                <a16:creationId xmlns:a16="http://schemas.microsoft.com/office/drawing/2014/main" id="{3B705E47-8601-D3CC-1DBD-4EC9D835B7F4}"/>
               </a:ext>
             </a:extLst>
           </p:cNvPr>
@@ -17189,7 +17183,7 @@
           <p:cNvPr id="5" name="TextBox 4">
             <a:extLst>
               <a:ext uri="{FF2B5EF4-FFF2-40B4-BE49-F238E27FC236}">
-                <a16:creationId xmlns:a16="http://schemas.microsoft.com/office/drawing/2014/main" id="{7A984EAA-1790-6756-CB97-48CECBCD900A}"/>
+                <a16:creationId xmlns:a16="http://schemas.microsoft.com/office/drawing/2014/main" id="{29792AE2-A709-AC70-1CE3-8EFDED023D08}"/>
               </a:ext>
             </a:extLst>
           </p:cNvPr>
@@ -17253,7 +17247,7 @@
           <p:cNvPr id="8" name="TextBox 7">
             <a:extLst>
               <a:ext uri="{FF2B5EF4-FFF2-40B4-BE49-F238E27FC236}">
-                <a16:creationId xmlns:a16="http://schemas.microsoft.com/office/drawing/2014/main" id="{51D415C7-2C4D-1A24-BD53-720C27DD21A5}"/>
+                <a16:creationId xmlns:a16="http://schemas.microsoft.com/office/drawing/2014/main" id="{0951DC25-4250-B104-C65F-0930890A8137}"/>
               </a:ext>
             </a:extLst>
           </p:cNvPr>
@@ -17296,7 +17290,7 @@
                 </a:solidFill>
                 <a:latin typeface="Arial" panose="020B0604020202020204" pitchFamily="34" charset="0"/>
               </a:rPr>
-              <a:t>Working reference implementation with a one-command demo and 47 automated tests: </a:t>
+              <a:t>Working Python reference prototype with a one-command demo and 47 automated tests: </a:t>
             </a:r>
             <a:r>
               <a:rPr lang="en-US" sz="1050">
@@ -17305,7 +17299,7 @@
                 </a:solidFill>
                 <a:latin typeface="Arial" panose="020B0604020202020204" pitchFamily="34" charset="0"/>
               </a:rPr>
-              <a:t>record format and offline verifier, colour engine, NCB kit protocol, searchable log, sync server. The Android app must match its outputs byte for byte.</a:t>
+              <a:t>record format and offline verifier, colour engine, NCB kit protocol, searchable log, sync protocol. Photos in the demo are simulated; the Android app must match its outputs.</a:t>
             </a:r>
           </a:p>
           <a:p>
@@ -17338,7 +17332,7 @@
                 </a:solidFill>
                 <a:latin typeface="Arial" panose="020B0604020202020204" pitchFamily="34" charset="0"/>
               </a:rPr>
-              <a:t>including 18 tampering attacks, 15 failure scenarios, sample-amount tests, night light and staged-sample detection.</a:t>
+              <a:t>including 18 tampering attacks and 15 failure scenarios (real code) and colour, sample-amount, night-light and staged-sample tests (simulated photos).</a:t>
             </a:r>
           </a:p>
           <a:p>
@@ -17362,7 +17356,7 @@
                 </a:solidFill>
                 <a:latin typeface="Arial" panose="020B0604020202020204" pitchFamily="34" charset="0"/>
               </a:rPr>
-              <a:t>An external review, re-checked claim by claim: </a:t>
+              <a:t>Reviewed adversarially, claim by claim: </a:t>
             </a:r>
             <a:r>
               <a:rPr lang="en-US" sz="1050">
@@ -17371,7 +17365,7 @@
                 </a:solidFill>
                 <a:latin typeface="Arial" panose="020B0604020202020204" pitchFamily="34" charset="0"/>
               </a:rPr>
-              <a:t>every confirmed defect was fixed and re-tested before this submission.</a:t>
+              <a:t>confirmed defects are either fixed and re-tested or listed openly in the repository's problem register.</a:t>
             </a:r>
           </a:p>
           <a:p>

</xml_diff>

<commit_message>
Deck slide 3: process-flow diagram of one package from seizure to court
Replaces the two component boxes with a single flow: pick test -> capture
-> read colour -> result (positive / no colour change / inconclusive, with
the flow-chart loop) -> sign and chain -> panchnama anchor -> offline
verify and server sync. Trust model and technologies kept as short lines.

Co-Authored-By: Claude Opus 5.5 <noreply@anthropic.com>
</commit_message>
<xml_diff>
--- a/docs/deck/SIH26231_Idea_Submission.pptx
+++ b/docs/deck/SIH26231_Idea_Submission.pptx
@@ -6164,7 +6164,7 @@
           <p:cNvPr id="2" name="TextBox 1">
             <a:extLst>
               <a:ext uri="{FF2B5EF4-FFF2-40B4-BE49-F238E27FC236}">
-                <a16:creationId xmlns:a16="http://schemas.microsoft.com/office/drawing/2014/main" id="{16E1323E-2F1A-3B7A-0DD6-233304EC9668}"/>
+                <a16:creationId xmlns:a16="http://schemas.microsoft.com/office/drawing/2014/main" id="{FE110FAD-3AF0-0728-9AE0-5368A995BEB8}"/>
               </a:ext>
             </a:extLst>
           </p:cNvPr>
@@ -6218,7 +6218,7 @@
           <p:cNvPr id="3" name="Rectangle: Rounded Corners 2">
             <a:extLst>
               <a:ext uri="{FF2B5EF4-FFF2-40B4-BE49-F238E27FC236}">
-                <a16:creationId xmlns:a16="http://schemas.microsoft.com/office/drawing/2014/main" id="{1DC7CAA6-40D7-A909-93B8-B603C2C02B78}"/>
+                <a16:creationId xmlns:a16="http://schemas.microsoft.com/office/drawing/2014/main" id="{31E4C81A-67A5-EAA4-A7FE-3B01AC74ADB8}"/>
               </a:ext>
             </a:extLst>
           </p:cNvPr>
@@ -6296,7 +6296,7 @@
           <p:cNvPr id="4" name="TextBox 3">
             <a:extLst>
               <a:ext uri="{FF2B5EF4-FFF2-40B4-BE49-F238E27FC236}">
-                <a16:creationId xmlns:a16="http://schemas.microsoft.com/office/drawing/2014/main" id="{4BABFEDE-A646-3FC8-6194-4F364F5612FD}"/>
+                <a16:creationId xmlns:a16="http://schemas.microsoft.com/office/drawing/2014/main" id="{B7C25CC3-4E32-D4C3-FFF6-8DC0A11AC911}"/>
               </a:ext>
             </a:extLst>
           </p:cNvPr>
@@ -6344,7 +6344,7 @@
           <p:cNvPr id="5" name="TextBox 4">
             <a:extLst>
               <a:ext uri="{FF2B5EF4-FFF2-40B4-BE49-F238E27FC236}">
-                <a16:creationId xmlns:a16="http://schemas.microsoft.com/office/drawing/2014/main" id="{15673AC9-AE34-DFE6-1D19-9C70BC22C028}"/>
+                <a16:creationId xmlns:a16="http://schemas.microsoft.com/office/drawing/2014/main" id="{92F117F0-AD0F-73A5-BA09-D9D62E51B793}"/>
               </a:ext>
             </a:extLst>
           </p:cNvPr>
@@ -6511,7 +6511,7 @@
           <p:cNvPr id="8" name="TextBox 7">
             <a:extLst>
               <a:ext uri="{FF2B5EF4-FFF2-40B4-BE49-F238E27FC236}">
-                <a16:creationId xmlns:a16="http://schemas.microsoft.com/office/drawing/2014/main" id="{7439658B-2655-80BB-B920-4C07D967E4A3}"/>
+                <a16:creationId xmlns:a16="http://schemas.microsoft.com/office/drawing/2014/main" id="{55ADEDFA-3118-D5B6-4DC4-2CE429393BCE}"/>
               </a:ext>
             </a:extLst>
           </p:cNvPr>
@@ -6565,7 +6565,7 @@
           <p:cNvPr id="12" name="Oval 11">
             <a:extLst>
               <a:ext uri="{FF2B5EF4-FFF2-40B4-BE49-F238E27FC236}">
-                <a16:creationId xmlns:a16="http://schemas.microsoft.com/office/drawing/2014/main" id="{D37E91DC-0FC3-2D64-655E-4DB3DB30FF77}"/>
+                <a16:creationId xmlns:a16="http://schemas.microsoft.com/office/drawing/2014/main" id="{10105FF9-9CB9-770B-45A0-7A51A8F6C9B3}"/>
               </a:ext>
             </a:extLst>
           </p:cNvPr>
@@ -6656,7 +6656,7 @@
           <p:cNvPr id="13" name="TextBox 12">
             <a:extLst>
               <a:ext uri="{FF2B5EF4-FFF2-40B4-BE49-F238E27FC236}">
-                <a16:creationId xmlns:a16="http://schemas.microsoft.com/office/drawing/2014/main" id="{D2872C9C-BB8F-F6AE-E945-0BB655F75310}"/>
+                <a16:creationId xmlns:a16="http://schemas.microsoft.com/office/drawing/2014/main" id="{90C322D7-D010-CC44-776D-A5E83C78C29E}"/>
               </a:ext>
             </a:extLst>
           </p:cNvPr>
@@ -6729,7 +6729,7 @@
           <p:cNvPr id="14" name="Straight Connector 13">
             <a:extLst>
               <a:ext uri="{FF2B5EF4-FFF2-40B4-BE49-F238E27FC236}">
-                <a16:creationId xmlns:a16="http://schemas.microsoft.com/office/drawing/2014/main" id="{ED640EC3-AA63-1D6B-4129-74940C694CE4}"/>
+                <a16:creationId xmlns:a16="http://schemas.microsoft.com/office/drawing/2014/main" id="{ECAAF628-DC64-EC56-C9E2-94B69A4FC722}"/>
               </a:ext>
             </a:extLst>
           </p:cNvPr>
@@ -6771,7 +6771,7 @@
           <p:cNvPr id="15" name="Oval 14">
             <a:extLst>
               <a:ext uri="{FF2B5EF4-FFF2-40B4-BE49-F238E27FC236}">
-                <a16:creationId xmlns:a16="http://schemas.microsoft.com/office/drawing/2014/main" id="{87D9B3C9-2C23-1589-7C27-5EDE20D01964}"/>
+                <a16:creationId xmlns:a16="http://schemas.microsoft.com/office/drawing/2014/main" id="{91D96589-488D-CDCD-C729-0398F4488ADA}"/>
               </a:ext>
             </a:extLst>
           </p:cNvPr>
@@ -6862,7 +6862,7 @@
           <p:cNvPr id="16" name="TextBox 15">
             <a:extLst>
               <a:ext uri="{FF2B5EF4-FFF2-40B4-BE49-F238E27FC236}">
-                <a16:creationId xmlns:a16="http://schemas.microsoft.com/office/drawing/2014/main" id="{CEF427EF-CC2E-2EB6-4837-035DE094A7B8}"/>
+                <a16:creationId xmlns:a16="http://schemas.microsoft.com/office/drawing/2014/main" id="{56C1A508-DC40-4C46-878E-21BB37418A0E}"/>
               </a:ext>
             </a:extLst>
           </p:cNvPr>
@@ -6935,7 +6935,7 @@
           <p:cNvPr id="17" name="Straight Connector 16">
             <a:extLst>
               <a:ext uri="{FF2B5EF4-FFF2-40B4-BE49-F238E27FC236}">
-                <a16:creationId xmlns:a16="http://schemas.microsoft.com/office/drawing/2014/main" id="{4AFB0530-3C58-0048-1A35-7CF0515C9C09}"/>
+                <a16:creationId xmlns:a16="http://schemas.microsoft.com/office/drawing/2014/main" id="{A6B0451D-ED59-D662-C1D4-985FFAC3C71C}"/>
               </a:ext>
             </a:extLst>
           </p:cNvPr>
@@ -6977,7 +6977,7 @@
           <p:cNvPr id="18" name="Oval 17">
             <a:extLst>
               <a:ext uri="{FF2B5EF4-FFF2-40B4-BE49-F238E27FC236}">
-                <a16:creationId xmlns:a16="http://schemas.microsoft.com/office/drawing/2014/main" id="{14B28911-06EA-2D83-9033-8FA0CD2FB23F}"/>
+                <a16:creationId xmlns:a16="http://schemas.microsoft.com/office/drawing/2014/main" id="{25B95CDC-C10A-867F-72FF-7D648F91CF8A}"/>
               </a:ext>
             </a:extLst>
           </p:cNvPr>
@@ -7068,7 +7068,7 @@
           <p:cNvPr id="19" name="TextBox 18">
             <a:extLst>
               <a:ext uri="{FF2B5EF4-FFF2-40B4-BE49-F238E27FC236}">
-                <a16:creationId xmlns:a16="http://schemas.microsoft.com/office/drawing/2014/main" id="{2AFF1D36-ED09-C125-A1AE-827E4419B3BA}"/>
+                <a16:creationId xmlns:a16="http://schemas.microsoft.com/office/drawing/2014/main" id="{A3B4E567-5598-76BB-B006-A12A04614210}"/>
               </a:ext>
             </a:extLst>
           </p:cNvPr>
@@ -7141,7 +7141,7 @@
           <p:cNvPr id="20" name="Straight Connector 19">
             <a:extLst>
               <a:ext uri="{FF2B5EF4-FFF2-40B4-BE49-F238E27FC236}">
-                <a16:creationId xmlns:a16="http://schemas.microsoft.com/office/drawing/2014/main" id="{8B453F8F-5102-5F38-C3EA-79C01F704C85}"/>
+                <a16:creationId xmlns:a16="http://schemas.microsoft.com/office/drawing/2014/main" id="{34B0D03E-F6CF-4029-0355-5853D0647BE3}"/>
               </a:ext>
             </a:extLst>
           </p:cNvPr>
@@ -7183,7 +7183,7 @@
           <p:cNvPr id="21" name="Oval 20">
             <a:extLst>
               <a:ext uri="{FF2B5EF4-FFF2-40B4-BE49-F238E27FC236}">
-                <a16:creationId xmlns:a16="http://schemas.microsoft.com/office/drawing/2014/main" id="{0AA9D019-AEA7-E05C-2675-ECDF77439863}"/>
+                <a16:creationId xmlns:a16="http://schemas.microsoft.com/office/drawing/2014/main" id="{22EA5B67-372E-CA9F-0300-BF0FD7645DFB}"/>
               </a:ext>
             </a:extLst>
           </p:cNvPr>
@@ -7274,7 +7274,7 @@
           <p:cNvPr id="22" name="TextBox 21">
             <a:extLst>
               <a:ext uri="{FF2B5EF4-FFF2-40B4-BE49-F238E27FC236}">
-                <a16:creationId xmlns:a16="http://schemas.microsoft.com/office/drawing/2014/main" id="{52B7C7AC-A53D-5470-3829-F8F2637B6C6E}"/>
+                <a16:creationId xmlns:a16="http://schemas.microsoft.com/office/drawing/2014/main" id="{F205F6CD-72A2-14DB-1121-D83369E8AD95}"/>
               </a:ext>
             </a:extLst>
           </p:cNvPr>
@@ -7347,7 +7347,7 @@
           <p:cNvPr id="23" name="Straight Connector 22">
             <a:extLst>
               <a:ext uri="{FF2B5EF4-FFF2-40B4-BE49-F238E27FC236}">
-                <a16:creationId xmlns:a16="http://schemas.microsoft.com/office/drawing/2014/main" id="{47E76ACD-5DC4-68B9-DDDD-958771C04154}"/>
+                <a16:creationId xmlns:a16="http://schemas.microsoft.com/office/drawing/2014/main" id="{ECDEA4A5-5771-7FF9-6C9D-549B68B697EA}"/>
               </a:ext>
             </a:extLst>
           </p:cNvPr>
@@ -7389,7 +7389,7 @@
           <p:cNvPr id="24" name="Oval 23">
             <a:extLst>
               <a:ext uri="{FF2B5EF4-FFF2-40B4-BE49-F238E27FC236}">
-                <a16:creationId xmlns:a16="http://schemas.microsoft.com/office/drawing/2014/main" id="{0D9940FE-FE7A-69DA-88FB-0BD1EF698430}"/>
+                <a16:creationId xmlns:a16="http://schemas.microsoft.com/office/drawing/2014/main" id="{AD66CB9A-E94F-8928-13CC-E1F2085BCB4B}"/>
               </a:ext>
             </a:extLst>
           </p:cNvPr>
@@ -7480,7 +7480,7 @@
           <p:cNvPr id="25" name="TextBox 24">
             <a:extLst>
               <a:ext uri="{FF2B5EF4-FFF2-40B4-BE49-F238E27FC236}">
-                <a16:creationId xmlns:a16="http://schemas.microsoft.com/office/drawing/2014/main" id="{F2B513A1-AFCB-EE84-2CC1-377DFF2B331B}"/>
+                <a16:creationId xmlns:a16="http://schemas.microsoft.com/office/drawing/2014/main" id="{FB395DCD-C1F2-B816-0C70-13F9C1B2B8A6}"/>
               </a:ext>
             </a:extLst>
           </p:cNvPr>
@@ -7553,7 +7553,7 @@
           <p:cNvPr id="26" name="Straight Connector 25">
             <a:extLst>
               <a:ext uri="{FF2B5EF4-FFF2-40B4-BE49-F238E27FC236}">
-                <a16:creationId xmlns:a16="http://schemas.microsoft.com/office/drawing/2014/main" id="{504F2962-8126-694F-A027-D200B3478D07}"/>
+                <a16:creationId xmlns:a16="http://schemas.microsoft.com/office/drawing/2014/main" id="{0AD5FF33-78A9-C55D-542E-3DD636770268}"/>
               </a:ext>
             </a:extLst>
           </p:cNvPr>
@@ -7595,7 +7595,7 @@
           <p:cNvPr id="27" name="Oval 26">
             <a:extLst>
               <a:ext uri="{FF2B5EF4-FFF2-40B4-BE49-F238E27FC236}">
-                <a16:creationId xmlns:a16="http://schemas.microsoft.com/office/drawing/2014/main" id="{0DCB2A95-FA71-9DFB-ADE1-637EEEE6CB6C}"/>
+                <a16:creationId xmlns:a16="http://schemas.microsoft.com/office/drawing/2014/main" id="{097A0E54-207B-AEF7-B78C-C3B7C9CDED0A}"/>
               </a:ext>
             </a:extLst>
           </p:cNvPr>
@@ -7686,7 +7686,7 @@
           <p:cNvPr id="28" name="TextBox 27">
             <a:extLst>
               <a:ext uri="{FF2B5EF4-FFF2-40B4-BE49-F238E27FC236}">
-                <a16:creationId xmlns:a16="http://schemas.microsoft.com/office/drawing/2014/main" id="{D6752966-36FB-7F0A-802B-9383F833625B}"/>
+                <a16:creationId xmlns:a16="http://schemas.microsoft.com/office/drawing/2014/main" id="{F4B0C35A-9E45-63FF-FF6D-8759174B36C3}"/>
               </a:ext>
             </a:extLst>
           </p:cNvPr>
@@ -7759,7 +7759,7 @@
           <p:cNvPr id="29" name="TextBox 28">
             <a:extLst>
               <a:ext uri="{FF2B5EF4-FFF2-40B4-BE49-F238E27FC236}">
-                <a16:creationId xmlns:a16="http://schemas.microsoft.com/office/drawing/2014/main" id="{92CB3587-2442-6788-77B1-E2529FF0D2A3}"/>
+                <a16:creationId xmlns:a16="http://schemas.microsoft.com/office/drawing/2014/main" id="{DFCAAE12-1B42-8BF1-D11C-5A526A32788A}"/>
               </a:ext>
             </a:extLst>
           </p:cNvPr>
@@ -7807,7 +7807,7 @@
           <p:cNvPr id="30" name="Rectangle: Rounded Corners 29">
             <a:extLst>
               <a:ext uri="{FF2B5EF4-FFF2-40B4-BE49-F238E27FC236}">
-                <a16:creationId xmlns:a16="http://schemas.microsoft.com/office/drawing/2014/main" id="{07FCA184-F52F-9369-D6A7-FACB23283F8A}"/>
+                <a16:creationId xmlns:a16="http://schemas.microsoft.com/office/drawing/2014/main" id="{C8CE4B0E-79CB-579C-317F-F3ADD996336E}"/>
               </a:ext>
             </a:extLst>
           </p:cNvPr>
@@ -7885,7 +7885,7 @@
           <p:cNvPr id="31" name="TextBox 30">
             <a:extLst>
               <a:ext uri="{FF2B5EF4-FFF2-40B4-BE49-F238E27FC236}">
-                <a16:creationId xmlns:a16="http://schemas.microsoft.com/office/drawing/2014/main" id="{2FB524B7-0EEB-AB65-FDB4-F9FB156DC2C6}"/>
+                <a16:creationId xmlns:a16="http://schemas.microsoft.com/office/drawing/2014/main" id="{F6EEEF3C-FA42-8AC6-6EDF-FF670FF9C549}"/>
               </a:ext>
             </a:extLst>
           </p:cNvPr>
@@ -7958,7 +7958,7 @@
           <p:cNvPr id="32" name="Rectangle: Rounded Corners 31">
             <a:extLst>
               <a:ext uri="{FF2B5EF4-FFF2-40B4-BE49-F238E27FC236}">
-                <a16:creationId xmlns:a16="http://schemas.microsoft.com/office/drawing/2014/main" id="{8F781FD0-0228-A952-3492-7A2C9321710D}"/>
+                <a16:creationId xmlns:a16="http://schemas.microsoft.com/office/drawing/2014/main" id="{E5906D0D-AB09-7F75-D98D-D4F5EA6A80E1}"/>
               </a:ext>
             </a:extLst>
           </p:cNvPr>
@@ -8036,7 +8036,7 @@
           <p:cNvPr id="33" name="TextBox 32">
             <a:extLst>
               <a:ext uri="{FF2B5EF4-FFF2-40B4-BE49-F238E27FC236}">
-                <a16:creationId xmlns:a16="http://schemas.microsoft.com/office/drawing/2014/main" id="{7C100788-6540-7635-8001-C0BD78054632}"/>
+                <a16:creationId xmlns:a16="http://schemas.microsoft.com/office/drawing/2014/main" id="{E4CEE13D-9489-8521-55C4-880BECD56436}"/>
               </a:ext>
             </a:extLst>
           </p:cNvPr>
@@ -8109,7 +8109,7 @@
           <p:cNvPr id="34" name="Rectangle: Rounded Corners 33">
             <a:extLst>
               <a:ext uri="{FF2B5EF4-FFF2-40B4-BE49-F238E27FC236}">
-                <a16:creationId xmlns:a16="http://schemas.microsoft.com/office/drawing/2014/main" id="{D6FE6D57-8028-26D9-25C2-B8F2C8FDC938}"/>
+                <a16:creationId xmlns:a16="http://schemas.microsoft.com/office/drawing/2014/main" id="{F8954409-6050-A219-67D6-A4FB679C4D67}"/>
               </a:ext>
             </a:extLst>
           </p:cNvPr>
@@ -8202,7 +8202,7 @@
           <p:cNvPr id="35" name="Rectangle: Rounded Corners 34">
             <a:extLst>
               <a:ext uri="{FF2B5EF4-FFF2-40B4-BE49-F238E27FC236}">
-                <a16:creationId xmlns:a16="http://schemas.microsoft.com/office/drawing/2014/main" id="{BD4DBA91-E161-727D-62BB-A17234AD5E0A}"/>
+                <a16:creationId xmlns:a16="http://schemas.microsoft.com/office/drawing/2014/main" id="{1A30C785-E52C-B737-1FC1-2EE528E874A5}"/>
               </a:ext>
             </a:extLst>
           </p:cNvPr>
@@ -8280,7 +8280,7 @@
           <p:cNvPr id="36" name="TextBox 35">
             <a:extLst>
               <a:ext uri="{FF2B5EF4-FFF2-40B4-BE49-F238E27FC236}">
-                <a16:creationId xmlns:a16="http://schemas.microsoft.com/office/drawing/2014/main" id="{AE2B175D-2115-9164-07B8-8A2E0D63D879}"/>
+                <a16:creationId xmlns:a16="http://schemas.microsoft.com/office/drawing/2014/main" id="{BBE1568E-316A-646C-3D8A-94FB48B88992}"/>
               </a:ext>
             </a:extLst>
           </p:cNvPr>
@@ -8353,7 +8353,7 @@
           <p:cNvPr id="37" name="Rectangle: Rounded Corners 36">
             <a:extLst>
               <a:ext uri="{FF2B5EF4-FFF2-40B4-BE49-F238E27FC236}">
-                <a16:creationId xmlns:a16="http://schemas.microsoft.com/office/drawing/2014/main" id="{409EBED9-C149-74FC-D09C-8153239A08A1}"/>
+                <a16:creationId xmlns:a16="http://schemas.microsoft.com/office/drawing/2014/main" id="{0E891F55-9158-D3C5-37EA-72202649FA87}"/>
               </a:ext>
             </a:extLst>
           </p:cNvPr>
@@ -8446,7 +8446,7 @@
           <p:cNvPr id="38" name="Rectangle: Rounded Corners 37">
             <a:extLst>
               <a:ext uri="{FF2B5EF4-FFF2-40B4-BE49-F238E27FC236}">
-                <a16:creationId xmlns:a16="http://schemas.microsoft.com/office/drawing/2014/main" id="{EE5B8211-3DB0-2670-FAC3-6F27C20E707C}"/>
+                <a16:creationId xmlns:a16="http://schemas.microsoft.com/office/drawing/2014/main" id="{294961EA-7BE0-CCB5-FDB5-5F451DB2FB5F}"/>
               </a:ext>
             </a:extLst>
           </p:cNvPr>
@@ -8524,7 +8524,7 @@
           <p:cNvPr id="39" name="TextBox 38">
             <a:extLst>
               <a:ext uri="{FF2B5EF4-FFF2-40B4-BE49-F238E27FC236}">
-                <a16:creationId xmlns:a16="http://schemas.microsoft.com/office/drawing/2014/main" id="{2CEFE3FF-AB4F-B954-509F-12B116CE089B}"/>
+                <a16:creationId xmlns:a16="http://schemas.microsoft.com/office/drawing/2014/main" id="{A2E83F22-C427-1F6E-B4FB-C4BECF7DB814}"/>
               </a:ext>
             </a:extLst>
           </p:cNvPr>
@@ -8872,10 +8872,64 @@
       </p:pic>
       <p:sp>
         <p:nvSpPr>
-          <p:cNvPr id="2" name="Rectangle: Rounded Corners 1">
+          <p:cNvPr id="2" name="TextBox 1">
             <a:extLst>
               <a:ext uri="{FF2B5EF4-FFF2-40B4-BE49-F238E27FC236}">
-                <a16:creationId xmlns:a16="http://schemas.microsoft.com/office/drawing/2014/main" id="{E0B9BEDA-2D6E-811E-3D9B-26CDED4B94D8}"/>
+                <a16:creationId xmlns:a16="http://schemas.microsoft.com/office/drawing/2014/main" id="{155D3776-8411-C744-FE3D-DB3F06106BBD}"/>
+              </a:ext>
+            </a:extLst>
+          </p:cNvPr>
+          <p:cNvSpPr txBox="1"/>
+          <p:nvPr/>
+        </p:nvSpPr>
+        <p:spPr>
+          <a:xfrm>
+            <a:off x="279400" y="1193800"/>
+            <a:ext cx="5588000" cy="369332"/>
+          </a:xfrm>
+          <a:prstGeom prst="rect">
+            <a:avLst/>
+          </a:prstGeom>
+          <a:noFill/>
+        </p:spPr>
+        <p:txBody>
+          <a:bodyPr vert="horz" wrap="square" lIns="0" tIns="0" rIns="0" bIns="0" rtlCol="0" anchor="t">
+            <a:noAutofit/>
+          </a:bodyPr>
+          <a:lstStyle/>
+          <a:p>
+            <a:pPr>
+              <a:spcBef>
+                <a:spcPts val="0"/>
+              </a:spcBef>
+              <a:spcAft>
+                <a:spcPts val="300"/>
+              </a:spcAft>
+            </a:pPr>
+            <a:r>
+              <a:rPr lang="en-US" sz="1100" b="1">
+                <a:solidFill>
+                  <a:srgbClr val="1F3864"/>
+                </a:solidFill>
+                <a:latin typeface="Arial" panose="020B0604020202020204" pitchFamily="34" charset="0"/>
+              </a:rPr>
+              <a:t>PROCESS FLOW: ONE PACKAGE, FROM SEIZURE TO COURT</a:t>
+            </a:r>
+            <a:endParaRPr lang="en-IN" sz="1100" b="1">
+              <a:solidFill>
+                <a:srgbClr val="1F3864"/>
+              </a:solidFill>
+              <a:latin typeface="Arial" panose="020B0604020202020204" pitchFamily="34" charset="0"/>
+            </a:endParaRPr>
+          </a:p>
+        </p:txBody>
+      </p:sp>
+      <p:sp>
+        <p:nvSpPr>
+          <p:cNvPr id="3" name="Rectangle: Rounded Corners 2">
+            <a:extLst>
+              <a:ext uri="{FF2B5EF4-FFF2-40B4-BE49-F238E27FC236}">
+                <a16:creationId xmlns:a16="http://schemas.microsoft.com/office/drawing/2014/main" id="{CF17CAA8-5A53-9489-4D31-2885C91F9961}"/>
               </a:ext>
             </a:extLst>
           </p:cNvPr>
@@ -8884,8 +8938,8 @@
         </p:nvSpPr>
         <p:spPr>
           <a:xfrm>
-            <a:off x="279400" y="1219200"/>
-            <a:ext cx="3556000" cy="3403600"/>
+            <a:off x="279400" y="1422400"/>
+            <a:ext cx="7340600" cy="2057400"/>
           </a:xfrm>
           <a:prstGeom prst="roundRect">
             <a:avLst>
@@ -8895,9 +8949,393 @@
           <a:solidFill>
             <a:srgbClr val="EEF3FA"/>
           </a:solidFill>
-          <a:ln w="9525">
+          <a:ln w="9525" cap="flat" cmpd="sng" algn="ctr">
+            <a:noFill/>
+            <a:prstDash val="solid"/>
+          </a:ln>
+          <a:effectLst/>
+          <a:extLst>
+            <a:ext uri="{91240B29-F687-4F45-9708-019B960494DF}">
+              <a14:hiddenLine xmlns:a14="http://schemas.microsoft.com/office/drawing/2010/main" w="9525" cap="flat" cmpd="sng" algn="ctr">
+                <a:solidFill>
+                  <a:schemeClr val="accent1">
+                    <a:shade val="95000"/>
+                    <a:satMod val="105000"/>
+                  </a:schemeClr>
+                </a:solidFill>
+                <a:prstDash val="solid"/>
+              </a14:hiddenLine>
+            </a:ext>
+            <a:ext uri="{AF507438-7753-43E0-B8FC-AC1667EBCBE1}">
+              <a14:hiddenEffects xmlns:a14="http://schemas.microsoft.com/office/drawing/2010/main">
+                <a:effectLst>
+                  <a:outerShdw blurRad="40000" dist="23000" dir="5400000" rotWithShape="0">
+                    <a:srgbClr val="000000">
+                      <a:alpha val="35000"/>
+                    </a:srgbClr>
+                  </a:outerShdw>
+                </a:effectLst>
+              </a14:hiddenEffects>
+            </a:ext>
+          </a:extLst>
+        </p:spPr>
+        <p:style>
+          <a:lnRef idx="1">
+            <a:schemeClr val="accent1"/>
+          </a:lnRef>
+          <a:fillRef idx="3">
+            <a:schemeClr val="accent1"/>
+          </a:fillRef>
+          <a:effectRef idx="2">
+            <a:schemeClr val="accent1"/>
+          </a:effectRef>
+          <a:fontRef idx="minor">
+            <a:schemeClr val="lt1"/>
+          </a:fontRef>
+        </p:style>
+        <p:txBody>
+          <a:bodyPr rtlCol="0" anchor="ctr"/>
+          <a:lstStyle/>
+          <a:p>
+            <a:pPr algn="ctr"/>
+            <a:endParaRPr lang="en-IN"/>
+          </a:p>
+        </p:txBody>
+      </p:sp>
+      <p:sp>
+        <p:nvSpPr>
+          <p:cNvPr id="4" name="TextBox 3">
+            <a:extLst>
+              <a:ext uri="{FF2B5EF4-FFF2-40B4-BE49-F238E27FC236}">
+                <a16:creationId xmlns:a16="http://schemas.microsoft.com/office/drawing/2014/main" id="{1B29D529-957E-8A37-EFB7-0B2B243F64DC}"/>
+              </a:ext>
+            </a:extLst>
+          </p:cNvPr>
+          <p:cNvSpPr txBox="1"/>
+          <p:nvPr/>
+        </p:nvSpPr>
+        <p:spPr>
+          <a:xfrm>
+            <a:off x="381000" y="1473200"/>
+            <a:ext cx="3810000" cy="369332"/>
+          </a:xfrm>
+          <a:prstGeom prst="rect">
+            <a:avLst/>
+          </a:prstGeom>
+          <a:noFill/>
+        </p:spPr>
+        <p:txBody>
+          <a:bodyPr vert="horz" wrap="square" lIns="0" tIns="0" rIns="0" bIns="0" rtlCol="0" anchor="t">
+            <a:noAutofit/>
+          </a:bodyPr>
+          <a:lstStyle/>
+          <a:p>
+            <a:pPr>
+              <a:spcBef>
+                <a:spcPts val="0"/>
+              </a:spcBef>
+              <a:spcAft>
+                <a:spcPts val="300"/>
+              </a:spcAft>
+            </a:pPr>
+            <a:r>
+              <a:rPr lang="en-IN" sz="750" b="1">
+                <a:solidFill>
+                  <a:srgbClr val="0070C0"/>
+                </a:solidFill>
+                <a:latin typeface="Arial" panose="020B0604020202020204" pitchFamily="34" charset="0"/>
+              </a:rPr>
+              <a:t>OFFICER'S PHONE · WORKS OFFLINE</a:t>
+            </a:r>
+          </a:p>
+        </p:txBody>
+      </p:sp>
+      <p:sp>
+        <p:nvSpPr>
+          <p:cNvPr id="5" name="Rectangle: Rounded Corners 4">
+            <a:extLst>
+              <a:ext uri="{FF2B5EF4-FFF2-40B4-BE49-F238E27FC236}">
+                <a16:creationId xmlns:a16="http://schemas.microsoft.com/office/drawing/2014/main" id="{A3F599BC-AAAF-C991-C1D4-4C303796C5EE}"/>
+              </a:ext>
+            </a:extLst>
+          </p:cNvPr>
+          <p:cNvSpPr/>
+          <p:nvPr/>
+        </p:nvSpPr>
+        <p:spPr>
+          <a:xfrm>
+            <a:off x="279400" y="3581400"/>
+            <a:ext cx="3606800" cy="1041400"/>
+          </a:xfrm>
+          <a:prstGeom prst="roundRect">
+            <a:avLst>
+              <a:gd name="adj" fmla="val 12000"/>
+            </a:avLst>
+          </a:prstGeom>
+          <a:solidFill>
+            <a:srgbClr val="EEF3FA"/>
+          </a:solidFill>
+          <a:ln w="9525" cap="flat" cmpd="sng" algn="ctr">
+            <a:noFill/>
+            <a:prstDash val="solid"/>
+          </a:ln>
+          <a:effectLst/>
+          <a:extLst>
+            <a:ext uri="{91240B29-F687-4F45-9708-019B960494DF}">
+              <a14:hiddenLine xmlns:a14="http://schemas.microsoft.com/office/drawing/2010/main" w="9525" cap="flat" cmpd="sng" algn="ctr">
+                <a:solidFill>
+                  <a:schemeClr val="accent1">
+                    <a:shade val="95000"/>
+                    <a:satMod val="105000"/>
+                  </a:schemeClr>
+                </a:solidFill>
+                <a:prstDash val="solid"/>
+              </a14:hiddenLine>
+            </a:ext>
+            <a:ext uri="{AF507438-7753-43E0-B8FC-AC1667EBCBE1}">
+              <a14:hiddenEffects xmlns:a14="http://schemas.microsoft.com/office/drawing/2010/main">
+                <a:effectLst>
+                  <a:outerShdw blurRad="40000" dist="23000" dir="5400000" rotWithShape="0">
+                    <a:srgbClr val="000000">
+                      <a:alpha val="35000"/>
+                    </a:srgbClr>
+                  </a:outerShdw>
+                </a:effectLst>
+              </a14:hiddenEffects>
+            </a:ext>
+          </a:extLst>
+        </p:spPr>
+        <p:style>
+          <a:lnRef idx="1">
+            <a:schemeClr val="accent1"/>
+          </a:lnRef>
+          <a:fillRef idx="3">
+            <a:schemeClr val="accent1"/>
+          </a:fillRef>
+          <a:effectRef idx="2">
+            <a:schemeClr val="accent1"/>
+          </a:effectRef>
+          <a:fontRef idx="minor">
+            <a:schemeClr val="lt1"/>
+          </a:fontRef>
+        </p:style>
+        <p:txBody>
+          <a:bodyPr rtlCol="0" anchor="ctr"/>
+          <a:lstStyle/>
+          <a:p>
+            <a:pPr algn="ctr"/>
+            <a:endParaRPr lang="en-IN"/>
+          </a:p>
+        </p:txBody>
+      </p:sp>
+      <p:sp>
+        <p:nvSpPr>
+          <p:cNvPr id="8" name="TextBox 7">
+            <a:extLst>
+              <a:ext uri="{FF2B5EF4-FFF2-40B4-BE49-F238E27FC236}">
+                <a16:creationId xmlns:a16="http://schemas.microsoft.com/office/drawing/2014/main" id="{83A45460-5FED-8BA3-EB07-5DE6E2E85576}"/>
+              </a:ext>
+            </a:extLst>
+          </p:cNvPr>
+          <p:cNvSpPr txBox="1"/>
+          <p:nvPr/>
+        </p:nvSpPr>
+        <p:spPr>
+          <a:xfrm>
+            <a:off x="381000" y="3632200"/>
+            <a:ext cx="3429000" cy="369332"/>
+          </a:xfrm>
+          <a:prstGeom prst="rect">
+            <a:avLst/>
+          </a:prstGeom>
+          <a:noFill/>
+        </p:spPr>
+        <p:txBody>
+          <a:bodyPr vert="horz" wrap="square" lIns="0" tIns="0" rIns="0" bIns="0" rtlCol="0" anchor="t">
+            <a:noAutofit/>
+          </a:bodyPr>
+          <a:lstStyle/>
+          <a:p>
+            <a:pPr>
+              <a:spcBef>
+                <a:spcPts val="0"/>
+              </a:spcBef>
+              <a:spcAft>
+                <a:spcPts val="300"/>
+              </a:spcAft>
+            </a:pPr>
+            <a:r>
+              <a:rPr lang="en-IN" sz="750" b="1">
+                <a:solidFill>
+                  <a:srgbClr val="0070C0"/>
+                </a:solidFill>
+                <a:latin typeface="Arial" panose="020B0604020202020204" pitchFamily="34" charset="0"/>
+              </a:rPr>
+              <a:t>ANYONE · OFFLINE VERIFIER</a:t>
+            </a:r>
+          </a:p>
+        </p:txBody>
+      </p:sp>
+      <p:sp>
+        <p:nvSpPr>
+          <p:cNvPr id="9" name="Rectangle: Rounded Corners 8">
+            <a:extLst>
+              <a:ext uri="{FF2B5EF4-FFF2-40B4-BE49-F238E27FC236}">
+                <a16:creationId xmlns:a16="http://schemas.microsoft.com/office/drawing/2014/main" id="{0C76090B-D982-EF28-9131-ACD7B7A3D706}"/>
+              </a:ext>
+            </a:extLst>
+          </p:cNvPr>
+          <p:cNvSpPr/>
+          <p:nvPr/>
+        </p:nvSpPr>
+        <p:spPr>
+          <a:xfrm>
+            <a:off x="4013200" y="3581400"/>
+            <a:ext cx="3606800" cy="1041400"/>
+          </a:xfrm>
+          <a:prstGeom prst="roundRect">
+            <a:avLst>
+              <a:gd name="adj" fmla="val 12000"/>
+            </a:avLst>
+          </a:prstGeom>
+          <a:solidFill>
+            <a:srgbClr val="EEF3FA"/>
+          </a:solidFill>
+          <a:ln w="9525" cap="flat" cmpd="sng" algn="ctr">
+            <a:noFill/>
+            <a:prstDash val="solid"/>
+          </a:ln>
+          <a:effectLst/>
+          <a:extLst>
+            <a:ext uri="{91240B29-F687-4F45-9708-019B960494DF}">
+              <a14:hiddenLine xmlns:a14="http://schemas.microsoft.com/office/drawing/2010/main" w="9525" cap="flat" cmpd="sng" algn="ctr">
+                <a:solidFill>
+                  <a:schemeClr val="accent1">
+                    <a:shade val="95000"/>
+                    <a:satMod val="105000"/>
+                  </a:schemeClr>
+                </a:solidFill>
+                <a:prstDash val="solid"/>
+              </a14:hiddenLine>
+            </a:ext>
+            <a:ext uri="{AF507438-7753-43E0-B8FC-AC1667EBCBE1}">
+              <a14:hiddenEffects xmlns:a14="http://schemas.microsoft.com/office/drawing/2010/main">
+                <a:effectLst>
+                  <a:outerShdw blurRad="40000" dist="23000" dir="5400000" rotWithShape="0">
+                    <a:srgbClr val="000000">
+                      <a:alpha val="35000"/>
+                    </a:srgbClr>
+                  </a:outerShdw>
+                </a:effectLst>
+              </a14:hiddenEffects>
+            </a:ext>
+          </a:extLst>
+        </p:spPr>
+        <p:style>
+          <a:lnRef idx="1">
+            <a:schemeClr val="accent1"/>
+          </a:lnRef>
+          <a:fillRef idx="3">
+            <a:schemeClr val="accent1"/>
+          </a:fillRef>
+          <a:effectRef idx="2">
+            <a:schemeClr val="accent1"/>
+          </a:effectRef>
+          <a:fontRef idx="minor">
+            <a:schemeClr val="lt1"/>
+          </a:fontRef>
+        </p:style>
+        <p:txBody>
+          <a:bodyPr rtlCol="0" anchor="ctr"/>
+          <a:lstStyle/>
+          <a:p>
+            <a:pPr algn="ctr"/>
+            <a:endParaRPr lang="en-IN"/>
+          </a:p>
+        </p:txBody>
+      </p:sp>
+      <p:sp>
+        <p:nvSpPr>
+          <p:cNvPr id="13" name="TextBox 12">
+            <a:extLst>
+              <a:ext uri="{FF2B5EF4-FFF2-40B4-BE49-F238E27FC236}">
+                <a16:creationId xmlns:a16="http://schemas.microsoft.com/office/drawing/2014/main" id="{7AF7043C-4F5D-882E-724D-9A72E7B76652}"/>
+              </a:ext>
+            </a:extLst>
+          </p:cNvPr>
+          <p:cNvSpPr txBox="1"/>
+          <p:nvPr/>
+        </p:nvSpPr>
+        <p:spPr>
+          <a:xfrm>
+            <a:off x="4114800" y="3632200"/>
+            <a:ext cx="3429000" cy="369332"/>
+          </a:xfrm>
+          <a:prstGeom prst="rect">
+            <a:avLst/>
+          </a:prstGeom>
+          <a:noFill/>
+        </p:spPr>
+        <p:txBody>
+          <a:bodyPr vert="horz" wrap="square" lIns="0" tIns="0" rIns="0" bIns="0" rtlCol="0" anchor="t">
+            <a:noAutofit/>
+          </a:bodyPr>
+          <a:lstStyle/>
+          <a:p>
+            <a:pPr>
+              <a:spcBef>
+                <a:spcPts val="0"/>
+              </a:spcBef>
+              <a:spcAft>
+                <a:spcPts val="300"/>
+              </a:spcAft>
+            </a:pPr>
+            <a:r>
+              <a:rPr lang="en-US" sz="750" b="1">
+                <a:solidFill>
+                  <a:srgbClr val="0070C0"/>
+                </a:solidFill>
+                <a:latin typeface="Arial" panose="020B0604020202020204" pitchFamily="34" charset="0"/>
+              </a:rPr>
+              <a:t>NCB SERVER (NIC / MeitY CLOUD) · WHEN ONLINE</a:t>
+            </a:r>
+            <a:endParaRPr lang="en-IN" sz="750" b="1">
+              <a:solidFill>
+                <a:srgbClr val="0070C0"/>
+              </a:solidFill>
+              <a:latin typeface="Arial" panose="020B0604020202020204" pitchFamily="34" charset="0"/>
+            </a:endParaRPr>
+          </a:p>
+        </p:txBody>
+      </p:sp>
+      <p:sp>
+        <p:nvSpPr>
+          <p:cNvPr id="14" name="Rectangle: Rounded Corners 13">
+            <a:extLst>
+              <a:ext uri="{FF2B5EF4-FFF2-40B4-BE49-F238E27FC236}">
+                <a16:creationId xmlns:a16="http://schemas.microsoft.com/office/drawing/2014/main" id="{DB924400-AA30-2FDB-A847-0A58E99B2BCE}"/>
+              </a:ext>
+            </a:extLst>
+          </p:cNvPr>
+          <p:cNvSpPr/>
+          <p:nvPr/>
+        </p:nvSpPr>
+        <p:spPr>
+          <a:xfrm>
+            <a:off x="381000" y="1676400"/>
+            <a:ext cx="1320800" cy="584200"/>
+          </a:xfrm>
+          <a:prstGeom prst="roundRect">
+            <a:avLst>
+              <a:gd name="adj" fmla="val 12000"/>
+            </a:avLst>
+          </a:prstGeom>
+          <a:solidFill>
+            <a:srgbClr val="FFFFFF"/>
+          </a:solidFill>
+          <a:ln w="12700">
             <a:solidFill>
-              <a:srgbClr val="B4C7E7"/>
+              <a:srgbClr val="0070C0"/>
             </a:solidFill>
           </a:ln>
           <a:effectLst/>
@@ -8930,40 +9368,7 @@
           </a:fontRef>
         </p:style>
         <p:txBody>
-          <a:bodyPr rtlCol="0" anchor="ctr"/>
-          <a:lstStyle/>
-          <a:p>
-            <a:pPr algn="ctr"/>
-            <a:endParaRPr lang="en-IN"/>
-          </a:p>
-        </p:txBody>
-      </p:sp>
-      <p:sp>
-        <p:nvSpPr>
-          <p:cNvPr id="3" name="TextBox 2">
-            <a:extLst>
-              <a:ext uri="{FF2B5EF4-FFF2-40B4-BE49-F238E27FC236}">
-                <a16:creationId xmlns:a16="http://schemas.microsoft.com/office/drawing/2014/main" id="{3CA0789C-6D5A-F631-0C5F-5DD86CC66E22}"/>
-              </a:ext>
-            </a:extLst>
-          </p:cNvPr>
-          <p:cNvSpPr txBox="1"/>
-          <p:nvPr/>
-        </p:nvSpPr>
-        <p:spPr>
-          <a:xfrm>
-            <a:off x="431800" y="1320800"/>
-            <a:ext cx="3251200" cy="369332"/>
-          </a:xfrm>
-          <a:prstGeom prst="rect">
-            <a:avLst/>
-          </a:prstGeom>
-          <a:noFill/>
-        </p:spPr>
-        <p:txBody>
-          <a:bodyPr vert="horz" wrap="square" lIns="0" tIns="0" rIns="0" bIns="0" rtlCol="0" anchor="t">
-            <a:noAutofit/>
-          </a:bodyPr>
+          <a:bodyPr lIns="63500" tIns="25400" rIns="50800" bIns="25400" rtlCol="0" anchor="ctr"/>
           <a:lstStyle/>
           <a:p>
             <a:pPr>
@@ -8971,21 +9376,49 @@
                 <a:spcPts val="0"/>
               </a:spcBef>
               <a:spcAft>
-                <a:spcPts val="300"/>
+                <a:spcPts val="100"/>
               </a:spcAft>
             </a:pPr>
             <a:r>
-              <a:rPr lang="en-US" sz="1100" b="1">
+              <a:rPr lang="en-IN" sz="950" b="1">
+                <a:solidFill>
+                  <a:srgbClr val="0070C0"/>
+                </a:solidFill>
+                <a:latin typeface="Arial" panose="020B0604020202020204" pitchFamily="34" charset="0"/>
+              </a:rPr>
+              <a:t>1  </a:t>
+            </a:r>
+            <a:r>
+              <a:rPr lang="en-IN" sz="950" b="1">
                 <a:solidFill>
                   <a:srgbClr val="1F3864"/>
                 </a:solidFill>
                 <a:latin typeface="Arial" panose="020B0604020202020204" pitchFamily="34" charset="0"/>
               </a:rPr>
-              <a:t>OFFICER'S PHONE APP (design, offline)</a:t>
-            </a:r>
-            <a:endParaRPr lang="en-IN" sz="1100" b="1">
+              <a:t>Pick the test</a:t>
+            </a:r>
+          </a:p>
+          <a:p>
+            <a:pPr>
+              <a:spcBef>
+                <a:spcPts val="0"/>
+              </a:spcBef>
+              <a:spcAft>
+                <a:spcPts val="0"/>
+              </a:spcAft>
+            </a:pPr>
+            <a:r>
+              <a:rPr lang="en-US" sz="800">
+                <a:solidFill>
+                  <a:srgbClr val="262626"/>
+                </a:solidFill>
+                <a:latin typeface="Arial" panose="020B0604020202020204" pitchFamily="34" charset="0"/>
+              </a:rPr>
+              <a:t>the kit's printed flow chart chooses Test A–E</a:t>
+            </a:r>
+            <a:endParaRPr lang="en-IN" sz="800">
               <a:solidFill>
-                <a:srgbClr val="1F3864"/>
+                <a:srgbClr val="262626"/>
               </a:solidFill>
               <a:latin typeface="Arial" panose="020B0604020202020204" pitchFamily="34" charset="0"/>
             </a:endParaRPr>
@@ -8994,10 +9427,10 @@
       </p:sp>
       <p:sp>
         <p:nvSpPr>
-          <p:cNvPr id="4" name="Rectangle: Rounded Corners 3">
+          <p:cNvPr id="15" name="Rectangle: Rounded Corners 14">
             <a:extLst>
               <a:ext uri="{FF2B5EF4-FFF2-40B4-BE49-F238E27FC236}">
-                <a16:creationId xmlns:a16="http://schemas.microsoft.com/office/drawing/2014/main" id="{705400AD-ED01-2761-DB17-0B14D2A3D862}"/>
+                <a16:creationId xmlns:a16="http://schemas.microsoft.com/office/drawing/2014/main" id="{B0ACAC3B-0582-78B3-63AF-9730647AE76F}"/>
               </a:ext>
             </a:extLst>
           </p:cNvPr>
@@ -9006,8 +9439,8 @@
         </p:nvSpPr>
         <p:spPr>
           <a:xfrm>
-            <a:off x="431800" y="1625600"/>
-            <a:ext cx="3251200" cy="508000"/>
+            <a:off x="1905000" y="1676400"/>
+            <a:ext cx="1422400" cy="584200"/>
           </a:xfrm>
           <a:prstGeom prst="roundRect">
             <a:avLst>
@@ -9017,9 +9450,9 @@
           <a:solidFill>
             <a:srgbClr val="FFFFFF"/>
           </a:solidFill>
-          <a:ln w="9525">
+          <a:ln w="12700">
             <a:solidFill>
-              <a:srgbClr val="B4C7E7"/>
+              <a:srgbClr val="0070C0"/>
             </a:solidFill>
           </a:ln>
           <a:effectLst/>
@@ -9052,40 +9485,7 @@
           </a:fontRef>
         </p:style>
         <p:txBody>
-          <a:bodyPr rtlCol="0" anchor="ctr"/>
-          <a:lstStyle/>
-          <a:p>
-            <a:pPr algn="ctr"/>
-            <a:endParaRPr lang="en-IN"/>
-          </a:p>
-        </p:txBody>
-      </p:sp>
-      <p:sp>
-        <p:nvSpPr>
-          <p:cNvPr id="5" name="TextBox 4">
-            <a:extLst>
-              <a:ext uri="{FF2B5EF4-FFF2-40B4-BE49-F238E27FC236}">
-                <a16:creationId xmlns:a16="http://schemas.microsoft.com/office/drawing/2014/main" id="{D495B35A-A766-74A7-5CE1-894E114AEBB4}"/>
-              </a:ext>
-            </a:extLst>
-          </p:cNvPr>
-          <p:cNvSpPr txBox="1"/>
-          <p:nvPr/>
-        </p:nvSpPr>
-        <p:spPr>
-          <a:xfrm>
-            <a:off x="533400" y="1689100"/>
-            <a:ext cx="3073400" cy="369332"/>
-          </a:xfrm>
-          <a:prstGeom prst="rect">
-            <a:avLst/>
-          </a:prstGeom>
-          <a:noFill/>
-        </p:spPr>
-        <p:txBody>
-          <a:bodyPr vert="horz" wrap="square" lIns="0" tIns="0" rIns="0" bIns="0" rtlCol="0" anchor="t">
-            <a:noAutofit/>
-          </a:bodyPr>
+          <a:bodyPr lIns="63500" tIns="25400" rIns="50800" bIns="25400" rtlCol="0" anchor="ctr"/>
           <a:lstStyle/>
           <a:p>
             <a:pPr>
@@ -9093,17 +9493,26 @@
                 <a:spcPts val="0"/>
               </a:spcBef>
               <a:spcAft>
-                <a:spcPts val="0"/>
+                <a:spcPts val="100"/>
               </a:spcAft>
             </a:pPr>
             <a:r>
-              <a:rPr lang="en-IN" sz="1050" b="1">
-                <a:solidFill>
-                  <a:srgbClr val="262626"/>
-                </a:solidFill>
-                <a:latin typeface="Arial" panose="020B0604020202020204" pitchFamily="34" charset="0"/>
-              </a:rPr>
-              <a:t>Guided NDDK protocol</a:t>
+              <a:rPr lang="en-IN" sz="950" b="1">
+                <a:solidFill>
+                  <a:srgbClr val="0070C0"/>
+                </a:solidFill>
+                <a:latin typeface="Arial" panose="020B0604020202020204" pitchFamily="34" charset="0"/>
+              </a:rPr>
+              <a:t>2  </a:t>
+            </a:r>
+            <a:r>
+              <a:rPr lang="en-IN" sz="950" b="1">
+                <a:solidFill>
+                  <a:srgbClr val="1F3864"/>
+                </a:solidFill>
+                <a:latin typeface="Arial" panose="020B0604020202020204" pitchFamily="34" charset="0"/>
+              </a:rPr>
+              <a:t>Capture</a:t>
             </a:r>
           </a:p>
           <a:p>
@@ -9116,17 +9525,17 @@
               </a:spcAft>
             </a:pPr>
             <a:r>
-              <a:rPr lang="en-US" sz="900">
-                <a:solidFill>
-                  <a:srgbClr val="595959"/>
-                </a:solidFill>
-                <a:latin typeface="Arial" panose="020B0604020202020204" pitchFamily="34" charset="0"/>
-              </a:rPr>
-              <a:t>signed file: steps, drops, flow charts (in prototype)</a:t>
-            </a:r>
-            <a:endParaRPr lang="en-IN" sz="900">
+              <a:rPr lang="en-US" sz="800">
+                <a:solidFill>
+                  <a:srgbClr val="262626"/>
+                </a:solidFill>
+                <a:latin typeface="Arial" panose="020B0604020202020204" pitchFamily="34" charset="0"/>
+              </a:rPr>
+              <a:t>one photo: colour card + sample well + blank well</a:t>
+            </a:r>
+            <a:endParaRPr lang="en-IN" sz="800">
               <a:solidFill>
-                <a:srgbClr val="595959"/>
+                <a:srgbClr val="262626"/>
               </a:solidFill>
               <a:latin typeface="Arial" panose="020B0604020202020204" pitchFamily="34" charset="0"/>
             </a:endParaRPr>
@@ -9135,10 +9544,10 @@
       </p:sp>
       <p:sp>
         <p:nvSpPr>
-          <p:cNvPr id="8" name="Rectangle: Rounded Corners 7">
+          <p:cNvPr id="16" name="Rectangle: Rounded Corners 15">
             <a:extLst>
               <a:ext uri="{FF2B5EF4-FFF2-40B4-BE49-F238E27FC236}">
-                <a16:creationId xmlns:a16="http://schemas.microsoft.com/office/drawing/2014/main" id="{6E4C1EE6-FF57-2E66-07F0-D780A297C474}"/>
+                <a16:creationId xmlns:a16="http://schemas.microsoft.com/office/drawing/2014/main" id="{EF176F1F-D650-9509-D17E-D7BBE7ACB3E6}"/>
               </a:ext>
             </a:extLst>
           </p:cNvPr>
@@ -9147,8 +9556,8 @@
         </p:nvSpPr>
         <p:spPr>
           <a:xfrm>
-            <a:off x="431800" y="2209800"/>
-            <a:ext cx="3251200" cy="508000"/>
+            <a:off x="3530600" y="1676400"/>
+            <a:ext cx="1600200" cy="584200"/>
           </a:xfrm>
           <a:prstGeom prst="roundRect">
             <a:avLst>
@@ -9158,9 +9567,9 @@
           <a:solidFill>
             <a:srgbClr val="FFFFFF"/>
           </a:solidFill>
-          <a:ln w="9525">
+          <a:ln w="12700">
             <a:solidFill>
-              <a:srgbClr val="B4C7E7"/>
+              <a:srgbClr val="0070C0"/>
             </a:solidFill>
           </a:ln>
           <a:effectLst/>
@@ -9193,93 +9602,195 @@
           </a:fontRef>
         </p:style>
         <p:txBody>
-          <a:bodyPr rtlCol="0" anchor="ctr"/>
+          <a:bodyPr lIns="63500" tIns="25400" rIns="50800" bIns="25400" rtlCol="0" anchor="ctr"/>
           <a:lstStyle/>
           <a:p>
-            <a:pPr algn="ctr"/>
-            <a:endParaRPr lang="en-IN"/>
-          </a:p>
-        </p:txBody>
-      </p:sp>
-      <p:sp>
-        <p:nvSpPr>
-          <p:cNvPr id="9" name="TextBox 8">
+            <a:pPr>
+              <a:spcBef>
+                <a:spcPts val="0"/>
+              </a:spcBef>
+              <a:spcAft>
+                <a:spcPts val="100"/>
+              </a:spcAft>
+            </a:pPr>
+            <a:r>
+              <a:rPr lang="en-IN" sz="950" b="1">
+                <a:solidFill>
+                  <a:srgbClr val="0070C0"/>
+                </a:solidFill>
+                <a:latin typeface="Arial" panose="020B0604020202020204" pitchFamily="34" charset="0"/>
+              </a:rPr>
+              <a:t>3  </a:t>
+            </a:r>
+            <a:r>
+              <a:rPr lang="en-IN" sz="950" b="1">
+                <a:solidFill>
+                  <a:srgbClr val="1F3864"/>
+                </a:solidFill>
+                <a:latin typeface="Arial" panose="020B0604020202020204" pitchFamily="34" charset="0"/>
+              </a:rPr>
+              <a:t>Read the colour</a:t>
+            </a:r>
+          </a:p>
+          <a:p>
+            <a:pPr>
+              <a:spcBef>
+                <a:spcPts val="0"/>
+              </a:spcBef>
+              <a:spcAft>
+                <a:spcPts val="0"/>
+              </a:spcAft>
+            </a:pPr>
+            <a:r>
+              <a:rPr lang="en-US" sz="800">
+                <a:solidFill>
+                  <a:srgbClr val="262626"/>
+                </a:solidFill>
+                <a:latin typeface="Arial" panose="020B0604020202020204" pitchFamily="34" charset="0"/>
+              </a:rPr>
+              <a:t>correct the light, compare with the blank, match the kit's colour bands</a:t>
+            </a:r>
+            <a:endParaRPr lang="en-IN" sz="800">
+              <a:solidFill>
+                <a:srgbClr val="262626"/>
+              </a:solidFill>
+              <a:latin typeface="Arial" panose="020B0604020202020204" pitchFamily="34" charset="0"/>
+            </a:endParaRPr>
+          </a:p>
+        </p:txBody>
+      </p:sp>
+      <p:cxnSp>
+        <p:nvCxnSpPr>
+          <p:cNvPr id="17" name="Straight Connector 16">
             <a:extLst>
               <a:ext uri="{FF2B5EF4-FFF2-40B4-BE49-F238E27FC236}">
-                <a16:creationId xmlns:a16="http://schemas.microsoft.com/office/drawing/2014/main" id="{69C45D8E-23B5-4FBD-7E78-5C99CE79E778}"/>
+                <a16:creationId xmlns:a16="http://schemas.microsoft.com/office/drawing/2014/main" id="{04ACF164-5C6F-342B-525D-4586234078DB}"/>
               </a:ext>
             </a:extLst>
           </p:cNvPr>
-          <p:cNvSpPr txBox="1"/>
+          <p:cNvCxnSpPr/>
           <p:nvPr/>
-        </p:nvSpPr>
+        </p:nvCxnSpPr>
         <p:spPr>
           <a:xfrm>
-            <a:off x="533400" y="2273300"/>
-            <a:ext cx="3073400" cy="369332"/>
-          </a:xfrm>
-          <a:prstGeom prst="rect">
+            <a:off x="1701800" y="1968500"/>
+            <a:ext cx="203200" cy="0"/>
+          </a:xfrm>
+          <a:prstGeom prst="line">
             <a:avLst/>
           </a:prstGeom>
-          <a:noFill/>
-        </p:spPr>
-        <p:txBody>
-          <a:bodyPr vert="horz" wrap="square" lIns="0" tIns="0" rIns="0" bIns="0" rtlCol="0" anchor="t">
-            <a:noAutofit/>
-          </a:bodyPr>
-          <a:lstStyle/>
-          <a:p>
-            <a:pPr>
-              <a:spcBef>
-                <a:spcPts val="0"/>
-              </a:spcBef>
-              <a:spcAft>
-                <a:spcPts val="0"/>
-              </a:spcAft>
-            </a:pPr>
-            <a:r>
-              <a:rPr lang="en-IN" sz="1050" b="1">
-                <a:solidFill>
-                  <a:srgbClr val="262626"/>
-                </a:solidFill>
-                <a:latin typeface="Arial" panose="020B0604020202020204" pitchFamily="34" charset="0"/>
-              </a:rPr>
-              <a:t>Capture</a:t>
-            </a:r>
-          </a:p>
-          <a:p>
-            <a:pPr>
-              <a:spcBef>
-                <a:spcPts val="0"/>
-              </a:spcBef>
-              <a:spcAft>
-                <a:spcPts val="0"/>
-              </a:spcAft>
-            </a:pPr>
-            <a:r>
-              <a:rPr lang="en-US" sz="900">
-                <a:solidFill>
-                  <a:srgbClr val="595959"/>
-                </a:solidFill>
-                <a:latin typeface="Arial" panose="020B0604020202020204" pitchFamily="34" charset="0"/>
-              </a:rPr>
-              <a:t>CameraX / Camera2 RAW; card found by ArUco markers</a:t>
-            </a:r>
-            <a:endParaRPr lang="en-IN" sz="900">
-              <a:solidFill>
-                <a:srgbClr val="595959"/>
-              </a:solidFill>
-              <a:latin typeface="Arial" panose="020B0604020202020204" pitchFamily="34" charset="0"/>
-            </a:endParaRPr>
-          </a:p>
-        </p:txBody>
-      </p:sp>
-      <p:sp>
-        <p:nvSpPr>
-          <p:cNvPr id="13" name="Rectangle: Rounded Corners 12">
+          <a:ln w="19050">
+            <a:solidFill>
+              <a:srgbClr val="0070C0"/>
+            </a:solidFill>
+            <a:tailEnd type="triangle"/>
+          </a:ln>
+        </p:spPr>
+        <p:style>
+          <a:lnRef idx="2">
+            <a:schemeClr val="accent1"/>
+          </a:lnRef>
+          <a:fillRef idx="0">
+            <a:schemeClr val="accent1"/>
+          </a:fillRef>
+          <a:effectRef idx="1">
+            <a:schemeClr val="accent1"/>
+          </a:effectRef>
+          <a:fontRef idx="minor">
+            <a:schemeClr val="tx1"/>
+          </a:fontRef>
+        </p:style>
+      </p:cxnSp>
+      <p:cxnSp>
+        <p:nvCxnSpPr>
+          <p:cNvPr id="18" name="Straight Connector 17">
             <a:extLst>
               <a:ext uri="{FF2B5EF4-FFF2-40B4-BE49-F238E27FC236}">
-                <a16:creationId xmlns:a16="http://schemas.microsoft.com/office/drawing/2014/main" id="{818F0251-8D11-F070-2D08-0763983FA9DB}"/>
+                <a16:creationId xmlns:a16="http://schemas.microsoft.com/office/drawing/2014/main" id="{637855FE-7874-36D3-CE92-674272B6B6C1}"/>
+              </a:ext>
+            </a:extLst>
+          </p:cNvPr>
+          <p:cNvCxnSpPr/>
+          <p:nvPr/>
+        </p:nvCxnSpPr>
+        <p:spPr>
+          <a:xfrm>
+            <a:off x="3327400" y="1968500"/>
+            <a:ext cx="203200" cy="0"/>
+          </a:xfrm>
+          <a:prstGeom prst="line">
+            <a:avLst/>
+          </a:prstGeom>
+          <a:ln w="19050">
+            <a:solidFill>
+              <a:srgbClr val="0070C0"/>
+            </a:solidFill>
+            <a:tailEnd type="triangle"/>
+          </a:ln>
+        </p:spPr>
+        <p:style>
+          <a:lnRef idx="2">
+            <a:schemeClr val="accent1"/>
+          </a:lnRef>
+          <a:fillRef idx="0">
+            <a:schemeClr val="accent1"/>
+          </a:fillRef>
+          <a:effectRef idx="1">
+            <a:schemeClr val="accent1"/>
+          </a:effectRef>
+          <a:fontRef idx="minor">
+            <a:schemeClr val="tx1"/>
+          </a:fontRef>
+        </p:style>
+      </p:cxnSp>
+      <p:cxnSp>
+        <p:nvCxnSpPr>
+          <p:cNvPr id="19" name="Straight Connector 18">
+            <a:extLst>
+              <a:ext uri="{FF2B5EF4-FFF2-40B4-BE49-F238E27FC236}">
+                <a16:creationId xmlns:a16="http://schemas.microsoft.com/office/drawing/2014/main" id="{A7E3BFFE-7EAE-67A3-F949-B81EE3E181A0}"/>
+              </a:ext>
+            </a:extLst>
+          </p:cNvPr>
+          <p:cNvCxnSpPr/>
+          <p:nvPr/>
+        </p:nvCxnSpPr>
+        <p:spPr>
+          <a:xfrm>
+            <a:off x="5130800" y="1968500"/>
+            <a:ext cx="177800" cy="0"/>
+          </a:xfrm>
+          <a:prstGeom prst="line">
+            <a:avLst/>
+          </a:prstGeom>
+          <a:ln w="19050">
+            <a:solidFill>
+              <a:srgbClr val="0070C0"/>
+            </a:solidFill>
+            <a:tailEnd type="triangle"/>
+          </a:ln>
+        </p:spPr>
+        <p:style>
+          <a:lnRef idx="2">
+            <a:schemeClr val="accent1"/>
+          </a:lnRef>
+          <a:fillRef idx="0">
+            <a:schemeClr val="accent1"/>
+          </a:fillRef>
+          <a:effectRef idx="1">
+            <a:schemeClr val="accent1"/>
+          </a:effectRef>
+          <a:fontRef idx="minor">
+            <a:schemeClr val="tx1"/>
+          </a:fontRef>
+        </p:style>
+      </p:cxnSp>
+      <p:sp>
+        <p:nvSpPr>
+          <p:cNvPr id="20" name="Diamond 19">
+            <a:extLst>
+              <a:ext uri="{FF2B5EF4-FFF2-40B4-BE49-F238E27FC236}">
+                <a16:creationId xmlns:a16="http://schemas.microsoft.com/office/drawing/2014/main" id="{CB5F2520-62C6-5F39-E6B9-C6E8C4CD7012}"/>
               </a:ext>
             </a:extLst>
           </p:cNvPr>
@@ -9288,20 +9799,18 @@
         </p:nvSpPr>
         <p:spPr>
           <a:xfrm>
-            <a:off x="431800" y="2794000"/>
-            <a:ext cx="3251200" cy="508000"/>
-          </a:xfrm>
-          <a:prstGeom prst="roundRect">
-            <a:avLst>
-              <a:gd name="adj" fmla="val 12000"/>
-            </a:avLst>
+            <a:off x="5308600" y="1625600"/>
+            <a:ext cx="990600" cy="685800"/>
+          </a:xfrm>
+          <a:prstGeom prst="diamond">
+            <a:avLst/>
           </a:prstGeom>
           <a:solidFill>
             <a:srgbClr val="FFFFFF"/>
           </a:solidFill>
-          <a:ln w="9525">
+          <a:ln w="12700">
             <a:solidFill>
-              <a:srgbClr val="B4C7E7"/>
+              <a:srgbClr val="0070C0"/>
             </a:solidFill>
           </a:ln>
           <a:effectLst/>
@@ -9334,93 +9843,35 @@
           </a:fontRef>
         </p:style>
         <p:txBody>
-          <a:bodyPr rtlCol="0" anchor="ctr"/>
+          <a:bodyPr lIns="0" tIns="0" rIns="0" bIns="0" rtlCol="0" anchor="ctr"/>
           <a:lstStyle/>
           <a:p>
-            <a:pPr algn="ctr"/>
-            <a:endParaRPr lang="en-IN"/>
-          </a:p>
-        </p:txBody>
-      </p:sp>
-      <p:sp>
-        <p:nvSpPr>
-          <p:cNvPr id="14" name="TextBox 13">
+            <a:pPr algn="ctr">
+              <a:spcBef>
+                <a:spcPts val="0"/>
+              </a:spcBef>
+              <a:spcAft>
+                <a:spcPts val="0"/>
+              </a:spcAft>
+            </a:pPr>
+            <a:r>
+              <a:rPr lang="en-IN" sz="900" b="1">
+                <a:solidFill>
+                  <a:srgbClr val="1F3864"/>
+                </a:solidFill>
+                <a:latin typeface="Arial" panose="020B0604020202020204" pitchFamily="34" charset="0"/>
+              </a:rPr>
+              <a:t>Result?</a:t>
+            </a:r>
+          </a:p>
+        </p:txBody>
+      </p:sp>
+      <p:sp>
+        <p:nvSpPr>
+          <p:cNvPr id="21" name="Rectangle: Rounded Corners 20">
             <a:extLst>
               <a:ext uri="{FF2B5EF4-FFF2-40B4-BE49-F238E27FC236}">
-                <a16:creationId xmlns:a16="http://schemas.microsoft.com/office/drawing/2014/main" id="{88BB2C0E-501B-A008-5AD2-2FB72682E280}"/>
-              </a:ext>
-            </a:extLst>
-          </p:cNvPr>
-          <p:cNvSpPr txBox="1"/>
-          <p:nvPr/>
-        </p:nvSpPr>
-        <p:spPr>
-          <a:xfrm>
-            <a:off x="533400" y="2857500"/>
-            <a:ext cx="3073400" cy="369332"/>
-          </a:xfrm>
-          <a:prstGeom prst="rect">
-            <a:avLst/>
-          </a:prstGeom>
-          <a:noFill/>
-        </p:spPr>
-        <p:txBody>
-          <a:bodyPr vert="horz" wrap="square" lIns="0" tIns="0" rIns="0" bIns="0" rtlCol="0" anchor="t">
-            <a:noAutofit/>
-          </a:bodyPr>
-          <a:lstStyle/>
-          <a:p>
-            <a:pPr>
-              <a:spcBef>
-                <a:spcPts val="0"/>
-              </a:spcBef>
-              <a:spcAft>
-                <a:spcPts val="0"/>
-              </a:spcAft>
-            </a:pPr>
-            <a:r>
-              <a:rPr lang="en-IN" sz="1050" b="1">
-                <a:solidFill>
-                  <a:srgbClr val="262626"/>
-                </a:solidFill>
-                <a:latin typeface="Arial" panose="020B0604020202020204" pitchFamily="34" charset="0"/>
-              </a:rPr>
-              <a:t>Colour engine</a:t>
-            </a:r>
-          </a:p>
-          <a:p>
-            <a:pPr>
-              <a:spcBef>
-                <a:spcPts val="0"/>
-              </a:spcBef>
-              <a:spcAft>
-                <a:spcPts val="0"/>
-              </a:spcAft>
-            </a:pPr>
-            <a:r>
-              <a:rPr lang="en-US" sz="900">
-                <a:solidFill>
-                  <a:srgbClr val="595959"/>
-                </a:solidFill>
-                <a:latin typeface="Arial" panose="020B0604020202020204" pitchFamily="34" charset="0"/>
-              </a:rPr>
-              <a:t>card correction, blank well, colour bands (in prototype)</a:t>
-            </a:r>
-            <a:endParaRPr lang="en-IN" sz="900">
-              <a:solidFill>
-                <a:srgbClr val="595959"/>
-              </a:solidFill>
-              <a:latin typeface="Arial" panose="020B0604020202020204" pitchFamily="34" charset="0"/>
-            </a:endParaRPr>
-          </a:p>
-        </p:txBody>
-      </p:sp>
-      <p:sp>
-        <p:nvSpPr>
-          <p:cNvPr id="15" name="Rectangle: Rounded Corners 14">
-            <a:extLst>
-              <a:ext uri="{FF2B5EF4-FFF2-40B4-BE49-F238E27FC236}">
-                <a16:creationId xmlns:a16="http://schemas.microsoft.com/office/drawing/2014/main" id="{A64BDDA7-36FA-682C-F4FF-BB2F513790CF}"/>
+                <a16:creationId xmlns:a16="http://schemas.microsoft.com/office/drawing/2014/main" id="{B83E71D9-5599-A814-85BA-CF6A377AC44D}"/>
               </a:ext>
             </a:extLst>
           </p:cNvPr>
@@ -9429,8 +9880,8 @@
         </p:nvSpPr>
         <p:spPr>
           <a:xfrm>
-            <a:off x="431800" y="3378200"/>
-            <a:ext cx="3251200" cy="508000"/>
+            <a:off x="6477000" y="1498600"/>
+            <a:ext cx="1092200" cy="330200"/>
           </a:xfrm>
           <a:prstGeom prst="roundRect">
             <a:avLst>
@@ -9438,11 +9889,11 @@
             </a:avLst>
           </a:prstGeom>
           <a:solidFill>
-            <a:srgbClr val="FFFFFF"/>
+            <a:srgbClr val="FBE5D6"/>
           </a:solidFill>
           <a:ln w="9525">
             <a:solidFill>
-              <a:srgbClr val="B4C7E7"/>
+              <a:srgbClr val="C55A11"/>
             </a:solidFill>
           </a:ln>
           <a:effectLst/>
@@ -9475,93 +9926,77 @@
           </a:fontRef>
         </p:style>
         <p:txBody>
-          <a:bodyPr rtlCol="0" anchor="ctr"/>
+          <a:bodyPr lIns="50800" tIns="0" rIns="38100" bIns="0" rtlCol="0" anchor="ctr"/>
           <a:lstStyle/>
           <a:p>
-            <a:pPr algn="ctr"/>
-            <a:endParaRPr lang="en-IN"/>
-          </a:p>
-        </p:txBody>
-      </p:sp>
-      <p:sp>
-        <p:nvSpPr>
-          <p:cNvPr id="16" name="TextBox 15">
+            <a:pPr>
+              <a:spcBef>
+                <a:spcPts val="0"/>
+              </a:spcBef>
+              <a:spcAft>
+                <a:spcPts val="0"/>
+              </a:spcAft>
+            </a:pPr>
+            <a:r>
+              <a:rPr lang="en-IN" sz="700" b="1">
+                <a:solidFill>
+                  <a:srgbClr val="C55A11"/>
+                </a:solidFill>
+                <a:latin typeface="Arial" panose="020B0604020202020204" pitchFamily="34" charset="0"/>
+              </a:rPr>
+              <a:t>POSITIVE: drug list + NDPS warning</a:t>
+            </a:r>
+          </a:p>
+        </p:txBody>
+      </p:sp>
+      <p:cxnSp>
+        <p:nvCxnSpPr>
+          <p:cNvPr id="22" name="Straight Connector 21">
             <a:extLst>
               <a:ext uri="{FF2B5EF4-FFF2-40B4-BE49-F238E27FC236}">
-                <a16:creationId xmlns:a16="http://schemas.microsoft.com/office/drawing/2014/main" id="{E300517A-43EE-AC53-E5AA-2A6F1D42BF63}"/>
+                <a16:creationId xmlns:a16="http://schemas.microsoft.com/office/drawing/2014/main" id="{3D818840-AFED-5858-180B-EB6C7CE06562}"/>
               </a:ext>
             </a:extLst>
           </p:cNvPr>
-          <p:cNvSpPr txBox="1"/>
+          <p:cNvCxnSpPr/>
           <p:nvPr/>
-        </p:nvSpPr>
+        </p:nvCxnSpPr>
         <p:spPr>
-          <a:xfrm>
-            <a:off x="533400" y="3441700"/>
-            <a:ext cx="3073400" cy="369332"/>
-          </a:xfrm>
-          <a:prstGeom prst="rect">
+          <a:xfrm flipV="1">
+            <a:off x="6299200" y="1663700"/>
+            <a:ext cx="177800" cy="304800"/>
+          </a:xfrm>
+          <a:prstGeom prst="line">
             <a:avLst/>
           </a:prstGeom>
-          <a:noFill/>
-        </p:spPr>
-        <p:txBody>
-          <a:bodyPr vert="horz" wrap="square" lIns="0" tIns="0" rIns="0" bIns="0" rtlCol="0" anchor="t">
-            <a:noAutofit/>
-          </a:bodyPr>
-          <a:lstStyle/>
-          <a:p>
-            <a:pPr>
-              <a:spcBef>
-                <a:spcPts val="0"/>
-              </a:spcBef>
-              <a:spcAft>
-                <a:spcPts val="0"/>
-              </a:spcAft>
-            </a:pPr>
-            <a:r>
-              <a:rPr lang="en-IN" sz="1050" b="1">
-                <a:solidFill>
-                  <a:srgbClr val="262626"/>
-                </a:solidFill>
-                <a:latin typeface="Arial" panose="020B0604020202020204" pitchFamily="34" charset="0"/>
-              </a:rPr>
-              <a:t>Record core</a:t>
-            </a:r>
-          </a:p>
-          <a:p>
-            <a:pPr>
-              <a:spcBef>
-                <a:spcPts val="0"/>
-              </a:spcBef>
-              <a:spcAft>
-                <a:spcPts val="0"/>
-              </a:spcAft>
-            </a:pPr>
-            <a:r>
-              <a:rPr lang="en-US" sz="900">
-                <a:solidFill>
-                  <a:srgbClr val="595959"/>
-                </a:solidFill>
-                <a:latin typeface="Arial" panose="020B0604020202020204" pitchFamily="34" charset="0"/>
-              </a:rPr>
-              <a:t>ECDSA P-256 + SHA-256 chain; key in StrongBox/TEE</a:t>
-            </a:r>
-            <a:endParaRPr lang="en-IN" sz="900">
-              <a:solidFill>
-                <a:srgbClr val="595959"/>
-              </a:solidFill>
-              <a:latin typeface="Arial" panose="020B0604020202020204" pitchFamily="34" charset="0"/>
-            </a:endParaRPr>
-          </a:p>
-        </p:txBody>
-      </p:sp>
-      <p:sp>
-        <p:nvSpPr>
-          <p:cNvPr id="17" name="Rectangle: Rounded Corners 16">
+          <a:ln w="19050">
+            <a:solidFill>
+              <a:srgbClr val="0070C0"/>
+            </a:solidFill>
+            <a:tailEnd type="triangle"/>
+          </a:ln>
+        </p:spPr>
+        <p:style>
+          <a:lnRef idx="2">
+            <a:schemeClr val="accent1"/>
+          </a:lnRef>
+          <a:fillRef idx="0">
+            <a:schemeClr val="accent1"/>
+          </a:fillRef>
+          <a:effectRef idx="1">
+            <a:schemeClr val="accent1"/>
+          </a:effectRef>
+          <a:fontRef idx="minor">
+            <a:schemeClr val="tx1"/>
+          </a:fontRef>
+        </p:style>
+      </p:cxnSp>
+      <p:sp>
+        <p:nvSpPr>
+          <p:cNvPr id="23" name="Rectangle: Rounded Corners 22">
             <a:extLst>
               <a:ext uri="{FF2B5EF4-FFF2-40B4-BE49-F238E27FC236}">
-                <a16:creationId xmlns:a16="http://schemas.microsoft.com/office/drawing/2014/main" id="{E2DD7C8F-941E-A327-A65A-3C84C7C521F0}"/>
+                <a16:creationId xmlns:a16="http://schemas.microsoft.com/office/drawing/2014/main" id="{5C07D88D-B649-8C53-EE13-3FEBC9586BC0}"/>
               </a:ext>
             </a:extLst>
           </p:cNvPr>
@@ -9570,8 +10005,8 @@
         </p:nvSpPr>
         <p:spPr>
           <a:xfrm>
-            <a:off x="431800" y="3962400"/>
-            <a:ext cx="3251200" cy="508000"/>
+            <a:off x="6477000" y="1879600"/>
+            <a:ext cx="1092200" cy="203200"/>
           </a:xfrm>
           <a:prstGeom prst="roundRect">
             <a:avLst>
@@ -9579,11 +10014,11 @@
             </a:avLst>
           </a:prstGeom>
           <a:solidFill>
-            <a:srgbClr val="FFFFFF"/>
+            <a:srgbClr val="E2F0D9"/>
           </a:solidFill>
           <a:ln w="9525">
             <a:solidFill>
-              <a:srgbClr val="B4C7E7"/>
+              <a:srgbClr val="2E7D32"/>
             </a:solidFill>
           </a:ln>
           <a:effectLst/>
@@ -9616,93 +10051,77 @@
           </a:fontRef>
         </p:style>
         <p:txBody>
-          <a:bodyPr rtlCol="0" anchor="ctr"/>
+          <a:bodyPr lIns="50800" tIns="0" rIns="38100" bIns="0" rtlCol="0" anchor="ctr"/>
           <a:lstStyle/>
           <a:p>
-            <a:pPr algn="ctr"/>
-            <a:endParaRPr lang="en-IN"/>
-          </a:p>
-        </p:txBody>
-      </p:sp>
-      <p:sp>
-        <p:nvSpPr>
-          <p:cNvPr id="18" name="TextBox 17">
+            <a:pPr>
+              <a:spcBef>
+                <a:spcPts val="0"/>
+              </a:spcBef>
+              <a:spcAft>
+                <a:spcPts val="0"/>
+              </a:spcAft>
+            </a:pPr>
+            <a:r>
+              <a:rPr lang="en-IN" sz="700" b="1">
+                <a:solidFill>
+                  <a:srgbClr val="2E7D32"/>
+                </a:solidFill>
+                <a:latin typeface="Arial" panose="020B0604020202020204" pitchFamily="34" charset="0"/>
+              </a:rPr>
+              <a:t>NO COLOUR CHANGE</a:t>
+            </a:r>
+          </a:p>
+        </p:txBody>
+      </p:sp>
+      <p:cxnSp>
+        <p:nvCxnSpPr>
+          <p:cNvPr id="24" name="Straight Connector 23">
             <a:extLst>
               <a:ext uri="{FF2B5EF4-FFF2-40B4-BE49-F238E27FC236}">
-                <a16:creationId xmlns:a16="http://schemas.microsoft.com/office/drawing/2014/main" id="{CD75DE96-BA89-788F-3E4E-E21577C9E982}"/>
+                <a16:creationId xmlns:a16="http://schemas.microsoft.com/office/drawing/2014/main" id="{51B41757-D108-EF59-D36E-8FE92BE0D07A}"/>
               </a:ext>
             </a:extLst>
           </p:cNvPr>
-          <p:cNvSpPr txBox="1"/>
+          <p:cNvCxnSpPr/>
           <p:nvPr/>
-        </p:nvSpPr>
+        </p:nvCxnSpPr>
         <p:spPr>
           <a:xfrm>
-            <a:off x="533400" y="4025900"/>
-            <a:ext cx="3073400" cy="369332"/>
-          </a:xfrm>
-          <a:prstGeom prst="rect">
+            <a:off x="6299200" y="1968500"/>
+            <a:ext cx="177800" cy="12700"/>
+          </a:xfrm>
+          <a:prstGeom prst="line">
             <a:avLst/>
           </a:prstGeom>
-          <a:noFill/>
-        </p:spPr>
-        <p:txBody>
-          <a:bodyPr vert="horz" wrap="square" lIns="0" tIns="0" rIns="0" bIns="0" rtlCol="0" anchor="t">
-            <a:noAutofit/>
-          </a:bodyPr>
-          <a:lstStyle/>
-          <a:p>
-            <a:pPr>
-              <a:spcBef>
-                <a:spcPts val="0"/>
-              </a:spcBef>
-              <a:spcAft>
-                <a:spcPts val="0"/>
-              </a:spcAft>
-            </a:pPr>
-            <a:r>
-              <a:rPr lang="en-IN" sz="1050" b="1">
-                <a:solidFill>
-                  <a:srgbClr val="262626"/>
-                </a:solidFill>
-                <a:latin typeface="Arial" panose="020B0604020202020204" pitchFamily="34" charset="0"/>
-              </a:rPr>
-              <a:t>Log + reports</a:t>
-            </a:r>
-          </a:p>
-          <a:p>
-            <a:pPr>
-              <a:spcBef>
-                <a:spcPts val="0"/>
-              </a:spcBef>
-              <a:spcAft>
-                <a:spcPts val="0"/>
-              </a:spcAft>
-            </a:pPr>
-            <a:r>
-              <a:rPr lang="en-US" sz="900">
-                <a:solidFill>
-                  <a:srgbClr val="595959"/>
-                </a:solidFill>
-                <a:latin typeface="Arial" panose="020B0604020202020204" pitchFamily="34" charset="0"/>
-              </a:rPr>
-              <a:t>searchable log (in prototype); memo, Form-1 (planned)</a:t>
-            </a:r>
-            <a:endParaRPr lang="en-IN" sz="900">
-              <a:solidFill>
-                <a:srgbClr val="595959"/>
-              </a:solidFill>
-              <a:latin typeface="Arial" panose="020B0604020202020204" pitchFamily="34" charset="0"/>
-            </a:endParaRPr>
-          </a:p>
-        </p:txBody>
-      </p:sp>
-      <p:sp>
-        <p:nvSpPr>
-          <p:cNvPr id="19" name="Rectangle: Rounded Corners 18">
+          <a:ln w="19050">
+            <a:solidFill>
+              <a:srgbClr val="0070C0"/>
+            </a:solidFill>
+            <a:tailEnd type="triangle"/>
+          </a:ln>
+        </p:spPr>
+        <p:style>
+          <a:lnRef idx="2">
+            <a:schemeClr val="accent1"/>
+          </a:lnRef>
+          <a:fillRef idx="0">
+            <a:schemeClr val="accent1"/>
+          </a:fillRef>
+          <a:effectRef idx="1">
+            <a:schemeClr val="accent1"/>
+          </a:effectRef>
+          <a:fontRef idx="minor">
+            <a:schemeClr val="tx1"/>
+          </a:fontRef>
+        </p:style>
+      </p:cxnSp>
+      <p:sp>
+        <p:nvSpPr>
+          <p:cNvPr id="25" name="Rectangle: Rounded Corners 24">
             <a:extLst>
               <a:ext uri="{FF2B5EF4-FFF2-40B4-BE49-F238E27FC236}">
-                <a16:creationId xmlns:a16="http://schemas.microsoft.com/office/drawing/2014/main" id="{F5D430A5-B799-DDEC-CB76-591C0BA96D78}"/>
+                <a16:creationId xmlns:a16="http://schemas.microsoft.com/office/drawing/2014/main" id="{93BB37BA-0AC2-A717-077D-FB7F558A1C0A}"/>
               </a:ext>
             </a:extLst>
           </p:cNvPr>
@@ -9711,8 +10130,8 @@
         </p:nvSpPr>
         <p:spPr>
           <a:xfrm>
-            <a:off x="4368800" y="1219200"/>
-            <a:ext cx="3251200" cy="3403600"/>
+            <a:off x="6477000" y="2133600"/>
+            <a:ext cx="1092200" cy="203200"/>
           </a:xfrm>
           <a:prstGeom prst="roundRect">
             <a:avLst>
@@ -9720,11 +10139,11 @@
             </a:avLst>
           </a:prstGeom>
           <a:solidFill>
-            <a:srgbClr val="EEF3FA"/>
+            <a:srgbClr val="EDEDED"/>
           </a:solidFill>
           <a:ln w="9525">
             <a:solidFill>
-              <a:srgbClr val="B4C7E7"/>
+              <a:srgbClr val="7F7F7F"/>
             </a:solidFill>
           </a:ln>
           <a:effectLst/>
@@ -9757,20 +10176,201 @@
           </a:fontRef>
         </p:style>
         <p:txBody>
-          <a:bodyPr rtlCol="0" anchor="ctr"/>
+          <a:bodyPr lIns="50800" tIns="0" rIns="38100" bIns="0" rtlCol="0" anchor="ctr"/>
           <a:lstStyle/>
           <a:p>
-            <a:pPr algn="ctr"/>
-            <a:endParaRPr lang="en-IN"/>
-          </a:p>
-        </p:txBody>
-      </p:sp>
-      <p:sp>
-        <p:nvSpPr>
-          <p:cNvPr id="20" name="TextBox 19">
+            <a:pPr>
+              <a:spcBef>
+                <a:spcPts val="0"/>
+              </a:spcBef>
+              <a:spcAft>
+                <a:spcPts val="0"/>
+              </a:spcAft>
+            </a:pPr>
+            <a:r>
+              <a:rPr lang="en-IN" sz="700" b="1">
+                <a:solidFill>
+                  <a:srgbClr val="7F7F7F"/>
+                </a:solidFill>
+                <a:latin typeface="Arial" panose="020B0604020202020204" pitchFamily="34" charset="0"/>
+              </a:rPr>
+              <a:t>INCONCLUSIVE: retake</a:t>
+            </a:r>
+          </a:p>
+        </p:txBody>
+      </p:sp>
+      <p:cxnSp>
+        <p:nvCxnSpPr>
+          <p:cNvPr id="26" name="Straight Connector 25">
             <a:extLst>
               <a:ext uri="{FF2B5EF4-FFF2-40B4-BE49-F238E27FC236}">
-                <a16:creationId xmlns:a16="http://schemas.microsoft.com/office/drawing/2014/main" id="{65946A70-E22A-545B-7CDA-397D91ACD610}"/>
+                <a16:creationId xmlns:a16="http://schemas.microsoft.com/office/drawing/2014/main" id="{1AA2037B-B6B7-5A9C-3120-A912F2E994AF}"/>
+              </a:ext>
+            </a:extLst>
+          </p:cNvPr>
+          <p:cNvCxnSpPr/>
+          <p:nvPr/>
+        </p:nvCxnSpPr>
+        <p:spPr>
+          <a:xfrm>
+            <a:off x="6299200" y="1968500"/>
+            <a:ext cx="177800" cy="266700"/>
+          </a:xfrm>
+          <a:prstGeom prst="line">
+            <a:avLst/>
+          </a:prstGeom>
+          <a:ln w="19050">
+            <a:solidFill>
+              <a:srgbClr val="0070C0"/>
+            </a:solidFill>
+            <a:tailEnd type="triangle"/>
+          </a:ln>
+        </p:spPr>
+        <p:style>
+          <a:lnRef idx="2">
+            <a:schemeClr val="accent1"/>
+          </a:lnRef>
+          <a:fillRef idx="0">
+            <a:schemeClr val="accent1"/>
+          </a:fillRef>
+          <a:effectRef idx="1">
+            <a:schemeClr val="accent1"/>
+          </a:effectRef>
+          <a:fontRef idx="minor">
+            <a:schemeClr val="tx1"/>
+          </a:fontRef>
+        </p:style>
+      </p:cxnSp>
+      <p:cxnSp>
+        <p:nvCxnSpPr>
+          <p:cNvPr id="27" name="Straight Connector 26">
+            <a:extLst>
+              <a:ext uri="{FF2B5EF4-FFF2-40B4-BE49-F238E27FC236}">
+                <a16:creationId xmlns:a16="http://schemas.microsoft.com/office/drawing/2014/main" id="{2FF072A3-28DD-16D9-1C31-AC8E729FB982}"/>
+              </a:ext>
+            </a:extLst>
+          </p:cNvPr>
+          <p:cNvCxnSpPr/>
+          <p:nvPr/>
+        </p:nvCxnSpPr>
+        <p:spPr>
+          <a:xfrm>
+            <a:off x="5803900" y="2311400"/>
+            <a:ext cx="0" cy="177800"/>
+          </a:xfrm>
+          <a:prstGeom prst="line">
+            <a:avLst/>
+          </a:prstGeom>
+          <a:ln w="19050">
+            <a:solidFill>
+              <a:srgbClr val="0070C0"/>
+            </a:solidFill>
+          </a:ln>
+        </p:spPr>
+        <p:style>
+          <a:lnRef idx="2">
+            <a:schemeClr val="accent1"/>
+          </a:lnRef>
+          <a:fillRef idx="0">
+            <a:schemeClr val="accent1"/>
+          </a:fillRef>
+          <a:effectRef idx="1">
+            <a:schemeClr val="accent1"/>
+          </a:effectRef>
+          <a:fontRef idx="minor">
+            <a:schemeClr val="tx1"/>
+          </a:fontRef>
+        </p:style>
+      </p:cxnSp>
+      <p:cxnSp>
+        <p:nvCxnSpPr>
+          <p:cNvPr id="28" name="Straight Connector 27">
+            <a:extLst>
+              <a:ext uri="{FF2B5EF4-FFF2-40B4-BE49-F238E27FC236}">
+                <a16:creationId xmlns:a16="http://schemas.microsoft.com/office/drawing/2014/main" id="{CDE06097-BBBD-64EB-1F31-F30A05445729}"/>
+              </a:ext>
+            </a:extLst>
+          </p:cNvPr>
+          <p:cNvCxnSpPr/>
+          <p:nvPr/>
+        </p:nvCxnSpPr>
+        <p:spPr>
+          <a:xfrm flipH="1">
+            <a:off x="1041400" y="2489200"/>
+            <a:ext cx="4762500" cy="0"/>
+          </a:xfrm>
+          <a:prstGeom prst="line">
+            <a:avLst/>
+          </a:prstGeom>
+          <a:ln w="19050">
+            <a:solidFill>
+              <a:srgbClr val="0070C0"/>
+            </a:solidFill>
+          </a:ln>
+        </p:spPr>
+        <p:style>
+          <a:lnRef idx="2">
+            <a:schemeClr val="accent1"/>
+          </a:lnRef>
+          <a:fillRef idx="0">
+            <a:schemeClr val="accent1"/>
+          </a:fillRef>
+          <a:effectRef idx="1">
+            <a:schemeClr val="accent1"/>
+          </a:effectRef>
+          <a:fontRef idx="minor">
+            <a:schemeClr val="tx1"/>
+          </a:fontRef>
+        </p:style>
+      </p:cxnSp>
+      <p:cxnSp>
+        <p:nvCxnSpPr>
+          <p:cNvPr id="29" name="Straight Connector 28">
+            <a:extLst>
+              <a:ext uri="{FF2B5EF4-FFF2-40B4-BE49-F238E27FC236}">
+                <a16:creationId xmlns:a16="http://schemas.microsoft.com/office/drawing/2014/main" id="{B14AB969-34E7-54EC-F93D-701902806186}"/>
+              </a:ext>
+            </a:extLst>
+          </p:cNvPr>
+          <p:cNvCxnSpPr/>
+          <p:nvPr/>
+        </p:nvCxnSpPr>
+        <p:spPr>
+          <a:xfrm flipV="1">
+            <a:off x="1041400" y="2273300"/>
+            <a:ext cx="0" cy="215900"/>
+          </a:xfrm>
+          <a:prstGeom prst="line">
+            <a:avLst/>
+          </a:prstGeom>
+          <a:ln w="19050">
+            <a:solidFill>
+              <a:srgbClr val="0070C0"/>
+            </a:solidFill>
+            <a:tailEnd type="triangle"/>
+          </a:ln>
+        </p:spPr>
+        <p:style>
+          <a:lnRef idx="2">
+            <a:schemeClr val="accent1"/>
+          </a:lnRef>
+          <a:fillRef idx="0">
+            <a:schemeClr val="accent1"/>
+          </a:fillRef>
+          <a:effectRef idx="1">
+            <a:schemeClr val="accent1"/>
+          </a:effectRef>
+          <a:fontRef idx="minor">
+            <a:schemeClr val="tx1"/>
+          </a:fontRef>
+        </p:style>
+      </p:cxnSp>
+      <p:sp>
+        <p:nvSpPr>
+          <p:cNvPr id="30" name="TextBox 29">
+            <a:extLst>
+              <a:ext uri="{FF2B5EF4-FFF2-40B4-BE49-F238E27FC236}">
+                <a16:creationId xmlns:a16="http://schemas.microsoft.com/office/drawing/2014/main" id="{AC68F81B-8DE5-26DD-0900-F5996DD77F54}"/>
               </a:ext>
             </a:extLst>
           </p:cNvPr>
@@ -9779,8 +10379,8 @@
         </p:nvSpPr>
         <p:spPr>
           <a:xfrm>
-            <a:off x="4521200" y="1320800"/>
-            <a:ext cx="2997200" cy="369332"/>
+            <a:off x="1219200" y="2514600"/>
+            <a:ext cx="4318000" cy="369332"/>
           </a:xfrm>
           <a:prstGeom prst="rect">
             <a:avLst/>
@@ -9802,29 +10402,119 @@
               </a:spcAft>
             </a:pPr>
             <a:r>
-              <a:rPr lang="en-US" sz="1100" b="1">
-                <a:solidFill>
-                  <a:srgbClr val="1F3864"/>
-                </a:solidFill>
-                <a:latin typeface="Arial" panose="020B0604020202020204" pitchFamily="34" charset="0"/>
-              </a:rPr>
-              <a:t>THIN SERVER (design): NIC / MeitY cloud</a:t>
-            </a:r>
-            <a:endParaRPr lang="en-IN" sz="1100" b="1">
+              <a:rPr lang="en-US" sz="750" i="1">
+                <a:solidFill>
+                  <a:srgbClr val="595959"/>
+                </a:solidFill>
+                <a:latin typeface="Arial" panose="020B0604020202020204" pitchFamily="34" charset="0"/>
+              </a:rPr>
+              <a:t>no colour change or inconclusive: next test, as the kit's flow chart says</a:t>
+            </a:r>
+            <a:endParaRPr lang="en-IN" sz="750" i="1">
               <a:solidFill>
-                <a:srgbClr val="1F3864"/>
+                <a:srgbClr val="595959"/>
               </a:solidFill>
               <a:latin typeface="Arial" panose="020B0604020202020204" pitchFamily="34" charset="0"/>
             </a:endParaRPr>
           </a:p>
         </p:txBody>
       </p:sp>
-      <p:sp>
-        <p:nvSpPr>
-          <p:cNvPr id="21" name="Rectangle: Rounded Corners 20">
+      <p:cxnSp>
+        <p:nvCxnSpPr>
+          <p:cNvPr id="31" name="Straight Connector 30">
             <a:extLst>
               <a:ext uri="{FF2B5EF4-FFF2-40B4-BE49-F238E27FC236}">
-                <a16:creationId xmlns:a16="http://schemas.microsoft.com/office/drawing/2014/main" id="{5B595798-BF1D-6F31-7C11-C7AC6C48E74E}"/>
+                <a16:creationId xmlns:a16="http://schemas.microsoft.com/office/drawing/2014/main" id="{0CE83182-CD40-48F3-BC64-C4FBA212DD6A}"/>
+              </a:ext>
+            </a:extLst>
+          </p:cNvPr>
+          <p:cNvCxnSpPr/>
+          <p:nvPr/>
+        </p:nvCxnSpPr>
+        <p:spPr>
+          <a:xfrm>
+            <a:off x="7023100" y="2336800"/>
+            <a:ext cx="0" cy="381000"/>
+          </a:xfrm>
+          <a:prstGeom prst="line">
+            <a:avLst/>
+          </a:prstGeom>
+          <a:ln w="19050">
+            <a:solidFill>
+              <a:srgbClr val="0070C0"/>
+            </a:solidFill>
+            <a:tailEnd type="triangle"/>
+          </a:ln>
+        </p:spPr>
+        <p:style>
+          <a:lnRef idx="2">
+            <a:schemeClr val="accent1"/>
+          </a:lnRef>
+          <a:fillRef idx="0">
+            <a:schemeClr val="accent1"/>
+          </a:fillRef>
+          <a:effectRef idx="1">
+            <a:schemeClr val="accent1"/>
+          </a:effectRef>
+          <a:fontRef idx="minor">
+            <a:schemeClr val="tx1"/>
+          </a:fontRef>
+        </p:style>
+      </p:cxnSp>
+      <p:sp>
+        <p:nvSpPr>
+          <p:cNvPr id="32" name="TextBox 31">
+            <a:extLst>
+              <a:ext uri="{FF2B5EF4-FFF2-40B4-BE49-F238E27FC236}">
+                <a16:creationId xmlns:a16="http://schemas.microsoft.com/office/drawing/2014/main" id="{D4BC4560-DC4D-89B0-3656-1E02A2016586}"/>
+              </a:ext>
+            </a:extLst>
+          </p:cNvPr>
+          <p:cNvSpPr txBox="1"/>
+          <p:nvPr/>
+        </p:nvSpPr>
+        <p:spPr>
+          <a:xfrm>
+            <a:off x="7073900" y="2438400"/>
+            <a:ext cx="508000" cy="369332"/>
+          </a:xfrm>
+          <a:prstGeom prst="rect">
+            <a:avLst/>
+          </a:prstGeom>
+          <a:noFill/>
+        </p:spPr>
+        <p:txBody>
+          <a:bodyPr vert="horz" wrap="square" lIns="0" tIns="0" rIns="0" bIns="0" rtlCol="0" anchor="t">
+            <a:noAutofit/>
+          </a:bodyPr>
+          <a:lstStyle/>
+          <a:p>
+            <a:pPr>
+              <a:spcBef>
+                <a:spcPts val="0"/>
+              </a:spcBef>
+              <a:spcAft>
+                <a:spcPts val="300"/>
+              </a:spcAft>
+            </a:pPr>
+            <a:r>
+              <a:rPr lang="en-IN" sz="700" i="1">
+                <a:solidFill>
+                  <a:srgbClr val="595959"/>
+                </a:solidFill>
+                <a:latin typeface="Arial" panose="020B0604020202020204" pitchFamily="34" charset="0"/>
+              </a:rPr>
+              <a:t>every result</a:t>
+            </a:r>
+          </a:p>
+        </p:txBody>
+      </p:sp>
+      <p:sp>
+        <p:nvSpPr>
+          <p:cNvPr id="33" name="Rectangle: Rounded Corners 32">
+            <a:extLst>
+              <a:ext uri="{FF2B5EF4-FFF2-40B4-BE49-F238E27FC236}">
+                <a16:creationId xmlns:a16="http://schemas.microsoft.com/office/drawing/2014/main" id="{B7DB1F25-660A-6862-85ED-C5E1F29987EC}"/>
               </a:ext>
             </a:extLst>
           </p:cNvPr>
@@ -9833,8 +10523,8 @@
         </p:nvSpPr>
         <p:spPr>
           <a:xfrm>
-            <a:off x="4521200" y="1625600"/>
-            <a:ext cx="2946400" cy="508000"/>
+            <a:off x="5588000" y="2717800"/>
+            <a:ext cx="1981200" cy="584200"/>
           </a:xfrm>
           <a:prstGeom prst="roundRect">
             <a:avLst>
@@ -9844,9 +10534,9 @@
           <a:solidFill>
             <a:srgbClr val="FFFFFF"/>
           </a:solidFill>
-          <a:ln w="9525">
+          <a:ln w="12700">
             <a:solidFill>
-              <a:srgbClr val="B4C7E7"/>
+              <a:srgbClr val="0070C0"/>
             </a:solidFill>
           </a:ln>
           <a:effectLst/>
@@ -9879,87 +10569,111 @@
           </a:fontRef>
         </p:style>
         <p:txBody>
-          <a:bodyPr rtlCol="0" anchor="ctr"/>
+          <a:bodyPr lIns="63500" tIns="25400" rIns="50800" bIns="25400" rtlCol="0" anchor="ctr"/>
           <a:lstStyle/>
           <a:p>
-            <a:pPr algn="ctr"/>
-            <a:endParaRPr lang="en-IN"/>
-          </a:p>
-        </p:txBody>
-      </p:sp>
-      <p:sp>
-        <p:nvSpPr>
-          <p:cNvPr id="22" name="TextBox 21">
+            <a:pPr>
+              <a:spcBef>
+                <a:spcPts val="0"/>
+              </a:spcBef>
+              <a:spcAft>
+                <a:spcPts val="100"/>
+              </a:spcAft>
+            </a:pPr>
+            <a:r>
+              <a:rPr lang="en-IN" sz="950" b="1">
+                <a:solidFill>
+                  <a:srgbClr val="0070C0"/>
+                </a:solidFill>
+                <a:latin typeface="Arial" panose="020B0604020202020204" pitchFamily="34" charset="0"/>
+              </a:rPr>
+              <a:t>4  </a:t>
+            </a:r>
+            <a:r>
+              <a:rPr lang="en-IN" sz="950" b="1">
+                <a:solidFill>
+                  <a:srgbClr val="1F3864"/>
+                </a:solidFill>
+                <a:latin typeface="Arial" panose="020B0604020202020204" pitchFamily="34" charset="0"/>
+              </a:rPr>
+              <a:t>Sign and chain</a:t>
+            </a:r>
+          </a:p>
+          <a:p>
+            <a:pPr>
+              <a:spcBef>
+                <a:spcPts val="0"/>
+              </a:spcBef>
+              <a:spcAft>
+                <a:spcPts val="0"/>
+              </a:spcAft>
+            </a:pPr>
+            <a:r>
+              <a:rPr lang="en-US" sz="800">
+                <a:solidFill>
+                  <a:srgbClr val="262626"/>
+                </a:solidFill>
+                <a:latin typeface="Arial" panose="020B0604020202020204" pitchFamily="34" charset="0"/>
+              </a:rPr>
+              <a:t>time, GNSS time, GPS, officer, image hash; signed, and linked to the last record</a:t>
+            </a:r>
+            <a:endParaRPr lang="en-IN" sz="800">
+              <a:solidFill>
+                <a:srgbClr val="262626"/>
+              </a:solidFill>
+              <a:latin typeface="Arial" panose="020B0604020202020204" pitchFamily="34" charset="0"/>
+            </a:endParaRPr>
+          </a:p>
+        </p:txBody>
+      </p:sp>
+      <p:cxnSp>
+        <p:nvCxnSpPr>
+          <p:cNvPr id="34" name="Straight Connector 33">
             <a:extLst>
               <a:ext uri="{FF2B5EF4-FFF2-40B4-BE49-F238E27FC236}">
-                <a16:creationId xmlns:a16="http://schemas.microsoft.com/office/drawing/2014/main" id="{E32604BF-BD58-9552-4E36-03A5B9767B5B}"/>
+                <a16:creationId xmlns:a16="http://schemas.microsoft.com/office/drawing/2014/main" id="{FAC01CE2-429C-729C-2835-326FC18B023B}"/>
               </a:ext>
             </a:extLst>
           </p:cNvPr>
-          <p:cNvSpPr txBox="1"/>
+          <p:cNvCxnSpPr/>
           <p:nvPr/>
-        </p:nvSpPr>
+        </p:nvCxnSpPr>
         <p:spPr>
-          <a:xfrm>
-            <a:off x="4622800" y="1689100"/>
-            <a:ext cx="2768600" cy="369332"/>
-          </a:xfrm>
-          <a:prstGeom prst="rect">
+          <a:xfrm flipH="1">
+            <a:off x="5346700" y="3009900"/>
+            <a:ext cx="241300" cy="0"/>
+          </a:xfrm>
+          <a:prstGeom prst="line">
             <a:avLst/>
           </a:prstGeom>
-          <a:noFill/>
-        </p:spPr>
-        <p:txBody>
-          <a:bodyPr vert="horz" wrap="square" lIns="0" tIns="0" rIns="0" bIns="0" rtlCol="0" anchor="t">
-            <a:noAutofit/>
-          </a:bodyPr>
-          <a:lstStyle/>
-          <a:p>
-            <a:pPr>
-              <a:spcBef>
-                <a:spcPts val="0"/>
-              </a:spcBef>
-              <a:spcAft>
-                <a:spcPts val="0"/>
-              </a:spcAft>
-            </a:pPr>
-            <a:r>
-              <a:rPr lang="en-IN" sz="1050" b="1">
-                <a:solidFill>
-                  <a:srgbClr val="262626"/>
-                </a:solidFill>
-                <a:latin typeface="Arial" panose="020B0604020202020204" pitchFamily="34" charset="0"/>
-              </a:rPr>
-              <a:t>Enrolment</a:t>
-            </a:r>
-          </a:p>
-          <a:p>
-            <a:pPr>
-              <a:spcBef>
-                <a:spcPts val="0"/>
-              </a:spcBef>
-              <a:spcAft>
-                <a:spcPts val="0"/>
-              </a:spcAft>
-            </a:pPr>
-            <a:r>
-              <a:rPr lang="en-IN" sz="900">
-                <a:solidFill>
-                  <a:srgbClr val="595959"/>
-                </a:solidFill>
-                <a:latin typeface="Arial" panose="020B0604020202020204" pitchFamily="34" charset="0"/>
-              </a:rPr>
-              <a:t>attestation + supervisor DSC (checker prototyped)</a:t>
-            </a:r>
-          </a:p>
-        </p:txBody>
-      </p:sp>
-      <p:sp>
-        <p:nvSpPr>
-          <p:cNvPr id="23" name="Rectangle: Rounded Corners 22">
+          <a:ln w="19050">
+            <a:solidFill>
+              <a:srgbClr val="0070C0"/>
+            </a:solidFill>
+            <a:tailEnd type="triangle"/>
+          </a:ln>
+        </p:spPr>
+        <p:style>
+          <a:lnRef idx="2">
+            <a:schemeClr val="accent1"/>
+          </a:lnRef>
+          <a:fillRef idx="0">
+            <a:schemeClr val="accent1"/>
+          </a:fillRef>
+          <a:effectRef idx="1">
+            <a:schemeClr val="accent1"/>
+          </a:effectRef>
+          <a:fontRef idx="minor">
+            <a:schemeClr val="tx1"/>
+          </a:fontRef>
+        </p:style>
+      </p:cxnSp>
+      <p:sp>
+        <p:nvSpPr>
+          <p:cNvPr id="35" name="Rectangle: Rounded Corners 34">
             <a:extLst>
               <a:ext uri="{FF2B5EF4-FFF2-40B4-BE49-F238E27FC236}">
-                <a16:creationId xmlns:a16="http://schemas.microsoft.com/office/drawing/2014/main" id="{ECF1267E-40DD-85EC-6B91-D622F2A9AEB8}"/>
+                <a16:creationId xmlns:a16="http://schemas.microsoft.com/office/drawing/2014/main" id="{EB9ECA86-5BD2-64EA-B1CE-859CD972AC19}"/>
               </a:ext>
             </a:extLst>
           </p:cNvPr>
@@ -9968,8 +10682,8 @@
         </p:nvSpPr>
         <p:spPr>
           <a:xfrm>
-            <a:off x="4521200" y="2209800"/>
-            <a:ext cx="2946400" cy="508000"/>
+            <a:off x="2997200" y="2717800"/>
+            <a:ext cx="2336800" cy="584200"/>
           </a:xfrm>
           <a:prstGeom prst="roundRect">
             <a:avLst>
@@ -9979,9 +10693,9 @@
           <a:solidFill>
             <a:srgbClr val="FFFFFF"/>
           </a:solidFill>
-          <a:ln w="9525">
+          <a:ln w="12700">
             <a:solidFill>
-              <a:srgbClr val="B4C7E7"/>
+              <a:srgbClr val="0070C0"/>
             </a:solidFill>
           </a:ln>
           <a:effectLst/>
@@ -10014,20 +10728,69 @@
           </a:fontRef>
         </p:style>
         <p:txBody>
-          <a:bodyPr rtlCol="0" anchor="ctr"/>
+          <a:bodyPr lIns="63500" tIns="25400" rIns="50800" bIns="25400" rtlCol="0" anchor="ctr"/>
           <a:lstStyle/>
           <a:p>
-            <a:pPr algn="ctr"/>
-            <a:endParaRPr lang="en-IN"/>
-          </a:p>
-        </p:txBody>
-      </p:sp>
-      <p:sp>
-        <p:nvSpPr>
-          <p:cNvPr id="24" name="TextBox 23">
+            <a:pPr>
+              <a:spcBef>
+                <a:spcPts val="0"/>
+              </a:spcBef>
+              <a:spcAft>
+                <a:spcPts val="100"/>
+              </a:spcAft>
+            </a:pPr>
+            <a:r>
+              <a:rPr lang="en-IN" sz="950" b="1">
+                <a:solidFill>
+                  <a:srgbClr val="0070C0"/>
+                </a:solidFill>
+                <a:latin typeface="Arial" panose="020B0604020202020204" pitchFamily="34" charset="0"/>
+              </a:rPr>
+              <a:t>5  </a:t>
+            </a:r>
+            <a:r>
+              <a:rPr lang="en-IN" sz="950" b="1">
+                <a:solidFill>
+                  <a:srgbClr val="1F3864"/>
+                </a:solidFill>
+                <a:latin typeface="Arial" panose="020B0604020202020204" pitchFamily="34" charset="0"/>
+              </a:rPr>
+              <a:t>Anchor</a:t>
+            </a:r>
+          </a:p>
+          <a:p>
+            <a:pPr>
+              <a:spcBef>
+                <a:spcPts val="0"/>
+              </a:spcBef>
+              <a:spcAft>
+                <a:spcPts val="0"/>
+              </a:spcAft>
+            </a:pPr>
+            <a:r>
+              <a:rPr lang="en-US" sz="800">
+                <a:solidFill>
+                  <a:srgbClr val="262626"/>
+                </a:solidFill>
+                <a:latin typeface="Arial" panose="020B0604020202020204" pitchFamily="34" charset="0"/>
+              </a:rPr>
+              <a:t>a 14-character code goes into the panchnama that the witnesses sign</a:t>
+            </a:r>
+            <a:endParaRPr lang="en-IN" sz="800">
+              <a:solidFill>
+                <a:srgbClr val="262626"/>
+              </a:solidFill>
+              <a:latin typeface="Arial" panose="020B0604020202020204" pitchFamily="34" charset="0"/>
+            </a:endParaRPr>
+          </a:p>
+        </p:txBody>
+      </p:sp>
+      <p:sp>
+        <p:nvSpPr>
+          <p:cNvPr id="36" name="TextBox 35">
             <a:extLst>
               <a:ext uri="{FF2B5EF4-FFF2-40B4-BE49-F238E27FC236}">
-                <a16:creationId xmlns:a16="http://schemas.microsoft.com/office/drawing/2014/main" id="{6685144D-FB2B-2343-3CF0-3CAC82DD6BF2}"/>
+                <a16:creationId xmlns:a16="http://schemas.microsoft.com/office/drawing/2014/main" id="{1887C6B0-985A-3D87-A448-29DB2E31CF9F}"/>
               </a:ext>
             </a:extLst>
           </p:cNvPr>
@@ -10036,8 +10799,8 @@
         </p:nvSpPr>
         <p:spPr>
           <a:xfrm>
-            <a:off x="4622800" y="2273300"/>
-            <a:ext cx="2768600" cy="369332"/>
+            <a:off x="381000" y="2768600"/>
+            <a:ext cx="2489200" cy="369332"/>
           </a:xfrm>
           <a:prstGeom prst="rect">
             <a:avLst/>
@@ -10055,38 +10818,19 @@
                 <a:spcPts val="0"/>
               </a:spcBef>
               <a:spcAft>
-                <a:spcPts val="0"/>
+                <a:spcPts val="300"/>
               </a:spcAft>
             </a:pPr>
             <a:r>
-              <a:rPr lang="en-IN" sz="1050" b="1">
-                <a:solidFill>
-                  <a:srgbClr val="262626"/>
-                </a:solidFill>
-                <a:latin typeface="Arial" panose="020B0604020202020204" pitchFamily="34" charset="0"/>
-              </a:rPr>
-              <a:t>Sync</a:t>
-            </a:r>
-          </a:p>
-          <a:p>
-            <a:pPr>
-              <a:spcBef>
-                <a:spcPts val="0"/>
-              </a:spcBef>
-              <a:spcAft>
-                <a:spcPts val="0"/>
-              </a:spcAft>
-            </a:pPr>
-            <a:r>
-              <a:rPr lang="en-US" sz="900">
+              <a:rPr lang="en-US" sz="800" i="1">
                 <a:solidFill>
                   <a:srgbClr val="595959"/>
                 </a:solidFill>
                 <a:latin typeface="Arial" panose="020B0604020202020204" pitchFamily="34" charset="0"/>
               </a:rPr>
-              <a:t>idempotent, fork/replay checks (protocol prototyped)</a:t>
-            </a:r>
-            <a:endParaRPr lang="en-IN" sz="900">
+              <a:t>Every capture is recorded, retakes and negatives too, so a test cannot be quietly dropped or re-run.</a:t>
+            </a:r>
+            <a:endParaRPr lang="en-IN" sz="800" i="1">
               <a:solidFill>
                 <a:srgbClr val="595959"/>
               </a:solidFill>
@@ -10095,12 +10839,54 @@
           </a:p>
         </p:txBody>
       </p:sp>
-      <p:sp>
-        <p:nvSpPr>
-          <p:cNvPr id="25" name="Rectangle: Rounded Corners 24">
+      <p:cxnSp>
+        <p:nvCxnSpPr>
+          <p:cNvPr id="37" name="Straight Connector 36">
             <a:extLst>
               <a:ext uri="{FF2B5EF4-FFF2-40B4-BE49-F238E27FC236}">
-                <a16:creationId xmlns:a16="http://schemas.microsoft.com/office/drawing/2014/main" id="{E2C95DCE-93EA-E484-BE6C-D45E8F2AB34D}"/>
+                <a16:creationId xmlns:a16="http://schemas.microsoft.com/office/drawing/2014/main" id="{3A03169A-2EA8-2DD5-82FD-C9DEAAD6EE9B}"/>
+              </a:ext>
+            </a:extLst>
+          </p:cNvPr>
+          <p:cNvCxnSpPr/>
+          <p:nvPr/>
+        </p:nvCxnSpPr>
+        <p:spPr>
+          <a:xfrm>
+            <a:off x="3556000" y="3302000"/>
+            <a:ext cx="0" cy="508000"/>
+          </a:xfrm>
+          <a:prstGeom prst="line">
+            <a:avLst/>
+          </a:prstGeom>
+          <a:ln w="19050">
+            <a:solidFill>
+              <a:srgbClr val="0070C0"/>
+            </a:solidFill>
+            <a:tailEnd type="triangle"/>
+          </a:ln>
+        </p:spPr>
+        <p:style>
+          <a:lnRef idx="2">
+            <a:schemeClr val="accent1"/>
+          </a:lnRef>
+          <a:fillRef idx="0">
+            <a:schemeClr val="accent1"/>
+          </a:fillRef>
+          <a:effectRef idx="1">
+            <a:schemeClr val="accent1"/>
+          </a:effectRef>
+          <a:fontRef idx="minor">
+            <a:schemeClr val="tx1"/>
+          </a:fontRef>
+        </p:style>
+      </p:cxnSp>
+      <p:sp>
+        <p:nvSpPr>
+          <p:cNvPr id="38" name="Rectangle: Rounded Corners 37">
+            <a:extLst>
+              <a:ext uri="{FF2B5EF4-FFF2-40B4-BE49-F238E27FC236}">
+                <a16:creationId xmlns:a16="http://schemas.microsoft.com/office/drawing/2014/main" id="{DC0E5C86-35BA-94E0-7B91-E8CC4EB966AB}"/>
               </a:ext>
             </a:extLst>
           </p:cNvPr>
@@ -10109,8 +10895,8 @@
         </p:nvSpPr>
         <p:spPr>
           <a:xfrm>
-            <a:off x="4521200" y="2794000"/>
-            <a:ext cx="2946400" cy="508000"/>
+            <a:off x="381000" y="3810000"/>
+            <a:ext cx="3403600" cy="736600"/>
           </a:xfrm>
           <a:prstGeom prst="roundRect">
             <a:avLst>
@@ -10120,9 +10906,9 @@
           <a:solidFill>
             <a:srgbClr val="FFFFFF"/>
           </a:solidFill>
-          <a:ln w="9525">
+          <a:ln w="12700">
             <a:solidFill>
-              <a:srgbClr val="B4C7E7"/>
+              <a:srgbClr val="0070C0"/>
             </a:solidFill>
           </a:ln>
           <a:effectLst/>
@@ -10155,93 +10941,102 @@
           </a:fontRef>
         </p:style>
         <p:txBody>
-          <a:bodyPr rtlCol="0" anchor="ctr"/>
+          <a:bodyPr lIns="63500" tIns="25400" rIns="50800" bIns="25400" rtlCol="0" anchor="ctr"/>
           <a:lstStyle/>
           <a:p>
-            <a:pPr algn="ctr"/>
-            <a:endParaRPr lang="en-IN"/>
-          </a:p>
-        </p:txBody>
-      </p:sp>
-      <p:sp>
-        <p:nvSpPr>
-          <p:cNvPr id="26" name="TextBox 25">
+            <a:pPr>
+              <a:spcBef>
+                <a:spcPts val="0"/>
+              </a:spcBef>
+              <a:spcAft>
+                <a:spcPts val="100"/>
+              </a:spcAft>
+            </a:pPr>
+            <a:r>
+              <a:rPr lang="en-IN" sz="950" b="1">
+                <a:solidFill>
+                  <a:srgbClr val="1F3864"/>
+                </a:solidFill>
+                <a:latin typeface="Arial" panose="020B0604020202020204" pitchFamily="34" charset="0"/>
+              </a:rPr>
+              <a:t>Verify, any time</a:t>
+            </a:r>
+          </a:p>
+          <a:p>
+            <a:pPr>
+              <a:spcBef>
+                <a:spcPts val="0"/>
+              </a:spcBef>
+              <a:spcAft>
+                <a:spcPts val="0"/>
+              </a:spcAft>
+            </a:pPr>
+            <a:r>
+              <a:rPr lang="en-US" sz="800">
+                <a:solidFill>
+                  <a:srgbClr val="262626"/>
+                </a:solidFill>
+                <a:latin typeface="Arial" panose="020B0604020202020204" pitchFamily="34" charset="0"/>
+              </a:rPr>
+              <a:t>a court expert, the defence or the lab re-checks signatures, the chain and the panchnama code: VERIFIED or tampering found</a:t>
+            </a:r>
+            <a:endParaRPr lang="en-IN" sz="800">
+              <a:solidFill>
+                <a:srgbClr val="262626"/>
+              </a:solidFill>
+              <a:latin typeface="Arial" panose="020B0604020202020204" pitchFamily="34" charset="0"/>
+            </a:endParaRPr>
+          </a:p>
+        </p:txBody>
+      </p:sp>
+      <p:cxnSp>
+        <p:nvCxnSpPr>
+          <p:cNvPr id="39" name="Straight Connector 38">
             <a:extLst>
               <a:ext uri="{FF2B5EF4-FFF2-40B4-BE49-F238E27FC236}">
-                <a16:creationId xmlns:a16="http://schemas.microsoft.com/office/drawing/2014/main" id="{4850C8C0-D323-1B60-075F-978655C6F80D}"/>
+                <a16:creationId xmlns:a16="http://schemas.microsoft.com/office/drawing/2014/main" id="{4C7CBB13-7A00-19EB-25E4-105EC32D7867}"/>
               </a:ext>
             </a:extLst>
           </p:cNvPr>
-          <p:cNvSpPr txBox="1"/>
+          <p:cNvCxnSpPr/>
           <p:nvPr/>
-        </p:nvSpPr>
+        </p:nvCxnSpPr>
         <p:spPr>
           <a:xfrm>
-            <a:off x="4622800" y="2857500"/>
-            <a:ext cx="2768600" cy="369332"/>
-          </a:xfrm>
-          <a:prstGeom prst="rect">
+            <a:off x="6578600" y="3302000"/>
+            <a:ext cx="0" cy="508000"/>
+          </a:xfrm>
+          <a:prstGeom prst="line">
             <a:avLst/>
           </a:prstGeom>
-          <a:noFill/>
-        </p:spPr>
-        <p:txBody>
-          <a:bodyPr vert="horz" wrap="square" lIns="0" tIns="0" rIns="0" bIns="0" rtlCol="0" anchor="t">
-            <a:noAutofit/>
-          </a:bodyPr>
-          <a:lstStyle/>
-          <a:p>
-            <a:pPr>
-              <a:spcBef>
-                <a:spcPts val="0"/>
-              </a:spcBef>
-              <a:spcAft>
-                <a:spcPts val="0"/>
-              </a:spcAft>
-            </a:pPr>
-            <a:r>
-              <a:rPr lang="en-IN" sz="1050" b="1">
-                <a:solidFill>
-                  <a:srgbClr val="262626"/>
-                </a:solidFill>
-                <a:latin typeface="Arial" panose="020B0604020202020204" pitchFamily="34" charset="0"/>
-              </a:rPr>
-              <a:t>Storage</a:t>
-            </a:r>
-          </a:p>
-          <a:p>
-            <a:pPr>
-              <a:spcBef>
-                <a:spcPts val="0"/>
-              </a:spcBef>
-              <a:spcAft>
-                <a:spcPts val="0"/>
-              </a:spcAft>
-            </a:pPr>
-            <a:r>
-              <a:rPr lang="en-US" sz="900">
-                <a:solidFill>
-                  <a:srgbClr val="595959"/>
-                </a:solidFill>
-                <a:latin typeface="Arial" panose="020B0604020202020204" pitchFamily="34" charset="0"/>
-              </a:rPr>
-              <a:t>PostgreSQL + S3 write-once (prototype: SQLite)</a:t>
-            </a:r>
-            <a:endParaRPr lang="en-IN" sz="900">
-              <a:solidFill>
-                <a:srgbClr val="595959"/>
-              </a:solidFill>
-              <a:latin typeface="Arial" panose="020B0604020202020204" pitchFamily="34" charset="0"/>
-            </a:endParaRPr>
-          </a:p>
-        </p:txBody>
-      </p:sp>
-      <p:sp>
-        <p:nvSpPr>
-          <p:cNvPr id="27" name="Rectangle: Rounded Corners 26">
+          <a:ln w="19050">
+            <a:solidFill>
+              <a:srgbClr val="0070C0"/>
+            </a:solidFill>
+            <a:tailEnd type="triangle"/>
+          </a:ln>
+        </p:spPr>
+        <p:style>
+          <a:lnRef idx="2">
+            <a:schemeClr val="accent1"/>
+          </a:lnRef>
+          <a:fillRef idx="0">
+            <a:schemeClr val="accent1"/>
+          </a:fillRef>
+          <a:effectRef idx="1">
+            <a:schemeClr val="accent1"/>
+          </a:effectRef>
+          <a:fontRef idx="minor">
+            <a:schemeClr val="tx1"/>
+          </a:fontRef>
+        </p:style>
+      </p:cxnSp>
+      <p:sp>
+        <p:nvSpPr>
+          <p:cNvPr id="40" name="Rectangle: Rounded Corners 39">
             <a:extLst>
               <a:ext uri="{FF2B5EF4-FFF2-40B4-BE49-F238E27FC236}">
-                <a16:creationId xmlns:a16="http://schemas.microsoft.com/office/drawing/2014/main" id="{5052018C-D2CC-A892-7752-09845325520E}"/>
+                <a16:creationId xmlns:a16="http://schemas.microsoft.com/office/drawing/2014/main" id="{16BF1495-281A-B31E-119F-C536BF4D0168}"/>
               </a:ext>
             </a:extLst>
           </p:cNvPr>
@@ -10250,8 +11045,8 @@
         </p:nvSpPr>
         <p:spPr>
           <a:xfrm>
-            <a:off x="4521200" y="3378200"/>
-            <a:ext cx="2946400" cy="508000"/>
+            <a:off x="4114800" y="3810000"/>
+            <a:ext cx="3403600" cy="736600"/>
           </a:xfrm>
           <a:prstGeom prst="roundRect">
             <a:avLst>
@@ -10261,9 +11056,9 @@
           <a:solidFill>
             <a:srgbClr val="FFFFFF"/>
           </a:solidFill>
-          <a:ln w="9525">
+          <a:ln w="12700">
             <a:solidFill>
-              <a:srgbClr val="B4C7E7"/>
+              <a:srgbClr val="0070C0"/>
             </a:solidFill>
           </a:ln>
           <a:effectLst/>
@@ -10296,20 +11091,60 @@
           </a:fontRef>
         </p:style>
         <p:txBody>
-          <a:bodyPr rtlCol="0" anchor="ctr"/>
+          <a:bodyPr lIns="63500" tIns="25400" rIns="50800" bIns="25400" rtlCol="0" anchor="ctr"/>
           <a:lstStyle/>
           <a:p>
-            <a:pPr algn="ctr"/>
-            <a:endParaRPr lang="en-IN"/>
-          </a:p>
-        </p:txBody>
-      </p:sp>
-      <p:sp>
-        <p:nvSpPr>
-          <p:cNvPr id="28" name="TextBox 27">
+            <a:pPr>
+              <a:spcBef>
+                <a:spcPts val="0"/>
+              </a:spcBef>
+              <a:spcAft>
+                <a:spcPts val="100"/>
+              </a:spcAft>
+            </a:pPr>
+            <a:r>
+              <a:rPr lang="en-IN" sz="950" b="1">
+                <a:solidFill>
+                  <a:srgbClr val="1F3864"/>
+                </a:solidFill>
+                <a:latin typeface="Arial" panose="020B0604020202020204" pitchFamily="34" charset="0"/>
+              </a:rPr>
+              <a:t>Sync and search</a:t>
+            </a:r>
+          </a:p>
+          <a:p>
+            <a:pPr>
+              <a:spcBef>
+                <a:spcPts val="0"/>
+              </a:spcBef>
+              <a:spcAft>
+                <a:spcPts val="0"/>
+              </a:spcAft>
+            </a:pPr>
+            <a:r>
+              <a:rPr lang="en-US" sz="800">
+                <a:solidFill>
+                  <a:srgbClr val="262626"/>
+                </a:solidFill>
+                <a:latin typeface="Arial" panose="020B0604020202020204" pitchFamily="34" charset="0"/>
+              </a:rPr>
+              <a:t>each record checked on arrival (forks, replays, gaps); case search; our server is never trusted; lab-result link planned</a:t>
+            </a:r>
+            <a:endParaRPr lang="en-IN" sz="800">
+              <a:solidFill>
+                <a:srgbClr val="262626"/>
+              </a:solidFill>
+              <a:latin typeface="Arial" panose="020B0604020202020204" pitchFamily="34" charset="0"/>
+            </a:endParaRPr>
+          </a:p>
+        </p:txBody>
+      </p:sp>
+      <p:sp>
+        <p:nvSpPr>
+          <p:cNvPr id="41" name="TextBox 40">
             <a:extLst>
               <a:ext uri="{FF2B5EF4-FFF2-40B4-BE49-F238E27FC236}">
-                <a16:creationId xmlns:a16="http://schemas.microsoft.com/office/drawing/2014/main" id="{3FBA14EB-A040-E408-8895-1DCDA4854F17}"/>
+                <a16:creationId xmlns:a16="http://schemas.microsoft.com/office/drawing/2014/main" id="{E8DE7C73-0ADF-AE12-E8A2-116A9FBD20F2}"/>
               </a:ext>
             </a:extLst>
           </p:cNvPr>
@@ -10318,8 +11153,8 @@
         </p:nvSpPr>
         <p:spPr>
           <a:xfrm>
-            <a:off x="4622800" y="3441700"/>
-            <a:ext cx="2768600" cy="369332"/>
+            <a:off x="279400" y="4660900"/>
+            <a:ext cx="7340600" cy="369332"/>
           </a:xfrm>
           <a:prstGeom prst="rect">
             <a:avLst/>
@@ -10337,38 +11172,19 @@
                 <a:spcPts val="0"/>
               </a:spcBef>
               <a:spcAft>
-                <a:spcPts val="0"/>
+                <a:spcPts val="300"/>
               </a:spcAft>
             </a:pPr>
             <a:r>
-              <a:rPr lang="en-IN" sz="1050" b="1">
-                <a:solidFill>
-                  <a:srgbClr val="262626"/>
-                </a:solidFill>
-                <a:latin typeface="Arial" panose="020B0604020202020204" pitchFamily="34" charset="0"/>
-              </a:rPr>
-              <a:t>Search + lab loop</a:t>
-            </a:r>
-          </a:p>
-          <a:p>
-            <a:pPr>
-              <a:spcBef>
-                <a:spcPts val="0"/>
-              </a:spcBef>
-              <a:spcAft>
-                <a:spcPts val="0"/>
-              </a:spcAft>
-            </a:pPr>
-            <a:r>
-              <a:rPr lang="en-US" sz="900">
+              <a:rPr lang="en-US" sz="800" i="1">
                 <a:solidFill>
                   <a:srgbClr val="595959"/>
                 </a:solidFill>
                 <a:latin typeface="Arial" panose="020B0604020202020204" pitchFamily="34" charset="0"/>
               </a:rPr>
-              <a:t>case search (prototyped); lab-result link (planned)</a:t>
-            </a:r>
-            <a:endParaRPr lang="en-IN" sz="900">
+              <a:t>Every step above runs today in our Python prototype (colour on simulated photos). The Android app and hardware-backed keys are next.</a:t>
+            </a:r>
+            <a:endParaRPr lang="en-IN" sz="800" i="1">
               <a:solidFill>
                 <a:srgbClr val="595959"/>
               </a:solidFill>
@@ -10379,78 +11195,10 @@
       </p:sp>
       <p:sp>
         <p:nvSpPr>
-          <p:cNvPr id="29" name="Rectangle: Rounded Corners 28">
+          <p:cNvPr id="42" name="TextBox 41">
             <a:extLst>
               <a:ext uri="{FF2B5EF4-FFF2-40B4-BE49-F238E27FC236}">
-                <a16:creationId xmlns:a16="http://schemas.microsoft.com/office/drawing/2014/main" id="{D816C4BB-0E8F-4A90-9CCC-3E1458485E92}"/>
-              </a:ext>
-            </a:extLst>
-          </p:cNvPr>
-          <p:cNvSpPr/>
-          <p:nvPr/>
-        </p:nvSpPr>
-        <p:spPr>
-          <a:xfrm>
-            <a:off x="4521200" y="3962400"/>
-            <a:ext cx="2946400" cy="508000"/>
-          </a:xfrm>
-          <a:prstGeom prst="roundRect">
-            <a:avLst>
-              <a:gd name="adj" fmla="val 12000"/>
-            </a:avLst>
-          </a:prstGeom>
-          <a:solidFill>
-            <a:srgbClr val="FFFFFF"/>
-          </a:solidFill>
-          <a:ln w="9525">
-            <a:solidFill>
-              <a:srgbClr val="B4C7E7"/>
-            </a:solidFill>
-          </a:ln>
-          <a:effectLst/>
-          <a:extLst>
-            <a:ext uri="{AF507438-7753-43E0-B8FC-AC1667EBCBE1}">
-              <a14:hiddenEffects xmlns:a14="http://schemas.microsoft.com/office/drawing/2010/main">
-                <a:effectLst>
-                  <a:outerShdw blurRad="40000" dist="23000" dir="5400000" rotWithShape="0">
-                    <a:srgbClr val="000000">
-                      <a:alpha val="35000"/>
-                    </a:srgbClr>
-                  </a:outerShdw>
-                </a:effectLst>
-              </a14:hiddenEffects>
-            </a:ext>
-          </a:extLst>
-        </p:spPr>
-        <p:style>
-          <a:lnRef idx="1">
-            <a:schemeClr val="accent1"/>
-          </a:lnRef>
-          <a:fillRef idx="3">
-            <a:schemeClr val="accent1"/>
-          </a:fillRef>
-          <a:effectRef idx="2">
-            <a:schemeClr val="accent1"/>
-          </a:effectRef>
-          <a:fontRef idx="minor">
-            <a:schemeClr val="lt1"/>
-          </a:fontRef>
-        </p:style>
-        <p:txBody>
-          <a:bodyPr rtlCol="0" anchor="ctr"/>
-          <a:lstStyle/>
-          <a:p>
-            <a:pPr algn="ctr"/>
-            <a:endParaRPr lang="en-IN"/>
-          </a:p>
-        </p:txBody>
-      </p:sp>
-      <p:sp>
-        <p:nvSpPr>
-          <p:cNvPr id="30" name="TextBox 29">
-            <a:extLst>
-              <a:ext uri="{FF2B5EF4-FFF2-40B4-BE49-F238E27FC236}">
-                <a16:creationId xmlns:a16="http://schemas.microsoft.com/office/drawing/2014/main" id="{5509B644-2A7A-D15B-3049-7E1939EA8A53}"/>
+                <a16:creationId xmlns:a16="http://schemas.microsoft.com/office/drawing/2014/main" id="{C65E0FAE-174B-8B38-8795-DA34BC72E1AC}"/>
               </a:ext>
             </a:extLst>
           </p:cNvPr>
@@ -10459,8 +11207,8 @@
         </p:nvSpPr>
         <p:spPr>
           <a:xfrm>
-            <a:off x="4622800" y="4025900"/>
-            <a:ext cx="2768600" cy="369332"/>
+            <a:off x="279400" y="4876800"/>
+            <a:ext cx="7340600" cy="369332"/>
           </a:xfrm>
           <a:prstGeom prst="rect">
             <a:avLst/>
@@ -10478,17 +11226,26 @@
                 <a:spcPts val="0"/>
               </a:spcBef>
               <a:spcAft>
-                <a:spcPts val="0"/>
+                <a:spcPts val="400"/>
               </a:spcAft>
             </a:pPr>
             <a:r>
-              <a:rPr lang="en-IN" sz="1050" b="1">
+              <a:rPr lang="en-IN" sz="900" b="1">
+                <a:solidFill>
+                  <a:srgbClr val="1F3864"/>
+                </a:solidFill>
+                <a:latin typeface="Arial" panose="020B0604020202020204" pitchFamily="34" charset="0"/>
+              </a:rPr>
+              <a:t>Trust: </a:t>
+            </a:r>
+            <a:r>
+              <a:rPr lang="en-US" sz="900">
                 <a:solidFill>
                   <a:srgbClr val="262626"/>
                 </a:solidFill>
                 <a:latin typeface="Arial" panose="020B0604020202020204" pitchFamily="34" charset="0"/>
               </a:rPr>
-              <a:t>Never trusted</a:t>
+              <a:t>NCB signs the supervisor list; a supervisor's key (a Class 3 DSC in production) binds officer + phone + key; the phone key is designed to live in StrongBox/TEE (prototype: test keys).</a:t>
             </a:r>
           </a:p>
           <a:p>
@@ -10497,75 +11254,70 @@
                 <a:spcPts val="0"/>
               </a:spcBef>
               <a:spcAft>
-                <a:spcPts val="0"/>
+                <a:spcPts val="400"/>
               </a:spcAft>
             </a:pPr>
             <a:r>
+              <a:rPr lang="en-IN" sz="900" b="1">
+                <a:solidFill>
+                  <a:srgbClr val="1F3864"/>
+                </a:solidFill>
+                <a:latin typeface="Arial" panose="020B0604020202020204" pitchFamily="34" charset="0"/>
+              </a:rPr>
+              <a:t>Technologies to be used: </a:t>
+            </a:r>
+            <a:r>
+              <a:rPr lang="en-IN" sz="900">
+                <a:solidFill>
+                  <a:srgbClr val="262626"/>
+                </a:solidFill>
+                <a:latin typeface="Arial" panose="020B0604020202020204" pitchFamily="34" charset="0"/>
+              </a:rPr>
+              <a:t>Kotlin · CameraX/Camera2 RAW · OpenCV · Android Keystore + attestation · SQLCipher · RFC 8785 JSON · ECDSA P-256 · Spring Boot · PostgreSQL · S3. Prototype today: Python, OpenCV, SQLite.</a:t>
+            </a:r>
+          </a:p>
+          <a:p>
+            <a:pPr>
+              <a:spcBef>
+                <a:spcPts val="0"/>
+              </a:spcBef>
+              <a:spcAft>
+                <a:spcPts val="300"/>
+              </a:spcAft>
+            </a:pPr>
+            <a:r>
+              <a:rPr lang="en-IN" sz="900" b="1">
+                <a:solidFill>
+                  <a:srgbClr val="1F3864"/>
+                </a:solidFill>
+                <a:latin typeface="Arial" panose="020B0604020202020204" pitchFamily="34" charset="0"/>
+              </a:rPr>
+              <a:t>Deliberately not used: </a:t>
+            </a:r>
+            <a:r>
               <a:rPr lang="en-US" sz="900">
                 <a:solidFill>
-                  <a:srgbClr val="595959"/>
-                </a:solidFill>
-                <a:latin typeface="Arial" panose="020B0604020202020204" pitchFamily="34" charset="0"/>
-              </a:rPr>
-              <a:t>records verify without the server</a:t>
+                  <a:srgbClr val="262626"/>
+                </a:solidFill>
+                <a:latin typeface="Arial" panose="020B0604020202020204" pitchFamily="34" charset="0"/>
+              </a:rPr>
+              <a:t>blockchain, cloud AI, a neural-network "drug detector" (a colour test cannot identify a drug; the court must be able to re-run the reading).</a:t>
             </a:r>
             <a:endParaRPr lang="en-IN" sz="900">
               <a:solidFill>
-                <a:srgbClr val="595959"/>
+                <a:srgbClr val="262626"/>
               </a:solidFill>
               <a:latin typeface="Arial" panose="020B0604020202020204" pitchFamily="34" charset="0"/>
             </a:endParaRPr>
           </a:p>
         </p:txBody>
       </p:sp>
-      <p:cxnSp>
-        <p:nvCxnSpPr>
-          <p:cNvPr id="31" name="Straight Connector 30">
+      <p:sp>
+        <p:nvSpPr>
+          <p:cNvPr id="43" name="TextBox 42">
             <a:extLst>
               <a:ext uri="{FF2B5EF4-FFF2-40B4-BE49-F238E27FC236}">
-                <a16:creationId xmlns:a16="http://schemas.microsoft.com/office/drawing/2014/main" id="{0C0ABB2D-0B41-2222-AD7E-0A2014FA7D56}"/>
-              </a:ext>
-            </a:extLst>
-          </p:cNvPr>
-          <p:cNvCxnSpPr/>
-          <p:nvPr/>
-        </p:nvCxnSpPr>
-        <p:spPr>
-          <a:xfrm>
-            <a:off x="3860800" y="2921000"/>
-            <a:ext cx="482600" cy="0"/>
-          </a:xfrm>
-          <a:prstGeom prst="line">
-            <a:avLst/>
-          </a:prstGeom>
-          <a:ln w="19050">
-            <a:solidFill>
-              <a:srgbClr val="0070C0"/>
-            </a:solidFill>
-            <a:tailEnd type="triangle"/>
-          </a:ln>
-        </p:spPr>
-        <p:style>
-          <a:lnRef idx="2">
-            <a:schemeClr val="accent1"/>
-          </a:lnRef>
-          <a:fillRef idx="0">
-            <a:schemeClr val="accent1"/>
-          </a:fillRef>
-          <a:effectRef idx="1">
-            <a:schemeClr val="accent1"/>
-          </a:effectRef>
-          <a:fontRef idx="minor">
-            <a:schemeClr val="tx1"/>
-          </a:fontRef>
-        </p:style>
-      </p:cxnSp>
-      <p:sp>
-        <p:nvSpPr>
-          <p:cNvPr id="32" name="TextBox 31">
-            <a:extLst>
-              <a:ext uri="{FF2B5EF4-FFF2-40B4-BE49-F238E27FC236}">
-                <a16:creationId xmlns:a16="http://schemas.microsoft.com/office/drawing/2014/main" id="{CC76A013-24D4-71F3-1356-0A3D2CFF4742}"/>
+                <a16:creationId xmlns:a16="http://schemas.microsoft.com/office/drawing/2014/main" id="{0EDCF619-3A28-09A1-0280-A9244D0CBECD}"/>
               </a:ext>
             </a:extLst>
           </p:cNvPr>
@@ -10574,124 +11326,8 @@
         </p:nvSpPr>
         <p:spPr>
           <a:xfrm>
-            <a:off x="3784600" y="2590800"/>
-            <a:ext cx="635000" cy="369332"/>
-          </a:xfrm>
-          <a:prstGeom prst="rect">
-            <a:avLst/>
-          </a:prstGeom>
-          <a:noFill/>
-        </p:spPr>
-        <p:txBody>
-          <a:bodyPr vert="horz" wrap="square" lIns="0" tIns="0" rIns="0" bIns="0" rtlCol="0" anchor="t">
-            <a:noAutofit/>
-          </a:bodyPr>
-          <a:lstStyle/>
-          <a:p>
-            <a:pPr algn="ctr">
-              <a:spcBef>
-                <a:spcPts val="0"/>
-              </a:spcBef>
-              <a:spcAft>
-                <a:spcPts val="0"/>
-              </a:spcAft>
-            </a:pPr>
-            <a:r>
-              <a:rPr lang="en-IN" sz="750" i="1">
-                <a:solidFill>
-                  <a:srgbClr val="595959"/>
-                </a:solidFill>
-                <a:latin typeface="Arial" panose="020B0604020202020204" pitchFamily="34" charset="0"/>
-              </a:rPr>
-              <a:t>sync when online</a:t>
-            </a:r>
-          </a:p>
-        </p:txBody>
-      </p:sp>
-      <p:sp>
-        <p:nvSpPr>
-          <p:cNvPr id="33" name="Rectangle: Rounded Corners 32">
-            <a:extLst>
-              <a:ext uri="{FF2B5EF4-FFF2-40B4-BE49-F238E27FC236}">
-                <a16:creationId xmlns:a16="http://schemas.microsoft.com/office/drawing/2014/main" id="{1FE97FCB-A245-48C5-5C04-9CE4CDB1B9D1}"/>
-              </a:ext>
-            </a:extLst>
-          </p:cNvPr>
-          <p:cNvSpPr/>
-          <p:nvPr/>
-        </p:nvSpPr>
-        <p:spPr>
-          <a:xfrm>
-            <a:off x="279400" y="4749800"/>
-            <a:ext cx="7340600" cy="711200"/>
-          </a:xfrm>
-          <a:prstGeom prst="roundRect">
-            <a:avLst>
-              <a:gd name="adj" fmla="val 12000"/>
-            </a:avLst>
-          </a:prstGeom>
-          <a:solidFill>
-            <a:srgbClr val="FFFFFF"/>
-          </a:solidFill>
-          <a:ln w="9525">
-            <a:solidFill>
-              <a:srgbClr val="B4C7E7"/>
-            </a:solidFill>
-          </a:ln>
-          <a:effectLst/>
-          <a:extLst>
-            <a:ext uri="{AF507438-7753-43E0-B8FC-AC1667EBCBE1}">
-              <a14:hiddenEffects xmlns:a14="http://schemas.microsoft.com/office/drawing/2010/main">
-                <a:effectLst>
-                  <a:outerShdw blurRad="40000" dist="23000" dir="5400000" rotWithShape="0">
-                    <a:srgbClr val="000000">
-                      <a:alpha val="35000"/>
-                    </a:srgbClr>
-                  </a:outerShdw>
-                </a:effectLst>
-              </a14:hiddenEffects>
-            </a:ext>
-          </a:extLst>
-        </p:spPr>
-        <p:style>
-          <a:lnRef idx="1">
-            <a:schemeClr val="accent1"/>
-          </a:lnRef>
-          <a:fillRef idx="3">
-            <a:schemeClr val="accent1"/>
-          </a:fillRef>
-          <a:effectRef idx="2">
-            <a:schemeClr val="accent1"/>
-          </a:effectRef>
-          <a:fontRef idx="minor">
-            <a:schemeClr val="lt1"/>
-          </a:fontRef>
-        </p:style>
-        <p:txBody>
-          <a:bodyPr rtlCol="0" anchor="ctr"/>
-          <a:lstStyle/>
-          <a:p>
-            <a:pPr algn="ctr"/>
-            <a:endParaRPr lang="en-IN"/>
-          </a:p>
-        </p:txBody>
-      </p:sp>
-      <p:sp>
-        <p:nvSpPr>
-          <p:cNvPr id="34" name="TextBox 33">
-            <a:extLst>
-              <a:ext uri="{FF2B5EF4-FFF2-40B4-BE49-F238E27FC236}">
-                <a16:creationId xmlns:a16="http://schemas.microsoft.com/office/drawing/2014/main" id="{B448B2EE-6760-3488-1392-FDD9C915B0A3}"/>
-              </a:ext>
-            </a:extLst>
-          </p:cNvPr>
-          <p:cNvSpPr txBox="1"/>
-          <p:nvPr/>
-        </p:nvSpPr>
-        <p:spPr>
-          <a:xfrm>
-            <a:off x="431800" y="4838700"/>
-            <a:ext cx="6223000" cy="369332"/>
+            <a:off x="7874000" y="1244600"/>
+            <a:ext cx="3048000" cy="369332"/>
           </a:xfrm>
           <a:prstGeom prst="rect">
             <a:avLst/>
@@ -10713,270 +11349,23 @@
               </a:spcAft>
             </a:pPr>
             <a:r>
-              <a:rPr lang="en-IN" sz="950" b="1">
+              <a:rPr lang="en-IN" sz="1100" b="1">
                 <a:solidFill>
                   <a:srgbClr val="1F3864"/>
                 </a:solidFill>
                 <a:latin typeface="Arial" panose="020B0604020202020204" pitchFamily="34" charset="0"/>
               </a:rPr>
-              <a:t>Trust without trusting us: </a:t>
-            </a:r>
-            <a:r>
-              <a:rPr lang="en-US" sz="950">
-                <a:solidFill>
-                  <a:srgbClr val="262626"/>
-                </a:solidFill>
-                <a:latin typeface="Arial" panose="020B0604020202020204" pitchFamily="34" charset="0"/>
-              </a:rPr>
-              <a:t>NCB signs the supervisor list; a supervisor's key (a Class 3 DSC in production) binds officer + phone + key; the phone signs and chains every test; every phone's chain head goes into the witness-signed panchnama. Our offline verifier checks all of it (prototype uses test keys).</a:t>
-            </a:r>
-            <a:endParaRPr lang="en-IN" sz="950">
-              <a:solidFill>
-                <a:srgbClr val="262626"/>
-              </a:solidFill>
-              <a:latin typeface="Arial" panose="020B0604020202020204" pitchFamily="34" charset="0"/>
-            </a:endParaRPr>
-          </a:p>
-        </p:txBody>
-      </p:sp>
-      <p:sp>
-        <p:nvSpPr>
-          <p:cNvPr id="35" name="Rectangle: Rounded Corners 34">
+              <a:t>WORKING PROTOTYPE OUTPUT</a:t>
+            </a:r>
+          </a:p>
+        </p:txBody>
+      </p:sp>
+      <p:sp>
+        <p:nvSpPr>
+          <p:cNvPr id="44" name="Rectangle: Rounded Corners 43">
             <a:extLst>
               <a:ext uri="{FF2B5EF4-FFF2-40B4-BE49-F238E27FC236}">
-                <a16:creationId xmlns:a16="http://schemas.microsoft.com/office/drawing/2014/main" id="{5841226B-A0FC-3EF0-55FF-23FC69B7922B}"/>
-              </a:ext>
-            </a:extLst>
-          </p:cNvPr>
-          <p:cNvSpPr/>
-          <p:nvPr/>
-        </p:nvSpPr>
-        <p:spPr>
-          <a:xfrm>
-            <a:off x="6756400" y="4838700"/>
-            <a:ext cx="787400" cy="139700"/>
-          </a:xfrm>
-          <a:prstGeom prst="roundRect">
-            <a:avLst>
-              <a:gd name="adj" fmla="val 50000"/>
-            </a:avLst>
-          </a:prstGeom>
-          <a:solidFill>
-            <a:srgbClr val="2E7D32"/>
-          </a:solidFill>
-          <a:ln w="9525" cap="flat" cmpd="sng" algn="ctr">
-            <a:noFill/>
-            <a:prstDash val="solid"/>
-          </a:ln>
-          <a:effectLst/>
-          <a:extLst>
-            <a:ext uri="{91240B29-F687-4F45-9708-019B960494DF}">
-              <a14:hiddenLine xmlns:a14="http://schemas.microsoft.com/office/drawing/2010/main" w="9525" cap="flat" cmpd="sng" algn="ctr">
-                <a:solidFill>
-                  <a:schemeClr val="accent1">
-                    <a:shade val="95000"/>
-                    <a:satMod val="105000"/>
-                  </a:schemeClr>
-                </a:solidFill>
-                <a:prstDash val="solid"/>
-              </a14:hiddenLine>
-            </a:ext>
-            <a:ext uri="{AF507438-7753-43E0-B8FC-AC1667EBCBE1}">
-              <a14:hiddenEffects xmlns:a14="http://schemas.microsoft.com/office/drawing/2010/main">
-                <a:effectLst>
-                  <a:outerShdw blurRad="40000" dist="23000" dir="5400000" rotWithShape="0">
-                    <a:srgbClr val="000000">
-                      <a:alpha val="35000"/>
-                    </a:srgbClr>
-                  </a:outerShdw>
-                </a:effectLst>
-              </a14:hiddenEffects>
-            </a:ext>
-          </a:extLst>
-        </p:spPr>
-        <p:style>
-          <a:lnRef idx="1">
-            <a:schemeClr val="accent1"/>
-          </a:lnRef>
-          <a:fillRef idx="3">
-            <a:schemeClr val="accent1"/>
-          </a:fillRef>
-          <a:effectRef idx="2">
-            <a:schemeClr val="accent1"/>
-          </a:effectRef>
-          <a:fontRef idx="minor">
-            <a:schemeClr val="lt1"/>
-          </a:fontRef>
-        </p:style>
-        <p:txBody>
-          <a:bodyPr lIns="0" tIns="0" rIns="0" bIns="0" rtlCol="0" anchor="ctr"/>
-          <a:lstStyle/>
-          <a:p>
-            <a:pPr algn="ctr">
-              <a:spcBef>
-                <a:spcPts val="0"/>
-              </a:spcBef>
-              <a:spcAft>
-                <a:spcPts val="0"/>
-              </a:spcAft>
-            </a:pPr>
-            <a:r>
-              <a:rPr lang="en-IN" sz="650" b="1">
-                <a:solidFill>
-                  <a:srgbClr val="FFFFFF"/>
-                </a:solidFill>
-                <a:latin typeface="Arial" panose="020B0604020202020204" pitchFamily="34" charset="0"/>
-              </a:rPr>
-              <a:t>PROVEN IN CODE</a:t>
-            </a:r>
-          </a:p>
-        </p:txBody>
-      </p:sp>
-      <p:sp>
-        <p:nvSpPr>
-          <p:cNvPr id="36" name="TextBox 35">
-            <a:extLst>
-              <a:ext uri="{FF2B5EF4-FFF2-40B4-BE49-F238E27FC236}">
-                <a16:creationId xmlns:a16="http://schemas.microsoft.com/office/drawing/2014/main" id="{C9A573C2-C09E-4586-8F2C-249EDD9143E0}"/>
-              </a:ext>
-            </a:extLst>
-          </p:cNvPr>
-          <p:cNvSpPr txBox="1"/>
-          <p:nvPr/>
-        </p:nvSpPr>
-        <p:spPr>
-          <a:xfrm>
-            <a:off x="279400" y="5588000"/>
-            <a:ext cx="7340600" cy="369332"/>
-          </a:xfrm>
-          <a:prstGeom prst="rect">
-            <a:avLst/>
-          </a:prstGeom>
-          <a:noFill/>
-        </p:spPr>
-        <p:txBody>
-          <a:bodyPr vert="horz" wrap="square" lIns="0" tIns="0" rIns="0" bIns="0" rtlCol="0" anchor="t">
-            <a:noAutofit/>
-          </a:bodyPr>
-          <a:lstStyle/>
-          <a:p>
-            <a:pPr>
-              <a:spcBef>
-                <a:spcPts val="0"/>
-              </a:spcBef>
-              <a:spcAft>
-                <a:spcPts val="300"/>
-              </a:spcAft>
-            </a:pPr>
-            <a:r>
-              <a:rPr lang="en-IN" sz="950" b="1">
-                <a:solidFill>
-                  <a:srgbClr val="1F3864"/>
-                </a:solidFill>
-                <a:latin typeface="Arial" panose="020B0604020202020204" pitchFamily="34" charset="0"/>
-              </a:rPr>
-              <a:t>Technologies to be used: </a:t>
-            </a:r>
-            <a:r>
-              <a:rPr lang="en-IN" sz="950">
-                <a:solidFill>
-                  <a:srgbClr val="262626"/>
-                </a:solidFill>
-                <a:latin typeface="Arial" panose="020B0604020202020204" pitchFamily="34" charset="0"/>
-              </a:rPr>
-              <a:t>Kotlin · CameraX/Camera2 · OpenCV · Android Keystore + attestation · SQLCipher · RFC 8785 JSON · ECDSA P-256 · Spring Boot · PostgreSQL · S3. Prototype today: Python, OpenCV, SQLite.</a:t>
-            </a:r>
-          </a:p>
-          <a:p>
-            <a:pPr>
-              <a:spcBef>
-                <a:spcPts val="0"/>
-              </a:spcBef>
-              <a:spcAft>
-                <a:spcPts val="300"/>
-              </a:spcAft>
-            </a:pPr>
-            <a:r>
-              <a:rPr lang="en-IN" sz="950" b="1">
-                <a:solidFill>
-                  <a:srgbClr val="1F3864"/>
-                </a:solidFill>
-                <a:latin typeface="Arial" panose="020B0604020202020204" pitchFamily="34" charset="0"/>
-              </a:rPr>
-              <a:t>Deliberately not used: </a:t>
-            </a:r>
-            <a:r>
-              <a:rPr lang="en-US" sz="950">
-                <a:solidFill>
-                  <a:srgbClr val="262626"/>
-                </a:solidFill>
-                <a:latin typeface="Arial" panose="020B0604020202020204" pitchFamily="34" charset="0"/>
-              </a:rPr>
-              <a:t>blockchain, cloud AI, a neural-network "drug detector" (a colour test cannot identify a drug; the court must be able to re-run the reading)</a:t>
-            </a:r>
-            <a:endParaRPr lang="en-IN" sz="950">
-              <a:solidFill>
-                <a:srgbClr val="262626"/>
-              </a:solidFill>
-              <a:latin typeface="Arial" panose="020B0604020202020204" pitchFamily="34" charset="0"/>
-            </a:endParaRPr>
-          </a:p>
-        </p:txBody>
-      </p:sp>
-      <p:sp>
-        <p:nvSpPr>
-          <p:cNvPr id="37" name="TextBox 36">
-            <a:extLst>
-              <a:ext uri="{FF2B5EF4-FFF2-40B4-BE49-F238E27FC236}">
-                <a16:creationId xmlns:a16="http://schemas.microsoft.com/office/drawing/2014/main" id="{D2DBFB70-258C-8F53-D549-90DF342EA522}"/>
-              </a:ext>
-            </a:extLst>
-          </p:cNvPr>
-          <p:cNvSpPr txBox="1"/>
-          <p:nvPr/>
-        </p:nvSpPr>
-        <p:spPr>
-          <a:xfrm>
-            <a:off x="7874000" y="1244600"/>
-            <a:ext cx="3048000" cy="369332"/>
-          </a:xfrm>
-          <a:prstGeom prst="rect">
-            <a:avLst/>
-          </a:prstGeom>
-          <a:noFill/>
-        </p:spPr>
-        <p:txBody>
-          <a:bodyPr vert="horz" wrap="square" lIns="0" tIns="0" rIns="0" bIns="0" rtlCol="0" anchor="t">
-            <a:noAutofit/>
-          </a:bodyPr>
-          <a:lstStyle/>
-          <a:p>
-            <a:pPr>
-              <a:spcBef>
-                <a:spcPts val="0"/>
-              </a:spcBef>
-              <a:spcAft>
-                <a:spcPts val="300"/>
-              </a:spcAft>
-            </a:pPr>
-            <a:r>
-              <a:rPr lang="en-IN" sz="1100" b="1">
-                <a:solidFill>
-                  <a:srgbClr val="1F3864"/>
-                </a:solidFill>
-                <a:latin typeface="Arial" panose="020B0604020202020204" pitchFamily="34" charset="0"/>
-              </a:rPr>
-              <a:t>WORKING PROTOTYPE OUTPUT</a:t>
-            </a:r>
-          </a:p>
-        </p:txBody>
-      </p:sp>
-      <p:sp>
-        <p:nvSpPr>
-          <p:cNvPr id="38" name="Rectangle: Rounded Corners 37">
-            <a:extLst>
-              <a:ext uri="{FF2B5EF4-FFF2-40B4-BE49-F238E27FC236}">
-                <a16:creationId xmlns:a16="http://schemas.microsoft.com/office/drawing/2014/main" id="{4A280CF5-342B-E4EB-3E9B-F080B47E42DE}"/>
+                <a16:creationId xmlns:a16="http://schemas.microsoft.com/office/drawing/2014/main" id="{745B29B3-7D85-89F0-FDAC-12132C49CFC9}"/>
               </a:ext>
             </a:extLst>
           </p:cNvPr>
@@ -11066,10 +11455,10 @@
       </p:sp>
       <p:pic>
         <p:nvPicPr>
-          <p:cNvPr id="40" name="Picture 39">
+          <p:cNvPr id="46" name="Picture 45">
             <a:extLst>
               <a:ext uri="{FF2B5EF4-FFF2-40B4-BE49-F238E27FC236}">
-                <a16:creationId xmlns:a16="http://schemas.microsoft.com/office/drawing/2014/main" id="{E1B5D70F-6BB3-A1AC-93B8-B0F13B6EA715}"/>
+                <a16:creationId xmlns:a16="http://schemas.microsoft.com/office/drawing/2014/main" id="{6F7FE708-87DE-BD0E-672A-9BC2E8D4F8F3}"/>
               </a:ext>
             </a:extLst>
           </p:cNvPr>
@@ -11101,10 +11490,10 @@
       </p:pic>
       <p:sp>
         <p:nvSpPr>
-          <p:cNvPr id="41" name="TextBox 40">
+          <p:cNvPr id="47" name="TextBox 46">
             <a:extLst>
               <a:ext uri="{FF2B5EF4-FFF2-40B4-BE49-F238E27FC236}">
-                <a16:creationId xmlns:a16="http://schemas.microsoft.com/office/drawing/2014/main" id="{E642D1B6-19B1-8434-ED7F-29910367F1F7}"/>
+                <a16:creationId xmlns:a16="http://schemas.microsoft.com/office/drawing/2014/main" id="{872BFD35-AE3A-0F00-C147-94384BC2DB13}"/>
               </a:ext>
             </a:extLst>
           </p:cNvPr>
@@ -11174,10 +11563,10 @@
       </p:sp>
       <p:pic>
         <p:nvPicPr>
-          <p:cNvPr id="43" name="Picture 42">
+          <p:cNvPr id="49" name="Picture 48">
             <a:extLst>
               <a:ext uri="{FF2B5EF4-FFF2-40B4-BE49-F238E27FC236}">
-                <a16:creationId xmlns:a16="http://schemas.microsoft.com/office/drawing/2014/main" id="{CA6AC23A-7A37-78DF-419A-68CE3B310335}"/>
+                <a16:creationId xmlns:a16="http://schemas.microsoft.com/office/drawing/2014/main" id="{E7F3C9CA-BF5F-88FA-C018-90B06735D88F}"/>
               </a:ext>
             </a:extLst>
           </p:cNvPr>
@@ -11209,10 +11598,10 @@
       </p:pic>
       <p:sp>
         <p:nvSpPr>
-          <p:cNvPr id="44" name="TextBox 43">
+          <p:cNvPr id="50" name="TextBox 49">
             <a:extLst>
               <a:ext uri="{FF2B5EF4-FFF2-40B4-BE49-F238E27FC236}">
-                <a16:creationId xmlns:a16="http://schemas.microsoft.com/office/drawing/2014/main" id="{86F51844-B50E-3B52-0D01-B6B16A1A5F93}"/>
+                <a16:creationId xmlns:a16="http://schemas.microsoft.com/office/drawing/2014/main" id="{3FFFC679-D3EC-76B2-CECF-B5AB3206A851}"/>
               </a:ext>
             </a:extLst>
           </p:cNvPr>
@@ -11282,10 +11671,10 @@
       </p:sp>
       <p:pic>
         <p:nvPicPr>
-          <p:cNvPr id="46" name="Picture 45">
+          <p:cNvPr id="52" name="Picture 51">
             <a:extLst>
               <a:ext uri="{FF2B5EF4-FFF2-40B4-BE49-F238E27FC236}">
-                <a16:creationId xmlns:a16="http://schemas.microsoft.com/office/drawing/2014/main" id="{705F3879-33FD-EFA5-6D15-A5667D907376}"/>
+                <a16:creationId xmlns:a16="http://schemas.microsoft.com/office/drawing/2014/main" id="{977957A5-30C7-DE70-2869-16B82A936460}"/>
               </a:ext>
             </a:extLst>
           </p:cNvPr>
@@ -11317,10 +11706,10 @@
       </p:pic>
       <p:sp>
         <p:nvSpPr>
-          <p:cNvPr id="47" name="TextBox 46">
+          <p:cNvPr id="53" name="TextBox 52">
             <a:extLst>
               <a:ext uri="{FF2B5EF4-FFF2-40B4-BE49-F238E27FC236}">
-                <a16:creationId xmlns:a16="http://schemas.microsoft.com/office/drawing/2014/main" id="{83E76316-D758-8E46-B07C-B2DA6B49D6FD}"/>
+                <a16:creationId xmlns:a16="http://schemas.microsoft.com/office/drawing/2014/main" id="{FEE45179-607F-9DA6-AAF6-B6F961B7CAFE}"/>
               </a:ext>
             </a:extLst>
           </p:cNvPr>
@@ -11390,10 +11779,10 @@
       </p:sp>
       <p:sp>
         <p:nvSpPr>
-          <p:cNvPr id="48" name="TextBox 47">
+          <p:cNvPr id="54" name="TextBox 53">
             <a:extLst>
               <a:ext uri="{FF2B5EF4-FFF2-40B4-BE49-F238E27FC236}">
-                <a16:creationId xmlns:a16="http://schemas.microsoft.com/office/drawing/2014/main" id="{FD886F51-023D-DFB8-6B1C-60B4DE15372B}"/>
+                <a16:creationId xmlns:a16="http://schemas.microsoft.com/office/drawing/2014/main" id="{81722FB4-916D-DFD0-39E4-ADD81DC50032}"/>
               </a:ext>
             </a:extLst>
           </p:cNvPr>
@@ -11444,10 +11833,10 @@
       </p:sp>
       <p:sp>
         <p:nvSpPr>
-          <p:cNvPr id="49" name="TextBox 48">
+          <p:cNvPr id="55" name="TextBox 54">
             <a:extLst>
               <a:ext uri="{FF2B5EF4-FFF2-40B4-BE49-F238E27FC236}">
-                <a16:creationId xmlns:a16="http://schemas.microsoft.com/office/drawing/2014/main" id="{630F092E-B5E3-4920-0A54-2C96B6058CA5}"/>
+                <a16:creationId xmlns:a16="http://schemas.microsoft.com/office/drawing/2014/main" id="{312AB3FC-755C-9380-0607-8FCED44BD230}"/>
               </a:ext>
             </a:extLst>
           </p:cNvPr>
@@ -11492,10 +11881,10 @@
       </p:sp>
       <p:sp>
         <p:nvSpPr>
-          <p:cNvPr id="50" name="Rectangle: Rounded Corners 49">
+          <p:cNvPr id="56" name="Rectangle: Rounded Corners 55">
             <a:extLst>
               <a:ext uri="{FF2B5EF4-FFF2-40B4-BE49-F238E27FC236}">
-                <a16:creationId xmlns:a16="http://schemas.microsoft.com/office/drawing/2014/main" id="{C137E857-A25F-FDA9-7861-286F5A383C8E}"/>
+                <a16:creationId xmlns:a16="http://schemas.microsoft.com/office/drawing/2014/main" id="{49FF31CE-8458-7038-4C46-1D3FBF847D39}"/>
               </a:ext>
             </a:extLst>
           </p:cNvPr>
@@ -11585,10 +11974,10 @@
       </p:sp>
       <p:sp>
         <p:nvSpPr>
-          <p:cNvPr id="51" name="TextBox 50">
+          <p:cNvPr id="57" name="TextBox 56">
             <a:extLst>
               <a:ext uri="{FF2B5EF4-FFF2-40B4-BE49-F238E27FC236}">
-                <a16:creationId xmlns:a16="http://schemas.microsoft.com/office/drawing/2014/main" id="{82FFEE23-665A-C763-9D26-0626C7DE0D5D}"/>
+                <a16:creationId xmlns:a16="http://schemas.microsoft.com/office/drawing/2014/main" id="{815854DC-B5E5-350C-008C-CF4E36832F9E}"/>
               </a:ext>
             </a:extLst>
           </p:cNvPr>
@@ -11639,10 +12028,10 @@
       </p:sp>
       <p:sp>
         <p:nvSpPr>
-          <p:cNvPr id="52" name="Rectangle: Rounded Corners 51">
+          <p:cNvPr id="58" name="Rectangle: Rounded Corners 57">
             <a:extLst>
               <a:ext uri="{FF2B5EF4-FFF2-40B4-BE49-F238E27FC236}">
-                <a16:creationId xmlns:a16="http://schemas.microsoft.com/office/drawing/2014/main" id="{F0147902-9FB8-33F1-3C49-83F23B841AB8}"/>
+                <a16:creationId xmlns:a16="http://schemas.microsoft.com/office/drawing/2014/main" id="{763757A4-E4F8-EC79-9837-894BC739AAD8}"/>
               </a:ext>
             </a:extLst>
           </p:cNvPr>
@@ -11732,10 +12121,10 @@
       </p:sp>
       <p:sp>
         <p:nvSpPr>
-          <p:cNvPr id="53" name="TextBox 52">
+          <p:cNvPr id="59" name="TextBox 58">
             <a:extLst>
               <a:ext uri="{FF2B5EF4-FFF2-40B4-BE49-F238E27FC236}">
-                <a16:creationId xmlns:a16="http://schemas.microsoft.com/office/drawing/2014/main" id="{ABD0FB62-E5DA-83C3-A100-E2600B1E9185}"/>
+                <a16:creationId xmlns:a16="http://schemas.microsoft.com/office/drawing/2014/main" id="{469BC4EE-1D57-BFA9-BD74-AF4D90C30A33}"/>
               </a:ext>
             </a:extLst>
           </p:cNvPr>
@@ -11786,10 +12175,10 @@
       </p:sp>
       <p:sp>
         <p:nvSpPr>
-          <p:cNvPr id="54" name="Rectangle: Rounded Corners 53">
+          <p:cNvPr id="60" name="Rectangle: Rounded Corners 59">
             <a:extLst>
               <a:ext uri="{FF2B5EF4-FFF2-40B4-BE49-F238E27FC236}">
-                <a16:creationId xmlns:a16="http://schemas.microsoft.com/office/drawing/2014/main" id="{F3377516-07E8-367B-5504-DDA362131AB4}"/>
+                <a16:creationId xmlns:a16="http://schemas.microsoft.com/office/drawing/2014/main" id="{3C78C20F-E89B-CE0A-98DA-1C2CA76B063D}"/>
               </a:ext>
             </a:extLst>
           </p:cNvPr>
@@ -11879,10 +12268,10 @@
       </p:sp>
       <p:sp>
         <p:nvSpPr>
-          <p:cNvPr id="55" name="TextBox 54">
+          <p:cNvPr id="61" name="TextBox 60">
             <a:extLst>
               <a:ext uri="{FF2B5EF4-FFF2-40B4-BE49-F238E27FC236}">
-                <a16:creationId xmlns:a16="http://schemas.microsoft.com/office/drawing/2014/main" id="{007B42F6-C93F-4DF5-C906-F923E3A36267}"/>
+                <a16:creationId xmlns:a16="http://schemas.microsoft.com/office/drawing/2014/main" id="{45CD6938-B384-F57E-F9A9-4B71F67195C7}"/>
               </a:ext>
             </a:extLst>
           </p:cNvPr>
@@ -12312,7 +12701,7 @@
           <p:cNvPr id="2" name="Rectangle: Rounded Corners 1">
             <a:extLst>
               <a:ext uri="{FF2B5EF4-FFF2-40B4-BE49-F238E27FC236}">
-                <a16:creationId xmlns:a16="http://schemas.microsoft.com/office/drawing/2014/main" id="{88191926-F881-FF5C-B42C-E3B9A508EB7A}"/>
+                <a16:creationId xmlns:a16="http://schemas.microsoft.com/office/drawing/2014/main" id="{BE6DBECC-E964-B735-F8B4-BF36DDC8DA5B}"/>
               </a:ext>
             </a:extLst>
           </p:cNvPr>
@@ -12390,7 +12779,7 @@
           <p:cNvPr id="3" name="TextBox 2">
             <a:extLst>
               <a:ext uri="{FF2B5EF4-FFF2-40B4-BE49-F238E27FC236}">
-                <a16:creationId xmlns:a16="http://schemas.microsoft.com/office/drawing/2014/main" id="{BC172E10-27AF-A2BA-7C06-252586EEB879}"/>
+                <a16:creationId xmlns:a16="http://schemas.microsoft.com/office/drawing/2014/main" id="{365985F7-B622-167D-5CE3-7DF7201A193C}"/>
               </a:ext>
             </a:extLst>
           </p:cNvPr>
@@ -12438,7 +12827,7 @@
           <p:cNvPr id="4" name="TextBox 3">
             <a:extLst>
               <a:ext uri="{FF2B5EF4-FFF2-40B4-BE49-F238E27FC236}">
-                <a16:creationId xmlns:a16="http://schemas.microsoft.com/office/drawing/2014/main" id="{1EB346DB-E131-0D63-3A50-0B6B9CC69B59}"/>
+                <a16:creationId xmlns:a16="http://schemas.microsoft.com/office/drawing/2014/main" id="{A53A646D-A76C-566A-1292-DEAFF85D36EC}"/>
               </a:ext>
             </a:extLst>
           </p:cNvPr>
@@ -12492,7 +12881,7 @@
           <p:cNvPr id="5" name="Rectangle: Rounded Corners 4">
             <a:extLst>
               <a:ext uri="{FF2B5EF4-FFF2-40B4-BE49-F238E27FC236}">
-                <a16:creationId xmlns:a16="http://schemas.microsoft.com/office/drawing/2014/main" id="{3BC8D9FB-D988-B6D3-4341-35241FA0BCC9}"/>
+                <a16:creationId xmlns:a16="http://schemas.microsoft.com/office/drawing/2014/main" id="{736D0F00-A599-23B1-DAAA-D75FBBE4A6E4}"/>
               </a:ext>
             </a:extLst>
           </p:cNvPr>
@@ -12585,7 +12974,7 @@
           <p:cNvPr id="8" name="Rectangle: Rounded Corners 7">
             <a:extLst>
               <a:ext uri="{FF2B5EF4-FFF2-40B4-BE49-F238E27FC236}">
-                <a16:creationId xmlns:a16="http://schemas.microsoft.com/office/drawing/2014/main" id="{D365BD85-9FFC-6449-6866-DF692E33BB99}"/>
+                <a16:creationId xmlns:a16="http://schemas.microsoft.com/office/drawing/2014/main" id="{B808A5BC-F913-9B7D-FAFB-0F2337A4DFDD}"/>
               </a:ext>
             </a:extLst>
           </p:cNvPr>
@@ -12663,7 +13052,7 @@
           <p:cNvPr id="9" name="TextBox 8">
             <a:extLst>
               <a:ext uri="{FF2B5EF4-FFF2-40B4-BE49-F238E27FC236}">
-                <a16:creationId xmlns:a16="http://schemas.microsoft.com/office/drawing/2014/main" id="{059898CA-532C-D746-E009-598341DEEE08}"/>
+                <a16:creationId xmlns:a16="http://schemas.microsoft.com/office/drawing/2014/main" id="{ED831CE7-51C2-CD23-992D-E0252833C969}"/>
               </a:ext>
             </a:extLst>
           </p:cNvPr>
@@ -12711,7 +13100,7 @@
           <p:cNvPr id="13" name="TextBox 12">
             <a:extLst>
               <a:ext uri="{FF2B5EF4-FFF2-40B4-BE49-F238E27FC236}">
-                <a16:creationId xmlns:a16="http://schemas.microsoft.com/office/drawing/2014/main" id="{6B4B449C-F511-5243-ADAE-BCF9E9AF7CF6}"/>
+                <a16:creationId xmlns:a16="http://schemas.microsoft.com/office/drawing/2014/main" id="{47AEA8C5-0892-3B61-19B7-C8B6D95E9AF3}"/>
               </a:ext>
             </a:extLst>
           </p:cNvPr>
@@ -12765,7 +13154,7 @@
           <p:cNvPr id="14" name="Rectangle: Rounded Corners 13">
             <a:extLst>
               <a:ext uri="{FF2B5EF4-FFF2-40B4-BE49-F238E27FC236}">
-                <a16:creationId xmlns:a16="http://schemas.microsoft.com/office/drawing/2014/main" id="{EBEEAE66-ADF2-138C-D5D6-78BDFCB3B1D5}"/>
+                <a16:creationId xmlns:a16="http://schemas.microsoft.com/office/drawing/2014/main" id="{67977830-455E-0B34-0FCD-49A299498C90}"/>
               </a:ext>
             </a:extLst>
           </p:cNvPr>
@@ -12858,7 +13247,7 @@
           <p:cNvPr id="15" name="Rectangle: Rounded Corners 14">
             <a:extLst>
               <a:ext uri="{FF2B5EF4-FFF2-40B4-BE49-F238E27FC236}">
-                <a16:creationId xmlns:a16="http://schemas.microsoft.com/office/drawing/2014/main" id="{DE5B35FC-4DA9-FDC2-3807-5E940418755D}"/>
+                <a16:creationId xmlns:a16="http://schemas.microsoft.com/office/drawing/2014/main" id="{9A0AA317-B435-4FF6-BD1C-23E883814B82}"/>
               </a:ext>
             </a:extLst>
           </p:cNvPr>
@@ -12936,7 +13325,7 @@
           <p:cNvPr id="16" name="TextBox 15">
             <a:extLst>
               <a:ext uri="{FF2B5EF4-FFF2-40B4-BE49-F238E27FC236}">
-                <a16:creationId xmlns:a16="http://schemas.microsoft.com/office/drawing/2014/main" id="{6456DD93-7CB9-5A4E-1572-E8EBB76A3C2F}"/>
+                <a16:creationId xmlns:a16="http://schemas.microsoft.com/office/drawing/2014/main" id="{69B3944F-4DCE-90B5-9CC6-D5B123EC2E12}"/>
               </a:ext>
             </a:extLst>
           </p:cNvPr>
@@ -12984,7 +13373,7 @@
           <p:cNvPr id="17" name="TextBox 16">
             <a:extLst>
               <a:ext uri="{FF2B5EF4-FFF2-40B4-BE49-F238E27FC236}">
-                <a16:creationId xmlns:a16="http://schemas.microsoft.com/office/drawing/2014/main" id="{E7ED29E4-2A34-E251-CDDD-3307D5B33085}"/>
+                <a16:creationId xmlns:a16="http://schemas.microsoft.com/office/drawing/2014/main" id="{EA364BB6-D150-7B03-4C90-F21CAA6169AF}"/>
               </a:ext>
             </a:extLst>
           </p:cNvPr>
@@ -13038,7 +13427,7 @@
           <p:cNvPr id="18" name="Rectangle: Rounded Corners 17">
             <a:extLst>
               <a:ext uri="{FF2B5EF4-FFF2-40B4-BE49-F238E27FC236}">
-                <a16:creationId xmlns:a16="http://schemas.microsoft.com/office/drawing/2014/main" id="{76DBC420-770B-6275-3EAD-6902F278EAC4}"/>
+                <a16:creationId xmlns:a16="http://schemas.microsoft.com/office/drawing/2014/main" id="{8170076E-EBCE-85F6-9D4D-FA1FAD2D12FF}"/>
               </a:ext>
             </a:extLst>
           </p:cNvPr>
@@ -13131,7 +13520,7 @@
           <p:cNvPr id="19" name="Rectangle: Rounded Corners 18">
             <a:extLst>
               <a:ext uri="{FF2B5EF4-FFF2-40B4-BE49-F238E27FC236}">
-                <a16:creationId xmlns:a16="http://schemas.microsoft.com/office/drawing/2014/main" id="{520ABB82-B24E-C83E-46B0-56F45395EE71}"/>
+                <a16:creationId xmlns:a16="http://schemas.microsoft.com/office/drawing/2014/main" id="{04003777-ABE1-44CB-9F08-2CBEB5B95E6F}"/>
               </a:ext>
             </a:extLst>
           </p:cNvPr>
@@ -13209,7 +13598,7 @@
           <p:cNvPr id="20" name="TextBox 19">
             <a:extLst>
               <a:ext uri="{FF2B5EF4-FFF2-40B4-BE49-F238E27FC236}">
-                <a16:creationId xmlns:a16="http://schemas.microsoft.com/office/drawing/2014/main" id="{AE538151-F87E-AE39-0DD4-1997D97A172F}"/>
+                <a16:creationId xmlns:a16="http://schemas.microsoft.com/office/drawing/2014/main" id="{CB8B8ACF-5EC9-CABE-73C5-EC96C942A397}"/>
               </a:ext>
             </a:extLst>
           </p:cNvPr>
@@ -13257,7 +13646,7 @@
           <p:cNvPr id="21" name="TextBox 20">
             <a:extLst>
               <a:ext uri="{FF2B5EF4-FFF2-40B4-BE49-F238E27FC236}">
-                <a16:creationId xmlns:a16="http://schemas.microsoft.com/office/drawing/2014/main" id="{B4CE46C2-B909-B650-264E-8C941F68D373}"/>
+                <a16:creationId xmlns:a16="http://schemas.microsoft.com/office/drawing/2014/main" id="{C518E634-547A-FE9A-E6FB-FBB8D49ED02F}"/>
               </a:ext>
             </a:extLst>
           </p:cNvPr>
@@ -13311,7 +13700,7 @@
           <p:cNvPr id="22" name="Rectangle: Rounded Corners 21">
             <a:extLst>
               <a:ext uri="{FF2B5EF4-FFF2-40B4-BE49-F238E27FC236}">
-                <a16:creationId xmlns:a16="http://schemas.microsoft.com/office/drawing/2014/main" id="{8021475D-FE8A-1B8D-A37F-33B8600AAC72}"/>
+                <a16:creationId xmlns:a16="http://schemas.microsoft.com/office/drawing/2014/main" id="{3ED76F5A-933D-99B2-58C7-59207CED60DA}"/>
               </a:ext>
             </a:extLst>
           </p:cNvPr>
@@ -13404,7 +13793,7 @@
           <p:cNvPr id="23" name="TextBox 22">
             <a:extLst>
               <a:ext uri="{FF2B5EF4-FFF2-40B4-BE49-F238E27FC236}">
-                <a16:creationId xmlns:a16="http://schemas.microsoft.com/office/drawing/2014/main" id="{61BDD45A-3D29-755F-6501-BD12A1A125F6}"/>
+                <a16:creationId xmlns:a16="http://schemas.microsoft.com/office/drawing/2014/main" id="{7320EEE9-A240-0F6F-F58E-07CB91D00227}"/>
               </a:ext>
             </a:extLst>
           </p:cNvPr>
@@ -13458,7 +13847,7 @@
           <p:cNvPr id="24" name="Table 23">
             <a:extLst>
               <a:ext uri="{FF2B5EF4-FFF2-40B4-BE49-F238E27FC236}">
-                <a16:creationId xmlns:a16="http://schemas.microsoft.com/office/drawing/2014/main" id="{E862B822-D287-1A06-3564-0D7FD619A627}"/>
+                <a16:creationId xmlns:a16="http://schemas.microsoft.com/office/drawing/2014/main" id="{29033978-CF68-C150-E8CB-C6721066F6FE}"/>
               </a:ext>
             </a:extLst>
           </p:cNvPr>
@@ -13468,7 +13857,7 @@
           <p:nvPr>
             <p:extLst>
               <p:ext uri="{D42A27DB-BD31-4B8C-83A1-F6EECF244321}">
-                <p14:modId xmlns:p14="http://schemas.microsoft.com/office/powerpoint/2010/main" val="942599207"/>
+                <p14:modId xmlns:p14="http://schemas.microsoft.com/office/powerpoint/2010/main" val="1053139535"/>
               </p:ext>
             </p:extLst>
           </p:nvPr>
@@ -13487,14 +13876,14 @@
                 <a:gridCol w="2540000">
                   <a:extLst>
                     <a:ext uri="{9D8B030D-6E8A-4147-A177-3AD203B41FA5}">
-                      <a16:colId xmlns:a16="http://schemas.microsoft.com/office/drawing/2014/main" val="1813775540"/>
+                      <a16:colId xmlns:a16="http://schemas.microsoft.com/office/drawing/2014/main" val="2853856836"/>
                     </a:ext>
                   </a:extLst>
                 </a:gridCol>
                 <a:gridCol w="5080000">
                   <a:extLst>
                     <a:ext uri="{9D8B030D-6E8A-4147-A177-3AD203B41FA5}">
-                      <a16:colId xmlns:a16="http://schemas.microsoft.com/office/drawing/2014/main" val="3104776906"/>
+                      <a16:colId xmlns:a16="http://schemas.microsoft.com/office/drawing/2014/main" val="2117677661"/>
                     </a:ext>
                   </a:extLst>
                 </a:gridCol>
@@ -13572,7 +13961,7 @@
                 </a:tc>
                 <a:extLst>
                   <a:ext uri="{0D108BD9-81ED-4DB2-BD59-A6C34878D82A}">
-                    <a16:rowId xmlns:a16="http://schemas.microsoft.com/office/drawing/2014/main" val="1139393263"/>
+                    <a16:rowId xmlns:a16="http://schemas.microsoft.com/office/drawing/2014/main" val="1883294768"/>
                   </a:ext>
                 </a:extLst>
               </a:tr>
@@ -13661,7 +14050,7 @@
                 </a:tc>
                 <a:extLst>
                   <a:ext uri="{0D108BD9-81ED-4DB2-BD59-A6C34878D82A}">
-                    <a16:rowId xmlns:a16="http://schemas.microsoft.com/office/drawing/2014/main" val="2132572006"/>
+                    <a16:rowId xmlns:a16="http://schemas.microsoft.com/office/drawing/2014/main" val="277656716"/>
                   </a:ext>
                 </a:extLst>
               </a:tr>
@@ -13750,7 +14139,7 @@
                 </a:tc>
                 <a:extLst>
                   <a:ext uri="{0D108BD9-81ED-4DB2-BD59-A6C34878D82A}">
-                    <a16:rowId xmlns:a16="http://schemas.microsoft.com/office/drawing/2014/main" val="3839232231"/>
+                    <a16:rowId xmlns:a16="http://schemas.microsoft.com/office/drawing/2014/main" val="1381239601"/>
                   </a:ext>
                 </a:extLst>
               </a:tr>
@@ -13839,7 +14228,7 @@
                 </a:tc>
                 <a:extLst>
                   <a:ext uri="{0D108BD9-81ED-4DB2-BD59-A6C34878D82A}">
-                    <a16:rowId xmlns:a16="http://schemas.microsoft.com/office/drawing/2014/main" val="4247490553"/>
+                    <a16:rowId xmlns:a16="http://schemas.microsoft.com/office/drawing/2014/main" val="1843896821"/>
                   </a:ext>
                 </a:extLst>
               </a:tr>
@@ -13922,7 +14311,7 @@
                 </a:tc>
                 <a:extLst>
                   <a:ext uri="{0D108BD9-81ED-4DB2-BD59-A6C34878D82A}">
-                    <a16:rowId xmlns:a16="http://schemas.microsoft.com/office/drawing/2014/main" val="4294592308"/>
+                    <a16:rowId xmlns:a16="http://schemas.microsoft.com/office/drawing/2014/main" val="2341834282"/>
                   </a:ext>
                 </a:extLst>
               </a:tr>
@@ -14011,7 +14400,7 @@
                 </a:tc>
                 <a:extLst>
                   <a:ext uri="{0D108BD9-81ED-4DB2-BD59-A6C34878D82A}">
-                    <a16:rowId xmlns:a16="http://schemas.microsoft.com/office/drawing/2014/main" val="3287021236"/>
+                    <a16:rowId xmlns:a16="http://schemas.microsoft.com/office/drawing/2014/main" val="1570165215"/>
                   </a:ext>
                 </a:extLst>
               </a:tr>
@@ -14024,7 +14413,7 @@
           <p:cNvPr id="25" name="Rectangle: Rounded Corners 24">
             <a:extLst>
               <a:ext uri="{FF2B5EF4-FFF2-40B4-BE49-F238E27FC236}">
-                <a16:creationId xmlns:a16="http://schemas.microsoft.com/office/drawing/2014/main" id="{25669916-6FC7-E490-C274-37ED6FC4A95B}"/>
+                <a16:creationId xmlns:a16="http://schemas.microsoft.com/office/drawing/2014/main" id="{8B1AD160-045A-422A-1EDE-4D48EC8D3ECA}"/>
               </a:ext>
             </a:extLst>
           </p:cNvPr>
@@ -14102,7 +14491,7 @@
           <p:cNvPr id="26" name="TextBox 25">
             <a:extLst>
               <a:ext uri="{FF2B5EF4-FFF2-40B4-BE49-F238E27FC236}">
-                <a16:creationId xmlns:a16="http://schemas.microsoft.com/office/drawing/2014/main" id="{D4013E0B-1C48-8620-6948-6810C7696B81}"/>
+                <a16:creationId xmlns:a16="http://schemas.microsoft.com/office/drawing/2014/main" id="{44EFEDB1-1070-FAFE-45BB-F0CFA9053F56}"/>
               </a:ext>
             </a:extLst>
           </p:cNvPr>
@@ -14150,7 +14539,7 @@
           <p:cNvPr id="27" name="TextBox 26">
             <a:extLst>
               <a:ext uri="{FF2B5EF4-FFF2-40B4-BE49-F238E27FC236}">
-                <a16:creationId xmlns:a16="http://schemas.microsoft.com/office/drawing/2014/main" id="{6536ECA6-0052-66AF-C62B-5C066C3306A6}"/>
+                <a16:creationId xmlns:a16="http://schemas.microsoft.com/office/drawing/2014/main" id="{AD29439E-375D-1062-6D2F-94D8925165F9}"/>
               </a:ext>
             </a:extLst>
           </p:cNvPr>
@@ -14731,7 +15120,7 @@
           <p:cNvPr id="2" name="TextBox 1">
             <a:extLst>
               <a:ext uri="{FF2B5EF4-FFF2-40B4-BE49-F238E27FC236}">
-                <a16:creationId xmlns:a16="http://schemas.microsoft.com/office/drawing/2014/main" id="{60524346-199F-E544-D6F0-A6B1274B1C29}"/>
+                <a16:creationId xmlns:a16="http://schemas.microsoft.com/office/drawing/2014/main" id="{EC2E6CD9-44AB-0609-2462-3DD8EBFD6A36}"/>
               </a:ext>
             </a:extLst>
           </p:cNvPr>
@@ -14785,7 +15174,7 @@
           <p:cNvPr id="3" name="Oval 2">
             <a:extLst>
               <a:ext uri="{FF2B5EF4-FFF2-40B4-BE49-F238E27FC236}">
-                <a16:creationId xmlns:a16="http://schemas.microsoft.com/office/drawing/2014/main" id="{499B122A-EA5A-8B5B-F030-BBC4072730F8}"/>
+                <a16:creationId xmlns:a16="http://schemas.microsoft.com/office/drawing/2014/main" id="{DE26D960-CBA6-C398-A311-786D6F5AE8CE}"/>
               </a:ext>
             </a:extLst>
           </p:cNvPr>
@@ -14876,7 +15265,7 @@
           <p:cNvPr id="4" name="TextBox 3">
             <a:extLst>
               <a:ext uri="{FF2B5EF4-FFF2-40B4-BE49-F238E27FC236}">
-                <a16:creationId xmlns:a16="http://schemas.microsoft.com/office/drawing/2014/main" id="{4234D997-3FC9-3BB1-F0A1-FDD0E96F8D60}"/>
+                <a16:creationId xmlns:a16="http://schemas.microsoft.com/office/drawing/2014/main" id="{3FA5CD8B-73D3-1F54-67EE-D21635C8B090}"/>
               </a:ext>
             </a:extLst>
           </p:cNvPr>
@@ -14949,7 +15338,7 @@
           <p:cNvPr id="5" name="Oval 4">
             <a:extLst>
               <a:ext uri="{FF2B5EF4-FFF2-40B4-BE49-F238E27FC236}">
-                <a16:creationId xmlns:a16="http://schemas.microsoft.com/office/drawing/2014/main" id="{C20485EA-EEA4-8FF0-0083-9A7D31297BEE}"/>
+                <a16:creationId xmlns:a16="http://schemas.microsoft.com/office/drawing/2014/main" id="{D870D3B4-5D52-565A-F216-7E49DC903E10}"/>
               </a:ext>
             </a:extLst>
           </p:cNvPr>
@@ -15040,7 +15429,7 @@
           <p:cNvPr id="8" name="TextBox 7">
             <a:extLst>
               <a:ext uri="{FF2B5EF4-FFF2-40B4-BE49-F238E27FC236}">
-                <a16:creationId xmlns:a16="http://schemas.microsoft.com/office/drawing/2014/main" id="{12359F5B-0B36-2E8E-AB7B-94A2BFBC4DFA}"/>
+                <a16:creationId xmlns:a16="http://schemas.microsoft.com/office/drawing/2014/main" id="{7584CBDA-4742-9202-8DE5-E2B78754891F}"/>
               </a:ext>
             </a:extLst>
           </p:cNvPr>
@@ -15113,7 +15502,7 @@
           <p:cNvPr id="9" name="Oval 8">
             <a:extLst>
               <a:ext uri="{FF2B5EF4-FFF2-40B4-BE49-F238E27FC236}">
-                <a16:creationId xmlns:a16="http://schemas.microsoft.com/office/drawing/2014/main" id="{75547B49-4B0E-68DB-1B1D-0D0441516FAA}"/>
+                <a16:creationId xmlns:a16="http://schemas.microsoft.com/office/drawing/2014/main" id="{6EEB6FEA-1E36-28CC-18ED-54CF0554B075}"/>
               </a:ext>
             </a:extLst>
           </p:cNvPr>
@@ -15204,7 +15593,7 @@
           <p:cNvPr id="13" name="TextBox 12">
             <a:extLst>
               <a:ext uri="{FF2B5EF4-FFF2-40B4-BE49-F238E27FC236}">
-                <a16:creationId xmlns:a16="http://schemas.microsoft.com/office/drawing/2014/main" id="{585E5C29-07D8-75FA-B44D-6949384C071F}"/>
+                <a16:creationId xmlns:a16="http://schemas.microsoft.com/office/drawing/2014/main" id="{BCD9A3D4-C8EF-43D3-EA7A-432537FF4820}"/>
               </a:ext>
             </a:extLst>
           </p:cNvPr>
@@ -15277,7 +15666,7 @@
           <p:cNvPr id="14" name="Oval 13">
             <a:extLst>
               <a:ext uri="{FF2B5EF4-FFF2-40B4-BE49-F238E27FC236}">
-                <a16:creationId xmlns:a16="http://schemas.microsoft.com/office/drawing/2014/main" id="{683DBCC4-2B58-60D0-491D-B550E2C40919}"/>
+                <a16:creationId xmlns:a16="http://schemas.microsoft.com/office/drawing/2014/main" id="{1A43F34C-15C3-912B-A9B8-08BC305B4C75}"/>
               </a:ext>
             </a:extLst>
           </p:cNvPr>
@@ -15368,7 +15757,7 @@
           <p:cNvPr id="15" name="TextBox 14">
             <a:extLst>
               <a:ext uri="{FF2B5EF4-FFF2-40B4-BE49-F238E27FC236}">
-                <a16:creationId xmlns:a16="http://schemas.microsoft.com/office/drawing/2014/main" id="{6B552E39-C7DD-C341-AF32-A18BF7C01E0F}"/>
+                <a16:creationId xmlns:a16="http://schemas.microsoft.com/office/drawing/2014/main" id="{F66EC640-D7D0-4E49-4F27-F00047C1F8A6}"/>
               </a:ext>
             </a:extLst>
           </p:cNvPr>
@@ -15441,7 +15830,7 @@
           <p:cNvPr id="16" name="TextBox 15">
             <a:extLst>
               <a:ext uri="{FF2B5EF4-FFF2-40B4-BE49-F238E27FC236}">
-                <a16:creationId xmlns:a16="http://schemas.microsoft.com/office/drawing/2014/main" id="{19C94AD7-F44F-9BC7-15E2-58BC2DFFFA97}"/>
+                <a16:creationId xmlns:a16="http://schemas.microsoft.com/office/drawing/2014/main" id="{9B0D5C10-2D89-40C6-6D52-6524ABF01DAC}"/>
               </a:ext>
             </a:extLst>
           </p:cNvPr>
@@ -15495,7 +15884,7 @@
           <p:cNvPr id="17" name="Table 16">
             <a:extLst>
               <a:ext uri="{FF2B5EF4-FFF2-40B4-BE49-F238E27FC236}">
-                <a16:creationId xmlns:a16="http://schemas.microsoft.com/office/drawing/2014/main" id="{4C7F753B-C832-D6A0-E6A6-9556FEC15EF0}"/>
+                <a16:creationId xmlns:a16="http://schemas.microsoft.com/office/drawing/2014/main" id="{526A4174-06D5-87D4-5811-C3938AA7E0B9}"/>
               </a:ext>
             </a:extLst>
           </p:cNvPr>
@@ -15505,7 +15894,7 @@
           <p:nvPr>
             <p:extLst>
               <p:ext uri="{D42A27DB-BD31-4B8C-83A1-F6EECF244321}">
-                <p14:modId xmlns:p14="http://schemas.microsoft.com/office/powerpoint/2010/main" val="2172467528"/>
+                <p14:modId xmlns:p14="http://schemas.microsoft.com/office/powerpoint/2010/main" val="1108092504"/>
               </p:ext>
             </p:extLst>
           </p:nvPr>
@@ -15524,14 +15913,14 @@
                 <a:gridCol w="2667000">
                   <a:extLst>
                     <a:ext uri="{9D8B030D-6E8A-4147-A177-3AD203B41FA5}">
-                      <a16:colId xmlns:a16="http://schemas.microsoft.com/office/drawing/2014/main" val="974579773"/>
+                      <a16:colId xmlns:a16="http://schemas.microsoft.com/office/drawing/2014/main" val="1897370188"/>
                     </a:ext>
                   </a:extLst>
                 </a:gridCol>
                 <a:gridCol w="3403600">
                   <a:extLst>
                     <a:ext uri="{9D8B030D-6E8A-4147-A177-3AD203B41FA5}">
-                      <a16:colId xmlns:a16="http://schemas.microsoft.com/office/drawing/2014/main" val="1796149958"/>
+                      <a16:colId xmlns:a16="http://schemas.microsoft.com/office/drawing/2014/main" val="4066275939"/>
                     </a:ext>
                   </a:extLst>
                 </a:gridCol>
@@ -15609,7 +15998,7 @@
                 </a:tc>
                 <a:extLst>
                   <a:ext uri="{0D108BD9-81ED-4DB2-BD59-A6C34878D82A}">
-                    <a16:rowId xmlns:a16="http://schemas.microsoft.com/office/drawing/2014/main" val="1386976635"/>
+                    <a16:rowId xmlns:a16="http://schemas.microsoft.com/office/drawing/2014/main" val="2381511230"/>
                   </a:ext>
                 </a:extLst>
               </a:tr>
@@ -15692,7 +16081,7 @@
                 </a:tc>
                 <a:extLst>
                   <a:ext uri="{0D108BD9-81ED-4DB2-BD59-A6C34878D82A}">
-                    <a16:rowId xmlns:a16="http://schemas.microsoft.com/office/drawing/2014/main" val="2620441671"/>
+                    <a16:rowId xmlns:a16="http://schemas.microsoft.com/office/drawing/2014/main" val="1580268315"/>
                   </a:ext>
                 </a:extLst>
               </a:tr>
@@ -15781,7 +16170,7 @@
                 </a:tc>
                 <a:extLst>
                   <a:ext uri="{0D108BD9-81ED-4DB2-BD59-A6C34878D82A}">
-                    <a16:rowId xmlns:a16="http://schemas.microsoft.com/office/drawing/2014/main" val="145669002"/>
+                    <a16:rowId xmlns:a16="http://schemas.microsoft.com/office/drawing/2014/main" val="2544777509"/>
                   </a:ext>
                 </a:extLst>
               </a:tr>
@@ -15870,7 +16259,7 @@
                 </a:tc>
                 <a:extLst>
                   <a:ext uri="{0D108BD9-81ED-4DB2-BD59-A6C34878D82A}">
-                    <a16:rowId xmlns:a16="http://schemas.microsoft.com/office/drawing/2014/main" val="388077626"/>
+                    <a16:rowId xmlns:a16="http://schemas.microsoft.com/office/drawing/2014/main" val="3802773256"/>
                   </a:ext>
                 </a:extLst>
               </a:tr>
@@ -15959,7 +16348,7 @@
                 </a:tc>
                 <a:extLst>
                   <a:ext uri="{0D108BD9-81ED-4DB2-BD59-A6C34878D82A}">
-                    <a16:rowId xmlns:a16="http://schemas.microsoft.com/office/drawing/2014/main" val="2856951989"/>
+                    <a16:rowId xmlns:a16="http://schemas.microsoft.com/office/drawing/2014/main" val="3596385663"/>
                   </a:ext>
                 </a:extLst>
               </a:tr>
@@ -16042,7 +16431,7 @@
                 </a:tc>
                 <a:extLst>
                   <a:ext uri="{0D108BD9-81ED-4DB2-BD59-A6C34878D82A}">
-                    <a16:rowId xmlns:a16="http://schemas.microsoft.com/office/drawing/2014/main" val="1285656692"/>
+                    <a16:rowId xmlns:a16="http://schemas.microsoft.com/office/drawing/2014/main" val="2018874555"/>
                   </a:ext>
                 </a:extLst>
               </a:tr>
@@ -16125,7 +16514,7 @@
                 </a:tc>
                 <a:extLst>
                   <a:ext uri="{0D108BD9-81ED-4DB2-BD59-A6C34878D82A}">
-                    <a16:rowId xmlns:a16="http://schemas.microsoft.com/office/drawing/2014/main" val="3495474870"/>
+                    <a16:rowId xmlns:a16="http://schemas.microsoft.com/office/drawing/2014/main" val="3500187190"/>
                   </a:ext>
                 </a:extLst>
               </a:tr>
@@ -16138,7 +16527,7 @@
           <p:cNvPr id="18" name="Rectangle: Rounded Corners 17">
             <a:extLst>
               <a:ext uri="{FF2B5EF4-FFF2-40B4-BE49-F238E27FC236}">
-                <a16:creationId xmlns:a16="http://schemas.microsoft.com/office/drawing/2014/main" id="{C1F94103-2A4F-B81D-AF04-11FDDF968EBC}"/>
+                <a16:creationId xmlns:a16="http://schemas.microsoft.com/office/drawing/2014/main" id="{A9E25067-477A-FF05-9BAD-2EAAADE5F73A}"/>
               </a:ext>
             </a:extLst>
           </p:cNvPr>
@@ -16206,7 +16595,7 @@
           <p:cNvPr id="19" name="TextBox 18">
             <a:extLst>
               <a:ext uri="{FF2B5EF4-FFF2-40B4-BE49-F238E27FC236}">
-                <a16:creationId xmlns:a16="http://schemas.microsoft.com/office/drawing/2014/main" id="{BB0DB4D8-63A7-6B7B-9FE7-DC920D5AFBFA}"/>
+                <a16:creationId xmlns:a16="http://schemas.microsoft.com/office/drawing/2014/main" id="{6037C575-C95A-5E71-B0E3-A8EF37FEDED5}"/>
               </a:ext>
             </a:extLst>
           </p:cNvPr>
@@ -16288,7 +16677,7 @@
           <p:cNvPr id="20" name="Rectangle: Rounded Corners 19">
             <a:extLst>
               <a:ext uri="{FF2B5EF4-FFF2-40B4-BE49-F238E27FC236}">
-                <a16:creationId xmlns:a16="http://schemas.microsoft.com/office/drawing/2014/main" id="{BCA77142-9F0F-B41A-F57C-4EE37AAF4C30}"/>
+                <a16:creationId xmlns:a16="http://schemas.microsoft.com/office/drawing/2014/main" id="{16AA87B6-B22E-D994-A3DC-8748D910BA70}"/>
               </a:ext>
             </a:extLst>
           </p:cNvPr>
@@ -16366,7 +16755,7 @@
           <p:cNvPr id="21" name="TextBox 20">
             <a:extLst>
               <a:ext uri="{FF2B5EF4-FFF2-40B4-BE49-F238E27FC236}">
-                <a16:creationId xmlns:a16="http://schemas.microsoft.com/office/drawing/2014/main" id="{BDAA290F-3731-F41D-20F2-F4C933AF46A1}"/>
+                <a16:creationId xmlns:a16="http://schemas.microsoft.com/office/drawing/2014/main" id="{FBEF11CE-D36F-2901-5100-3A5CDBA6E802}"/>
               </a:ext>
             </a:extLst>
           </p:cNvPr>
@@ -16439,7 +16828,7 @@
           <p:cNvPr id="22" name="TextBox 21">
             <a:extLst>
               <a:ext uri="{FF2B5EF4-FFF2-40B4-BE49-F238E27FC236}">
-                <a16:creationId xmlns:a16="http://schemas.microsoft.com/office/drawing/2014/main" id="{983BE815-DFFB-D0E4-8673-5253EA470E74}"/>
+                <a16:creationId xmlns:a16="http://schemas.microsoft.com/office/drawing/2014/main" id="{4CE54742-E7AF-BDAC-D8B9-97A8FFF6E22F}"/>
               </a:ext>
             </a:extLst>
           </p:cNvPr>
@@ -16512,7 +16901,7 @@
           <p:cNvPr id="23" name="TextBox 22">
             <a:extLst>
               <a:ext uri="{FF2B5EF4-FFF2-40B4-BE49-F238E27FC236}">
-                <a16:creationId xmlns:a16="http://schemas.microsoft.com/office/drawing/2014/main" id="{6F2083B2-56B6-201E-0FD5-AB62EDD75209}"/>
+                <a16:creationId xmlns:a16="http://schemas.microsoft.com/office/drawing/2014/main" id="{CCACF9F1-5114-80D9-889D-47B8F2DFB824}"/>
               </a:ext>
             </a:extLst>
           </p:cNvPr>
@@ -16585,7 +16974,7 @@
           <p:cNvPr id="24" name="TextBox 23">
             <a:extLst>
               <a:ext uri="{FF2B5EF4-FFF2-40B4-BE49-F238E27FC236}">
-                <a16:creationId xmlns:a16="http://schemas.microsoft.com/office/drawing/2014/main" id="{298A40B0-90B2-25FB-96B7-D4A90DE08DAC}"/>
+                <a16:creationId xmlns:a16="http://schemas.microsoft.com/office/drawing/2014/main" id="{9ABF9F41-4A67-3F4A-C832-7E4453BD74C6}"/>
               </a:ext>
             </a:extLst>
           </p:cNvPr>
@@ -17039,7 +17428,7 @@
           <p:cNvPr id="2" name="TextBox 1">
             <a:extLst>
               <a:ext uri="{FF2B5EF4-FFF2-40B4-BE49-F238E27FC236}">
-                <a16:creationId xmlns:a16="http://schemas.microsoft.com/office/drawing/2014/main" id="{305872CD-37EF-8231-99E9-45524E6831EE}"/>
+                <a16:creationId xmlns:a16="http://schemas.microsoft.com/office/drawing/2014/main" id="{B1E6F814-BEE8-48D7-9B03-EB9D55C9B87D}"/>
               </a:ext>
             </a:extLst>
           </p:cNvPr>
@@ -17296,7 +17685,7 @@
           <p:cNvPr id="3" name="TextBox 2">
             <a:extLst>
               <a:ext uri="{FF2B5EF4-FFF2-40B4-BE49-F238E27FC236}">
-                <a16:creationId xmlns:a16="http://schemas.microsoft.com/office/drawing/2014/main" id="{82FCC899-18D3-9691-49D1-3BE47CCB0CA9}"/>
+                <a16:creationId xmlns:a16="http://schemas.microsoft.com/office/drawing/2014/main" id="{9CE31DFC-6527-FF40-AEAE-7A4B30E3556F}"/>
               </a:ext>
             </a:extLst>
           </p:cNvPr>
@@ -17547,7 +17936,7 @@
           <p:cNvPr id="4" name="Rectangle: Rounded Corners 3">
             <a:extLst>
               <a:ext uri="{FF2B5EF4-FFF2-40B4-BE49-F238E27FC236}">
-                <a16:creationId xmlns:a16="http://schemas.microsoft.com/office/drawing/2014/main" id="{B404DD7B-2F5F-16EB-DF66-77A35769E4BD}"/>
+                <a16:creationId xmlns:a16="http://schemas.microsoft.com/office/drawing/2014/main" id="{CC1E90B1-F8F0-7568-F630-6B8EB9425D4D}"/>
               </a:ext>
             </a:extLst>
           </p:cNvPr>
@@ -17625,7 +18014,7 @@
           <p:cNvPr id="5" name="TextBox 4">
             <a:extLst>
               <a:ext uri="{FF2B5EF4-FFF2-40B4-BE49-F238E27FC236}">
-                <a16:creationId xmlns:a16="http://schemas.microsoft.com/office/drawing/2014/main" id="{3ABEA697-CCEC-93B5-8478-4EE66D18E3D2}"/>
+                <a16:creationId xmlns:a16="http://schemas.microsoft.com/office/drawing/2014/main" id="{1CD1DF09-869F-49C3-3DDB-8DC52AF3B761}"/>
               </a:ext>
             </a:extLst>
           </p:cNvPr>
@@ -17689,7 +18078,7 @@
           <p:cNvPr id="8" name="TextBox 7">
             <a:extLst>
               <a:ext uri="{FF2B5EF4-FFF2-40B4-BE49-F238E27FC236}">
-                <a16:creationId xmlns:a16="http://schemas.microsoft.com/office/drawing/2014/main" id="{ED9BA8E4-3602-DD1D-F0C1-D08370025505}"/>
+                <a16:creationId xmlns:a16="http://schemas.microsoft.com/office/drawing/2014/main" id="{D5C1736C-B9B1-CE34-D81F-40F33474C9B9}"/>
               </a:ext>
             </a:extLst>
           </p:cNvPr>

</xml_diff>